<commit_message>
Expand week 4 slides (first real AI request)
Week 4 is the first expanded week with a rewritten block and a deletion,
so the generator now handles both: a set block shows a type-this slide
only for the lines it CHANGES (the rest appear as dimmed context), and a
removed line gets its own struck-through delete slide. Week 4 introduces
JSON.stringify; POST, headers, messages, roles and choices are taught in
the per-line notes. 328 -> 349 slides.

Co-Authored-By: Claude Opus 5 <noreply@anthropic.com>
</commit_message>
<xml_diff>
--- a/ai101/slides/week-02.pptx
+++ b/ai101/slides/week-02.pptx
@@ -41,10 +41,6 @@
     <p:sldId id="289" r:id="rId40"/>
     <p:sldId id="290" r:id="rId41"/>
     <p:sldId id="291" r:id="rId42"/>
-    <p:sldId id="292" r:id="rId43"/>
-    <p:sldId id="293" r:id="rId44"/>
-    <p:sldId id="294" r:id="rId45"/>
-    <p:sldId id="295" r:id="rId46"/>
   </p:sldIdLst>
   <p:sldSz cx="12191695" cy="6858000" type="screen4x3"/>
   <p:notesSz cx="6858000" cy="9144000"/>
@@ -5974,7 +5970,7 @@
                   <a:srgbClr val="DCECEF"/>
                 </a:solidFill>
               </a:rPr>
-              <a:t>A comment tying this to PixelPad: instead of checking every frame, you leave a note for the browser.</a:t>
+              <a:t>A comment: the browser calls this when the form is submitted.</a:t>
             </a:r>
           </a:p>
         </p:txBody>
@@ -5988,136 +5984,6 @@
 </file>
 
 <file path=ppt/slides/slide25.xml><?xml version="1.0" encoding="utf-8"?>
-<p:sld xmlns:a="http://schemas.openxmlformats.org/drawingml/2006/main" xmlns:p="http://schemas.openxmlformats.org/presentationml/2006/main" xmlns:r="http://schemas.openxmlformats.org/officeDocument/2006/relationships">
-  <p:cSld>
-    <p:spTree>
-      <p:nvGrpSpPr>
-        <p:cNvPr id="1" name=""/>
-        <p:cNvGrpSpPr/>
-        <p:nvPr/>
-      </p:nvGrpSpPr>
-      <p:grpSpPr/>
-      <p:sp>
-        <p:nvSpPr>
-          <p:cNvPr id="2" name="Title 1"/>
-          <p:cNvSpPr>
-            <a:spLocks noGrp="1"/>
-          </p:cNvSpPr>
-          <p:nvPr>
-            <p:ph type="title"/>
-          </p:nvPr>
-        </p:nvSpPr>
-        <p:spPr/>
-        <p:txBody>
-          <a:bodyPr/>
-          <a:lstStyle/>
-          <a:p>
-            <a:r>
-              <a:rPr sz="3800" b="1">
-                <a:solidFill>
-                  <a:srgbClr val="1F2A37"/>
-                </a:solidFill>
-              </a:rPr>
-              <a:t>.addEventListener()</a:t>
-            </a:r>
-          </a:p>
-        </p:txBody>
-      </p:sp>
-      <p:sp>
-        <p:nvSpPr>
-          <p:cNvPr id="3" name="TextBox 2"/>
-          <p:cNvSpPr txBox="1"/>
-          <p:nvPr/>
-        </p:nvSpPr>
-        <p:spPr>
-          <a:xfrm>
-            <a:off x="868680" y="502920"/>
-            <a:ext cx="5486400" cy="457200"/>
-          </a:xfrm>
-          <a:prstGeom prst="rect">
-            <a:avLst/>
-          </a:prstGeom>
-          <a:noFill/>
-        </p:spPr>
-        <p:txBody>
-          <a:bodyPr wrap="none">
-            <a:spAutoFit/>
-          </a:bodyPr>
-          <a:lstStyle/>
-          <a:p>
-            <a:r>
-              <a:rPr sz="1500" b="1">
-                <a:solidFill>
-                  <a:srgbClr val="01AEFD"/>
-                </a:solidFill>
-              </a:rPr>
-              <a:t>JAVASCRIPT</a:t>
-            </a:r>
-          </a:p>
-        </p:txBody>
-      </p:sp>
-      <p:sp>
-        <p:nvSpPr>
-          <p:cNvPr id="4" name="TextBox 3"/>
-          <p:cNvSpPr txBox="1"/>
-          <p:nvPr/>
-        </p:nvSpPr>
-        <p:spPr>
-          <a:xfrm>
-            <a:off x="822960" y="1828800"/>
-            <a:ext cx="10515600" cy="4206240"/>
-          </a:xfrm>
-          <a:prstGeom prst="rect">
-            <a:avLst/>
-          </a:prstGeom>
-          <a:noFill/>
-        </p:spPr>
-        <p:txBody>
-          <a:bodyPr wrap="square">
-            <a:spAutoFit/>
-          </a:bodyPr>
-          <a:lstStyle/>
-          <a:p>
-            <a:pPr>
-              <a:spcAft>
-                <a:spcPts val="1400"/>
-              </a:spcAft>
-            </a:pPr>
-            <a:r>
-              <a:rPr sz="2400">
-                <a:solidFill>
-                  <a:srgbClr val="1F2A37"/>
-                </a:solidFill>
-              </a:rPr>
-              <a:t>• Leaves a note: 'when THIS happens, run THAT'.</a:t>
-            </a:r>
-          </a:p>
-          <a:p>
-            <a:pPr>
-              <a:spcAft>
-                <a:spcPts val="1400"/>
-              </a:spcAft>
-            </a:pPr>
-            <a:r>
-              <a:rPr sz="2400">
-                <a:solidFill>
-                  <a:srgbClr val="1F2A37"/>
-                </a:solidFill>
-              </a:rPr>
-              <a:t>• Like your PixelPad loop watching for a key - but the browser waits and calls you.</a:t>
-            </a:r>
-          </a:p>
-        </p:txBody>
-      </p:sp>
-    </p:spTree>
-  </p:cSld>
-  <p:clrMapOvr>
-    <a:masterClrMapping/>
-  </p:clrMapOvr>
-</p:sld>
-</file>
-
-<file path=ppt/slides/slide26.xml><?xml version="1.0" encoding="utf-8"?>
 <p:sld xmlns:a="http://schemas.openxmlformats.org/drawingml/2006/main" xmlns:p="http://schemas.openxmlformats.org/presentationml/2006/main" xmlns:r="http://schemas.openxmlformats.org/officeDocument/2006/relationships">
   <p:cSld>
     <p:bg>
@@ -6163,7 +6029,7 @@
                   <a:srgbClr val="01AEFD"/>
                 </a:solidFill>
               </a:rPr>
-              <a:t>Type this into script.js   -   line 24</a:t>
+              <a:t>Type this into script.js   -   line 23</a:t>
             </a:r>
           </a:p>
         </p:txBody>
@@ -6257,36 +6123,11 @@
             <a:r>
               <a:rPr sz="1800">
                 <a:solidFill>
-                  <a:srgbClr val="6D8C97"/>
+                  <a:srgbClr val="7FE0A0"/>
                 </a:solidFill>
                 <a:latin typeface="Consolas"/>
               </a:rPr>
               <a:t>// leave a note: when this form is submitted, run this. The browser waits.</a:t>
-            </a:r>
-          </a:p>
-          <a:p>
-            <a:pPr>
-              <a:spcAft>
-                <a:spcPts val="0"/>
-              </a:spcAft>
-            </a:pPr>
-            <a:r>
-              <a:rPr sz="1800">
-                <a:solidFill>
-                  <a:srgbClr val="6D8C97"/>
-                </a:solidFill>
-                <a:latin typeface="Consolas"/>
-              </a:rPr>
-              <a:t>  24  </a:t>
-            </a:r>
-            <a:r>
-              <a:rPr sz="1800">
-                <a:solidFill>
-                  <a:srgbClr val="7FE0A0"/>
-                </a:solidFill>
-                <a:latin typeface="Consolas"/>
-              </a:rPr>
-              <a:t>composer.addEventListener('submit', function (event) {</a:t>
             </a:r>
           </a:p>
         </p:txBody>
@@ -6319,7 +6160,137 @@
                   <a:srgbClr val="DCECEF"/>
                 </a:solidFill>
               </a:rPr>
-              <a:t>When the form is submitted, run the function inside. event holds details of what happened.</a:t>
+              <a:t>Add async so we are allowed to await the slow AI call inside.</a:t>
+            </a:r>
+          </a:p>
+        </p:txBody>
+      </p:sp>
+    </p:spTree>
+  </p:cSld>
+  <p:clrMapOvr>
+    <a:masterClrMapping/>
+  </p:clrMapOvr>
+</p:sld>
+</file>
+
+<file path=ppt/slides/slide26.xml><?xml version="1.0" encoding="utf-8"?>
+<p:sld xmlns:a="http://schemas.openxmlformats.org/drawingml/2006/main" xmlns:p="http://schemas.openxmlformats.org/presentationml/2006/main" xmlns:r="http://schemas.openxmlformats.org/officeDocument/2006/relationships">
+  <p:cSld>
+    <p:spTree>
+      <p:nvGrpSpPr>
+        <p:cNvPr id="1" name=""/>
+        <p:cNvGrpSpPr/>
+        <p:nvPr/>
+      </p:nvGrpSpPr>
+      <p:grpSpPr/>
+      <p:sp>
+        <p:nvSpPr>
+          <p:cNvPr id="2" name="Title 1"/>
+          <p:cNvSpPr>
+            <a:spLocks noGrp="1"/>
+          </p:cNvSpPr>
+          <p:nvPr>
+            <p:ph type="title"/>
+          </p:nvPr>
+        </p:nvSpPr>
+        <p:spPr/>
+        <p:txBody>
+          <a:bodyPr/>
+          <a:lstStyle/>
+          <a:p>
+            <a:r>
+              <a:rPr sz="3800" b="1">
+                <a:solidFill>
+                  <a:srgbClr val="1F2A37"/>
+                </a:solidFill>
+              </a:rPr>
+              <a:t>.addEventListener()</a:t>
+            </a:r>
+          </a:p>
+        </p:txBody>
+      </p:sp>
+      <p:sp>
+        <p:nvSpPr>
+          <p:cNvPr id="3" name="TextBox 2"/>
+          <p:cNvSpPr txBox="1"/>
+          <p:nvPr/>
+        </p:nvSpPr>
+        <p:spPr>
+          <a:xfrm>
+            <a:off x="868680" y="502920"/>
+            <a:ext cx="5486400" cy="457200"/>
+          </a:xfrm>
+          <a:prstGeom prst="rect">
+            <a:avLst/>
+          </a:prstGeom>
+          <a:noFill/>
+        </p:spPr>
+        <p:txBody>
+          <a:bodyPr wrap="none">
+            <a:spAutoFit/>
+          </a:bodyPr>
+          <a:lstStyle/>
+          <a:p>
+            <a:r>
+              <a:rPr sz="1500" b="1">
+                <a:solidFill>
+                  <a:srgbClr val="01AEFD"/>
+                </a:solidFill>
+              </a:rPr>
+              <a:t>JAVASCRIPT</a:t>
+            </a:r>
+          </a:p>
+        </p:txBody>
+      </p:sp>
+      <p:sp>
+        <p:nvSpPr>
+          <p:cNvPr id="4" name="TextBox 3"/>
+          <p:cNvSpPr txBox="1"/>
+          <p:nvPr/>
+        </p:nvSpPr>
+        <p:spPr>
+          <a:xfrm>
+            <a:off x="822960" y="1828800"/>
+            <a:ext cx="10515600" cy="4206240"/>
+          </a:xfrm>
+          <a:prstGeom prst="rect">
+            <a:avLst/>
+          </a:prstGeom>
+          <a:noFill/>
+        </p:spPr>
+        <p:txBody>
+          <a:bodyPr wrap="square">
+            <a:spAutoFit/>
+          </a:bodyPr>
+          <a:lstStyle/>
+          <a:p>
+            <a:pPr>
+              <a:spcAft>
+                <a:spcPts val="1400"/>
+              </a:spcAft>
+            </a:pPr>
+            <a:r>
+              <a:rPr sz="2400">
+                <a:solidFill>
+                  <a:srgbClr val="1F2A37"/>
+                </a:solidFill>
+              </a:rPr>
+              <a:t>• Leaves a note: 'when THIS happens, run THAT'.</a:t>
+            </a:r>
+          </a:p>
+          <a:p>
+            <a:pPr>
+              <a:spcAft>
+                <a:spcPts val="1400"/>
+              </a:spcAft>
+            </a:pPr>
+            <a:r>
+              <a:rPr sz="2400">
+                <a:solidFill>
+                  <a:srgbClr val="1F2A37"/>
+                </a:solidFill>
+              </a:rPr>
+              <a:t>• Like your PixelPad loop watching for a key - but the browser waits and calls you.</a:t>
             </a:r>
           </a:p>
         </p:txBody>
@@ -6465,14 +6436,6 @@
 <file path=ppt/slides/slide28.xml><?xml version="1.0" encoding="utf-8"?>
 <p:sld xmlns:a="http://schemas.openxmlformats.org/drawingml/2006/main" xmlns:p="http://schemas.openxmlformats.org/presentationml/2006/main" xmlns:r="http://schemas.openxmlformats.org/officeDocument/2006/relationships">
   <p:cSld>
-    <p:bg>
-      <p:bgPr>
-        <a:solidFill>
-          <a:srgbClr val="102127"/>
-        </a:solidFill>
-        <a:effectLst/>
-      </p:bgPr>
-    </p:bg>
     <p:spTree>
       <p:nvGrpSpPr>
         <p:cNvPr id="1" name=""/>
@@ -6482,14 +6445,40 @@
       <p:grpSpPr/>
       <p:sp>
         <p:nvSpPr>
-          <p:cNvPr id="2" name="TextBox 1"/>
+          <p:cNvPr id="2" name="Title 1"/>
+          <p:cNvSpPr>
+            <a:spLocks noGrp="1"/>
+          </p:cNvSpPr>
+          <p:nvPr>
+            <p:ph type="title"/>
+          </p:nvPr>
+        </p:nvSpPr>
+        <p:spPr/>
+        <p:txBody>
+          <a:bodyPr/>
+          <a:lstStyle/>
+          <a:p>
+            <a:r>
+              <a:rPr sz="3800" b="1">
+                <a:solidFill>
+                  <a:srgbClr val="1F2A37"/>
+                </a:solidFill>
+              </a:rPr>
+              <a:t>Reading .value</a:t>
+            </a:r>
+          </a:p>
+        </p:txBody>
+      </p:sp>
+      <p:sp>
+        <p:nvSpPr>
+          <p:cNvPr id="3" name="TextBox 2"/>
           <p:cNvSpPr txBox="1"/>
           <p:nvPr/>
         </p:nvSpPr>
         <p:spPr>
           <a:xfrm>
-            <a:off x="502920" y="274320"/>
-            <a:ext cx="11155680" cy="548640"/>
+            <a:off x="868680" y="502920"/>
+            <a:ext cx="5486400" cy="457200"/>
           </a:xfrm>
           <a:prstGeom prst="rect">
             <a:avLst/>
@@ -6503,26 +6492,26 @@
           <a:lstStyle/>
           <a:p>
             <a:r>
-              <a:rPr sz="2200" b="1">
+              <a:rPr sz="1500" b="1">
                 <a:solidFill>
                   <a:srgbClr val="01AEFD"/>
                 </a:solidFill>
               </a:rPr>
-              <a:t>Type this into script.js   -   line 25</a:t>
-            </a:r>
-          </a:p>
-        </p:txBody>
-      </p:sp>
-      <p:sp>
-        <p:nvSpPr>
-          <p:cNvPr id="3" name="TextBox 2"/>
+              <a:t>JAVASCRIPT</a:t>
+            </a:r>
+          </a:p>
+        </p:txBody>
+      </p:sp>
+      <p:sp>
+        <p:nvSpPr>
+          <p:cNvPr id="4" name="TextBox 3"/>
           <p:cNvSpPr txBox="1"/>
           <p:nvPr/>
         </p:nvSpPr>
         <p:spPr>
           <a:xfrm>
-            <a:off x="502920" y="960120"/>
-            <a:ext cx="11155680" cy="4297680"/>
+            <a:off x="822960" y="1828800"/>
+            <a:ext cx="10515600" cy="4206240"/>
           </a:xfrm>
           <a:prstGeom prst="rect">
             <a:avLst/>
@@ -6530,166 +6519,23 @@
           <a:noFill/>
         </p:spPr>
         <p:txBody>
-          <a:bodyPr wrap="none">
-            <a:spAutoFit/>
-          </a:bodyPr>
-          <a:lstStyle/>
-          <a:p>
-            <a:pPr>
-              <a:spcAft>
-                <a:spcPts val="0"/>
-              </a:spcAft>
-            </a:pPr>
-            <a:r>
-              <a:rPr sz="1800">
-                <a:solidFill>
-                  <a:srgbClr val="6D8C97"/>
-                </a:solidFill>
-                <a:latin typeface="Consolas"/>
-              </a:rPr>
-              <a:t>  21  </a:t>
-            </a:r>
-            <a:r>
-              <a:rPr sz="1800">
-                <a:solidFill>
-                  <a:srgbClr val="6D8C97"/>
-                </a:solidFill>
-                <a:latin typeface="Consolas"/>
-              </a:rPr>
-              <a:t> </a:t>
-            </a:r>
-          </a:p>
-          <a:p>
-            <a:pPr>
-              <a:spcAft>
-                <a:spcPts val="0"/>
-              </a:spcAft>
-            </a:pPr>
-            <a:r>
-              <a:rPr sz="1800">
-                <a:solidFill>
-                  <a:srgbClr val="6D8C97"/>
-                </a:solidFill>
-                <a:latin typeface="Consolas"/>
-              </a:rPr>
-              <a:t>  22  </a:t>
-            </a:r>
-            <a:r>
-              <a:rPr sz="1800">
-                <a:solidFill>
-                  <a:srgbClr val="6D8C97"/>
-                </a:solidFill>
-                <a:latin typeface="Consolas"/>
-              </a:rPr>
-              <a:t>// In PixelPad your loop() checked 'was a key pressed?' every frame. Here you</a:t>
-            </a:r>
-          </a:p>
-          <a:p>
-            <a:pPr>
-              <a:spcAft>
-                <a:spcPts val="0"/>
-              </a:spcAft>
-            </a:pPr>
-            <a:r>
-              <a:rPr sz="1800">
-                <a:solidFill>
-                  <a:srgbClr val="6D8C97"/>
-                </a:solidFill>
-                <a:latin typeface="Consolas"/>
-              </a:rPr>
-              <a:t>  23  </a:t>
-            </a:r>
-            <a:r>
-              <a:rPr sz="1800">
-                <a:solidFill>
-                  <a:srgbClr val="6D8C97"/>
-                </a:solidFill>
-                <a:latin typeface="Consolas"/>
-              </a:rPr>
-              <a:t>// leave a note: when this form is submitted, run this. The browser waits.</a:t>
-            </a:r>
-          </a:p>
-          <a:p>
-            <a:pPr>
-              <a:spcAft>
-                <a:spcPts val="0"/>
-              </a:spcAft>
-            </a:pPr>
-            <a:r>
-              <a:rPr sz="1800">
-                <a:solidFill>
-                  <a:srgbClr val="6D8C97"/>
-                </a:solidFill>
-                <a:latin typeface="Consolas"/>
-              </a:rPr>
-              <a:t>  24  </a:t>
-            </a:r>
-            <a:r>
-              <a:rPr sz="1800">
-                <a:solidFill>
-                  <a:srgbClr val="6D8C97"/>
-                </a:solidFill>
-                <a:latin typeface="Consolas"/>
-              </a:rPr>
-              <a:t>composer.addEventListener('submit', function (event) {</a:t>
-            </a:r>
-          </a:p>
-          <a:p>
-            <a:pPr>
-              <a:spcAft>
-                <a:spcPts val="0"/>
-              </a:spcAft>
-            </a:pPr>
-            <a:r>
-              <a:rPr sz="1800">
-                <a:solidFill>
-                  <a:srgbClr val="6D8C97"/>
-                </a:solidFill>
-                <a:latin typeface="Consolas"/>
-              </a:rPr>
-              <a:t>  25  </a:t>
-            </a:r>
-            <a:r>
-              <a:rPr sz="1800">
-                <a:solidFill>
-                  <a:srgbClr val="7FE0A0"/>
-                </a:solidFill>
-                <a:latin typeface="Consolas"/>
-              </a:rPr>
-              <a:t>  event.preventDefault();          // stop the browser reloading the page</a:t>
-            </a:r>
-          </a:p>
-        </p:txBody>
-      </p:sp>
-      <p:sp>
-        <p:nvSpPr>
-          <p:cNvPr id="4" name="TextBox 3"/>
-          <p:cNvSpPr txBox="1"/>
-          <p:nvPr/>
-        </p:nvSpPr>
-        <p:spPr>
-          <a:xfrm>
-            <a:off x="548640" y="5623560"/>
-            <a:ext cx="11064240" cy="1051560"/>
-          </a:xfrm>
-          <a:prstGeom prst="rect">
-            <a:avLst/>
-          </a:prstGeom>
-          <a:noFill/>
-        </p:spPr>
-        <p:txBody>
           <a:bodyPr wrap="square">
             <a:spAutoFit/>
           </a:bodyPr>
           <a:lstStyle/>
           <a:p>
-            <a:r>
-              <a:rPr sz="2000">
-                <a:solidFill>
-                  <a:srgbClr val="DCECEF"/>
-                </a:solidFill>
-              </a:rPr>
-              <a:t>Stops the browser reloading the page, so we can handle it ourselves.</a:t>
+            <a:pPr>
+              <a:spcAft>
+                <a:spcPts val="1400"/>
+              </a:spcAft>
+            </a:pPr>
+            <a:r>
+              <a:rPr sz="2400">
+                <a:solidFill>
+                  <a:srgbClr val="1F2A37"/>
+                </a:solidFill>
+              </a:rPr>
+              <a:t>• box.value is whatever the student has typed in that input right now.</a:t>
             </a:r>
           </a:p>
         </p:txBody>
@@ -6733,7 +6579,7 @@
                   <a:srgbClr val="1F2A37"/>
                 </a:solidFill>
               </a:rPr>
-              <a:t>Reading .value</a:t>
+              <a:t>.trim()</a:t>
             </a:r>
           </a:p>
         </p:txBody>
@@ -6804,7 +6650,22 @@
                   <a:srgbClr val="1F2A37"/>
                 </a:solidFill>
               </a:rPr>
-              <a:t>• box.value is whatever the student has typed in that input right now.</a:t>
+              <a:t>• Removes blank space from the ends of text.</a:t>
+            </a:r>
+          </a:p>
+          <a:p>
+            <a:pPr>
+              <a:spcAft>
+                <a:spcPts val="1400"/>
+              </a:spcAft>
+            </a:pPr>
+            <a:r>
+              <a:rPr sz="2400">
+                <a:solidFill>
+                  <a:srgbClr val="1F2A37"/>
+                </a:solidFill>
+              </a:rPr>
+              <a:t>• ' hi ' becomes 'hi'.</a:t>
             </a:r>
           </a:p>
         </p:txBody>
@@ -6975,7 +6836,7 @@
                   <a:srgbClr val="1F2A37"/>
                 </a:solidFill>
               </a:rPr>
-              <a:t>.trim()</a:t>
+              <a:t>The if statement</a:t>
             </a:r>
           </a:p>
         </p:txBody>
@@ -7046,22 +6907,7 @@
                   <a:srgbClr val="1F2A37"/>
                 </a:solidFill>
               </a:rPr>
-              <a:t>• Removes blank space from the ends of text.</a:t>
-            </a:r>
-          </a:p>
-          <a:p>
-            <a:pPr>
-              <a:spcAft>
-                <a:spcPts val="1400"/>
-              </a:spcAft>
-            </a:pPr>
-            <a:r>
-              <a:rPr sz="2400">
-                <a:solidFill>
-                  <a:srgbClr val="1F2A37"/>
-                </a:solidFill>
-              </a:rPr>
-              <a:t>• ' hi ' becomes 'hi'.</a:t>
+              <a:t>• Runs the code in { } only WHEN the test in ( ) is true.</a:t>
             </a:r>
           </a:p>
         </p:txBody>
@@ -7075,6 +6921,121 @@
 </file>
 
 <file path=ppt/slides/slide31.xml><?xml version="1.0" encoding="utf-8"?>
+<p:sld xmlns:a="http://schemas.openxmlformats.org/drawingml/2006/main" xmlns:p="http://schemas.openxmlformats.org/presentationml/2006/main" xmlns:r="http://schemas.openxmlformats.org/officeDocument/2006/relationships">
+  <p:cSld>
+    <p:spTree>
+      <p:nvGrpSpPr>
+        <p:cNvPr id="1" name=""/>
+        <p:cNvGrpSpPr/>
+        <p:nvPr/>
+      </p:nvGrpSpPr>
+      <p:grpSpPr/>
+      <p:sp>
+        <p:nvSpPr>
+          <p:cNvPr id="2" name="Title 1"/>
+          <p:cNvSpPr>
+            <a:spLocks noGrp="1"/>
+          </p:cNvSpPr>
+          <p:nvPr>
+            <p:ph type="title"/>
+          </p:nvPr>
+        </p:nvSpPr>
+        <p:spPr/>
+        <p:txBody>
+          <a:bodyPr/>
+          <a:lstStyle/>
+          <a:p>
+            <a:r>
+              <a:rPr sz="3800" b="1">
+                <a:solidFill>
+                  <a:srgbClr val="1F2A37"/>
+                </a:solidFill>
+              </a:rPr>
+              <a:t>return</a:t>
+            </a:r>
+          </a:p>
+        </p:txBody>
+      </p:sp>
+      <p:sp>
+        <p:nvSpPr>
+          <p:cNvPr id="3" name="TextBox 2"/>
+          <p:cNvSpPr txBox="1"/>
+          <p:nvPr/>
+        </p:nvSpPr>
+        <p:spPr>
+          <a:xfrm>
+            <a:off x="868680" y="502920"/>
+            <a:ext cx="5486400" cy="457200"/>
+          </a:xfrm>
+          <a:prstGeom prst="rect">
+            <a:avLst/>
+          </a:prstGeom>
+          <a:noFill/>
+        </p:spPr>
+        <p:txBody>
+          <a:bodyPr wrap="none">
+            <a:spAutoFit/>
+          </a:bodyPr>
+          <a:lstStyle/>
+          <a:p>
+            <a:r>
+              <a:rPr sz="1500" b="1">
+                <a:solidFill>
+                  <a:srgbClr val="01AEFD"/>
+                </a:solidFill>
+              </a:rPr>
+              <a:t>JAVASCRIPT</a:t>
+            </a:r>
+          </a:p>
+        </p:txBody>
+      </p:sp>
+      <p:sp>
+        <p:nvSpPr>
+          <p:cNvPr id="4" name="TextBox 3"/>
+          <p:cNvSpPr txBox="1"/>
+          <p:nvPr/>
+        </p:nvSpPr>
+        <p:spPr>
+          <a:xfrm>
+            <a:off x="822960" y="1828800"/>
+            <a:ext cx="10515600" cy="4206240"/>
+          </a:xfrm>
+          <a:prstGeom prst="rect">
+            <a:avLst/>
+          </a:prstGeom>
+          <a:noFill/>
+        </p:spPr>
+        <p:txBody>
+          <a:bodyPr wrap="square">
+            <a:spAutoFit/>
+          </a:bodyPr>
+          <a:lstStyle/>
+          <a:p>
+            <a:pPr>
+              <a:spcAft>
+                <a:spcPts val="1400"/>
+              </a:spcAft>
+            </a:pPr>
+            <a:r>
+              <a:rPr sz="2400">
+                <a:solidFill>
+                  <a:srgbClr val="1F2A37"/>
+                </a:solidFill>
+              </a:rPr>
+              <a:t>• Stops the function right there. Nothing after it runs.</a:t>
+            </a:r>
+          </a:p>
+        </p:txBody>
+      </p:sp>
+    </p:spTree>
+  </p:cSld>
+  <p:clrMapOvr>
+    <a:masterClrMapping/>
+  </p:clrMapOvr>
+</p:sld>
+</file>
+
+<file path=ppt/slides/slide32.xml><?xml version="1.0" encoding="utf-8"?>
 <p:sld xmlns:a="http://schemas.openxmlformats.org/drawingml/2006/main" xmlns:p="http://schemas.openxmlformats.org/presentationml/2006/main" xmlns:r="http://schemas.openxmlformats.org/officeDocument/2006/relationships">
   <p:cSld>
     <p:bg>
@@ -7120,7 +7081,7 @@
                   <a:srgbClr val="01AEFD"/>
                 </a:solidFill>
               </a:rPr>
-              <a:t>Type this into script.js   -   line 26</a:t>
+              <a:t>Type this into script.js   -   line 29</a:t>
             </a:r>
           </a:p>
         </p:txBody>
@@ -7289,11 +7250,86 @@
             <a:r>
               <a:rPr sz="1800">
                 <a:solidFill>
+                  <a:srgbClr val="6D8C97"/>
+                </a:solidFill>
+                <a:latin typeface="Consolas"/>
+              </a:rPr>
+              <a:t>  const text = promptBox.value.trim();</a:t>
+            </a:r>
+          </a:p>
+          <a:p>
+            <a:pPr>
+              <a:spcAft>
+                <a:spcPts val="0"/>
+              </a:spcAft>
+            </a:pPr>
+            <a:r>
+              <a:rPr sz="1800">
+                <a:solidFill>
+                  <a:srgbClr val="6D8C97"/>
+                </a:solidFill>
+                <a:latin typeface="Consolas"/>
+              </a:rPr>
+              <a:t>  27  </a:t>
+            </a:r>
+            <a:r>
+              <a:rPr sz="1800">
+                <a:solidFill>
+                  <a:srgbClr val="6D8C97"/>
+                </a:solidFill>
+                <a:latin typeface="Consolas"/>
+              </a:rPr>
+              <a:t>  if (text === '') { return; }     // nothing typed, nothing to do</a:t>
+            </a:r>
+          </a:p>
+          <a:p>
+            <a:pPr>
+              <a:spcAft>
+                <a:spcPts val="0"/>
+              </a:spcAft>
+            </a:pPr>
+            <a:r>
+              <a:rPr sz="1800">
+                <a:solidFill>
+                  <a:srgbClr val="6D8C97"/>
+                </a:solidFill>
+                <a:latin typeface="Consolas"/>
+              </a:rPr>
+              <a:t>  28  </a:t>
+            </a:r>
+            <a:r>
+              <a:rPr sz="1800">
+                <a:solidFill>
+                  <a:srgbClr val="6D8C97"/>
+                </a:solidFill>
+                <a:latin typeface="Consolas"/>
+              </a:rPr>
+              <a:t>  promptBox.value = '';            // clear the box, ready for the next one</a:t>
+            </a:r>
+          </a:p>
+          <a:p>
+            <a:pPr>
+              <a:spcAft>
+                <a:spcPts val="0"/>
+              </a:spcAft>
+            </a:pPr>
+            <a:r>
+              <a:rPr sz="1800">
+                <a:solidFill>
+                  <a:srgbClr val="6D8C97"/>
+                </a:solidFill>
+                <a:latin typeface="Consolas"/>
+              </a:rPr>
+              <a:t>  29  </a:t>
+            </a:r>
+            <a:r>
+              <a:rPr sz="1800">
+                <a:solidFill>
                   <a:srgbClr val="7FE0A0"/>
                 </a:solidFill>
                 <a:latin typeface="Consolas"/>
               </a:rPr>
-              <a:t>  const text = promptBox.value.trim();</a:t>
+              <a:t>  addLine('You', text);</a:t>
             </a:r>
           </a:p>
         </p:txBody>
@@ -7326,122 +7362,7 @@
                   <a:srgbClr val="DCECEF"/>
                 </a:solidFill>
               </a:rPr>
-              <a:t>Reads what the student typed and trims blank space off the ends.</a:t>
-            </a:r>
-          </a:p>
-        </p:txBody>
-      </p:sp>
-    </p:spTree>
-  </p:cSld>
-  <p:clrMapOvr>
-    <a:masterClrMapping/>
-  </p:clrMapOvr>
-</p:sld>
-</file>
-
-<file path=ppt/slides/slide32.xml><?xml version="1.0" encoding="utf-8"?>
-<p:sld xmlns:a="http://schemas.openxmlformats.org/drawingml/2006/main" xmlns:p="http://schemas.openxmlformats.org/presentationml/2006/main" xmlns:r="http://schemas.openxmlformats.org/officeDocument/2006/relationships">
-  <p:cSld>
-    <p:spTree>
-      <p:nvGrpSpPr>
-        <p:cNvPr id="1" name=""/>
-        <p:cNvGrpSpPr/>
-        <p:nvPr/>
-      </p:nvGrpSpPr>
-      <p:grpSpPr/>
-      <p:sp>
-        <p:nvSpPr>
-          <p:cNvPr id="2" name="Title 1"/>
-          <p:cNvSpPr>
-            <a:spLocks noGrp="1"/>
-          </p:cNvSpPr>
-          <p:nvPr>
-            <p:ph type="title"/>
-          </p:nvPr>
-        </p:nvSpPr>
-        <p:spPr/>
-        <p:txBody>
-          <a:bodyPr/>
-          <a:lstStyle/>
-          <a:p>
-            <a:r>
-              <a:rPr sz="3800" b="1">
-                <a:solidFill>
-                  <a:srgbClr val="1F2A37"/>
-                </a:solidFill>
-              </a:rPr>
-              <a:t>The if statement</a:t>
-            </a:r>
-          </a:p>
-        </p:txBody>
-      </p:sp>
-      <p:sp>
-        <p:nvSpPr>
-          <p:cNvPr id="3" name="TextBox 2"/>
-          <p:cNvSpPr txBox="1"/>
-          <p:nvPr/>
-        </p:nvSpPr>
-        <p:spPr>
-          <a:xfrm>
-            <a:off x="868680" y="502920"/>
-            <a:ext cx="5486400" cy="457200"/>
-          </a:xfrm>
-          <a:prstGeom prst="rect">
-            <a:avLst/>
-          </a:prstGeom>
-          <a:noFill/>
-        </p:spPr>
-        <p:txBody>
-          <a:bodyPr wrap="none">
-            <a:spAutoFit/>
-          </a:bodyPr>
-          <a:lstStyle/>
-          <a:p>
-            <a:r>
-              <a:rPr sz="1500" b="1">
-                <a:solidFill>
-                  <a:srgbClr val="01AEFD"/>
-                </a:solidFill>
-              </a:rPr>
-              <a:t>JAVASCRIPT</a:t>
-            </a:r>
-          </a:p>
-        </p:txBody>
-      </p:sp>
-      <p:sp>
-        <p:nvSpPr>
-          <p:cNvPr id="4" name="TextBox 3"/>
-          <p:cNvSpPr txBox="1"/>
-          <p:nvPr/>
-        </p:nvSpPr>
-        <p:spPr>
-          <a:xfrm>
-            <a:off x="822960" y="1828800"/>
-            <a:ext cx="10515600" cy="4206240"/>
-          </a:xfrm>
-          <a:prstGeom prst="rect">
-            <a:avLst/>
-          </a:prstGeom>
-          <a:noFill/>
-        </p:spPr>
-        <p:txBody>
-          <a:bodyPr wrap="square">
-            <a:spAutoFit/>
-          </a:bodyPr>
-          <a:lstStyle/>
-          <a:p>
-            <a:pPr>
-              <a:spcAft>
-                <a:spcPts val="1400"/>
-              </a:spcAft>
-            </a:pPr>
-            <a:r>
-              <a:rPr sz="2400">
-                <a:solidFill>
-                  <a:srgbClr val="1F2A37"/>
-                </a:solidFill>
-              </a:rPr>
-              <a:t>• Runs the code in { } only WHEN the test in ( ) is true.</a:t>
+              <a:t>Change the pretend reply to a 'thinking...' line while we wait.</a:t>
             </a:r>
           </a:p>
         </p:txBody>
@@ -7457,6 +7378,14 @@
 <file path=ppt/slides/slide33.xml><?xml version="1.0" encoding="utf-8"?>
 <p:sld xmlns:a="http://schemas.openxmlformats.org/drawingml/2006/main" xmlns:p="http://schemas.openxmlformats.org/presentationml/2006/main" xmlns:r="http://schemas.openxmlformats.org/officeDocument/2006/relationships">
   <p:cSld>
+    <p:bg>
+      <p:bgPr>
+        <a:solidFill>
+          <a:srgbClr val="102127"/>
+        </a:solidFill>
+        <a:effectLst/>
+      </p:bgPr>
+    </p:bg>
     <p:spTree>
       <p:nvGrpSpPr>
         <p:cNvPr id="1" name=""/>
@@ -7466,40 +7395,14 @@
       <p:grpSpPr/>
       <p:sp>
         <p:nvSpPr>
-          <p:cNvPr id="2" name="Title 1"/>
-          <p:cNvSpPr>
-            <a:spLocks noGrp="1"/>
-          </p:cNvSpPr>
-          <p:nvPr>
-            <p:ph type="title"/>
-          </p:nvPr>
-        </p:nvSpPr>
-        <p:spPr/>
-        <p:txBody>
-          <a:bodyPr/>
-          <a:lstStyle/>
-          <a:p>
-            <a:r>
-              <a:rPr sz="3800" b="1">
-                <a:solidFill>
-                  <a:srgbClr val="1F2A37"/>
-                </a:solidFill>
-              </a:rPr>
-              <a:t>return</a:t>
-            </a:r>
-          </a:p>
-        </p:txBody>
-      </p:sp>
-      <p:sp>
-        <p:nvSpPr>
-          <p:cNvPr id="3" name="TextBox 2"/>
+          <p:cNvPr id="2" name="TextBox 1"/>
           <p:cNvSpPr txBox="1"/>
           <p:nvPr/>
         </p:nvSpPr>
         <p:spPr>
           <a:xfrm>
-            <a:off x="868680" y="502920"/>
-            <a:ext cx="5486400" cy="457200"/>
+            <a:off x="502920" y="274320"/>
+            <a:ext cx="11155680" cy="548640"/>
           </a:xfrm>
           <a:prstGeom prst="rect">
             <a:avLst/>
@@ -7513,26 +7416,26 @@
           <a:lstStyle/>
           <a:p>
             <a:r>
-              <a:rPr sz="1500" b="1">
+              <a:rPr sz="2200" b="1">
                 <a:solidFill>
                   <a:srgbClr val="01AEFD"/>
                 </a:solidFill>
               </a:rPr>
-              <a:t>JAVASCRIPT</a:t>
-            </a:r>
-          </a:p>
-        </p:txBody>
-      </p:sp>
-      <p:sp>
-        <p:nvSpPr>
-          <p:cNvPr id="4" name="TextBox 3"/>
+              <a:t>Type this into script.js   -   line 30</a:t>
+            </a:r>
+          </a:p>
+        </p:txBody>
+      </p:sp>
+      <p:sp>
+        <p:nvSpPr>
+          <p:cNvPr id="3" name="TextBox 2"/>
           <p:cNvSpPr txBox="1"/>
           <p:nvPr/>
         </p:nvSpPr>
         <p:spPr>
           <a:xfrm>
-            <a:off x="822960" y="1828800"/>
-            <a:ext cx="10515600" cy="4206240"/>
+            <a:off x="502920" y="960120"/>
+            <a:ext cx="11155680" cy="4297680"/>
           </a:xfrm>
           <a:prstGeom prst="rect">
             <a:avLst/>
@@ -7540,23 +7443,291 @@
           <a:noFill/>
         </p:spPr>
         <p:txBody>
+          <a:bodyPr wrap="none">
+            <a:spAutoFit/>
+          </a:bodyPr>
+          <a:lstStyle/>
+          <a:p>
+            <a:pPr>
+              <a:spcAft>
+                <a:spcPts val="0"/>
+              </a:spcAft>
+            </a:pPr>
+            <a:r>
+              <a:rPr sz="1800">
+                <a:solidFill>
+                  <a:srgbClr val="6D8C97"/>
+                </a:solidFill>
+                <a:latin typeface="Consolas"/>
+              </a:rPr>
+              <a:t>  21  </a:t>
+            </a:r>
+            <a:r>
+              <a:rPr sz="1800">
+                <a:solidFill>
+                  <a:srgbClr val="6D8C97"/>
+                </a:solidFill>
+                <a:latin typeface="Consolas"/>
+              </a:rPr>
+              <a:t> </a:t>
+            </a:r>
+          </a:p>
+          <a:p>
+            <a:pPr>
+              <a:spcAft>
+                <a:spcPts val="0"/>
+              </a:spcAft>
+            </a:pPr>
+            <a:r>
+              <a:rPr sz="1800">
+                <a:solidFill>
+                  <a:srgbClr val="6D8C97"/>
+                </a:solidFill>
+                <a:latin typeface="Consolas"/>
+              </a:rPr>
+              <a:t>  22  </a:t>
+            </a:r>
+            <a:r>
+              <a:rPr sz="1800">
+                <a:solidFill>
+                  <a:srgbClr val="6D8C97"/>
+                </a:solidFill>
+                <a:latin typeface="Consolas"/>
+              </a:rPr>
+              <a:t>// In PixelPad your loop() checked 'was a key pressed?' every frame. Here you</a:t>
+            </a:r>
+          </a:p>
+          <a:p>
+            <a:pPr>
+              <a:spcAft>
+                <a:spcPts val="0"/>
+              </a:spcAft>
+            </a:pPr>
+            <a:r>
+              <a:rPr sz="1800">
+                <a:solidFill>
+                  <a:srgbClr val="6D8C97"/>
+                </a:solidFill>
+                <a:latin typeface="Consolas"/>
+              </a:rPr>
+              <a:t>  23  </a:t>
+            </a:r>
+            <a:r>
+              <a:rPr sz="1800">
+                <a:solidFill>
+                  <a:srgbClr val="6D8C97"/>
+                </a:solidFill>
+                <a:latin typeface="Consolas"/>
+              </a:rPr>
+              <a:t>// leave a note: when this form is submitted, run this. The browser waits.</a:t>
+            </a:r>
+          </a:p>
+          <a:p>
+            <a:pPr>
+              <a:spcAft>
+                <a:spcPts val="0"/>
+              </a:spcAft>
+            </a:pPr>
+            <a:r>
+              <a:rPr sz="1800">
+                <a:solidFill>
+                  <a:srgbClr val="6D8C97"/>
+                </a:solidFill>
+                <a:latin typeface="Consolas"/>
+              </a:rPr>
+              <a:t>  24  </a:t>
+            </a:r>
+            <a:r>
+              <a:rPr sz="1800">
+                <a:solidFill>
+                  <a:srgbClr val="6D8C97"/>
+                </a:solidFill>
+                <a:latin typeface="Consolas"/>
+              </a:rPr>
+              <a:t>composer.addEventListener('submit', function (event) {</a:t>
+            </a:r>
+          </a:p>
+          <a:p>
+            <a:pPr>
+              <a:spcAft>
+                <a:spcPts val="0"/>
+              </a:spcAft>
+            </a:pPr>
+            <a:r>
+              <a:rPr sz="1800">
+                <a:solidFill>
+                  <a:srgbClr val="6D8C97"/>
+                </a:solidFill>
+                <a:latin typeface="Consolas"/>
+              </a:rPr>
+              <a:t>  25  </a:t>
+            </a:r>
+            <a:r>
+              <a:rPr sz="1800">
+                <a:solidFill>
+                  <a:srgbClr val="6D8C97"/>
+                </a:solidFill>
+                <a:latin typeface="Consolas"/>
+              </a:rPr>
+              <a:t>  event.preventDefault();          // stop the browser reloading the page</a:t>
+            </a:r>
+          </a:p>
+          <a:p>
+            <a:pPr>
+              <a:spcAft>
+                <a:spcPts val="0"/>
+              </a:spcAft>
+            </a:pPr>
+            <a:r>
+              <a:rPr sz="1800">
+                <a:solidFill>
+                  <a:srgbClr val="6D8C97"/>
+                </a:solidFill>
+                <a:latin typeface="Consolas"/>
+              </a:rPr>
+              <a:t>  26  </a:t>
+            </a:r>
+            <a:r>
+              <a:rPr sz="1800">
+                <a:solidFill>
+                  <a:srgbClr val="6D8C97"/>
+                </a:solidFill>
+                <a:latin typeface="Consolas"/>
+              </a:rPr>
+              <a:t>  const text = promptBox.value.trim();</a:t>
+            </a:r>
+          </a:p>
+          <a:p>
+            <a:pPr>
+              <a:spcAft>
+                <a:spcPts val="0"/>
+              </a:spcAft>
+            </a:pPr>
+            <a:r>
+              <a:rPr sz="1800">
+                <a:solidFill>
+                  <a:srgbClr val="6D8C97"/>
+                </a:solidFill>
+                <a:latin typeface="Consolas"/>
+              </a:rPr>
+              <a:t>  27  </a:t>
+            </a:r>
+            <a:r>
+              <a:rPr sz="1800">
+                <a:solidFill>
+                  <a:srgbClr val="6D8C97"/>
+                </a:solidFill>
+                <a:latin typeface="Consolas"/>
+              </a:rPr>
+              <a:t>  if (text === '') { return; }     // nothing typed, nothing to do</a:t>
+            </a:r>
+          </a:p>
+          <a:p>
+            <a:pPr>
+              <a:spcAft>
+                <a:spcPts val="0"/>
+              </a:spcAft>
+            </a:pPr>
+            <a:r>
+              <a:rPr sz="1800">
+                <a:solidFill>
+                  <a:srgbClr val="6D8C97"/>
+                </a:solidFill>
+                <a:latin typeface="Consolas"/>
+              </a:rPr>
+              <a:t>  28  </a:t>
+            </a:r>
+            <a:r>
+              <a:rPr sz="1800">
+                <a:solidFill>
+                  <a:srgbClr val="6D8C97"/>
+                </a:solidFill>
+                <a:latin typeface="Consolas"/>
+              </a:rPr>
+              <a:t>  promptBox.value = '';            // clear the box, ready for the next one</a:t>
+            </a:r>
+          </a:p>
+          <a:p>
+            <a:pPr>
+              <a:spcAft>
+                <a:spcPts val="0"/>
+              </a:spcAft>
+            </a:pPr>
+            <a:r>
+              <a:rPr sz="1800">
+                <a:solidFill>
+                  <a:srgbClr val="6D8C97"/>
+                </a:solidFill>
+                <a:latin typeface="Consolas"/>
+              </a:rPr>
+              <a:t>  29  </a:t>
+            </a:r>
+            <a:r>
+              <a:rPr sz="1800">
+                <a:solidFill>
+                  <a:srgbClr val="6D8C97"/>
+                </a:solidFill>
+                <a:latin typeface="Consolas"/>
+              </a:rPr>
+              <a:t>  addLine('You', text);</a:t>
+            </a:r>
+          </a:p>
+          <a:p>
+            <a:pPr>
+              <a:spcAft>
+                <a:spcPts val="0"/>
+              </a:spcAft>
+            </a:pPr>
+            <a:r>
+              <a:rPr sz="1800">
+                <a:solidFill>
+                  <a:srgbClr val="6D8C97"/>
+                </a:solidFill>
+                <a:latin typeface="Consolas"/>
+              </a:rPr>
+              <a:t>  30  </a:t>
+            </a:r>
+            <a:r>
+              <a:rPr sz="1800">
+                <a:solidFill>
+                  <a:srgbClr val="7FE0A0"/>
+                </a:solidFill>
+                <a:latin typeface="Consolas"/>
+              </a:rPr>
+              <a:t>  addLine('Companion', 'You said: ' + text);   // a pretend answer, for now</a:t>
+            </a:r>
+          </a:p>
+        </p:txBody>
+      </p:sp>
+      <p:sp>
+        <p:nvSpPr>
+          <p:cNvPr id="4" name="TextBox 3"/>
+          <p:cNvSpPr txBox="1"/>
+          <p:nvPr/>
+        </p:nvSpPr>
+        <p:spPr>
+          <a:xfrm>
+            <a:off x="548640" y="5623560"/>
+            <a:ext cx="11064240" cy="1051560"/>
+          </a:xfrm>
+          <a:prstGeom prst="rect">
+            <a:avLst/>
+          </a:prstGeom>
+          <a:noFill/>
+        </p:spPr>
+        <p:txBody>
           <a:bodyPr wrap="square">
             <a:spAutoFit/>
           </a:bodyPr>
           <a:lstStyle/>
           <a:p>
-            <a:pPr>
-              <a:spcAft>
-                <a:spcPts val="1400"/>
-              </a:spcAft>
-            </a:pPr>
-            <a:r>
-              <a:rPr sz="2400">
-                <a:solidFill>
-                  <a:srgbClr val="1F2A37"/>
-                </a:solidFill>
-              </a:rPr>
-              <a:t>• Stops the function right there. Nothing after it runs.</a:t>
+            <a:r>
+              <a:rPr sz="2000">
+                <a:solidFill>
+                  <a:srgbClr val="DCECEF"/>
+                </a:solidFill>
+              </a:rPr>
+              <a:t>await askAI(text): the slow bit - ask the AI and wait for the answer.</a:t>
             </a:r>
           </a:p>
         </p:txBody>
@@ -7615,7 +7786,7 @@
                   <a:srgbClr val="01AEFD"/>
                 </a:solidFill>
               </a:rPr>
-              <a:t>Type this into script.js   -   line 27</a:t>
+              <a:t>Type this into script.js   -   line 31</a:t>
             </a:r>
           </a:p>
         </p:txBody>
@@ -7648,7 +7819,7 @@
               </a:spcAft>
             </a:pPr>
             <a:r>
-              <a:rPr sz="1800">
+              <a:rPr sz="1300">
                 <a:solidFill>
                   <a:srgbClr val="6D8C97"/>
                 </a:solidFill>
@@ -7657,7 +7828,7 @@
               <a:t>  21  </a:t>
             </a:r>
             <a:r>
-              <a:rPr sz="1800">
+              <a:rPr sz="1300">
                 <a:solidFill>
                   <a:srgbClr val="6D8C97"/>
                 </a:solidFill>
@@ -7673,7 +7844,7 @@
               </a:spcAft>
             </a:pPr>
             <a:r>
-              <a:rPr sz="1800">
+              <a:rPr sz="1300">
                 <a:solidFill>
                   <a:srgbClr val="6D8C97"/>
                 </a:solidFill>
@@ -7682,7 +7853,7 @@
               <a:t>  22  </a:t>
             </a:r>
             <a:r>
-              <a:rPr sz="1800">
+              <a:rPr sz="1300">
                 <a:solidFill>
                   <a:srgbClr val="6D8C97"/>
                 </a:solidFill>
@@ -7698,7 +7869,7 @@
               </a:spcAft>
             </a:pPr>
             <a:r>
-              <a:rPr sz="1800">
+              <a:rPr sz="1300">
                 <a:solidFill>
                   <a:srgbClr val="6D8C97"/>
                 </a:solidFill>
@@ -7707,7 +7878,7 @@
               <a:t>  23  </a:t>
             </a:r>
             <a:r>
-              <a:rPr sz="1800">
+              <a:rPr sz="1300">
                 <a:solidFill>
                   <a:srgbClr val="6D8C97"/>
                 </a:solidFill>
@@ -7723,7 +7894,7 @@
               </a:spcAft>
             </a:pPr>
             <a:r>
-              <a:rPr sz="1800">
+              <a:rPr sz="1300">
                 <a:solidFill>
                   <a:srgbClr val="6D8C97"/>
                 </a:solidFill>
@@ -7732,7 +7903,7 @@
               <a:t>  24  </a:t>
             </a:r>
             <a:r>
-              <a:rPr sz="1800">
+              <a:rPr sz="1300">
                 <a:solidFill>
                   <a:srgbClr val="6D8C97"/>
                 </a:solidFill>
@@ -7748,7 +7919,7 @@
               </a:spcAft>
             </a:pPr>
             <a:r>
-              <a:rPr sz="1800">
+              <a:rPr sz="1300">
                 <a:solidFill>
                   <a:srgbClr val="6D8C97"/>
                 </a:solidFill>
@@ -7757,7 +7928,7 @@
               <a:t>  25  </a:t>
             </a:r>
             <a:r>
-              <a:rPr sz="1800">
+              <a:rPr sz="1300">
                 <a:solidFill>
                   <a:srgbClr val="6D8C97"/>
                 </a:solidFill>
@@ -7773,7 +7944,7 @@
               </a:spcAft>
             </a:pPr>
             <a:r>
-              <a:rPr sz="1800">
+              <a:rPr sz="1300">
                 <a:solidFill>
                   <a:srgbClr val="6D8C97"/>
                 </a:solidFill>
@@ -7782,7 +7953,7 @@
               <a:t>  26  </a:t>
             </a:r>
             <a:r>
-              <a:rPr sz="1800">
+              <a:rPr sz="1300">
                 <a:solidFill>
                   <a:srgbClr val="6D8C97"/>
                 </a:solidFill>
@@ -7798,7 +7969,7 @@
               </a:spcAft>
             </a:pPr>
             <a:r>
-              <a:rPr sz="1800">
+              <a:rPr sz="1300">
                 <a:solidFill>
                   <a:srgbClr val="6D8C97"/>
                 </a:solidFill>
@@ -7807,13 +7978,113 @@
               <a:t>  27  </a:t>
             </a:r>
             <a:r>
-              <a:rPr sz="1800">
+              <a:rPr sz="1300">
+                <a:solidFill>
+                  <a:srgbClr val="6D8C97"/>
+                </a:solidFill>
+                <a:latin typeface="Consolas"/>
+              </a:rPr>
+              <a:t>  if (text === '') { return; }     // nothing typed, nothing to do</a:t>
+            </a:r>
+          </a:p>
+          <a:p>
+            <a:pPr>
+              <a:spcAft>
+                <a:spcPts val="0"/>
+              </a:spcAft>
+            </a:pPr>
+            <a:r>
+              <a:rPr sz="1300">
+                <a:solidFill>
+                  <a:srgbClr val="6D8C97"/>
+                </a:solidFill>
+                <a:latin typeface="Consolas"/>
+              </a:rPr>
+              <a:t>  28  </a:t>
+            </a:r>
+            <a:r>
+              <a:rPr sz="1300">
+                <a:solidFill>
+                  <a:srgbClr val="6D8C97"/>
+                </a:solidFill>
+                <a:latin typeface="Consolas"/>
+              </a:rPr>
+              <a:t>  promptBox.value = '';            // clear the box, ready for the next one</a:t>
+            </a:r>
+          </a:p>
+          <a:p>
+            <a:pPr>
+              <a:spcAft>
+                <a:spcPts val="0"/>
+              </a:spcAft>
+            </a:pPr>
+            <a:r>
+              <a:rPr sz="1300">
+                <a:solidFill>
+                  <a:srgbClr val="6D8C97"/>
+                </a:solidFill>
+                <a:latin typeface="Consolas"/>
+              </a:rPr>
+              <a:t>  29  </a:t>
+            </a:r>
+            <a:r>
+              <a:rPr sz="1300">
+                <a:solidFill>
+                  <a:srgbClr val="6D8C97"/>
+                </a:solidFill>
+                <a:latin typeface="Consolas"/>
+              </a:rPr>
+              <a:t>  addLine('You', text);</a:t>
+            </a:r>
+          </a:p>
+          <a:p>
+            <a:pPr>
+              <a:spcAft>
+                <a:spcPts val="0"/>
+              </a:spcAft>
+            </a:pPr>
+            <a:r>
+              <a:rPr sz="1300">
+                <a:solidFill>
+                  <a:srgbClr val="6D8C97"/>
+                </a:solidFill>
+                <a:latin typeface="Consolas"/>
+              </a:rPr>
+              <a:t>  30  </a:t>
+            </a:r>
+            <a:r>
+              <a:rPr sz="1300">
+                <a:solidFill>
+                  <a:srgbClr val="6D8C97"/>
+                </a:solidFill>
+                <a:latin typeface="Consolas"/>
+              </a:rPr>
+              <a:t>  addLine('Companion', 'You said: ' + text);   // a pretend answer, for now</a:t>
+            </a:r>
+          </a:p>
+          <a:p>
+            <a:pPr>
+              <a:spcAft>
+                <a:spcPts val="0"/>
+              </a:spcAft>
+            </a:pPr>
+            <a:r>
+              <a:rPr sz="1300">
+                <a:solidFill>
+                  <a:srgbClr val="6D8C97"/>
+                </a:solidFill>
+                <a:latin typeface="Consolas"/>
+              </a:rPr>
+              <a:t>  31  </a:t>
+            </a:r>
+            <a:r>
+              <a:rPr sz="1300">
                 <a:solidFill>
                   <a:srgbClr val="7FE0A0"/>
                 </a:solidFill>
                 <a:latin typeface="Consolas"/>
               </a:rPr>
-              <a:t>  if (text === '') { return; }     // nothing typed, nothing to do</a:t>
+              <a:t>});</a:t>
             </a:r>
           </a:p>
         </p:txBody>
@@ -7846,7 +8117,7 @@
                   <a:srgbClr val="DCECEF"/>
                 </a:solidFill>
               </a:rPr>
-              <a:t>If the box was empty, return - stop here and do nothing.</a:t>
+              <a:t>Remove the 'thinking...' line now the real answer is here.</a:t>
             </a:r>
           </a:p>
         </p:txBody>
@@ -7905,7 +8176,7 @@
                   <a:srgbClr val="01AEFD"/>
                 </a:solidFill>
               </a:rPr>
-              <a:t>Type this into script.js   -   line 28</a:t>
+              <a:t>All together in script.js</a:t>
             </a:r>
           </a:p>
         </p:txBody>
@@ -7938,7 +8209,7 @@
               </a:spcAft>
             </a:pPr>
             <a:r>
-              <a:rPr sz="1800">
+              <a:rPr sz="1300">
                 <a:solidFill>
                   <a:srgbClr val="6D8C97"/>
                 </a:solidFill>
@@ -7947,9 +8218,9 @@
               <a:t>  21  </a:t>
             </a:r>
             <a:r>
-              <a:rPr sz="1800">
-                <a:solidFill>
-                  <a:srgbClr val="6D8C97"/>
+              <a:rPr sz="1300">
+                <a:solidFill>
+                  <a:srgbClr val="7FE0A0"/>
                 </a:solidFill>
                 <a:latin typeface="Consolas"/>
               </a:rPr>
@@ -7963,7 +8234,7 @@
               </a:spcAft>
             </a:pPr>
             <a:r>
-              <a:rPr sz="1800">
+              <a:rPr sz="1300">
                 <a:solidFill>
                   <a:srgbClr val="6D8C97"/>
                 </a:solidFill>
@@ -7972,9 +8243,9 @@
               <a:t>  22  </a:t>
             </a:r>
             <a:r>
-              <a:rPr sz="1800">
-                <a:solidFill>
-                  <a:srgbClr val="6D8C97"/>
+              <a:rPr sz="1300">
+                <a:solidFill>
+                  <a:srgbClr val="7FE0A0"/>
                 </a:solidFill>
                 <a:latin typeface="Consolas"/>
               </a:rPr>
@@ -7988,7 +8259,7 @@
               </a:spcAft>
             </a:pPr>
             <a:r>
-              <a:rPr sz="1800">
+              <a:rPr sz="1300">
                 <a:solidFill>
                   <a:srgbClr val="6D8C97"/>
                 </a:solidFill>
@@ -7997,9 +8268,9 @@
               <a:t>  23  </a:t>
             </a:r>
             <a:r>
-              <a:rPr sz="1800">
-                <a:solidFill>
-                  <a:srgbClr val="6D8C97"/>
+              <a:rPr sz="1300">
+                <a:solidFill>
+                  <a:srgbClr val="7FE0A0"/>
                 </a:solidFill>
                 <a:latin typeface="Consolas"/>
               </a:rPr>
@@ -8013,7 +8284,7 @@
               </a:spcAft>
             </a:pPr>
             <a:r>
-              <a:rPr sz="1800">
+              <a:rPr sz="1300">
                 <a:solidFill>
                   <a:srgbClr val="6D8C97"/>
                 </a:solidFill>
@@ -8022,9 +8293,9 @@
               <a:t>  24  </a:t>
             </a:r>
             <a:r>
-              <a:rPr sz="1800">
-                <a:solidFill>
-                  <a:srgbClr val="6D8C97"/>
+              <a:rPr sz="1300">
+                <a:solidFill>
+                  <a:srgbClr val="7FE0A0"/>
                 </a:solidFill>
                 <a:latin typeface="Consolas"/>
               </a:rPr>
@@ -8038,7 +8309,7 @@
               </a:spcAft>
             </a:pPr>
             <a:r>
-              <a:rPr sz="1800">
+              <a:rPr sz="1300">
                 <a:solidFill>
                   <a:srgbClr val="6D8C97"/>
                 </a:solidFill>
@@ -8047,9 +8318,9 @@
               <a:t>  25  </a:t>
             </a:r>
             <a:r>
-              <a:rPr sz="1800">
-                <a:solidFill>
-                  <a:srgbClr val="6D8C97"/>
+              <a:rPr sz="1300">
+                <a:solidFill>
+                  <a:srgbClr val="7FE0A0"/>
                 </a:solidFill>
                 <a:latin typeface="Consolas"/>
               </a:rPr>
@@ -8063,7 +8334,7 @@
               </a:spcAft>
             </a:pPr>
             <a:r>
-              <a:rPr sz="1800">
+              <a:rPr sz="1300">
                 <a:solidFill>
                   <a:srgbClr val="6D8C97"/>
                 </a:solidFill>
@@ -8072,9 +8343,9 @@
               <a:t>  26  </a:t>
             </a:r>
             <a:r>
-              <a:rPr sz="1800">
-                <a:solidFill>
-                  <a:srgbClr val="6D8C97"/>
+              <a:rPr sz="1300">
+                <a:solidFill>
+                  <a:srgbClr val="7FE0A0"/>
                 </a:solidFill>
                 <a:latin typeface="Consolas"/>
               </a:rPr>
@@ -8088,7 +8359,7 @@
               </a:spcAft>
             </a:pPr>
             <a:r>
-              <a:rPr sz="1800">
+              <a:rPr sz="1300">
                 <a:solidFill>
                   <a:srgbClr val="6D8C97"/>
                 </a:solidFill>
@@ -8097,9 +8368,9 @@
               <a:t>  27  </a:t>
             </a:r>
             <a:r>
-              <a:rPr sz="1800">
-                <a:solidFill>
-                  <a:srgbClr val="6D8C97"/>
+              <a:rPr sz="1300">
+                <a:solidFill>
+                  <a:srgbClr val="7FE0A0"/>
                 </a:solidFill>
                 <a:latin typeface="Consolas"/>
               </a:rPr>
@@ -8113,7 +8384,7 @@
               </a:spcAft>
             </a:pPr>
             <a:r>
-              <a:rPr sz="1800">
+              <a:rPr sz="1300">
                 <a:solidFill>
                   <a:srgbClr val="6D8C97"/>
                 </a:solidFill>
@@ -8122,13 +8393,88 @@
               <a:t>  28  </a:t>
             </a:r>
             <a:r>
-              <a:rPr sz="1800">
+              <a:rPr sz="1300">
                 <a:solidFill>
                   <a:srgbClr val="7FE0A0"/>
                 </a:solidFill>
                 <a:latin typeface="Consolas"/>
               </a:rPr>
               <a:t>  promptBox.value = '';            // clear the box, ready for the next one</a:t>
+            </a:r>
+          </a:p>
+          <a:p>
+            <a:pPr>
+              <a:spcAft>
+                <a:spcPts val="0"/>
+              </a:spcAft>
+            </a:pPr>
+            <a:r>
+              <a:rPr sz="1300">
+                <a:solidFill>
+                  <a:srgbClr val="6D8C97"/>
+                </a:solidFill>
+                <a:latin typeface="Consolas"/>
+              </a:rPr>
+              <a:t>  29  </a:t>
+            </a:r>
+            <a:r>
+              <a:rPr sz="1300">
+                <a:solidFill>
+                  <a:srgbClr val="7FE0A0"/>
+                </a:solidFill>
+                <a:latin typeface="Consolas"/>
+              </a:rPr>
+              <a:t>  addLine('You', text);</a:t>
+            </a:r>
+          </a:p>
+          <a:p>
+            <a:pPr>
+              <a:spcAft>
+                <a:spcPts val="0"/>
+              </a:spcAft>
+            </a:pPr>
+            <a:r>
+              <a:rPr sz="1300">
+                <a:solidFill>
+                  <a:srgbClr val="6D8C97"/>
+                </a:solidFill>
+                <a:latin typeface="Consolas"/>
+              </a:rPr>
+              <a:t>  30  </a:t>
+            </a:r>
+            <a:r>
+              <a:rPr sz="1300">
+                <a:solidFill>
+                  <a:srgbClr val="7FE0A0"/>
+                </a:solidFill>
+                <a:latin typeface="Consolas"/>
+              </a:rPr>
+              <a:t>  addLine('Companion', 'You said: ' + text);   // a pretend answer, for now</a:t>
+            </a:r>
+          </a:p>
+          <a:p>
+            <a:pPr>
+              <a:spcAft>
+                <a:spcPts val="0"/>
+              </a:spcAft>
+            </a:pPr>
+            <a:r>
+              <a:rPr sz="1300">
+                <a:solidFill>
+                  <a:srgbClr val="6D8C97"/>
+                </a:solidFill>
+                <a:latin typeface="Consolas"/>
+              </a:rPr>
+              <a:t>  31  </a:t>
+            </a:r>
+            <a:r>
+              <a:rPr sz="1300">
+                <a:solidFill>
+                  <a:srgbClr val="7FE0A0"/>
+                </a:solidFill>
+                <a:latin typeface="Consolas"/>
+              </a:rPr>
+              <a:t>});</a:t>
             </a:r>
           </a:p>
         </p:txBody>
@@ -8161,7 +8507,7 @@
                   <a:srgbClr val="DCECEF"/>
                 </a:solidFill>
               </a:rPr>
-              <a:t>Empties the text box, ready for the next message.</a:t>
+              <a:t>That is the whole piece. Check yours looks the same before moving on.</a:t>
             </a:r>
           </a:p>
         </p:txBody>
@@ -8177,14 +8523,6 @@
 <file path=ppt/slides/slide36.xml><?xml version="1.0" encoding="utf-8"?>
 <p:sld xmlns:a="http://schemas.openxmlformats.org/drawingml/2006/main" xmlns:p="http://schemas.openxmlformats.org/presentationml/2006/main" xmlns:r="http://schemas.openxmlformats.org/officeDocument/2006/relationships">
   <p:cSld>
-    <p:bg>
-      <p:bgPr>
-        <a:solidFill>
-          <a:srgbClr val="102127"/>
-        </a:solidFill>
-        <a:effectLst/>
-      </p:bgPr>
-    </p:bg>
     <p:spTree>
       <p:nvGrpSpPr>
         <p:cNvPr id="1" name=""/>
@@ -8194,14 +8532,40 @@
       <p:grpSpPr/>
       <p:sp>
         <p:nvSpPr>
-          <p:cNvPr id="2" name="TextBox 1"/>
+          <p:cNvPr id="2" name="Title 1"/>
+          <p:cNvSpPr>
+            <a:spLocks noGrp="1"/>
+          </p:cNvSpPr>
+          <p:nvPr>
+            <p:ph type="title"/>
+          </p:nvPr>
+        </p:nvSpPr>
+        <p:spPr/>
+        <p:txBody>
+          <a:bodyPr/>
+          <a:lstStyle/>
+          <a:p>
+            <a:r>
+              <a:rPr sz="3800" b="1">
+                <a:solidFill>
+                  <a:srgbClr val="1F2A37"/>
+                </a:solidFill>
+              </a:rPr>
+              <a:t>Your turn</a:t>
+            </a:r>
+          </a:p>
+        </p:txBody>
+      </p:sp>
+      <p:sp>
+        <p:nvSpPr>
+          <p:cNvPr id="3" name="TextBox 2"/>
           <p:cNvSpPr txBox="1"/>
           <p:nvPr/>
         </p:nvSpPr>
         <p:spPr>
           <a:xfrm>
-            <a:off x="502920" y="274320"/>
-            <a:ext cx="11155680" cy="548640"/>
+            <a:off x="822960" y="1828800"/>
+            <a:ext cx="10515600" cy="4206240"/>
           </a:xfrm>
           <a:prstGeom prst="rect">
             <a:avLst/>
@@ -8209,1444 +8573,68 @@
           <a:noFill/>
         </p:spPr>
         <p:txBody>
-          <a:bodyPr wrap="none">
-            <a:spAutoFit/>
-          </a:bodyPr>
-          <a:lstStyle/>
-          <a:p>
-            <a:r>
-              <a:rPr sz="2200" b="1">
-                <a:solidFill>
-                  <a:srgbClr val="01AEFD"/>
-                </a:solidFill>
-              </a:rPr>
-              <a:t>Type this into script.js   -   line 29</a:t>
-            </a:r>
-          </a:p>
-        </p:txBody>
-      </p:sp>
-      <p:sp>
-        <p:nvSpPr>
-          <p:cNvPr id="3" name="TextBox 2"/>
-          <p:cNvSpPr txBox="1"/>
-          <p:nvPr/>
-        </p:nvSpPr>
-        <p:spPr>
-          <a:xfrm>
-            <a:off x="502920" y="960120"/>
-            <a:ext cx="11155680" cy="4297680"/>
-          </a:xfrm>
-          <a:prstGeom prst="rect">
-            <a:avLst/>
-          </a:prstGeom>
-          <a:noFill/>
-        </p:spPr>
-        <p:txBody>
-          <a:bodyPr wrap="none">
-            <a:spAutoFit/>
-          </a:bodyPr>
-          <a:lstStyle/>
-          <a:p>
-            <a:pPr>
-              <a:spcAft>
-                <a:spcPts val="0"/>
-              </a:spcAft>
-            </a:pPr>
-            <a:r>
-              <a:rPr sz="1800">
-                <a:solidFill>
-                  <a:srgbClr val="6D8C97"/>
-                </a:solidFill>
-                <a:latin typeface="Consolas"/>
-              </a:rPr>
-              <a:t>  21  </a:t>
-            </a:r>
-            <a:r>
-              <a:rPr sz="1800">
-                <a:solidFill>
-                  <a:srgbClr val="6D8C97"/>
-                </a:solidFill>
-                <a:latin typeface="Consolas"/>
-              </a:rPr>
-              <a:t> </a:t>
-            </a:r>
-          </a:p>
-          <a:p>
-            <a:pPr>
-              <a:spcAft>
-                <a:spcPts val="0"/>
-              </a:spcAft>
-            </a:pPr>
-            <a:r>
-              <a:rPr sz="1800">
-                <a:solidFill>
-                  <a:srgbClr val="6D8C97"/>
-                </a:solidFill>
-                <a:latin typeface="Consolas"/>
-              </a:rPr>
-              <a:t>  22  </a:t>
-            </a:r>
-            <a:r>
-              <a:rPr sz="1800">
-                <a:solidFill>
-                  <a:srgbClr val="6D8C97"/>
-                </a:solidFill>
-                <a:latin typeface="Consolas"/>
-              </a:rPr>
-              <a:t>// In PixelPad your loop() checked 'was a key pressed?' every frame. Here you</a:t>
-            </a:r>
-          </a:p>
-          <a:p>
-            <a:pPr>
-              <a:spcAft>
-                <a:spcPts val="0"/>
-              </a:spcAft>
-            </a:pPr>
-            <a:r>
-              <a:rPr sz="1800">
-                <a:solidFill>
-                  <a:srgbClr val="6D8C97"/>
-                </a:solidFill>
-                <a:latin typeface="Consolas"/>
-              </a:rPr>
-              <a:t>  23  </a:t>
-            </a:r>
-            <a:r>
-              <a:rPr sz="1800">
-                <a:solidFill>
-                  <a:srgbClr val="6D8C97"/>
-                </a:solidFill>
-                <a:latin typeface="Consolas"/>
-              </a:rPr>
-              <a:t>// leave a note: when this form is submitted, run this. The browser waits.</a:t>
-            </a:r>
-          </a:p>
-          <a:p>
-            <a:pPr>
-              <a:spcAft>
-                <a:spcPts val="0"/>
-              </a:spcAft>
-            </a:pPr>
-            <a:r>
-              <a:rPr sz="1800">
-                <a:solidFill>
-                  <a:srgbClr val="6D8C97"/>
-                </a:solidFill>
-                <a:latin typeface="Consolas"/>
-              </a:rPr>
-              <a:t>  24  </a:t>
-            </a:r>
-            <a:r>
-              <a:rPr sz="1800">
-                <a:solidFill>
-                  <a:srgbClr val="6D8C97"/>
-                </a:solidFill>
-                <a:latin typeface="Consolas"/>
-              </a:rPr>
-              <a:t>composer.addEventListener('submit', function (event) {</a:t>
-            </a:r>
-          </a:p>
-          <a:p>
-            <a:pPr>
-              <a:spcAft>
-                <a:spcPts val="0"/>
-              </a:spcAft>
-            </a:pPr>
-            <a:r>
-              <a:rPr sz="1800">
-                <a:solidFill>
-                  <a:srgbClr val="6D8C97"/>
-                </a:solidFill>
-                <a:latin typeface="Consolas"/>
-              </a:rPr>
-              <a:t>  25  </a:t>
-            </a:r>
-            <a:r>
-              <a:rPr sz="1800">
-                <a:solidFill>
-                  <a:srgbClr val="6D8C97"/>
-                </a:solidFill>
-                <a:latin typeface="Consolas"/>
-              </a:rPr>
-              <a:t>  event.preventDefault();          // stop the browser reloading the page</a:t>
-            </a:r>
-          </a:p>
-          <a:p>
-            <a:pPr>
-              <a:spcAft>
-                <a:spcPts val="0"/>
-              </a:spcAft>
-            </a:pPr>
-            <a:r>
-              <a:rPr sz="1800">
-                <a:solidFill>
-                  <a:srgbClr val="6D8C97"/>
-                </a:solidFill>
-                <a:latin typeface="Consolas"/>
-              </a:rPr>
-              <a:t>  26  </a:t>
-            </a:r>
-            <a:r>
-              <a:rPr sz="1800">
-                <a:solidFill>
-                  <a:srgbClr val="6D8C97"/>
-                </a:solidFill>
-                <a:latin typeface="Consolas"/>
-              </a:rPr>
-              <a:t>  const text = promptBox.value.trim();</a:t>
-            </a:r>
-          </a:p>
-          <a:p>
-            <a:pPr>
-              <a:spcAft>
-                <a:spcPts val="0"/>
-              </a:spcAft>
-            </a:pPr>
-            <a:r>
-              <a:rPr sz="1800">
-                <a:solidFill>
-                  <a:srgbClr val="6D8C97"/>
-                </a:solidFill>
-                <a:latin typeface="Consolas"/>
-              </a:rPr>
-              <a:t>  27  </a:t>
-            </a:r>
-            <a:r>
-              <a:rPr sz="1800">
-                <a:solidFill>
-                  <a:srgbClr val="6D8C97"/>
-                </a:solidFill>
-                <a:latin typeface="Consolas"/>
-              </a:rPr>
-              <a:t>  if (text === '') { return; }     // nothing typed, nothing to do</a:t>
-            </a:r>
-          </a:p>
-          <a:p>
-            <a:pPr>
-              <a:spcAft>
-                <a:spcPts val="0"/>
-              </a:spcAft>
-            </a:pPr>
-            <a:r>
-              <a:rPr sz="1800">
-                <a:solidFill>
-                  <a:srgbClr val="6D8C97"/>
-                </a:solidFill>
-                <a:latin typeface="Consolas"/>
-              </a:rPr>
-              <a:t>  28  </a:t>
-            </a:r>
-            <a:r>
-              <a:rPr sz="1800">
-                <a:solidFill>
-                  <a:srgbClr val="6D8C97"/>
-                </a:solidFill>
-                <a:latin typeface="Consolas"/>
-              </a:rPr>
-              <a:t>  promptBox.value = '';            // clear the box, ready for the next one</a:t>
-            </a:r>
-          </a:p>
-          <a:p>
-            <a:pPr>
-              <a:spcAft>
-                <a:spcPts val="0"/>
-              </a:spcAft>
-            </a:pPr>
-            <a:r>
-              <a:rPr sz="1800">
-                <a:solidFill>
-                  <a:srgbClr val="6D8C97"/>
-                </a:solidFill>
-                <a:latin typeface="Consolas"/>
-              </a:rPr>
-              <a:t>  29  </a:t>
-            </a:r>
-            <a:r>
-              <a:rPr sz="1800">
-                <a:solidFill>
-                  <a:srgbClr val="7FE0A0"/>
-                </a:solidFill>
-                <a:latin typeface="Consolas"/>
-              </a:rPr>
-              <a:t>  addLine('You', text);</a:t>
-            </a:r>
-          </a:p>
-        </p:txBody>
-      </p:sp>
-      <p:sp>
-        <p:nvSpPr>
-          <p:cNvPr id="4" name="TextBox 3"/>
-          <p:cNvSpPr txBox="1"/>
-          <p:nvPr/>
-        </p:nvSpPr>
-        <p:spPr>
-          <a:xfrm>
-            <a:off x="548640" y="5623560"/>
-            <a:ext cx="11064240" cy="1051560"/>
-          </a:xfrm>
-          <a:prstGeom prst="rect">
-            <a:avLst/>
-          </a:prstGeom>
-          <a:noFill/>
-        </p:spPr>
-        <p:txBody>
           <a:bodyPr wrap="square">
             <a:spAutoFit/>
           </a:bodyPr>
           <a:lstStyle/>
           <a:p>
-            <a:r>
-              <a:rPr sz="2000">
-                <a:solidFill>
-                  <a:srgbClr val="DCECEF"/>
-                </a:solidFill>
-              </a:rPr>
-              <a:t>Adds their message to the chat as 'You: ...'.</a:t>
-            </a:r>
-          </a:p>
-        </p:txBody>
-      </p:sp>
-    </p:spTree>
-  </p:cSld>
-  <p:clrMapOvr>
-    <a:masterClrMapping/>
-  </p:clrMapOvr>
-</p:sld>
-</file>
-
-<file path=ppt/slides/slide37.xml><?xml version="1.0" encoding="utf-8"?>
-<p:sld xmlns:a="http://schemas.openxmlformats.org/drawingml/2006/main" xmlns:p="http://schemas.openxmlformats.org/presentationml/2006/main" xmlns:r="http://schemas.openxmlformats.org/officeDocument/2006/relationships">
-  <p:cSld>
-    <p:bg>
-      <p:bgPr>
-        <a:solidFill>
-          <a:srgbClr val="102127"/>
-        </a:solidFill>
-        <a:effectLst/>
-      </p:bgPr>
-    </p:bg>
-    <p:spTree>
-      <p:nvGrpSpPr>
-        <p:cNvPr id="1" name=""/>
-        <p:cNvGrpSpPr/>
-        <p:nvPr/>
-      </p:nvGrpSpPr>
-      <p:grpSpPr/>
-      <p:sp>
-        <p:nvSpPr>
-          <p:cNvPr id="2" name="TextBox 1"/>
-          <p:cNvSpPr txBox="1"/>
-          <p:nvPr/>
-        </p:nvSpPr>
-        <p:spPr>
-          <a:xfrm>
-            <a:off x="502920" y="274320"/>
-            <a:ext cx="11155680" cy="548640"/>
-          </a:xfrm>
-          <a:prstGeom prst="rect">
-            <a:avLst/>
-          </a:prstGeom>
-          <a:noFill/>
-        </p:spPr>
-        <p:txBody>
-          <a:bodyPr wrap="none">
-            <a:spAutoFit/>
-          </a:bodyPr>
-          <a:lstStyle/>
-          <a:p>
-            <a:r>
-              <a:rPr sz="2200" b="1">
+            <a:pPr>
+              <a:spcAft>
+                <a:spcPts val="1400"/>
+              </a:spcAft>
+            </a:pPr>
+            <a:r>
+              <a:rPr sz="2800">
                 <a:solidFill>
                   <a:srgbClr val="01AEFD"/>
                 </a:solidFill>
               </a:rPr>
-              <a:t>Type this into script.js   -   line 30</a:t>
-            </a:r>
-          </a:p>
-        </p:txBody>
-      </p:sp>
-      <p:sp>
-        <p:nvSpPr>
-          <p:cNvPr id="3" name="TextBox 2"/>
-          <p:cNvSpPr txBox="1"/>
-          <p:nvPr/>
-        </p:nvSpPr>
-        <p:spPr>
-          <a:xfrm>
-            <a:off x="502920" y="960120"/>
-            <a:ext cx="11155680" cy="4297680"/>
-          </a:xfrm>
-          <a:prstGeom prst="rect">
-            <a:avLst/>
-          </a:prstGeom>
-          <a:noFill/>
-        </p:spPr>
-        <p:txBody>
-          <a:bodyPr wrap="none">
-            <a:spAutoFit/>
-          </a:bodyPr>
-          <a:lstStyle/>
-          <a:p>
-            <a:pPr>
-              <a:spcAft>
-                <a:spcPts val="0"/>
-              </a:spcAft>
-            </a:pPr>
-            <a:r>
-              <a:rPr sz="1800">
-                <a:solidFill>
-                  <a:srgbClr val="6D8C97"/>
-                </a:solidFill>
-                <a:latin typeface="Consolas"/>
-              </a:rPr>
-              <a:t>  21  </a:t>
-            </a:r>
-            <a:r>
-              <a:rPr sz="1800">
-                <a:solidFill>
-                  <a:srgbClr val="6D8C97"/>
-                </a:solidFill>
-                <a:latin typeface="Consolas"/>
-              </a:rPr>
-              <a:t> </a:t>
-            </a:r>
-          </a:p>
-          <a:p>
-            <a:pPr>
-              <a:spcAft>
-                <a:spcPts val="0"/>
-              </a:spcAft>
-            </a:pPr>
-            <a:r>
-              <a:rPr sz="1800">
-                <a:solidFill>
-                  <a:srgbClr val="6D8C97"/>
-                </a:solidFill>
-                <a:latin typeface="Consolas"/>
-              </a:rPr>
-              <a:t>  22  </a:t>
-            </a:r>
-            <a:r>
-              <a:rPr sz="1800">
-                <a:solidFill>
-                  <a:srgbClr val="6D8C97"/>
-                </a:solidFill>
-                <a:latin typeface="Consolas"/>
-              </a:rPr>
-              <a:t>// In PixelPad your loop() checked 'was a key pressed?' every frame. Here you</a:t>
-            </a:r>
-          </a:p>
-          <a:p>
-            <a:pPr>
-              <a:spcAft>
-                <a:spcPts val="0"/>
-              </a:spcAft>
-            </a:pPr>
-            <a:r>
-              <a:rPr sz="1800">
-                <a:solidFill>
-                  <a:srgbClr val="6D8C97"/>
-                </a:solidFill>
-                <a:latin typeface="Consolas"/>
-              </a:rPr>
-              <a:t>  23  </a:t>
-            </a:r>
-            <a:r>
-              <a:rPr sz="1800">
-                <a:solidFill>
-                  <a:srgbClr val="6D8C97"/>
-                </a:solidFill>
-                <a:latin typeface="Consolas"/>
-              </a:rPr>
-              <a:t>// leave a note: when this form is submitted, run this. The browser waits.</a:t>
-            </a:r>
-          </a:p>
-          <a:p>
-            <a:pPr>
-              <a:spcAft>
-                <a:spcPts val="0"/>
-              </a:spcAft>
-            </a:pPr>
-            <a:r>
-              <a:rPr sz="1800">
-                <a:solidFill>
-                  <a:srgbClr val="6D8C97"/>
-                </a:solidFill>
-                <a:latin typeface="Consolas"/>
-              </a:rPr>
-              <a:t>  24  </a:t>
-            </a:r>
-            <a:r>
-              <a:rPr sz="1800">
-                <a:solidFill>
-                  <a:srgbClr val="6D8C97"/>
-                </a:solidFill>
-                <a:latin typeface="Consolas"/>
-              </a:rPr>
-              <a:t>composer.addEventListener('submit', function (event) {</a:t>
-            </a:r>
-          </a:p>
-          <a:p>
-            <a:pPr>
-              <a:spcAft>
-                <a:spcPts val="0"/>
-              </a:spcAft>
-            </a:pPr>
-            <a:r>
-              <a:rPr sz="1800">
-                <a:solidFill>
-                  <a:srgbClr val="6D8C97"/>
-                </a:solidFill>
-                <a:latin typeface="Consolas"/>
-              </a:rPr>
-              <a:t>  25  </a:t>
-            </a:r>
-            <a:r>
-              <a:rPr sz="1800">
-                <a:solidFill>
-                  <a:srgbClr val="6D8C97"/>
-                </a:solidFill>
-                <a:latin typeface="Consolas"/>
-              </a:rPr>
-              <a:t>  event.preventDefault();          // stop the browser reloading the page</a:t>
-            </a:r>
-          </a:p>
-          <a:p>
-            <a:pPr>
-              <a:spcAft>
-                <a:spcPts val="0"/>
-              </a:spcAft>
-            </a:pPr>
-            <a:r>
-              <a:rPr sz="1800">
-                <a:solidFill>
-                  <a:srgbClr val="6D8C97"/>
-                </a:solidFill>
-                <a:latin typeface="Consolas"/>
-              </a:rPr>
-              <a:t>  26  </a:t>
-            </a:r>
-            <a:r>
-              <a:rPr sz="1800">
-                <a:solidFill>
-                  <a:srgbClr val="6D8C97"/>
-                </a:solidFill>
-                <a:latin typeface="Consolas"/>
-              </a:rPr>
-              <a:t>  const text = promptBox.value.trim();</a:t>
-            </a:r>
-          </a:p>
-          <a:p>
-            <a:pPr>
-              <a:spcAft>
-                <a:spcPts val="0"/>
-              </a:spcAft>
-            </a:pPr>
-            <a:r>
-              <a:rPr sz="1800">
-                <a:solidFill>
-                  <a:srgbClr val="6D8C97"/>
-                </a:solidFill>
-                <a:latin typeface="Consolas"/>
-              </a:rPr>
-              <a:t>  27  </a:t>
-            </a:r>
-            <a:r>
-              <a:rPr sz="1800">
-                <a:solidFill>
-                  <a:srgbClr val="6D8C97"/>
-                </a:solidFill>
-                <a:latin typeface="Consolas"/>
-              </a:rPr>
-              <a:t>  if (text === '') { return; }     // nothing typed, nothing to do</a:t>
-            </a:r>
-          </a:p>
-          <a:p>
-            <a:pPr>
-              <a:spcAft>
-                <a:spcPts val="0"/>
-              </a:spcAft>
-            </a:pPr>
-            <a:r>
-              <a:rPr sz="1800">
-                <a:solidFill>
-                  <a:srgbClr val="6D8C97"/>
-                </a:solidFill>
-                <a:latin typeface="Consolas"/>
-              </a:rPr>
-              <a:t>  28  </a:t>
-            </a:r>
-            <a:r>
-              <a:rPr sz="1800">
-                <a:solidFill>
-                  <a:srgbClr val="6D8C97"/>
-                </a:solidFill>
-                <a:latin typeface="Consolas"/>
-              </a:rPr>
-              <a:t>  promptBox.value = '';            // clear the box, ready for the next one</a:t>
-            </a:r>
-          </a:p>
-          <a:p>
-            <a:pPr>
-              <a:spcAft>
-                <a:spcPts val="0"/>
-              </a:spcAft>
-            </a:pPr>
-            <a:r>
-              <a:rPr sz="1800">
-                <a:solidFill>
-                  <a:srgbClr val="6D8C97"/>
-                </a:solidFill>
-                <a:latin typeface="Consolas"/>
-              </a:rPr>
-              <a:t>  29  </a:t>
-            </a:r>
-            <a:r>
-              <a:rPr sz="1800">
-                <a:solidFill>
-                  <a:srgbClr val="6D8C97"/>
-                </a:solidFill>
-                <a:latin typeface="Consolas"/>
-              </a:rPr>
-              <a:t>  addLine('You', text);</a:t>
-            </a:r>
-          </a:p>
-          <a:p>
-            <a:pPr>
-              <a:spcAft>
-                <a:spcPts val="0"/>
-              </a:spcAft>
-            </a:pPr>
-            <a:r>
-              <a:rPr sz="1800">
-                <a:solidFill>
-                  <a:srgbClr val="6D8C97"/>
-                </a:solidFill>
-                <a:latin typeface="Consolas"/>
-              </a:rPr>
-              <a:t>  30  </a:t>
-            </a:r>
-            <a:r>
-              <a:rPr sz="1800">
-                <a:solidFill>
-                  <a:srgbClr val="7FE0A0"/>
-                </a:solidFill>
-                <a:latin typeface="Consolas"/>
-              </a:rPr>
-              <a:t>  addLine('Companion', 'You said: ' + text);   // a pretend answer, for now</a:t>
-            </a:r>
-          </a:p>
-        </p:txBody>
-      </p:sp>
-      <p:sp>
-        <p:nvSpPr>
-          <p:cNvPr id="4" name="TextBox 3"/>
-          <p:cNvSpPr txBox="1"/>
-          <p:nvPr/>
-        </p:nvSpPr>
-        <p:spPr>
-          <a:xfrm>
-            <a:off x="548640" y="5623560"/>
-            <a:ext cx="11064240" cy="1051560"/>
-          </a:xfrm>
-          <a:prstGeom prst="rect">
-            <a:avLst/>
-          </a:prstGeom>
-          <a:noFill/>
-        </p:spPr>
-        <p:txBody>
-          <a:bodyPr wrap="square">
-            <a:spAutoFit/>
-          </a:bodyPr>
-          <a:lstStyle/>
-          <a:p>
-            <a:r>
-              <a:rPr sz="2000">
-                <a:solidFill>
-                  <a:srgbClr val="DCECEF"/>
-                </a:solidFill>
-              </a:rPr>
-              <a:t>Adds a pretend reply for now - week 4 makes it real.</a:t>
-            </a:r>
-          </a:p>
-        </p:txBody>
-      </p:sp>
-    </p:spTree>
-  </p:cSld>
-  <p:clrMapOvr>
-    <a:masterClrMapping/>
-  </p:clrMapOvr>
-</p:sld>
-</file>
-
-<file path=ppt/slides/slide38.xml><?xml version="1.0" encoding="utf-8"?>
-<p:sld xmlns:a="http://schemas.openxmlformats.org/drawingml/2006/main" xmlns:p="http://schemas.openxmlformats.org/presentationml/2006/main" xmlns:r="http://schemas.openxmlformats.org/officeDocument/2006/relationships">
-  <p:cSld>
-    <p:bg>
-      <p:bgPr>
-        <a:solidFill>
-          <a:srgbClr val="102127"/>
-        </a:solidFill>
-        <a:effectLst/>
-      </p:bgPr>
-    </p:bg>
-    <p:spTree>
-      <p:nvGrpSpPr>
-        <p:cNvPr id="1" name=""/>
-        <p:cNvGrpSpPr/>
-        <p:nvPr/>
-      </p:nvGrpSpPr>
-      <p:grpSpPr/>
-      <p:sp>
-        <p:nvSpPr>
-          <p:cNvPr id="2" name="TextBox 1"/>
-          <p:cNvSpPr txBox="1"/>
-          <p:nvPr/>
-        </p:nvSpPr>
-        <p:spPr>
-          <a:xfrm>
-            <a:off x="502920" y="274320"/>
-            <a:ext cx="11155680" cy="548640"/>
-          </a:xfrm>
-          <a:prstGeom prst="rect">
-            <a:avLst/>
-          </a:prstGeom>
-          <a:noFill/>
-        </p:spPr>
-        <p:txBody>
-          <a:bodyPr wrap="none">
-            <a:spAutoFit/>
-          </a:bodyPr>
-          <a:lstStyle/>
-          <a:p>
-            <a:r>
-              <a:rPr sz="2200" b="1">
-                <a:solidFill>
-                  <a:srgbClr val="01AEFD"/>
-                </a:solidFill>
-              </a:rPr>
-              <a:t>Type this into script.js   -   line 31</a:t>
-            </a:r>
-          </a:p>
-        </p:txBody>
-      </p:sp>
-      <p:sp>
-        <p:nvSpPr>
-          <p:cNvPr id="3" name="TextBox 2"/>
-          <p:cNvSpPr txBox="1"/>
-          <p:nvPr/>
-        </p:nvSpPr>
-        <p:spPr>
-          <a:xfrm>
-            <a:off x="502920" y="960120"/>
-            <a:ext cx="11155680" cy="4297680"/>
-          </a:xfrm>
-          <a:prstGeom prst="rect">
-            <a:avLst/>
-          </a:prstGeom>
-          <a:noFill/>
-        </p:spPr>
-        <p:txBody>
-          <a:bodyPr wrap="none">
-            <a:spAutoFit/>
-          </a:bodyPr>
-          <a:lstStyle/>
-          <a:p>
-            <a:pPr>
-              <a:spcAft>
-                <a:spcPts val="0"/>
-              </a:spcAft>
-            </a:pPr>
-            <a:r>
-              <a:rPr sz="1300">
-                <a:solidFill>
-                  <a:srgbClr val="6D8C97"/>
-                </a:solidFill>
-                <a:latin typeface="Consolas"/>
-              </a:rPr>
-              <a:t>  21  </a:t>
-            </a:r>
-            <a:r>
-              <a:rPr sz="1300">
-                <a:solidFill>
-                  <a:srgbClr val="6D8C97"/>
-                </a:solidFill>
-                <a:latin typeface="Consolas"/>
-              </a:rPr>
-              <a:t> </a:t>
-            </a:r>
-          </a:p>
-          <a:p>
-            <a:pPr>
-              <a:spcAft>
-                <a:spcPts val="0"/>
-              </a:spcAft>
-            </a:pPr>
-            <a:r>
-              <a:rPr sz="1300">
-                <a:solidFill>
-                  <a:srgbClr val="6D8C97"/>
-                </a:solidFill>
-                <a:latin typeface="Consolas"/>
-              </a:rPr>
-              <a:t>  22  </a:t>
-            </a:r>
-            <a:r>
-              <a:rPr sz="1300">
-                <a:solidFill>
-                  <a:srgbClr val="6D8C97"/>
-                </a:solidFill>
-                <a:latin typeface="Consolas"/>
-              </a:rPr>
-              <a:t>// In PixelPad your loop() checked 'was a key pressed?' every frame. Here you</a:t>
-            </a:r>
-          </a:p>
-          <a:p>
-            <a:pPr>
-              <a:spcAft>
-                <a:spcPts val="0"/>
-              </a:spcAft>
-            </a:pPr>
-            <a:r>
-              <a:rPr sz="1300">
-                <a:solidFill>
-                  <a:srgbClr val="6D8C97"/>
-                </a:solidFill>
-                <a:latin typeface="Consolas"/>
-              </a:rPr>
-              <a:t>  23  </a:t>
-            </a:r>
-            <a:r>
-              <a:rPr sz="1300">
-                <a:solidFill>
-                  <a:srgbClr val="6D8C97"/>
-                </a:solidFill>
-                <a:latin typeface="Consolas"/>
-              </a:rPr>
-              <a:t>// leave a note: when this form is submitted, run this. The browser waits.</a:t>
-            </a:r>
-          </a:p>
-          <a:p>
-            <a:pPr>
-              <a:spcAft>
-                <a:spcPts val="0"/>
-              </a:spcAft>
-            </a:pPr>
-            <a:r>
-              <a:rPr sz="1300">
-                <a:solidFill>
-                  <a:srgbClr val="6D8C97"/>
-                </a:solidFill>
-                <a:latin typeface="Consolas"/>
-              </a:rPr>
-              <a:t>  24  </a:t>
-            </a:r>
-            <a:r>
-              <a:rPr sz="1300">
-                <a:solidFill>
-                  <a:srgbClr val="6D8C97"/>
-                </a:solidFill>
-                <a:latin typeface="Consolas"/>
-              </a:rPr>
-              <a:t>composer.addEventListener('submit', function (event) {</a:t>
-            </a:r>
-          </a:p>
-          <a:p>
-            <a:pPr>
-              <a:spcAft>
-                <a:spcPts val="0"/>
-              </a:spcAft>
-            </a:pPr>
-            <a:r>
-              <a:rPr sz="1300">
-                <a:solidFill>
-                  <a:srgbClr val="6D8C97"/>
-                </a:solidFill>
-                <a:latin typeface="Consolas"/>
-              </a:rPr>
-              <a:t>  25  </a:t>
-            </a:r>
-            <a:r>
-              <a:rPr sz="1300">
-                <a:solidFill>
-                  <a:srgbClr val="6D8C97"/>
-                </a:solidFill>
-                <a:latin typeface="Consolas"/>
-              </a:rPr>
-              <a:t>  event.preventDefault();          // stop the browser reloading the page</a:t>
-            </a:r>
-          </a:p>
-          <a:p>
-            <a:pPr>
-              <a:spcAft>
-                <a:spcPts val="0"/>
-              </a:spcAft>
-            </a:pPr>
-            <a:r>
-              <a:rPr sz="1300">
-                <a:solidFill>
-                  <a:srgbClr val="6D8C97"/>
-                </a:solidFill>
-                <a:latin typeface="Consolas"/>
-              </a:rPr>
-              <a:t>  26  </a:t>
-            </a:r>
-            <a:r>
-              <a:rPr sz="1300">
-                <a:solidFill>
-                  <a:srgbClr val="6D8C97"/>
-                </a:solidFill>
-                <a:latin typeface="Consolas"/>
-              </a:rPr>
-              <a:t>  const text = promptBox.value.trim();</a:t>
-            </a:r>
-          </a:p>
-          <a:p>
-            <a:pPr>
-              <a:spcAft>
-                <a:spcPts val="0"/>
-              </a:spcAft>
-            </a:pPr>
-            <a:r>
-              <a:rPr sz="1300">
-                <a:solidFill>
-                  <a:srgbClr val="6D8C97"/>
-                </a:solidFill>
-                <a:latin typeface="Consolas"/>
-              </a:rPr>
-              <a:t>  27  </a:t>
-            </a:r>
-            <a:r>
-              <a:rPr sz="1300">
-                <a:solidFill>
-                  <a:srgbClr val="6D8C97"/>
-                </a:solidFill>
-                <a:latin typeface="Consolas"/>
-              </a:rPr>
-              <a:t>  if (text === '') { return; }     // nothing typed, nothing to do</a:t>
-            </a:r>
-          </a:p>
-          <a:p>
-            <a:pPr>
-              <a:spcAft>
-                <a:spcPts val="0"/>
-              </a:spcAft>
-            </a:pPr>
-            <a:r>
-              <a:rPr sz="1300">
-                <a:solidFill>
-                  <a:srgbClr val="6D8C97"/>
-                </a:solidFill>
-                <a:latin typeface="Consolas"/>
-              </a:rPr>
-              <a:t>  28  </a:t>
-            </a:r>
-            <a:r>
-              <a:rPr sz="1300">
-                <a:solidFill>
-                  <a:srgbClr val="6D8C97"/>
-                </a:solidFill>
-                <a:latin typeface="Consolas"/>
-              </a:rPr>
-              <a:t>  promptBox.value = '';            // clear the box, ready for the next one</a:t>
-            </a:r>
-          </a:p>
-          <a:p>
-            <a:pPr>
-              <a:spcAft>
-                <a:spcPts val="0"/>
-              </a:spcAft>
-            </a:pPr>
-            <a:r>
-              <a:rPr sz="1300">
-                <a:solidFill>
-                  <a:srgbClr val="6D8C97"/>
-                </a:solidFill>
-                <a:latin typeface="Consolas"/>
-              </a:rPr>
-              <a:t>  29  </a:t>
-            </a:r>
-            <a:r>
-              <a:rPr sz="1300">
-                <a:solidFill>
-                  <a:srgbClr val="6D8C97"/>
-                </a:solidFill>
-                <a:latin typeface="Consolas"/>
-              </a:rPr>
-              <a:t>  addLine('You', text);</a:t>
-            </a:r>
-          </a:p>
-          <a:p>
-            <a:pPr>
-              <a:spcAft>
-                <a:spcPts val="0"/>
-              </a:spcAft>
-            </a:pPr>
-            <a:r>
-              <a:rPr sz="1300">
-                <a:solidFill>
-                  <a:srgbClr val="6D8C97"/>
-                </a:solidFill>
-                <a:latin typeface="Consolas"/>
-              </a:rPr>
-              <a:t>  30  </a:t>
-            </a:r>
-            <a:r>
-              <a:rPr sz="1300">
-                <a:solidFill>
-                  <a:srgbClr val="6D8C97"/>
-                </a:solidFill>
-                <a:latin typeface="Consolas"/>
-              </a:rPr>
-              <a:t>  addLine('Companion', 'You said: ' + text);   // a pretend answer, for now</a:t>
-            </a:r>
-          </a:p>
-          <a:p>
-            <a:pPr>
-              <a:spcAft>
-                <a:spcPts val="0"/>
-              </a:spcAft>
-            </a:pPr>
-            <a:r>
-              <a:rPr sz="1300">
-                <a:solidFill>
-                  <a:srgbClr val="6D8C97"/>
-                </a:solidFill>
-                <a:latin typeface="Consolas"/>
-              </a:rPr>
-              <a:t>  31  </a:t>
-            </a:r>
-            <a:r>
-              <a:rPr sz="1300">
-                <a:solidFill>
-                  <a:srgbClr val="7FE0A0"/>
-                </a:solidFill>
-                <a:latin typeface="Consolas"/>
-              </a:rPr>
-              <a:t>});</a:t>
-            </a:r>
-          </a:p>
-        </p:txBody>
-      </p:sp>
-      <p:sp>
-        <p:nvSpPr>
-          <p:cNvPr id="4" name="TextBox 3"/>
-          <p:cNvSpPr txBox="1"/>
-          <p:nvPr/>
-        </p:nvSpPr>
-        <p:spPr>
-          <a:xfrm>
-            <a:off x="548640" y="5623560"/>
-            <a:ext cx="11064240" cy="1051560"/>
-          </a:xfrm>
-          <a:prstGeom prst="rect">
-            <a:avLst/>
-          </a:prstGeom>
-          <a:noFill/>
-        </p:spPr>
-        <p:txBody>
-          <a:bodyPr wrap="square">
-            <a:spAutoFit/>
-          </a:bodyPr>
-          <a:lstStyle/>
-          <a:p>
-            <a:r>
-              <a:rPr sz="2000">
-                <a:solidFill>
-                  <a:srgbClr val="DCECEF"/>
-                </a:solidFill>
-              </a:rPr>
-              <a:t>Closes the listener. Type in the box and press Enter to test it.</a:t>
-            </a:r>
-          </a:p>
-        </p:txBody>
-      </p:sp>
-    </p:spTree>
-  </p:cSld>
-  <p:clrMapOvr>
-    <a:masterClrMapping/>
-  </p:clrMapOvr>
-</p:sld>
-</file>
-
-<file path=ppt/slides/slide39.xml><?xml version="1.0" encoding="utf-8"?>
-<p:sld xmlns:a="http://schemas.openxmlformats.org/drawingml/2006/main" xmlns:p="http://schemas.openxmlformats.org/presentationml/2006/main" xmlns:r="http://schemas.openxmlformats.org/officeDocument/2006/relationships">
-  <p:cSld>
-    <p:bg>
-      <p:bgPr>
-        <a:solidFill>
-          <a:srgbClr val="102127"/>
-        </a:solidFill>
-        <a:effectLst/>
-      </p:bgPr>
-    </p:bg>
-    <p:spTree>
-      <p:nvGrpSpPr>
-        <p:cNvPr id="1" name=""/>
-        <p:cNvGrpSpPr/>
-        <p:nvPr/>
-      </p:nvGrpSpPr>
-      <p:grpSpPr/>
-      <p:sp>
-        <p:nvSpPr>
-          <p:cNvPr id="2" name="TextBox 1"/>
-          <p:cNvSpPr txBox="1"/>
-          <p:nvPr/>
-        </p:nvSpPr>
-        <p:spPr>
-          <a:xfrm>
-            <a:off x="502920" y="274320"/>
-            <a:ext cx="11155680" cy="548640"/>
-          </a:xfrm>
-          <a:prstGeom prst="rect">
-            <a:avLst/>
-          </a:prstGeom>
-          <a:noFill/>
-        </p:spPr>
-        <p:txBody>
-          <a:bodyPr wrap="none">
-            <a:spAutoFit/>
-          </a:bodyPr>
-          <a:lstStyle/>
-          <a:p>
-            <a:r>
-              <a:rPr sz="2200" b="1">
-                <a:solidFill>
-                  <a:srgbClr val="01AEFD"/>
-                </a:solidFill>
-              </a:rPr>
-              <a:t>All together in script.js</a:t>
-            </a:r>
-          </a:p>
-        </p:txBody>
-      </p:sp>
-      <p:sp>
-        <p:nvSpPr>
-          <p:cNvPr id="3" name="TextBox 2"/>
-          <p:cNvSpPr txBox="1"/>
-          <p:nvPr/>
-        </p:nvSpPr>
-        <p:spPr>
-          <a:xfrm>
-            <a:off x="502920" y="960120"/>
-            <a:ext cx="11155680" cy="4297680"/>
-          </a:xfrm>
-          <a:prstGeom prst="rect">
-            <a:avLst/>
-          </a:prstGeom>
-          <a:noFill/>
-        </p:spPr>
-        <p:txBody>
-          <a:bodyPr wrap="none">
-            <a:spAutoFit/>
-          </a:bodyPr>
-          <a:lstStyle/>
-          <a:p>
-            <a:pPr>
-              <a:spcAft>
-                <a:spcPts val="0"/>
-              </a:spcAft>
-            </a:pPr>
-            <a:r>
-              <a:rPr sz="1300">
-                <a:solidFill>
-                  <a:srgbClr val="6D8C97"/>
-                </a:solidFill>
-                <a:latin typeface="Consolas"/>
-              </a:rPr>
-              <a:t>  21  </a:t>
-            </a:r>
-            <a:r>
-              <a:rPr sz="1300">
-                <a:solidFill>
-                  <a:srgbClr val="7FE0A0"/>
-                </a:solidFill>
-                <a:latin typeface="Consolas"/>
-              </a:rPr>
-              <a:t> </a:t>
-            </a:r>
-          </a:p>
-          <a:p>
-            <a:pPr>
-              <a:spcAft>
-                <a:spcPts val="0"/>
-              </a:spcAft>
-            </a:pPr>
-            <a:r>
-              <a:rPr sz="1300">
-                <a:solidFill>
-                  <a:srgbClr val="6D8C97"/>
-                </a:solidFill>
-                <a:latin typeface="Consolas"/>
-              </a:rPr>
-              <a:t>  22  </a:t>
-            </a:r>
-            <a:r>
-              <a:rPr sz="1300">
-                <a:solidFill>
-                  <a:srgbClr val="7FE0A0"/>
-                </a:solidFill>
-                <a:latin typeface="Consolas"/>
-              </a:rPr>
-              <a:t>// In PixelPad your loop() checked 'was a key pressed?' every frame. Here you</a:t>
-            </a:r>
-          </a:p>
-          <a:p>
-            <a:pPr>
-              <a:spcAft>
-                <a:spcPts val="0"/>
-              </a:spcAft>
-            </a:pPr>
-            <a:r>
-              <a:rPr sz="1300">
-                <a:solidFill>
-                  <a:srgbClr val="6D8C97"/>
-                </a:solidFill>
-                <a:latin typeface="Consolas"/>
-              </a:rPr>
-              <a:t>  23  </a:t>
-            </a:r>
-            <a:r>
-              <a:rPr sz="1300">
-                <a:solidFill>
-                  <a:srgbClr val="7FE0A0"/>
-                </a:solidFill>
-                <a:latin typeface="Consolas"/>
-              </a:rPr>
-              <a:t>// leave a note: when this form is submitted, run this. The browser waits.</a:t>
-            </a:r>
-          </a:p>
-          <a:p>
-            <a:pPr>
-              <a:spcAft>
-                <a:spcPts val="0"/>
-              </a:spcAft>
-            </a:pPr>
-            <a:r>
-              <a:rPr sz="1300">
-                <a:solidFill>
-                  <a:srgbClr val="6D8C97"/>
-                </a:solidFill>
-                <a:latin typeface="Consolas"/>
-              </a:rPr>
-              <a:t>  24  </a:t>
-            </a:r>
-            <a:r>
-              <a:rPr sz="1300">
-                <a:solidFill>
-                  <a:srgbClr val="7FE0A0"/>
-                </a:solidFill>
-                <a:latin typeface="Consolas"/>
-              </a:rPr>
-              <a:t>composer.addEventListener('submit', function (event) {</a:t>
-            </a:r>
-          </a:p>
-          <a:p>
-            <a:pPr>
-              <a:spcAft>
-                <a:spcPts val="0"/>
-              </a:spcAft>
-            </a:pPr>
-            <a:r>
-              <a:rPr sz="1300">
-                <a:solidFill>
-                  <a:srgbClr val="6D8C97"/>
-                </a:solidFill>
-                <a:latin typeface="Consolas"/>
-              </a:rPr>
-              <a:t>  25  </a:t>
-            </a:r>
-            <a:r>
-              <a:rPr sz="1300">
-                <a:solidFill>
-                  <a:srgbClr val="7FE0A0"/>
-                </a:solidFill>
-                <a:latin typeface="Consolas"/>
-              </a:rPr>
-              <a:t>  event.preventDefault();          // stop the browser reloading the page</a:t>
-            </a:r>
-          </a:p>
-          <a:p>
-            <a:pPr>
-              <a:spcAft>
-                <a:spcPts val="0"/>
-              </a:spcAft>
-            </a:pPr>
-            <a:r>
-              <a:rPr sz="1300">
-                <a:solidFill>
-                  <a:srgbClr val="6D8C97"/>
-                </a:solidFill>
-                <a:latin typeface="Consolas"/>
-              </a:rPr>
-              <a:t>  26  </a:t>
-            </a:r>
-            <a:r>
-              <a:rPr sz="1300">
-                <a:solidFill>
-                  <a:srgbClr val="7FE0A0"/>
-                </a:solidFill>
-                <a:latin typeface="Consolas"/>
-              </a:rPr>
-              <a:t>  const text = promptBox.value.trim();</a:t>
-            </a:r>
-          </a:p>
-          <a:p>
-            <a:pPr>
-              <a:spcAft>
-                <a:spcPts val="0"/>
-              </a:spcAft>
-            </a:pPr>
-            <a:r>
-              <a:rPr sz="1300">
-                <a:solidFill>
-                  <a:srgbClr val="6D8C97"/>
-                </a:solidFill>
-                <a:latin typeface="Consolas"/>
-              </a:rPr>
-              <a:t>  27  </a:t>
-            </a:r>
-            <a:r>
-              <a:rPr sz="1300">
-                <a:solidFill>
-                  <a:srgbClr val="7FE0A0"/>
-                </a:solidFill>
-                <a:latin typeface="Consolas"/>
-              </a:rPr>
-              <a:t>  if (text === '') { return; }     // nothing typed, nothing to do</a:t>
-            </a:r>
-          </a:p>
-          <a:p>
-            <a:pPr>
-              <a:spcAft>
-                <a:spcPts val="0"/>
-              </a:spcAft>
-            </a:pPr>
-            <a:r>
-              <a:rPr sz="1300">
-                <a:solidFill>
-                  <a:srgbClr val="6D8C97"/>
-                </a:solidFill>
-                <a:latin typeface="Consolas"/>
-              </a:rPr>
-              <a:t>  28  </a:t>
-            </a:r>
-            <a:r>
-              <a:rPr sz="1300">
-                <a:solidFill>
-                  <a:srgbClr val="7FE0A0"/>
-                </a:solidFill>
-                <a:latin typeface="Consolas"/>
-              </a:rPr>
-              <a:t>  promptBox.value = '';            // clear the box, ready for the next one</a:t>
-            </a:r>
-          </a:p>
-          <a:p>
-            <a:pPr>
-              <a:spcAft>
-                <a:spcPts val="0"/>
-              </a:spcAft>
-            </a:pPr>
-            <a:r>
-              <a:rPr sz="1300">
-                <a:solidFill>
-                  <a:srgbClr val="6D8C97"/>
-                </a:solidFill>
-                <a:latin typeface="Consolas"/>
-              </a:rPr>
-              <a:t>  29  </a:t>
-            </a:r>
-            <a:r>
-              <a:rPr sz="1300">
-                <a:solidFill>
-                  <a:srgbClr val="7FE0A0"/>
-                </a:solidFill>
-                <a:latin typeface="Consolas"/>
-              </a:rPr>
-              <a:t>  addLine('You', text);</a:t>
-            </a:r>
-          </a:p>
-          <a:p>
-            <a:pPr>
-              <a:spcAft>
-                <a:spcPts val="0"/>
-              </a:spcAft>
-            </a:pPr>
-            <a:r>
-              <a:rPr sz="1300">
-                <a:solidFill>
-                  <a:srgbClr val="6D8C97"/>
-                </a:solidFill>
-                <a:latin typeface="Consolas"/>
-              </a:rPr>
-              <a:t>  30  </a:t>
-            </a:r>
-            <a:r>
-              <a:rPr sz="1300">
-                <a:solidFill>
-                  <a:srgbClr val="7FE0A0"/>
-                </a:solidFill>
-                <a:latin typeface="Consolas"/>
-              </a:rPr>
-              <a:t>  addLine('Companion', 'You said: ' + text);   // a pretend answer, for now</a:t>
-            </a:r>
-          </a:p>
-          <a:p>
-            <a:pPr>
-              <a:spcAft>
-                <a:spcPts val="0"/>
-              </a:spcAft>
-            </a:pPr>
-            <a:r>
-              <a:rPr sz="1300">
-                <a:solidFill>
-                  <a:srgbClr val="6D8C97"/>
-                </a:solidFill>
-                <a:latin typeface="Consolas"/>
-              </a:rPr>
-              <a:t>  31  </a:t>
-            </a:r>
-            <a:r>
-              <a:rPr sz="1300">
-                <a:solidFill>
-                  <a:srgbClr val="7FE0A0"/>
-                </a:solidFill>
-                <a:latin typeface="Consolas"/>
-              </a:rPr>
-              <a:t>});</a:t>
-            </a:r>
-          </a:p>
-        </p:txBody>
-      </p:sp>
-      <p:sp>
-        <p:nvSpPr>
-          <p:cNvPr id="4" name="TextBox 3"/>
-          <p:cNvSpPr txBox="1"/>
-          <p:nvPr/>
-        </p:nvSpPr>
-        <p:spPr>
-          <a:xfrm>
-            <a:off x="548640" y="5623560"/>
-            <a:ext cx="11064240" cy="1051560"/>
-          </a:xfrm>
-          <a:prstGeom prst="rect">
-            <a:avLst/>
-          </a:prstGeom>
-          <a:noFill/>
-        </p:spPr>
-        <p:txBody>
-          <a:bodyPr wrap="square">
-            <a:spAutoFit/>
-          </a:bodyPr>
-          <a:lstStyle/>
-          <a:p>
-            <a:r>
-              <a:rPr sz="2000">
-                <a:solidFill>
-                  <a:srgbClr val="DCECEF"/>
-                </a:solidFill>
-              </a:rPr>
-              <a:t>That is the whole piece. Check yours looks the same before moving on.</a:t>
+              <a:t>Get the echo working</a:t>
+            </a:r>
+          </a:p>
+          <a:p>
+            <a:pPr>
+              <a:spcAft>
+                <a:spcPts val="1400"/>
+              </a:spcAft>
+            </a:pPr>
+            <a:r>
+              <a:rPr sz="2400">
+                <a:solidFill>
+                  <a:srgbClr val="1F2A37"/>
+                </a:solidFill>
+              </a:rPr>
+              <a:t>• Type a message</a:t>
+            </a:r>
+          </a:p>
+          <a:p>
+            <a:pPr>
+              <a:spcAft>
+                <a:spcPts val="1400"/>
+              </a:spcAft>
+            </a:pPr>
+            <a:r>
+              <a:rPr sz="2400">
+                <a:solidFill>
+                  <a:srgbClr val="1F2A37"/>
+                </a:solidFill>
+              </a:rPr>
+              <a:t>• Press Send</a:t>
+            </a:r>
+          </a:p>
+          <a:p>
+            <a:pPr>
+              <a:spcAft>
+                <a:spcPts val="1400"/>
+              </a:spcAft>
+            </a:pPr>
+            <a:r>
+              <a:rPr sz="2400">
+                <a:solidFill>
+                  <a:srgbClr val="1F2A37"/>
+                </a:solidFill>
+              </a:rPr>
+              <a:t>• See it appear twice</a:t>
             </a:r>
           </a:p>
         </p:txBody>
@@ -9812,133 +8800,6 @@
                 </a:solidFill>
               </a:rPr>
               <a:t>A comment: this week we grab the boxes we built in week 1 so the code can use them.</a:t>
-            </a:r>
-          </a:p>
-        </p:txBody>
-      </p:sp>
-    </p:spTree>
-  </p:cSld>
-  <p:clrMapOvr>
-    <a:masterClrMapping/>
-  </p:clrMapOvr>
-</p:sld>
-</file>
-
-<file path=ppt/slides/slide40.xml><?xml version="1.0" encoding="utf-8"?>
-<p:sld xmlns:a="http://schemas.openxmlformats.org/drawingml/2006/main" xmlns:p="http://schemas.openxmlformats.org/presentationml/2006/main" xmlns:r="http://schemas.openxmlformats.org/officeDocument/2006/relationships">
-  <p:cSld>
-    <p:spTree>
-      <p:nvGrpSpPr>
-        <p:cNvPr id="1" name=""/>
-        <p:cNvGrpSpPr/>
-        <p:nvPr/>
-      </p:nvGrpSpPr>
-      <p:grpSpPr/>
-      <p:sp>
-        <p:nvSpPr>
-          <p:cNvPr id="2" name="Title 1"/>
-          <p:cNvSpPr>
-            <a:spLocks noGrp="1"/>
-          </p:cNvSpPr>
-          <p:nvPr>
-            <p:ph type="title"/>
-          </p:nvPr>
-        </p:nvSpPr>
-        <p:spPr/>
-        <p:txBody>
-          <a:bodyPr/>
-          <a:lstStyle/>
-          <a:p>
-            <a:r>
-              <a:rPr sz="3800" b="1">
-                <a:solidFill>
-                  <a:srgbClr val="1F2A37"/>
-                </a:solidFill>
-              </a:rPr>
-              <a:t>Your turn</a:t>
-            </a:r>
-          </a:p>
-        </p:txBody>
-      </p:sp>
-      <p:sp>
-        <p:nvSpPr>
-          <p:cNvPr id="3" name="TextBox 2"/>
-          <p:cNvSpPr txBox="1"/>
-          <p:nvPr/>
-        </p:nvSpPr>
-        <p:spPr>
-          <a:xfrm>
-            <a:off x="822960" y="1828800"/>
-            <a:ext cx="10515600" cy="4206240"/>
-          </a:xfrm>
-          <a:prstGeom prst="rect">
-            <a:avLst/>
-          </a:prstGeom>
-          <a:noFill/>
-        </p:spPr>
-        <p:txBody>
-          <a:bodyPr wrap="square">
-            <a:spAutoFit/>
-          </a:bodyPr>
-          <a:lstStyle/>
-          <a:p>
-            <a:pPr>
-              <a:spcAft>
-                <a:spcPts val="1400"/>
-              </a:spcAft>
-            </a:pPr>
-            <a:r>
-              <a:rPr sz="2800">
-                <a:solidFill>
-                  <a:srgbClr val="01AEFD"/>
-                </a:solidFill>
-              </a:rPr>
-              <a:t>Get the echo working</a:t>
-            </a:r>
-          </a:p>
-          <a:p>
-            <a:pPr>
-              <a:spcAft>
-                <a:spcPts val="1400"/>
-              </a:spcAft>
-            </a:pPr>
-            <a:r>
-              <a:rPr sz="2400">
-                <a:solidFill>
-                  <a:srgbClr val="1F2A37"/>
-                </a:solidFill>
-              </a:rPr>
-              <a:t>• Type a message</a:t>
-            </a:r>
-          </a:p>
-          <a:p>
-            <a:pPr>
-              <a:spcAft>
-                <a:spcPts val="1400"/>
-              </a:spcAft>
-            </a:pPr>
-            <a:r>
-              <a:rPr sz="2400">
-                <a:solidFill>
-                  <a:srgbClr val="1F2A37"/>
-                </a:solidFill>
-              </a:rPr>
-              <a:t>• Press Send</a:t>
-            </a:r>
-          </a:p>
-          <a:p>
-            <a:pPr>
-              <a:spcAft>
-                <a:spcPts val="1400"/>
-              </a:spcAft>
-            </a:pPr>
-            <a:r>
-              <a:rPr sz="2400">
-                <a:solidFill>
-                  <a:srgbClr val="1F2A37"/>
-                </a:solidFill>
-              </a:rPr>
-              <a:t>• See it appear twice</a:t>
             </a:r>
           </a:p>
         </p:txBody>

</xml_diff>

<commit_message>
Explain the structural fundamentals before first use (wk 1-4)
The decks introduced each specific tag/property/built-in but assumed the
shape of the languages. Now, before the first line that needs them, the
deck teaches: what an HTML tag is (opening/closing/content), self-closing
tags, and attributes; what a CSS rule is and how selectors are built
(element, class, nested), plus hex colours and px sizes; and how a
JavaScript line is built - statements, strings, calling a function, dot
notation, joining with +, comparing with ===, objects, lists and
indexing. Each appears once, the first time it is used. An audit over
weeks 1-4 confirms no structural element is used before it is introduced.

Co-Authored-By: Claude Opus 5 <noreply@anthropic.com>
</commit_message>
<xml_diff>
--- a/ai101/slides/week-02.pptx
+++ b/ai101/slides/week-02.pptx
@@ -41,6 +41,8 @@
     <p:sldId id="289" r:id="rId40"/>
     <p:sldId id="290" r:id="rId41"/>
     <p:sldId id="291" r:id="rId42"/>
+    <p:sldId id="292" r:id="rId43"/>
+    <p:sldId id="293" r:id="rId44"/>
   </p:sldIdLst>
   <p:sldSz cx="12191695" cy="6858000" type="screen4x3"/>
   <p:notesSz cx="6858000" cy="9144000"/>
@@ -4153,7 +4155,7 @@
                   <a:srgbClr val="1F2A37"/>
                 </a:solidFill>
               </a:rPr>
-              <a:t>.textContent</a:t>
+              <a:t>Joining text with +</a:t>
             </a:r>
           </a:p>
         </p:txBody>
@@ -4224,7 +4226,7 @@
                   <a:srgbClr val="1F2A37"/>
                 </a:solidFill>
               </a:rPr>
-              <a:t>• Sets the words inside an element.</a:t>
+              <a:t>• 'You' + ': ' + text glues pieces of text into one.</a:t>
             </a:r>
           </a:p>
           <a:p>
@@ -4239,7 +4241,7 @@
                   <a:srgbClr val="1F2A37"/>
                 </a:solidFill>
               </a:rPr>
-              <a:t>• box.textContent = 'hi' puts hi inside it.</a:t>
+              <a:t>• The same + also adds numbers.</a:t>
             </a:r>
           </a:p>
         </p:txBody>
@@ -4253,6 +4255,136 @@
 </file>
 
 <file path=ppt/slides/slide17.xml><?xml version="1.0" encoding="utf-8"?>
+<p:sld xmlns:a="http://schemas.openxmlformats.org/drawingml/2006/main" xmlns:p="http://schemas.openxmlformats.org/presentationml/2006/main" xmlns:r="http://schemas.openxmlformats.org/officeDocument/2006/relationships">
+  <p:cSld>
+    <p:spTree>
+      <p:nvGrpSpPr>
+        <p:cNvPr id="1" name=""/>
+        <p:cNvGrpSpPr/>
+        <p:nvPr/>
+      </p:nvGrpSpPr>
+      <p:grpSpPr/>
+      <p:sp>
+        <p:nvSpPr>
+          <p:cNvPr id="2" name="Title 1"/>
+          <p:cNvSpPr>
+            <a:spLocks noGrp="1"/>
+          </p:cNvSpPr>
+          <p:nvPr>
+            <p:ph type="title"/>
+          </p:nvPr>
+        </p:nvSpPr>
+        <p:spPr/>
+        <p:txBody>
+          <a:bodyPr/>
+          <a:lstStyle/>
+          <a:p>
+            <a:r>
+              <a:rPr sz="3800" b="1">
+                <a:solidFill>
+                  <a:srgbClr val="1F2A37"/>
+                </a:solidFill>
+              </a:rPr>
+              <a:t>.textContent</a:t>
+            </a:r>
+          </a:p>
+        </p:txBody>
+      </p:sp>
+      <p:sp>
+        <p:nvSpPr>
+          <p:cNvPr id="3" name="TextBox 2"/>
+          <p:cNvSpPr txBox="1"/>
+          <p:nvPr/>
+        </p:nvSpPr>
+        <p:spPr>
+          <a:xfrm>
+            <a:off x="868680" y="502920"/>
+            <a:ext cx="5486400" cy="457200"/>
+          </a:xfrm>
+          <a:prstGeom prst="rect">
+            <a:avLst/>
+          </a:prstGeom>
+          <a:noFill/>
+        </p:spPr>
+        <p:txBody>
+          <a:bodyPr wrap="none">
+            <a:spAutoFit/>
+          </a:bodyPr>
+          <a:lstStyle/>
+          <a:p>
+            <a:r>
+              <a:rPr sz="1500" b="1">
+                <a:solidFill>
+                  <a:srgbClr val="01AEFD"/>
+                </a:solidFill>
+              </a:rPr>
+              <a:t>JAVASCRIPT</a:t>
+            </a:r>
+          </a:p>
+        </p:txBody>
+      </p:sp>
+      <p:sp>
+        <p:nvSpPr>
+          <p:cNvPr id="4" name="TextBox 3"/>
+          <p:cNvSpPr txBox="1"/>
+          <p:nvPr/>
+        </p:nvSpPr>
+        <p:spPr>
+          <a:xfrm>
+            <a:off x="822960" y="1828800"/>
+            <a:ext cx="10515600" cy="4206240"/>
+          </a:xfrm>
+          <a:prstGeom prst="rect">
+            <a:avLst/>
+          </a:prstGeom>
+          <a:noFill/>
+        </p:spPr>
+        <p:txBody>
+          <a:bodyPr wrap="square">
+            <a:spAutoFit/>
+          </a:bodyPr>
+          <a:lstStyle/>
+          <a:p>
+            <a:pPr>
+              <a:spcAft>
+                <a:spcPts val="1400"/>
+              </a:spcAft>
+            </a:pPr>
+            <a:r>
+              <a:rPr sz="2400">
+                <a:solidFill>
+                  <a:srgbClr val="1F2A37"/>
+                </a:solidFill>
+              </a:rPr>
+              <a:t>• Sets the words inside an element.</a:t>
+            </a:r>
+          </a:p>
+          <a:p>
+            <a:pPr>
+              <a:spcAft>
+                <a:spcPts val="1400"/>
+              </a:spcAft>
+            </a:pPr>
+            <a:r>
+              <a:rPr sz="2400">
+                <a:solidFill>
+                  <a:srgbClr val="1F2A37"/>
+                </a:solidFill>
+              </a:rPr>
+              <a:t>• box.textContent = 'hi' puts hi inside it.</a:t>
+            </a:r>
+          </a:p>
+        </p:txBody>
+      </p:sp>
+    </p:spTree>
+  </p:cSld>
+  <p:clrMapOvr>
+    <a:masterClrMapping/>
+  </p:clrMapOvr>
+</p:sld>
+</file>
+
+<file path=ppt/slides/slide18.xml><?xml version="1.0" encoding="utf-8"?>
 <p:sld xmlns:a="http://schemas.openxmlformats.org/drawingml/2006/main" xmlns:p="http://schemas.openxmlformats.org/presentationml/2006/main" xmlns:r="http://schemas.openxmlformats.org/officeDocument/2006/relationships">
   <p:cSld>
     <p:bg>
@@ -4492,7 +4624,7 @@
 </p:sld>
 </file>
 
-<file path=ppt/slides/slide18.xml><?xml version="1.0" encoding="utf-8"?>
+<file path=ppt/slides/slide19.xml><?xml version="1.0" encoding="utf-8"?>
 <p:sld xmlns:a="http://schemas.openxmlformats.org/drawingml/2006/main" xmlns:p="http://schemas.openxmlformats.org/presentationml/2006/main" xmlns:r="http://schemas.openxmlformats.org/officeDocument/2006/relationships">
   <p:cSld>
     <p:spTree>
@@ -4595,271 +4727,6 @@
                 </a:solidFill>
               </a:rPr>
               <a:t>• Puts one element inside another, so it finally shows on the page.</a:t>
-            </a:r>
-          </a:p>
-        </p:txBody>
-      </p:sp>
-    </p:spTree>
-  </p:cSld>
-  <p:clrMapOvr>
-    <a:masterClrMapping/>
-  </p:clrMapOvr>
-</p:sld>
-</file>
-
-<file path=ppt/slides/slide19.xml><?xml version="1.0" encoding="utf-8"?>
-<p:sld xmlns:a="http://schemas.openxmlformats.org/drawingml/2006/main" xmlns:p="http://schemas.openxmlformats.org/presentationml/2006/main" xmlns:r="http://schemas.openxmlformats.org/officeDocument/2006/relationships">
-  <p:cSld>
-    <p:bg>
-      <p:bgPr>
-        <a:solidFill>
-          <a:srgbClr val="102127"/>
-        </a:solidFill>
-        <a:effectLst/>
-      </p:bgPr>
-    </p:bg>
-    <p:spTree>
-      <p:nvGrpSpPr>
-        <p:cNvPr id="1" name=""/>
-        <p:cNvGrpSpPr/>
-        <p:nvPr/>
-      </p:nvGrpSpPr>
-      <p:grpSpPr/>
-      <p:sp>
-        <p:nvSpPr>
-          <p:cNvPr id="2" name="TextBox 1"/>
-          <p:cNvSpPr txBox="1"/>
-          <p:nvPr/>
-        </p:nvSpPr>
-        <p:spPr>
-          <a:xfrm>
-            <a:off x="502920" y="274320"/>
-            <a:ext cx="11155680" cy="548640"/>
-          </a:xfrm>
-          <a:prstGeom prst="rect">
-            <a:avLst/>
-          </a:prstGeom>
-          <a:noFill/>
-        </p:spPr>
-        <p:txBody>
-          <a:bodyPr wrap="none">
-            <a:spAutoFit/>
-          </a:bodyPr>
-          <a:lstStyle/>
-          <a:p>
-            <a:r>
-              <a:rPr sz="2200" b="1">
-                <a:solidFill>
-                  <a:srgbClr val="01AEFD"/>
-                </a:solidFill>
-              </a:rPr>
-              <a:t>Type this into script.js   -   line 19</a:t>
-            </a:r>
-          </a:p>
-        </p:txBody>
-      </p:sp>
-      <p:sp>
-        <p:nvSpPr>
-          <p:cNvPr id="3" name="TextBox 2"/>
-          <p:cNvSpPr txBox="1"/>
-          <p:nvPr/>
-        </p:nvSpPr>
-        <p:spPr>
-          <a:xfrm>
-            <a:off x="502920" y="960120"/>
-            <a:ext cx="11155680" cy="4297680"/>
-          </a:xfrm>
-          <a:prstGeom prst="rect">
-            <a:avLst/>
-          </a:prstGeom>
-          <a:noFill/>
-        </p:spPr>
-        <p:txBody>
-          <a:bodyPr wrap="none">
-            <a:spAutoFit/>
-          </a:bodyPr>
-          <a:lstStyle/>
-          <a:p>
-            <a:pPr>
-              <a:spcAft>
-                <a:spcPts val="0"/>
-              </a:spcAft>
-            </a:pPr>
-            <a:r>
-              <a:rPr sz="1800">
-                <a:solidFill>
-                  <a:srgbClr val="6D8C97"/>
-                </a:solidFill>
-                <a:latin typeface="Consolas"/>
-              </a:rPr>
-              <a:t>  14  </a:t>
-            </a:r>
-            <a:r>
-              <a:rPr sz="1800">
-                <a:solidFill>
-                  <a:srgbClr val="6D8C97"/>
-                </a:solidFill>
-                <a:latin typeface="Consolas"/>
-              </a:rPr>
-              <a:t> </a:t>
-            </a:r>
-          </a:p>
-          <a:p>
-            <a:pPr>
-              <a:spcAft>
-                <a:spcPts val="0"/>
-              </a:spcAft>
-            </a:pPr>
-            <a:r>
-              <a:rPr sz="1800">
-                <a:solidFill>
-                  <a:srgbClr val="6D8C97"/>
-                </a:solidFill>
-                <a:latin typeface="Consolas"/>
-              </a:rPr>
-              <a:t>  15  </a:t>
-            </a:r>
-            <a:r>
-              <a:rPr sz="1800">
-                <a:solidFill>
-                  <a:srgbClr val="6D8C97"/>
-                </a:solidFill>
-                <a:latin typeface="Consolas"/>
-              </a:rPr>
-              <a:t>// Put one line of text into the chat box.</a:t>
-            </a:r>
-          </a:p>
-          <a:p>
-            <a:pPr>
-              <a:spcAft>
-                <a:spcPts val="0"/>
-              </a:spcAft>
-            </a:pPr>
-            <a:r>
-              <a:rPr sz="1800">
-                <a:solidFill>
-                  <a:srgbClr val="6D8C97"/>
-                </a:solidFill>
-                <a:latin typeface="Consolas"/>
-              </a:rPr>
-              <a:t>  16  </a:t>
-            </a:r>
-            <a:r>
-              <a:rPr sz="1800">
-                <a:solidFill>
-                  <a:srgbClr val="6D8C97"/>
-                </a:solidFill>
-                <a:latin typeface="Consolas"/>
-              </a:rPr>
-              <a:t>function addLine(who, text) {</a:t>
-            </a:r>
-          </a:p>
-          <a:p>
-            <a:pPr>
-              <a:spcAft>
-                <a:spcPts val="0"/>
-              </a:spcAft>
-            </a:pPr>
-            <a:r>
-              <a:rPr sz="1800">
-                <a:solidFill>
-                  <a:srgbClr val="6D8C97"/>
-                </a:solidFill>
-                <a:latin typeface="Consolas"/>
-              </a:rPr>
-              <a:t>  17  </a:t>
-            </a:r>
-            <a:r>
-              <a:rPr sz="1800">
-                <a:solidFill>
-                  <a:srgbClr val="6D8C97"/>
-                </a:solidFill>
-                <a:latin typeface="Consolas"/>
-              </a:rPr>
-              <a:t>  const line = document.createElement('p');</a:t>
-            </a:r>
-          </a:p>
-          <a:p>
-            <a:pPr>
-              <a:spcAft>
-                <a:spcPts val="0"/>
-              </a:spcAft>
-            </a:pPr>
-            <a:r>
-              <a:rPr sz="1800">
-                <a:solidFill>
-                  <a:srgbClr val="6D8C97"/>
-                </a:solidFill>
-                <a:latin typeface="Consolas"/>
-              </a:rPr>
-              <a:t>  18  </a:t>
-            </a:r>
-            <a:r>
-              <a:rPr sz="1800">
-                <a:solidFill>
-                  <a:srgbClr val="6D8C97"/>
-                </a:solidFill>
-                <a:latin typeface="Consolas"/>
-              </a:rPr>
-              <a:t>  line.textContent = who + ': ' + text;</a:t>
-            </a:r>
-          </a:p>
-          <a:p>
-            <a:pPr>
-              <a:spcAft>
-                <a:spcPts val="0"/>
-              </a:spcAft>
-            </a:pPr>
-            <a:r>
-              <a:rPr sz="1800">
-                <a:solidFill>
-                  <a:srgbClr val="6D8C97"/>
-                </a:solidFill>
-                <a:latin typeface="Consolas"/>
-              </a:rPr>
-              <a:t>  19  </a:t>
-            </a:r>
-            <a:r>
-              <a:rPr sz="1800">
-                <a:solidFill>
-                  <a:srgbClr val="7FE0A0"/>
-                </a:solidFill>
-                <a:latin typeface="Consolas"/>
-              </a:rPr>
-              <a:t>  chat.appendChild(line);</a:t>
-            </a:r>
-          </a:p>
-        </p:txBody>
-      </p:sp>
-      <p:sp>
-        <p:nvSpPr>
-          <p:cNvPr id="4" name="TextBox 3"/>
-          <p:cNvSpPr txBox="1"/>
-          <p:nvPr/>
-        </p:nvSpPr>
-        <p:spPr>
-          <a:xfrm>
-            <a:off x="548640" y="5623560"/>
-            <a:ext cx="11064240" cy="1051560"/>
-          </a:xfrm>
-          <a:prstGeom prst="rect">
-            <a:avLst/>
-          </a:prstGeom>
-          <a:noFill/>
-        </p:spPr>
-        <p:txBody>
-          <a:bodyPr wrap="square">
-            <a:spAutoFit/>
-          </a:bodyPr>
-          <a:lstStyle/>
-          <a:p>
-            <a:r>
-              <a:rPr sz="2000">
-                <a:solidFill>
-                  <a:srgbClr val="DCECEF"/>
-                </a:solidFill>
-              </a:rPr>
-              <a:t>Adds the &lt;p&gt; inside the chat box, so it finally appears on screen.</a:t>
             </a:r>
           </a:p>
         </p:txBody>
@@ -5030,7 +4897,7 @@
                   <a:srgbClr val="01AEFD"/>
                 </a:solidFill>
               </a:rPr>
-              <a:t>Type this into script.js   -   line 20</a:t>
+              <a:t>Type this into script.js   -   line 19</a:t>
             </a:r>
           </a:p>
         </p:txBody>
@@ -5199,36 +5066,11 @@
             <a:r>
               <a:rPr sz="1800">
                 <a:solidFill>
-                  <a:srgbClr val="6D8C97"/>
+                  <a:srgbClr val="7FE0A0"/>
                 </a:solidFill>
                 <a:latin typeface="Consolas"/>
               </a:rPr>
               <a:t>  chat.appendChild(line);</a:t>
-            </a:r>
-          </a:p>
-          <a:p>
-            <a:pPr>
-              <a:spcAft>
-                <a:spcPts val="0"/>
-              </a:spcAft>
-            </a:pPr>
-            <a:r>
-              <a:rPr sz="1800">
-                <a:solidFill>
-                  <a:srgbClr val="6D8C97"/>
-                </a:solidFill>
-                <a:latin typeface="Consolas"/>
-              </a:rPr>
-              <a:t>  20  </a:t>
-            </a:r>
-            <a:r>
-              <a:rPr sz="1800">
-                <a:solidFill>
-                  <a:srgbClr val="7FE0A0"/>
-                </a:solidFill>
-                <a:latin typeface="Consolas"/>
-              </a:rPr>
-              <a:t>}</a:t>
             </a:r>
           </a:p>
         </p:txBody>
@@ -5261,7 +5103,7 @@
                   <a:srgbClr val="DCECEF"/>
                 </a:solidFill>
               </a:rPr>
-              <a:t>Closes the function. Nothing happens until something CALLS addLine.</a:t>
+              <a:t>Adds the &lt;p&gt; inside the chat box, so it finally appears on screen.</a:t>
             </a:r>
           </a:p>
         </p:txBody>
@@ -5320,7 +5162,7 @@
                   <a:srgbClr val="01AEFD"/>
                 </a:solidFill>
               </a:rPr>
-              <a:t>All together in script.js</a:t>
+              <a:t>Type this into script.js   -   line 20</a:t>
             </a:r>
           </a:p>
         </p:txBody>
@@ -5364,7 +5206,7 @@
             <a:r>
               <a:rPr sz="1800">
                 <a:solidFill>
-                  <a:srgbClr val="7FE0A0"/>
+                  <a:srgbClr val="6D8C97"/>
                 </a:solidFill>
                 <a:latin typeface="Consolas"/>
               </a:rPr>
@@ -5389,7 +5231,7 @@
             <a:r>
               <a:rPr sz="1800">
                 <a:solidFill>
-                  <a:srgbClr val="7FE0A0"/>
+                  <a:srgbClr val="6D8C97"/>
                 </a:solidFill>
                 <a:latin typeface="Consolas"/>
               </a:rPr>
@@ -5414,7 +5256,7 @@
             <a:r>
               <a:rPr sz="1800">
                 <a:solidFill>
-                  <a:srgbClr val="7FE0A0"/>
+                  <a:srgbClr val="6D8C97"/>
                 </a:solidFill>
                 <a:latin typeface="Consolas"/>
               </a:rPr>
@@ -5439,7 +5281,7 @@
             <a:r>
               <a:rPr sz="1800">
                 <a:solidFill>
-                  <a:srgbClr val="7FE0A0"/>
+                  <a:srgbClr val="6D8C97"/>
                 </a:solidFill>
                 <a:latin typeface="Consolas"/>
               </a:rPr>
@@ -5464,7 +5306,7 @@
             <a:r>
               <a:rPr sz="1800">
                 <a:solidFill>
-                  <a:srgbClr val="7FE0A0"/>
+                  <a:srgbClr val="6D8C97"/>
                 </a:solidFill>
                 <a:latin typeface="Consolas"/>
               </a:rPr>
@@ -5489,7 +5331,7 @@
             <a:r>
               <a:rPr sz="1800">
                 <a:solidFill>
-                  <a:srgbClr val="7FE0A0"/>
+                  <a:srgbClr val="6D8C97"/>
                 </a:solidFill>
                 <a:latin typeface="Consolas"/>
               </a:rPr>
@@ -5551,7 +5393,7 @@
                   <a:srgbClr val="DCECEF"/>
                 </a:solidFill>
               </a:rPr>
-              <a:t>That is the whole piece. Check yours looks the same before moving on.</a:t>
+              <a:t>Closes the function. Nothing happens until something CALLS addLine.</a:t>
             </a:r>
           </a:p>
         </p:txBody>
@@ -5567,6 +5409,14 @@
 <file path=ppt/slides/slide22.xml><?xml version="1.0" encoding="utf-8"?>
 <p:sld xmlns:a="http://schemas.openxmlformats.org/drawingml/2006/main" xmlns:p="http://schemas.openxmlformats.org/presentationml/2006/main" xmlns:r="http://schemas.openxmlformats.org/officeDocument/2006/relationships">
   <p:cSld>
+    <p:bg>
+      <p:bgPr>
+        <a:solidFill>
+          <a:srgbClr val="102127"/>
+        </a:solidFill>
+        <a:effectLst/>
+      </p:bgPr>
+    </p:bg>
     <p:spTree>
       <p:nvGrpSpPr>
         <p:cNvPr id="1" name=""/>
@@ -5576,40 +5426,14 @@
       <p:grpSpPr/>
       <p:sp>
         <p:nvSpPr>
-          <p:cNvPr id="2" name="Title 1"/>
-          <p:cNvSpPr>
-            <a:spLocks noGrp="1"/>
-          </p:cNvSpPr>
-          <p:nvPr>
-            <p:ph type="title"/>
-          </p:nvPr>
-        </p:nvSpPr>
-        <p:spPr/>
-        <p:txBody>
-          <a:bodyPr/>
-          <a:lstStyle/>
-          <a:p>
-            <a:r>
-              <a:rPr sz="3800" b="1">
-                <a:solidFill>
-                  <a:srgbClr val="1F2A37"/>
-                </a:solidFill>
-              </a:rPr>
-              <a:t>PixelPad had a loop</a:t>
-            </a:r>
-          </a:p>
-        </p:txBody>
-      </p:sp>
-      <p:sp>
-        <p:nvSpPr>
-          <p:cNvPr id="3" name="TextBox 2"/>
+          <p:cNvPr id="2" name="TextBox 1"/>
           <p:cNvSpPr txBox="1"/>
           <p:nvPr/>
         </p:nvSpPr>
         <p:spPr>
           <a:xfrm>
-            <a:off x="822960" y="1828800"/>
-            <a:ext cx="10515600" cy="4206240"/>
+            <a:off x="502920" y="274320"/>
+            <a:ext cx="11155680" cy="548640"/>
           </a:xfrm>
           <a:prstGeom prst="rect">
             <a:avLst/>
@@ -5617,68 +5441,249 @@
           <a:noFill/>
         </p:spPr>
         <p:txBody>
+          <a:bodyPr wrap="none">
+            <a:spAutoFit/>
+          </a:bodyPr>
+          <a:lstStyle/>
+          <a:p>
+            <a:r>
+              <a:rPr sz="2200" b="1">
+                <a:solidFill>
+                  <a:srgbClr val="01AEFD"/>
+                </a:solidFill>
+              </a:rPr>
+              <a:t>All together in script.js</a:t>
+            </a:r>
+          </a:p>
+        </p:txBody>
+      </p:sp>
+      <p:sp>
+        <p:nvSpPr>
+          <p:cNvPr id="3" name="TextBox 2"/>
+          <p:cNvSpPr txBox="1"/>
+          <p:nvPr/>
+        </p:nvSpPr>
+        <p:spPr>
+          <a:xfrm>
+            <a:off x="502920" y="960120"/>
+            <a:ext cx="11155680" cy="4297680"/>
+          </a:xfrm>
+          <a:prstGeom prst="rect">
+            <a:avLst/>
+          </a:prstGeom>
+          <a:noFill/>
+        </p:spPr>
+        <p:txBody>
+          <a:bodyPr wrap="none">
+            <a:spAutoFit/>
+          </a:bodyPr>
+          <a:lstStyle/>
+          <a:p>
+            <a:pPr>
+              <a:spcAft>
+                <a:spcPts val="0"/>
+              </a:spcAft>
+            </a:pPr>
+            <a:r>
+              <a:rPr sz="1800">
+                <a:solidFill>
+                  <a:srgbClr val="6D8C97"/>
+                </a:solidFill>
+                <a:latin typeface="Consolas"/>
+              </a:rPr>
+              <a:t>  14  </a:t>
+            </a:r>
+            <a:r>
+              <a:rPr sz="1800">
+                <a:solidFill>
+                  <a:srgbClr val="7FE0A0"/>
+                </a:solidFill>
+                <a:latin typeface="Consolas"/>
+              </a:rPr>
+              <a:t> </a:t>
+            </a:r>
+          </a:p>
+          <a:p>
+            <a:pPr>
+              <a:spcAft>
+                <a:spcPts val="0"/>
+              </a:spcAft>
+            </a:pPr>
+            <a:r>
+              <a:rPr sz="1800">
+                <a:solidFill>
+                  <a:srgbClr val="6D8C97"/>
+                </a:solidFill>
+                <a:latin typeface="Consolas"/>
+              </a:rPr>
+              <a:t>  15  </a:t>
+            </a:r>
+            <a:r>
+              <a:rPr sz="1800">
+                <a:solidFill>
+                  <a:srgbClr val="7FE0A0"/>
+                </a:solidFill>
+                <a:latin typeface="Consolas"/>
+              </a:rPr>
+              <a:t>// Put one line of text into the chat box.</a:t>
+            </a:r>
+          </a:p>
+          <a:p>
+            <a:pPr>
+              <a:spcAft>
+                <a:spcPts val="0"/>
+              </a:spcAft>
+            </a:pPr>
+            <a:r>
+              <a:rPr sz="1800">
+                <a:solidFill>
+                  <a:srgbClr val="6D8C97"/>
+                </a:solidFill>
+                <a:latin typeface="Consolas"/>
+              </a:rPr>
+              <a:t>  16  </a:t>
+            </a:r>
+            <a:r>
+              <a:rPr sz="1800">
+                <a:solidFill>
+                  <a:srgbClr val="7FE0A0"/>
+                </a:solidFill>
+                <a:latin typeface="Consolas"/>
+              </a:rPr>
+              <a:t>function addLine(who, text) {</a:t>
+            </a:r>
+          </a:p>
+          <a:p>
+            <a:pPr>
+              <a:spcAft>
+                <a:spcPts val="0"/>
+              </a:spcAft>
+            </a:pPr>
+            <a:r>
+              <a:rPr sz="1800">
+                <a:solidFill>
+                  <a:srgbClr val="6D8C97"/>
+                </a:solidFill>
+                <a:latin typeface="Consolas"/>
+              </a:rPr>
+              <a:t>  17  </a:t>
+            </a:r>
+            <a:r>
+              <a:rPr sz="1800">
+                <a:solidFill>
+                  <a:srgbClr val="7FE0A0"/>
+                </a:solidFill>
+                <a:latin typeface="Consolas"/>
+              </a:rPr>
+              <a:t>  const line = document.createElement('p');</a:t>
+            </a:r>
+          </a:p>
+          <a:p>
+            <a:pPr>
+              <a:spcAft>
+                <a:spcPts val="0"/>
+              </a:spcAft>
+            </a:pPr>
+            <a:r>
+              <a:rPr sz="1800">
+                <a:solidFill>
+                  <a:srgbClr val="6D8C97"/>
+                </a:solidFill>
+                <a:latin typeface="Consolas"/>
+              </a:rPr>
+              <a:t>  18  </a:t>
+            </a:r>
+            <a:r>
+              <a:rPr sz="1800">
+                <a:solidFill>
+                  <a:srgbClr val="7FE0A0"/>
+                </a:solidFill>
+                <a:latin typeface="Consolas"/>
+              </a:rPr>
+              <a:t>  line.textContent = who + ': ' + text;</a:t>
+            </a:r>
+          </a:p>
+          <a:p>
+            <a:pPr>
+              <a:spcAft>
+                <a:spcPts val="0"/>
+              </a:spcAft>
+            </a:pPr>
+            <a:r>
+              <a:rPr sz="1800">
+                <a:solidFill>
+                  <a:srgbClr val="6D8C97"/>
+                </a:solidFill>
+                <a:latin typeface="Consolas"/>
+              </a:rPr>
+              <a:t>  19  </a:t>
+            </a:r>
+            <a:r>
+              <a:rPr sz="1800">
+                <a:solidFill>
+                  <a:srgbClr val="7FE0A0"/>
+                </a:solidFill>
+                <a:latin typeface="Consolas"/>
+              </a:rPr>
+              <a:t>  chat.appendChild(line);</a:t>
+            </a:r>
+          </a:p>
+          <a:p>
+            <a:pPr>
+              <a:spcAft>
+                <a:spcPts val="0"/>
+              </a:spcAft>
+            </a:pPr>
+            <a:r>
+              <a:rPr sz="1800">
+                <a:solidFill>
+                  <a:srgbClr val="6D8C97"/>
+                </a:solidFill>
+                <a:latin typeface="Consolas"/>
+              </a:rPr>
+              <a:t>  20  </a:t>
+            </a:r>
+            <a:r>
+              <a:rPr sz="1800">
+                <a:solidFill>
+                  <a:srgbClr val="7FE0A0"/>
+                </a:solidFill>
+                <a:latin typeface="Consolas"/>
+              </a:rPr>
+              <a:t>}</a:t>
+            </a:r>
+          </a:p>
+        </p:txBody>
+      </p:sp>
+      <p:sp>
+        <p:nvSpPr>
+          <p:cNvPr id="4" name="TextBox 3"/>
+          <p:cNvSpPr txBox="1"/>
+          <p:nvPr/>
+        </p:nvSpPr>
+        <p:spPr>
+          <a:xfrm>
+            <a:off x="548640" y="5623560"/>
+            <a:ext cx="11064240" cy="1051560"/>
+          </a:xfrm>
+          <a:prstGeom prst="rect">
+            <a:avLst/>
+          </a:prstGeom>
+          <a:noFill/>
+        </p:spPr>
+        <p:txBody>
           <a:bodyPr wrap="square">
             <a:spAutoFit/>
           </a:bodyPr>
           <a:lstStyle/>
           <a:p>
-            <a:pPr>
-              <a:spcAft>
-                <a:spcPts val="1400"/>
-              </a:spcAft>
-            </a:pPr>
-            <a:r>
-              <a:rPr sz="2800">
-                <a:solidFill>
-                  <a:srgbClr val="01AEFD"/>
-                </a:solidFill>
-              </a:rPr>
-              <a:t>def loop(self): ...</a:t>
-            </a:r>
-          </a:p>
-          <a:p>
-            <a:pPr>
-              <a:spcAft>
-                <a:spcPts val="1400"/>
-              </a:spcAft>
-            </a:pPr>
-            <a:r>
-              <a:rPr sz="2400">
-                <a:solidFill>
-                  <a:srgbClr val="1F2A37"/>
-                </a:solidFill>
-              </a:rPr>
-              <a:t>• It ran 60 times a second</a:t>
-            </a:r>
-          </a:p>
-          <a:p>
-            <a:pPr>
-              <a:spcAft>
-                <a:spcPts val="1400"/>
-              </a:spcAft>
-            </a:pPr>
-            <a:r>
-              <a:rPr sz="2400">
-                <a:solidFill>
-                  <a:srgbClr val="1F2A37"/>
-                </a:solidFill>
-              </a:rPr>
-              <a:t>• You asked: did anything happen yet?</a:t>
-            </a:r>
-          </a:p>
-          <a:p>
-            <a:pPr>
-              <a:spcAft>
-                <a:spcPts val="1400"/>
-              </a:spcAft>
-            </a:pPr>
-            <a:r>
-              <a:rPr sz="2400">
-                <a:solidFill>
-                  <a:srgbClr val="1F2A37"/>
-                </a:solidFill>
-              </a:rPr>
-              <a:t>• You were in charge of the loop</a:t>
+            <a:r>
+              <a:rPr sz="2000">
+                <a:solidFill>
+                  <a:srgbClr val="DCECEF"/>
+                </a:solidFill>
+              </a:rPr>
+              <a:t>That is the whole piece. Check yours looks the same before moving on.</a:t>
             </a:r>
           </a:p>
         </p:txBody>
@@ -5722,7 +5727,7 @@
                   <a:srgbClr val="1F2A37"/>
                 </a:solidFill>
               </a:rPr>
-              <a:t>The browser owns the loop</a:t>
+              <a:t>PixelPad had a loop</a:t>
             </a:r>
           </a:p>
         </p:txBody>
@@ -5760,7 +5765,7 @@
                   <a:srgbClr val="01AEFD"/>
                 </a:solidFill>
               </a:rPr>
-              <a:t>addEventListener('submit', ...)</a:t>
+              <a:t>def loop(self): ...</a:t>
             </a:r>
           </a:p>
           <a:p>
@@ -5775,7 +5780,7 @@
                   <a:srgbClr val="1F2A37"/>
                 </a:solidFill>
               </a:rPr>
-              <a:t>• You leave a note about what to do</a:t>
+              <a:t>• It ran 60 times a second</a:t>
             </a:r>
           </a:p>
           <a:p>
@@ -5790,7 +5795,7 @@
                   <a:srgbClr val="1F2A37"/>
                 </a:solidFill>
               </a:rPr>
-              <a:t>• The browser calls you when it happens</a:t>
+              <a:t>• You asked: did anything happen yet?</a:t>
             </a:r>
           </a:p>
           <a:p>
@@ -5805,7 +5810,7 @@
                   <a:srgbClr val="1F2A37"/>
                 </a:solidFill>
               </a:rPr>
-              <a:t>• Same idea, opposite direction</a:t>
+              <a:t>• You were in charge of the loop</a:t>
             </a:r>
           </a:p>
         </p:txBody>
@@ -5821,14 +5826,6 @@
 <file path=ppt/slides/slide24.xml><?xml version="1.0" encoding="utf-8"?>
 <p:sld xmlns:a="http://schemas.openxmlformats.org/drawingml/2006/main" xmlns:p="http://schemas.openxmlformats.org/presentationml/2006/main" xmlns:r="http://schemas.openxmlformats.org/officeDocument/2006/relationships">
   <p:cSld>
-    <p:bg>
-      <p:bgPr>
-        <a:solidFill>
-          <a:srgbClr val="102127"/>
-        </a:solidFill>
-        <a:effectLst/>
-      </p:bgPr>
-    </p:bg>
     <p:spTree>
       <p:nvGrpSpPr>
         <p:cNvPr id="1" name=""/>
@@ -5838,14 +5835,40 @@
       <p:grpSpPr/>
       <p:sp>
         <p:nvSpPr>
-          <p:cNvPr id="2" name="TextBox 1"/>
+          <p:cNvPr id="2" name="Title 1"/>
+          <p:cNvSpPr>
+            <a:spLocks noGrp="1"/>
+          </p:cNvSpPr>
+          <p:nvPr>
+            <p:ph type="title"/>
+          </p:nvPr>
+        </p:nvSpPr>
+        <p:spPr/>
+        <p:txBody>
+          <a:bodyPr/>
+          <a:lstStyle/>
+          <a:p>
+            <a:r>
+              <a:rPr sz="3800" b="1">
+                <a:solidFill>
+                  <a:srgbClr val="1F2A37"/>
+                </a:solidFill>
+              </a:rPr>
+              <a:t>The browser owns the loop</a:t>
+            </a:r>
+          </a:p>
+        </p:txBody>
+      </p:sp>
+      <p:sp>
+        <p:nvSpPr>
+          <p:cNvPr id="3" name="TextBox 2"/>
           <p:cNvSpPr txBox="1"/>
           <p:nvPr/>
         </p:nvSpPr>
         <p:spPr>
           <a:xfrm>
-            <a:off x="502920" y="274320"/>
-            <a:ext cx="11155680" cy="548640"/>
+            <a:off x="822960" y="1828800"/>
+            <a:ext cx="10515600" cy="4206240"/>
           </a:xfrm>
           <a:prstGeom prst="rect">
             <a:avLst/>
@@ -5853,124 +5876,68 @@
           <a:noFill/>
         </p:spPr>
         <p:txBody>
-          <a:bodyPr wrap="none">
-            <a:spAutoFit/>
-          </a:bodyPr>
-          <a:lstStyle/>
-          <a:p>
-            <a:r>
-              <a:rPr sz="2200" b="1">
-                <a:solidFill>
-                  <a:srgbClr val="01AEFD"/>
-                </a:solidFill>
-              </a:rPr>
-              <a:t>Type this into script.js   -   line 22</a:t>
-            </a:r>
-          </a:p>
-        </p:txBody>
-      </p:sp>
-      <p:sp>
-        <p:nvSpPr>
-          <p:cNvPr id="3" name="TextBox 2"/>
-          <p:cNvSpPr txBox="1"/>
-          <p:nvPr/>
-        </p:nvSpPr>
-        <p:spPr>
-          <a:xfrm>
-            <a:off x="502920" y="960120"/>
-            <a:ext cx="11155680" cy="4297680"/>
-          </a:xfrm>
-          <a:prstGeom prst="rect">
-            <a:avLst/>
-          </a:prstGeom>
-          <a:noFill/>
-        </p:spPr>
-        <p:txBody>
-          <a:bodyPr wrap="none">
-            <a:spAutoFit/>
-          </a:bodyPr>
-          <a:lstStyle/>
-          <a:p>
-            <a:pPr>
-              <a:spcAft>
-                <a:spcPts val="0"/>
-              </a:spcAft>
-            </a:pPr>
-            <a:r>
-              <a:rPr sz="1800">
-                <a:solidFill>
-                  <a:srgbClr val="6D8C97"/>
-                </a:solidFill>
-                <a:latin typeface="Consolas"/>
-              </a:rPr>
-              <a:t>  21  </a:t>
-            </a:r>
-            <a:r>
-              <a:rPr sz="1800">
-                <a:solidFill>
-                  <a:srgbClr val="6D8C97"/>
-                </a:solidFill>
-                <a:latin typeface="Consolas"/>
-              </a:rPr>
-              <a:t> </a:t>
-            </a:r>
-          </a:p>
-          <a:p>
-            <a:pPr>
-              <a:spcAft>
-                <a:spcPts val="0"/>
-              </a:spcAft>
-            </a:pPr>
-            <a:r>
-              <a:rPr sz="1800">
-                <a:solidFill>
-                  <a:srgbClr val="6D8C97"/>
-                </a:solidFill>
-                <a:latin typeface="Consolas"/>
-              </a:rPr>
-              <a:t>  22  </a:t>
-            </a:r>
-            <a:r>
-              <a:rPr sz="1800">
-                <a:solidFill>
-                  <a:srgbClr val="7FE0A0"/>
-                </a:solidFill>
-                <a:latin typeface="Consolas"/>
-              </a:rPr>
-              <a:t>// In PixelPad your loop() checked 'was a key pressed?' every frame. Here you</a:t>
-            </a:r>
-          </a:p>
-        </p:txBody>
-      </p:sp>
-      <p:sp>
-        <p:nvSpPr>
-          <p:cNvPr id="4" name="TextBox 3"/>
-          <p:cNvSpPr txBox="1"/>
-          <p:nvPr/>
-        </p:nvSpPr>
-        <p:spPr>
-          <a:xfrm>
-            <a:off x="548640" y="5623560"/>
-            <a:ext cx="11064240" cy="1051560"/>
-          </a:xfrm>
-          <a:prstGeom prst="rect">
-            <a:avLst/>
-          </a:prstGeom>
-          <a:noFill/>
-        </p:spPr>
-        <p:txBody>
           <a:bodyPr wrap="square">
             <a:spAutoFit/>
           </a:bodyPr>
           <a:lstStyle/>
           <a:p>
-            <a:r>
-              <a:rPr sz="2000">
-                <a:solidFill>
-                  <a:srgbClr val="DCECEF"/>
-                </a:solidFill>
-              </a:rPr>
-              <a:t>A comment: the browser calls this when the form is submitted.</a:t>
+            <a:pPr>
+              <a:spcAft>
+                <a:spcPts val="1400"/>
+              </a:spcAft>
+            </a:pPr>
+            <a:r>
+              <a:rPr sz="2800">
+                <a:solidFill>
+                  <a:srgbClr val="01AEFD"/>
+                </a:solidFill>
+              </a:rPr>
+              <a:t>addEventListener('submit', ...)</a:t>
+            </a:r>
+          </a:p>
+          <a:p>
+            <a:pPr>
+              <a:spcAft>
+                <a:spcPts val="1400"/>
+              </a:spcAft>
+            </a:pPr>
+            <a:r>
+              <a:rPr sz="2400">
+                <a:solidFill>
+                  <a:srgbClr val="1F2A37"/>
+                </a:solidFill>
+              </a:rPr>
+              <a:t>• You leave a note about what to do</a:t>
+            </a:r>
+          </a:p>
+          <a:p>
+            <a:pPr>
+              <a:spcAft>
+                <a:spcPts val="1400"/>
+              </a:spcAft>
+            </a:pPr>
+            <a:r>
+              <a:rPr sz="2400">
+                <a:solidFill>
+                  <a:srgbClr val="1F2A37"/>
+                </a:solidFill>
+              </a:rPr>
+              <a:t>• The browser calls you when it happens</a:t>
+            </a:r>
+          </a:p>
+          <a:p>
+            <a:pPr>
+              <a:spcAft>
+                <a:spcPts val="1400"/>
+              </a:spcAft>
+            </a:pPr>
+            <a:r>
+              <a:rPr sz="2400">
+                <a:solidFill>
+                  <a:srgbClr val="1F2A37"/>
+                </a:solidFill>
+              </a:rPr>
+              <a:t>• Same idea, opposite direction</a:t>
             </a:r>
           </a:p>
         </p:txBody>
@@ -6029,7 +5996,7 @@
                   <a:srgbClr val="01AEFD"/>
                 </a:solidFill>
               </a:rPr>
-              <a:t>Type this into script.js   -   line 23</a:t>
+              <a:t>Type this into script.js   -   line 22</a:t>
             </a:r>
           </a:p>
         </p:txBody>
@@ -6098,36 +6065,11 @@
             <a:r>
               <a:rPr sz="1800">
                 <a:solidFill>
-                  <a:srgbClr val="6D8C97"/>
+                  <a:srgbClr val="7FE0A0"/>
                 </a:solidFill>
                 <a:latin typeface="Consolas"/>
               </a:rPr>
               <a:t>// In PixelPad your loop() checked 'was a key pressed?' every frame. Here you</a:t>
-            </a:r>
-          </a:p>
-          <a:p>
-            <a:pPr>
-              <a:spcAft>
-                <a:spcPts val="0"/>
-              </a:spcAft>
-            </a:pPr>
-            <a:r>
-              <a:rPr sz="1800">
-                <a:solidFill>
-                  <a:srgbClr val="6D8C97"/>
-                </a:solidFill>
-                <a:latin typeface="Consolas"/>
-              </a:rPr>
-              <a:t>  23  </a:t>
-            </a:r>
-            <a:r>
-              <a:rPr sz="1800">
-                <a:solidFill>
-                  <a:srgbClr val="7FE0A0"/>
-                </a:solidFill>
-                <a:latin typeface="Consolas"/>
-              </a:rPr>
-              <a:t>// leave a note: when this form is submitted, run this. The browser waits.</a:t>
             </a:r>
           </a:p>
         </p:txBody>
@@ -6160,7 +6102,7 @@
                   <a:srgbClr val="DCECEF"/>
                 </a:solidFill>
               </a:rPr>
-              <a:t>Add async so we are allowed to await the slow AI call inside.</a:t>
+              <a:t>A comment: the browser calls this when the form is submitted.</a:t>
             </a:r>
           </a:p>
         </p:txBody>
@@ -6176,6 +6118,14 @@
 <file path=ppt/slides/slide26.xml><?xml version="1.0" encoding="utf-8"?>
 <p:sld xmlns:a="http://schemas.openxmlformats.org/drawingml/2006/main" xmlns:p="http://schemas.openxmlformats.org/presentationml/2006/main" xmlns:r="http://schemas.openxmlformats.org/officeDocument/2006/relationships">
   <p:cSld>
+    <p:bg>
+      <p:bgPr>
+        <a:solidFill>
+          <a:srgbClr val="102127"/>
+        </a:solidFill>
+        <a:effectLst/>
+      </p:bgPr>
+    </p:bg>
     <p:spTree>
       <p:nvGrpSpPr>
         <p:cNvPr id="1" name=""/>
@@ -6185,40 +6135,14 @@
       <p:grpSpPr/>
       <p:sp>
         <p:nvSpPr>
-          <p:cNvPr id="2" name="Title 1"/>
-          <p:cNvSpPr>
-            <a:spLocks noGrp="1"/>
-          </p:cNvSpPr>
-          <p:nvPr>
-            <p:ph type="title"/>
-          </p:nvPr>
-        </p:nvSpPr>
-        <p:spPr/>
-        <p:txBody>
-          <a:bodyPr/>
-          <a:lstStyle/>
-          <a:p>
-            <a:r>
-              <a:rPr sz="3800" b="1">
-                <a:solidFill>
-                  <a:srgbClr val="1F2A37"/>
-                </a:solidFill>
-              </a:rPr>
-              <a:t>.addEventListener()</a:t>
-            </a:r>
-          </a:p>
-        </p:txBody>
-      </p:sp>
-      <p:sp>
-        <p:nvSpPr>
-          <p:cNvPr id="3" name="TextBox 2"/>
+          <p:cNvPr id="2" name="TextBox 1"/>
           <p:cNvSpPr txBox="1"/>
           <p:nvPr/>
         </p:nvSpPr>
         <p:spPr>
           <a:xfrm>
-            <a:off x="868680" y="502920"/>
-            <a:ext cx="5486400" cy="457200"/>
+            <a:off x="502920" y="274320"/>
+            <a:ext cx="11155680" cy="548640"/>
           </a:xfrm>
           <a:prstGeom prst="rect">
             <a:avLst/>
@@ -6232,26 +6156,26 @@
           <a:lstStyle/>
           <a:p>
             <a:r>
-              <a:rPr sz="1500" b="1">
+              <a:rPr sz="2200" b="1">
                 <a:solidFill>
                   <a:srgbClr val="01AEFD"/>
                 </a:solidFill>
               </a:rPr>
-              <a:t>JAVASCRIPT</a:t>
-            </a:r>
-          </a:p>
-        </p:txBody>
-      </p:sp>
-      <p:sp>
-        <p:nvSpPr>
-          <p:cNvPr id="4" name="TextBox 3"/>
+              <a:t>Type this into script.js   -   line 23</a:t>
+            </a:r>
+          </a:p>
+        </p:txBody>
+      </p:sp>
+      <p:sp>
+        <p:nvSpPr>
+          <p:cNvPr id="3" name="TextBox 2"/>
           <p:cNvSpPr txBox="1"/>
           <p:nvPr/>
         </p:nvSpPr>
         <p:spPr>
           <a:xfrm>
-            <a:off x="822960" y="1828800"/>
-            <a:ext cx="10515600" cy="4206240"/>
+            <a:off x="502920" y="960120"/>
+            <a:ext cx="11155680" cy="4297680"/>
           </a:xfrm>
           <a:prstGeom prst="rect">
             <a:avLst/>
@@ -6259,38 +6183,116 @@
           <a:noFill/>
         </p:spPr>
         <p:txBody>
+          <a:bodyPr wrap="none">
+            <a:spAutoFit/>
+          </a:bodyPr>
+          <a:lstStyle/>
+          <a:p>
+            <a:pPr>
+              <a:spcAft>
+                <a:spcPts val="0"/>
+              </a:spcAft>
+            </a:pPr>
+            <a:r>
+              <a:rPr sz="1800">
+                <a:solidFill>
+                  <a:srgbClr val="6D8C97"/>
+                </a:solidFill>
+                <a:latin typeface="Consolas"/>
+              </a:rPr>
+              <a:t>  21  </a:t>
+            </a:r>
+            <a:r>
+              <a:rPr sz="1800">
+                <a:solidFill>
+                  <a:srgbClr val="6D8C97"/>
+                </a:solidFill>
+                <a:latin typeface="Consolas"/>
+              </a:rPr>
+              <a:t> </a:t>
+            </a:r>
+          </a:p>
+          <a:p>
+            <a:pPr>
+              <a:spcAft>
+                <a:spcPts val="0"/>
+              </a:spcAft>
+            </a:pPr>
+            <a:r>
+              <a:rPr sz="1800">
+                <a:solidFill>
+                  <a:srgbClr val="6D8C97"/>
+                </a:solidFill>
+                <a:latin typeface="Consolas"/>
+              </a:rPr>
+              <a:t>  22  </a:t>
+            </a:r>
+            <a:r>
+              <a:rPr sz="1800">
+                <a:solidFill>
+                  <a:srgbClr val="6D8C97"/>
+                </a:solidFill>
+                <a:latin typeface="Consolas"/>
+              </a:rPr>
+              <a:t>// In PixelPad your loop() checked 'was a key pressed?' every frame. Here you</a:t>
+            </a:r>
+          </a:p>
+          <a:p>
+            <a:pPr>
+              <a:spcAft>
+                <a:spcPts val="0"/>
+              </a:spcAft>
+            </a:pPr>
+            <a:r>
+              <a:rPr sz="1800">
+                <a:solidFill>
+                  <a:srgbClr val="6D8C97"/>
+                </a:solidFill>
+                <a:latin typeface="Consolas"/>
+              </a:rPr>
+              <a:t>  23  </a:t>
+            </a:r>
+            <a:r>
+              <a:rPr sz="1800">
+                <a:solidFill>
+                  <a:srgbClr val="7FE0A0"/>
+                </a:solidFill>
+                <a:latin typeface="Consolas"/>
+              </a:rPr>
+              <a:t>// leave a note: when this form is submitted, run this. The browser waits.</a:t>
+            </a:r>
+          </a:p>
+        </p:txBody>
+      </p:sp>
+      <p:sp>
+        <p:nvSpPr>
+          <p:cNvPr id="4" name="TextBox 3"/>
+          <p:cNvSpPr txBox="1"/>
+          <p:nvPr/>
+        </p:nvSpPr>
+        <p:spPr>
+          <a:xfrm>
+            <a:off x="548640" y="5623560"/>
+            <a:ext cx="11064240" cy="1051560"/>
+          </a:xfrm>
+          <a:prstGeom prst="rect">
+            <a:avLst/>
+          </a:prstGeom>
+          <a:noFill/>
+        </p:spPr>
+        <p:txBody>
           <a:bodyPr wrap="square">
             <a:spAutoFit/>
           </a:bodyPr>
           <a:lstStyle/>
           <a:p>
-            <a:pPr>
-              <a:spcAft>
-                <a:spcPts val="1400"/>
-              </a:spcAft>
-            </a:pPr>
-            <a:r>
-              <a:rPr sz="2400">
-                <a:solidFill>
-                  <a:srgbClr val="1F2A37"/>
-                </a:solidFill>
-              </a:rPr>
-              <a:t>• Leaves a note: 'when THIS happens, run THAT'.</a:t>
-            </a:r>
-          </a:p>
-          <a:p>
-            <a:pPr>
-              <a:spcAft>
-                <a:spcPts val="1400"/>
-              </a:spcAft>
-            </a:pPr>
-            <a:r>
-              <a:rPr sz="2400">
-                <a:solidFill>
-                  <a:srgbClr val="1F2A37"/>
-                </a:solidFill>
-              </a:rPr>
-              <a:t>• Like your PixelPad loop watching for a key - but the browser waits and calls you.</a:t>
+            <a:r>
+              <a:rPr sz="2000">
+                <a:solidFill>
+                  <a:srgbClr val="DCECEF"/>
+                </a:solidFill>
+              </a:rPr>
+              <a:t>Add async so we are allowed to await the slow AI call inside.</a:t>
             </a:r>
           </a:p>
         </p:txBody>
@@ -6334,7 +6336,7 @@
                   <a:srgbClr val="1F2A37"/>
                 </a:solidFill>
               </a:rPr>
-              <a:t>event.preventDefault()</a:t>
+              <a:t>.addEventListener()</a:t>
             </a:r>
           </a:p>
         </p:txBody>
@@ -6405,7 +6407,7 @@
                   <a:srgbClr val="1F2A37"/>
                 </a:solidFill>
               </a:rPr>
-              <a:t>• Stops the browser's normal reaction.</a:t>
+              <a:t>• Leaves a note: 'when THIS happens, run THAT'.</a:t>
             </a:r>
           </a:p>
           <a:p>
@@ -6420,7 +6422,7 @@
                   <a:srgbClr val="1F2A37"/>
                 </a:solidFill>
               </a:rPr>
-              <a:t>• Here it stops the page reloading, so we handle the form ourselves.</a:t>
+              <a:t>• Like your PixelPad loop watching for a key - but the browser waits and calls you.</a:t>
             </a:r>
           </a:p>
         </p:txBody>
@@ -6464,7 +6466,7 @@
                   <a:srgbClr val="1F2A37"/>
                 </a:solidFill>
               </a:rPr>
-              <a:t>Reading .value</a:t>
+              <a:t>event.preventDefault()</a:t>
             </a:r>
           </a:p>
         </p:txBody>
@@ -6535,7 +6537,22 @@
                   <a:srgbClr val="1F2A37"/>
                 </a:solidFill>
               </a:rPr>
-              <a:t>• box.value is whatever the student has typed in that input right now.</a:t>
+              <a:t>• Stops the browser's normal reaction.</a:t>
+            </a:r>
+          </a:p>
+          <a:p>
+            <a:pPr>
+              <a:spcAft>
+                <a:spcPts val="1400"/>
+              </a:spcAft>
+            </a:pPr>
+            <a:r>
+              <a:rPr sz="2400">
+                <a:solidFill>
+                  <a:srgbClr val="1F2A37"/>
+                </a:solidFill>
+              </a:rPr>
+              <a:t>• Here it stops the page reloading, so we handle the form ourselves.</a:t>
             </a:r>
           </a:p>
         </p:txBody>
@@ -6579,7 +6596,7 @@
                   <a:srgbClr val="1F2A37"/>
                 </a:solidFill>
               </a:rPr>
-              <a:t>.trim()</a:t>
+              <a:t>Reading .value</a:t>
             </a:r>
           </a:p>
         </p:txBody>
@@ -6650,22 +6667,7 @@
                   <a:srgbClr val="1F2A37"/>
                 </a:solidFill>
               </a:rPr>
-              <a:t>• Removes blank space from the ends of text.</a:t>
-            </a:r>
-          </a:p>
-          <a:p>
-            <a:pPr>
-              <a:spcAft>
-                <a:spcPts val="1400"/>
-              </a:spcAft>
-            </a:pPr>
-            <a:r>
-              <a:rPr sz="2400">
-                <a:solidFill>
-                  <a:srgbClr val="1F2A37"/>
-                </a:solidFill>
-              </a:rPr>
-              <a:t>• ' hi ' becomes 'hi'.</a:t>
+              <a:t>• box.value is whatever the student has typed in that input right now.</a:t>
             </a:r>
           </a:p>
         </p:txBody>
@@ -6836,7 +6838,7 @@
                   <a:srgbClr val="1F2A37"/>
                 </a:solidFill>
               </a:rPr>
-              <a:t>The if statement</a:t>
+              <a:t>.trim()</a:t>
             </a:r>
           </a:p>
         </p:txBody>
@@ -6907,7 +6909,22 @@
                   <a:srgbClr val="1F2A37"/>
                 </a:solidFill>
               </a:rPr>
-              <a:t>• Runs the code in { } only WHEN the test in ( ) is true.</a:t>
+              <a:t>• Removes blank space from the ends of text.</a:t>
+            </a:r>
+          </a:p>
+          <a:p>
+            <a:pPr>
+              <a:spcAft>
+                <a:spcPts val="1400"/>
+              </a:spcAft>
+            </a:pPr>
+            <a:r>
+              <a:rPr sz="2400">
+                <a:solidFill>
+                  <a:srgbClr val="1F2A37"/>
+                </a:solidFill>
+              </a:rPr>
+              <a:t>• ' hi ' becomes 'hi'.</a:t>
             </a:r>
           </a:p>
         </p:txBody>
@@ -6951,7 +6968,7 @@
                   <a:srgbClr val="1F2A37"/>
                 </a:solidFill>
               </a:rPr>
-              <a:t>return</a:t>
+              <a:t>Comparing with ===</a:t>
             </a:r>
           </a:p>
         </p:txBody>
@@ -7022,7 +7039,22 @@
                   <a:srgbClr val="1F2A37"/>
                 </a:solidFill>
               </a:rPr>
-              <a:t>• Stops the function right there. Nothing after it runs.</a:t>
+              <a:t>• === asks 'are these exactly equal?' and gives true or false.</a:t>
+            </a:r>
+          </a:p>
+          <a:p>
+            <a:pPr>
+              <a:spcAft>
+                <a:spcPts val="1400"/>
+              </a:spcAft>
+            </a:pPr>
+            <a:r>
+              <a:rPr sz="2400">
+                <a:solidFill>
+                  <a:srgbClr val="1F2A37"/>
+                </a:solidFill>
+              </a:rPr>
+              <a:t>• One = SETS a value; three === CHECKS a value.</a:t>
             </a:r>
           </a:p>
         </p:txBody>
@@ -7038,14 +7070,6 @@
 <file path=ppt/slides/slide32.xml><?xml version="1.0" encoding="utf-8"?>
 <p:sld xmlns:a="http://schemas.openxmlformats.org/drawingml/2006/main" xmlns:p="http://schemas.openxmlformats.org/presentationml/2006/main" xmlns:r="http://schemas.openxmlformats.org/officeDocument/2006/relationships">
   <p:cSld>
-    <p:bg>
-      <p:bgPr>
-        <a:solidFill>
-          <a:srgbClr val="102127"/>
-        </a:solidFill>
-        <a:effectLst/>
-      </p:bgPr>
-    </p:bg>
     <p:spTree>
       <p:nvGrpSpPr>
         <p:cNvPr id="1" name=""/>
@@ -7055,14 +7079,40 @@
       <p:grpSpPr/>
       <p:sp>
         <p:nvSpPr>
-          <p:cNvPr id="2" name="TextBox 1"/>
+          <p:cNvPr id="2" name="Title 1"/>
+          <p:cNvSpPr>
+            <a:spLocks noGrp="1"/>
+          </p:cNvSpPr>
+          <p:nvPr>
+            <p:ph type="title"/>
+          </p:nvPr>
+        </p:nvSpPr>
+        <p:spPr/>
+        <p:txBody>
+          <a:bodyPr/>
+          <a:lstStyle/>
+          <a:p>
+            <a:r>
+              <a:rPr sz="3800" b="1">
+                <a:solidFill>
+                  <a:srgbClr val="1F2A37"/>
+                </a:solidFill>
+              </a:rPr>
+              <a:t>The if statement</a:t>
+            </a:r>
+          </a:p>
+        </p:txBody>
+      </p:sp>
+      <p:sp>
+        <p:nvSpPr>
+          <p:cNvPr id="3" name="TextBox 2"/>
           <p:cNvSpPr txBox="1"/>
           <p:nvPr/>
         </p:nvSpPr>
         <p:spPr>
           <a:xfrm>
-            <a:off x="502920" y="274320"/>
-            <a:ext cx="11155680" cy="548640"/>
+            <a:off x="868680" y="502920"/>
+            <a:ext cx="5486400" cy="457200"/>
           </a:xfrm>
           <a:prstGeom prst="rect">
             <a:avLst/>
@@ -7076,26 +7126,26 @@
           <a:lstStyle/>
           <a:p>
             <a:r>
-              <a:rPr sz="2200" b="1">
+              <a:rPr sz="1500" b="1">
                 <a:solidFill>
                   <a:srgbClr val="01AEFD"/>
                 </a:solidFill>
               </a:rPr>
-              <a:t>Type this into script.js   -   line 29</a:t>
-            </a:r>
-          </a:p>
-        </p:txBody>
-      </p:sp>
-      <p:sp>
-        <p:nvSpPr>
-          <p:cNvPr id="3" name="TextBox 2"/>
+              <a:t>JAVASCRIPT</a:t>
+            </a:r>
+          </a:p>
+        </p:txBody>
+      </p:sp>
+      <p:sp>
+        <p:nvSpPr>
+          <p:cNvPr id="4" name="TextBox 3"/>
           <p:cNvSpPr txBox="1"/>
           <p:nvPr/>
         </p:nvSpPr>
         <p:spPr>
           <a:xfrm>
-            <a:off x="502920" y="960120"/>
-            <a:ext cx="11155680" cy="4297680"/>
+            <a:off x="822960" y="1828800"/>
+            <a:ext cx="10515600" cy="4206240"/>
           </a:xfrm>
           <a:prstGeom prst="rect">
             <a:avLst/>
@@ -7103,266 +7153,23 @@
           <a:noFill/>
         </p:spPr>
         <p:txBody>
-          <a:bodyPr wrap="none">
-            <a:spAutoFit/>
-          </a:bodyPr>
-          <a:lstStyle/>
-          <a:p>
-            <a:pPr>
-              <a:spcAft>
-                <a:spcPts val="0"/>
-              </a:spcAft>
-            </a:pPr>
-            <a:r>
-              <a:rPr sz="1800">
-                <a:solidFill>
-                  <a:srgbClr val="6D8C97"/>
-                </a:solidFill>
-                <a:latin typeface="Consolas"/>
-              </a:rPr>
-              <a:t>  21  </a:t>
-            </a:r>
-            <a:r>
-              <a:rPr sz="1800">
-                <a:solidFill>
-                  <a:srgbClr val="6D8C97"/>
-                </a:solidFill>
-                <a:latin typeface="Consolas"/>
-              </a:rPr>
-              <a:t> </a:t>
-            </a:r>
-          </a:p>
-          <a:p>
-            <a:pPr>
-              <a:spcAft>
-                <a:spcPts val="0"/>
-              </a:spcAft>
-            </a:pPr>
-            <a:r>
-              <a:rPr sz="1800">
-                <a:solidFill>
-                  <a:srgbClr val="6D8C97"/>
-                </a:solidFill>
-                <a:latin typeface="Consolas"/>
-              </a:rPr>
-              <a:t>  22  </a:t>
-            </a:r>
-            <a:r>
-              <a:rPr sz="1800">
-                <a:solidFill>
-                  <a:srgbClr val="6D8C97"/>
-                </a:solidFill>
-                <a:latin typeface="Consolas"/>
-              </a:rPr>
-              <a:t>// In PixelPad your loop() checked 'was a key pressed?' every frame. Here you</a:t>
-            </a:r>
-          </a:p>
-          <a:p>
-            <a:pPr>
-              <a:spcAft>
-                <a:spcPts val="0"/>
-              </a:spcAft>
-            </a:pPr>
-            <a:r>
-              <a:rPr sz="1800">
-                <a:solidFill>
-                  <a:srgbClr val="6D8C97"/>
-                </a:solidFill>
-                <a:latin typeface="Consolas"/>
-              </a:rPr>
-              <a:t>  23  </a:t>
-            </a:r>
-            <a:r>
-              <a:rPr sz="1800">
-                <a:solidFill>
-                  <a:srgbClr val="6D8C97"/>
-                </a:solidFill>
-                <a:latin typeface="Consolas"/>
-              </a:rPr>
-              <a:t>// leave a note: when this form is submitted, run this. The browser waits.</a:t>
-            </a:r>
-          </a:p>
-          <a:p>
-            <a:pPr>
-              <a:spcAft>
-                <a:spcPts val="0"/>
-              </a:spcAft>
-            </a:pPr>
-            <a:r>
-              <a:rPr sz="1800">
-                <a:solidFill>
-                  <a:srgbClr val="6D8C97"/>
-                </a:solidFill>
-                <a:latin typeface="Consolas"/>
-              </a:rPr>
-              <a:t>  24  </a:t>
-            </a:r>
-            <a:r>
-              <a:rPr sz="1800">
-                <a:solidFill>
-                  <a:srgbClr val="6D8C97"/>
-                </a:solidFill>
-                <a:latin typeface="Consolas"/>
-              </a:rPr>
-              <a:t>composer.addEventListener('submit', function (event) {</a:t>
-            </a:r>
-          </a:p>
-          <a:p>
-            <a:pPr>
-              <a:spcAft>
-                <a:spcPts val="0"/>
-              </a:spcAft>
-            </a:pPr>
-            <a:r>
-              <a:rPr sz="1800">
-                <a:solidFill>
-                  <a:srgbClr val="6D8C97"/>
-                </a:solidFill>
-                <a:latin typeface="Consolas"/>
-              </a:rPr>
-              <a:t>  25  </a:t>
-            </a:r>
-            <a:r>
-              <a:rPr sz="1800">
-                <a:solidFill>
-                  <a:srgbClr val="6D8C97"/>
-                </a:solidFill>
-                <a:latin typeface="Consolas"/>
-              </a:rPr>
-              <a:t>  event.preventDefault();          // stop the browser reloading the page</a:t>
-            </a:r>
-          </a:p>
-          <a:p>
-            <a:pPr>
-              <a:spcAft>
-                <a:spcPts val="0"/>
-              </a:spcAft>
-            </a:pPr>
-            <a:r>
-              <a:rPr sz="1800">
-                <a:solidFill>
-                  <a:srgbClr val="6D8C97"/>
-                </a:solidFill>
-                <a:latin typeface="Consolas"/>
-              </a:rPr>
-              <a:t>  26  </a:t>
-            </a:r>
-            <a:r>
-              <a:rPr sz="1800">
-                <a:solidFill>
-                  <a:srgbClr val="6D8C97"/>
-                </a:solidFill>
-                <a:latin typeface="Consolas"/>
-              </a:rPr>
-              <a:t>  const text = promptBox.value.trim();</a:t>
-            </a:r>
-          </a:p>
-          <a:p>
-            <a:pPr>
-              <a:spcAft>
-                <a:spcPts val="0"/>
-              </a:spcAft>
-            </a:pPr>
-            <a:r>
-              <a:rPr sz="1800">
-                <a:solidFill>
-                  <a:srgbClr val="6D8C97"/>
-                </a:solidFill>
-                <a:latin typeface="Consolas"/>
-              </a:rPr>
-              <a:t>  27  </a:t>
-            </a:r>
-            <a:r>
-              <a:rPr sz="1800">
-                <a:solidFill>
-                  <a:srgbClr val="6D8C97"/>
-                </a:solidFill>
-                <a:latin typeface="Consolas"/>
-              </a:rPr>
-              <a:t>  if (text === '') { return; }     // nothing typed, nothing to do</a:t>
-            </a:r>
-          </a:p>
-          <a:p>
-            <a:pPr>
-              <a:spcAft>
-                <a:spcPts val="0"/>
-              </a:spcAft>
-            </a:pPr>
-            <a:r>
-              <a:rPr sz="1800">
-                <a:solidFill>
-                  <a:srgbClr val="6D8C97"/>
-                </a:solidFill>
-                <a:latin typeface="Consolas"/>
-              </a:rPr>
-              <a:t>  28  </a:t>
-            </a:r>
-            <a:r>
-              <a:rPr sz="1800">
-                <a:solidFill>
-                  <a:srgbClr val="6D8C97"/>
-                </a:solidFill>
-                <a:latin typeface="Consolas"/>
-              </a:rPr>
-              <a:t>  promptBox.value = '';            // clear the box, ready for the next one</a:t>
-            </a:r>
-          </a:p>
-          <a:p>
-            <a:pPr>
-              <a:spcAft>
-                <a:spcPts val="0"/>
-              </a:spcAft>
-            </a:pPr>
-            <a:r>
-              <a:rPr sz="1800">
-                <a:solidFill>
-                  <a:srgbClr val="6D8C97"/>
-                </a:solidFill>
-                <a:latin typeface="Consolas"/>
-              </a:rPr>
-              <a:t>  29  </a:t>
-            </a:r>
-            <a:r>
-              <a:rPr sz="1800">
-                <a:solidFill>
-                  <a:srgbClr val="7FE0A0"/>
-                </a:solidFill>
-                <a:latin typeface="Consolas"/>
-              </a:rPr>
-              <a:t>  addLine('You', text);</a:t>
-            </a:r>
-          </a:p>
-        </p:txBody>
-      </p:sp>
-      <p:sp>
-        <p:nvSpPr>
-          <p:cNvPr id="4" name="TextBox 3"/>
-          <p:cNvSpPr txBox="1"/>
-          <p:nvPr/>
-        </p:nvSpPr>
-        <p:spPr>
-          <a:xfrm>
-            <a:off x="548640" y="5623560"/>
-            <a:ext cx="11064240" cy="1051560"/>
-          </a:xfrm>
-          <a:prstGeom prst="rect">
-            <a:avLst/>
-          </a:prstGeom>
-          <a:noFill/>
-        </p:spPr>
-        <p:txBody>
           <a:bodyPr wrap="square">
             <a:spAutoFit/>
           </a:bodyPr>
           <a:lstStyle/>
           <a:p>
-            <a:r>
-              <a:rPr sz="2000">
-                <a:solidFill>
-                  <a:srgbClr val="DCECEF"/>
-                </a:solidFill>
-              </a:rPr>
-              <a:t>Change the pretend reply to a 'thinking...' line while we wait.</a:t>
+            <a:pPr>
+              <a:spcAft>
+                <a:spcPts val="1400"/>
+              </a:spcAft>
+            </a:pPr>
+            <a:r>
+              <a:rPr sz="2400">
+                <a:solidFill>
+                  <a:srgbClr val="1F2A37"/>
+                </a:solidFill>
+              </a:rPr>
+              <a:t>• Runs the code in { } only WHEN the test in ( ) is true.</a:t>
             </a:r>
           </a:p>
         </p:txBody>
@@ -7378,14 +7185,6 @@
 <file path=ppt/slides/slide33.xml><?xml version="1.0" encoding="utf-8"?>
 <p:sld xmlns:a="http://schemas.openxmlformats.org/drawingml/2006/main" xmlns:p="http://schemas.openxmlformats.org/presentationml/2006/main" xmlns:r="http://schemas.openxmlformats.org/officeDocument/2006/relationships">
   <p:cSld>
-    <p:bg>
-      <p:bgPr>
-        <a:solidFill>
-          <a:srgbClr val="102127"/>
-        </a:solidFill>
-        <a:effectLst/>
-      </p:bgPr>
-    </p:bg>
     <p:spTree>
       <p:nvGrpSpPr>
         <p:cNvPr id="1" name=""/>
@@ -7395,14 +7194,40 @@
       <p:grpSpPr/>
       <p:sp>
         <p:nvSpPr>
-          <p:cNvPr id="2" name="TextBox 1"/>
+          <p:cNvPr id="2" name="Title 1"/>
+          <p:cNvSpPr>
+            <a:spLocks noGrp="1"/>
+          </p:cNvSpPr>
+          <p:nvPr>
+            <p:ph type="title"/>
+          </p:nvPr>
+        </p:nvSpPr>
+        <p:spPr/>
+        <p:txBody>
+          <a:bodyPr/>
+          <a:lstStyle/>
+          <a:p>
+            <a:r>
+              <a:rPr sz="3800" b="1">
+                <a:solidFill>
+                  <a:srgbClr val="1F2A37"/>
+                </a:solidFill>
+              </a:rPr>
+              <a:t>return</a:t>
+            </a:r>
+          </a:p>
+        </p:txBody>
+      </p:sp>
+      <p:sp>
+        <p:nvSpPr>
+          <p:cNvPr id="3" name="TextBox 2"/>
           <p:cNvSpPr txBox="1"/>
           <p:nvPr/>
         </p:nvSpPr>
         <p:spPr>
           <a:xfrm>
-            <a:off x="502920" y="274320"/>
-            <a:ext cx="11155680" cy="548640"/>
+            <a:off x="868680" y="502920"/>
+            <a:ext cx="5486400" cy="457200"/>
           </a:xfrm>
           <a:prstGeom prst="rect">
             <a:avLst/>
@@ -7416,26 +7241,26 @@
           <a:lstStyle/>
           <a:p>
             <a:r>
-              <a:rPr sz="2200" b="1">
+              <a:rPr sz="1500" b="1">
                 <a:solidFill>
                   <a:srgbClr val="01AEFD"/>
                 </a:solidFill>
               </a:rPr>
-              <a:t>Type this into script.js   -   line 30</a:t>
-            </a:r>
-          </a:p>
-        </p:txBody>
-      </p:sp>
-      <p:sp>
-        <p:nvSpPr>
-          <p:cNvPr id="3" name="TextBox 2"/>
+              <a:t>JAVASCRIPT</a:t>
+            </a:r>
+          </a:p>
+        </p:txBody>
+      </p:sp>
+      <p:sp>
+        <p:nvSpPr>
+          <p:cNvPr id="4" name="TextBox 3"/>
           <p:cNvSpPr txBox="1"/>
           <p:nvPr/>
         </p:nvSpPr>
         <p:spPr>
           <a:xfrm>
-            <a:off x="502920" y="960120"/>
-            <a:ext cx="11155680" cy="4297680"/>
+            <a:off x="822960" y="1828800"/>
+            <a:ext cx="10515600" cy="4206240"/>
           </a:xfrm>
           <a:prstGeom prst="rect">
             <a:avLst/>
@@ -7443,291 +7268,23 @@
           <a:noFill/>
         </p:spPr>
         <p:txBody>
-          <a:bodyPr wrap="none">
-            <a:spAutoFit/>
-          </a:bodyPr>
-          <a:lstStyle/>
-          <a:p>
-            <a:pPr>
-              <a:spcAft>
-                <a:spcPts val="0"/>
-              </a:spcAft>
-            </a:pPr>
-            <a:r>
-              <a:rPr sz="1800">
-                <a:solidFill>
-                  <a:srgbClr val="6D8C97"/>
-                </a:solidFill>
-                <a:latin typeface="Consolas"/>
-              </a:rPr>
-              <a:t>  21  </a:t>
-            </a:r>
-            <a:r>
-              <a:rPr sz="1800">
-                <a:solidFill>
-                  <a:srgbClr val="6D8C97"/>
-                </a:solidFill>
-                <a:latin typeface="Consolas"/>
-              </a:rPr>
-              <a:t> </a:t>
-            </a:r>
-          </a:p>
-          <a:p>
-            <a:pPr>
-              <a:spcAft>
-                <a:spcPts val="0"/>
-              </a:spcAft>
-            </a:pPr>
-            <a:r>
-              <a:rPr sz="1800">
-                <a:solidFill>
-                  <a:srgbClr val="6D8C97"/>
-                </a:solidFill>
-                <a:latin typeface="Consolas"/>
-              </a:rPr>
-              <a:t>  22  </a:t>
-            </a:r>
-            <a:r>
-              <a:rPr sz="1800">
-                <a:solidFill>
-                  <a:srgbClr val="6D8C97"/>
-                </a:solidFill>
-                <a:latin typeface="Consolas"/>
-              </a:rPr>
-              <a:t>// In PixelPad your loop() checked 'was a key pressed?' every frame. Here you</a:t>
-            </a:r>
-          </a:p>
-          <a:p>
-            <a:pPr>
-              <a:spcAft>
-                <a:spcPts val="0"/>
-              </a:spcAft>
-            </a:pPr>
-            <a:r>
-              <a:rPr sz="1800">
-                <a:solidFill>
-                  <a:srgbClr val="6D8C97"/>
-                </a:solidFill>
-                <a:latin typeface="Consolas"/>
-              </a:rPr>
-              <a:t>  23  </a:t>
-            </a:r>
-            <a:r>
-              <a:rPr sz="1800">
-                <a:solidFill>
-                  <a:srgbClr val="6D8C97"/>
-                </a:solidFill>
-                <a:latin typeface="Consolas"/>
-              </a:rPr>
-              <a:t>// leave a note: when this form is submitted, run this. The browser waits.</a:t>
-            </a:r>
-          </a:p>
-          <a:p>
-            <a:pPr>
-              <a:spcAft>
-                <a:spcPts val="0"/>
-              </a:spcAft>
-            </a:pPr>
-            <a:r>
-              <a:rPr sz="1800">
-                <a:solidFill>
-                  <a:srgbClr val="6D8C97"/>
-                </a:solidFill>
-                <a:latin typeface="Consolas"/>
-              </a:rPr>
-              <a:t>  24  </a:t>
-            </a:r>
-            <a:r>
-              <a:rPr sz="1800">
-                <a:solidFill>
-                  <a:srgbClr val="6D8C97"/>
-                </a:solidFill>
-                <a:latin typeface="Consolas"/>
-              </a:rPr>
-              <a:t>composer.addEventListener('submit', function (event) {</a:t>
-            </a:r>
-          </a:p>
-          <a:p>
-            <a:pPr>
-              <a:spcAft>
-                <a:spcPts val="0"/>
-              </a:spcAft>
-            </a:pPr>
-            <a:r>
-              <a:rPr sz="1800">
-                <a:solidFill>
-                  <a:srgbClr val="6D8C97"/>
-                </a:solidFill>
-                <a:latin typeface="Consolas"/>
-              </a:rPr>
-              <a:t>  25  </a:t>
-            </a:r>
-            <a:r>
-              <a:rPr sz="1800">
-                <a:solidFill>
-                  <a:srgbClr val="6D8C97"/>
-                </a:solidFill>
-                <a:latin typeface="Consolas"/>
-              </a:rPr>
-              <a:t>  event.preventDefault();          // stop the browser reloading the page</a:t>
-            </a:r>
-          </a:p>
-          <a:p>
-            <a:pPr>
-              <a:spcAft>
-                <a:spcPts val="0"/>
-              </a:spcAft>
-            </a:pPr>
-            <a:r>
-              <a:rPr sz="1800">
-                <a:solidFill>
-                  <a:srgbClr val="6D8C97"/>
-                </a:solidFill>
-                <a:latin typeface="Consolas"/>
-              </a:rPr>
-              <a:t>  26  </a:t>
-            </a:r>
-            <a:r>
-              <a:rPr sz="1800">
-                <a:solidFill>
-                  <a:srgbClr val="6D8C97"/>
-                </a:solidFill>
-                <a:latin typeface="Consolas"/>
-              </a:rPr>
-              <a:t>  const text = promptBox.value.trim();</a:t>
-            </a:r>
-          </a:p>
-          <a:p>
-            <a:pPr>
-              <a:spcAft>
-                <a:spcPts val="0"/>
-              </a:spcAft>
-            </a:pPr>
-            <a:r>
-              <a:rPr sz="1800">
-                <a:solidFill>
-                  <a:srgbClr val="6D8C97"/>
-                </a:solidFill>
-                <a:latin typeface="Consolas"/>
-              </a:rPr>
-              <a:t>  27  </a:t>
-            </a:r>
-            <a:r>
-              <a:rPr sz="1800">
-                <a:solidFill>
-                  <a:srgbClr val="6D8C97"/>
-                </a:solidFill>
-                <a:latin typeface="Consolas"/>
-              </a:rPr>
-              <a:t>  if (text === '') { return; }     // nothing typed, nothing to do</a:t>
-            </a:r>
-          </a:p>
-          <a:p>
-            <a:pPr>
-              <a:spcAft>
-                <a:spcPts val="0"/>
-              </a:spcAft>
-            </a:pPr>
-            <a:r>
-              <a:rPr sz="1800">
-                <a:solidFill>
-                  <a:srgbClr val="6D8C97"/>
-                </a:solidFill>
-                <a:latin typeface="Consolas"/>
-              </a:rPr>
-              <a:t>  28  </a:t>
-            </a:r>
-            <a:r>
-              <a:rPr sz="1800">
-                <a:solidFill>
-                  <a:srgbClr val="6D8C97"/>
-                </a:solidFill>
-                <a:latin typeface="Consolas"/>
-              </a:rPr>
-              <a:t>  promptBox.value = '';            // clear the box, ready for the next one</a:t>
-            </a:r>
-          </a:p>
-          <a:p>
-            <a:pPr>
-              <a:spcAft>
-                <a:spcPts val="0"/>
-              </a:spcAft>
-            </a:pPr>
-            <a:r>
-              <a:rPr sz="1800">
-                <a:solidFill>
-                  <a:srgbClr val="6D8C97"/>
-                </a:solidFill>
-                <a:latin typeface="Consolas"/>
-              </a:rPr>
-              <a:t>  29  </a:t>
-            </a:r>
-            <a:r>
-              <a:rPr sz="1800">
-                <a:solidFill>
-                  <a:srgbClr val="6D8C97"/>
-                </a:solidFill>
-                <a:latin typeface="Consolas"/>
-              </a:rPr>
-              <a:t>  addLine('You', text);</a:t>
-            </a:r>
-          </a:p>
-          <a:p>
-            <a:pPr>
-              <a:spcAft>
-                <a:spcPts val="0"/>
-              </a:spcAft>
-            </a:pPr>
-            <a:r>
-              <a:rPr sz="1800">
-                <a:solidFill>
-                  <a:srgbClr val="6D8C97"/>
-                </a:solidFill>
-                <a:latin typeface="Consolas"/>
-              </a:rPr>
-              <a:t>  30  </a:t>
-            </a:r>
-            <a:r>
-              <a:rPr sz="1800">
-                <a:solidFill>
-                  <a:srgbClr val="7FE0A0"/>
-                </a:solidFill>
-                <a:latin typeface="Consolas"/>
-              </a:rPr>
-              <a:t>  addLine('Companion', 'You said: ' + text);   // a pretend answer, for now</a:t>
-            </a:r>
-          </a:p>
-        </p:txBody>
-      </p:sp>
-      <p:sp>
-        <p:nvSpPr>
-          <p:cNvPr id="4" name="TextBox 3"/>
-          <p:cNvSpPr txBox="1"/>
-          <p:nvPr/>
-        </p:nvSpPr>
-        <p:spPr>
-          <a:xfrm>
-            <a:off x="548640" y="5623560"/>
-            <a:ext cx="11064240" cy="1051560"/>
-          </a:xfrm>
-          <a:prstGeom prst="rect">
-            <a:avLst/>
-          </a:prstGeom>
-          <a:noFill/>
-        </p:spPr>
-        <p:txBody>
           <a:bodyPr wrap="square">
             <a:spAutoFit/>
           </a:bodyPr>
           <a:lstStyle/>
           <a:p>
-            <a:r>
-              <a:rPr sz="2000">
-                <a:solidFill>
-                  <a:srgbClr val="DCECEF"/>
-                </a:solidFill>
-              </a:rPr>
-              <a:t>await askAI(text): the slow bit - ask the AI and wait for the answer.</a:t>
+            <a:pPr>
+              <a:spcAft>
+                <a:spcPts val="1400"/>
+              </a:spcAft>
+            </a:pPr>
+            <a:r>
+              <a:rPr sz="2400">
+                <a:solidFill>
+                  <a:srgbClr val="1F2A37"/>
+                </a:solidFill>
+              </a:rPr>
+              <a:t>• Stops the function right there. Nothing after it runs.</a:t>
             </a:r>
           </a:p>
         </p:txBody>
@@ -7786,7 +7343,7 @@
                   <a:srgbClr val="01AEFD"/>
                 </a:solidFill>
               </a:rPr>
-              <a:t>Type this into script.js   -   line 31</a:t>
+              <a:t>Type this into script.js   -   line 29</a:t>
             </a:r>
           </a:p>
         </p:txBody>
@@ -7819,7 +7376,7 @@
               </a:spcAft>
             </a:pPr>
             <a:r>
-              <a:rPr sz="1300">
+              <a:rPr sz="1800">
                 <a:solidFill>
                   <a:srgbClr val="6D8C97"/>
                 </a:solidFill>
@@ -7828,7 +7385,7 @@
               <a:t>  21  </a:t>
             </a:r>
             <a:r>
-              <a:rPr sz="1300">
+              <a:rPr sz="1800">
                 <a:solidFill>
                   <a:srgbClr val="6D8C97"/>
                 </a:solidFill>
@@ -7844,7 +7401,7 @@
               </a:spcAft>
             </a:pPr>
             <a:r>
-              <a:rPr sz="1300">
+              <a:rPr sz="1800">
                 <a:solidFill>
                   <a:srgbClr val="6D8C97"/>
                 </a:solidFill>
@@ -7853,7 +7410,7 @@
               <a:t>  22  </a:t>
             </a:r>
             <a:r>
-              <a:rPr sz="1300">
+              <a:rPr sz="1800">
                 <a:solidFill>
                   <a:srgbClr val="6D8C97"/>
                 </a:solidFill>
@@ -7869,7 +7426,7 @@
               </a:spcAft>
             </a:pPr>
             <a:r>
-              <a:rPr sz="1300">
+              <a:rPr sz="1800">
                 <a:solidFill>
                   <a:srgbClr val="6D8C97"/>
                 </a:solidFill>
@@ -7878,7 +7435,7 @@
               <a:t>  23  </a:t>
             </a:r>
             <a:r>
-              <a:rPr sz="1300">
+              <a:rPr sz="1800">
                 <a:solidFill>
                   <a:srgbClr val="6D8C97"/>
                 </a:solidFill>
@@ -7894,7 +7451,7 @@
               </a:spcAft>
             </a:pPr>
             <a:r>
-              <a:rPr sz="1300">
+              <a:rPr sz="1800">
                 <a:solidFill>
                   <a:srgbClr val="6D8C97"/>
                 </a:solidFill>
@@ -7903,7 +7460,7 @@
               <a:t>  24  </a:t>
             </a:r>
             <a:r>
-              <a:rPr sz="1300">
+              <a:rPr sz="1800">
                 <a:solidFill>
                   <a:srgbClr val="6D8C97"/>
                 </a:solidFill>
@@ -7919,7 +7476,7 @@
               </a:spcAft>
             </a:pPr>
             <a:r>
-              <a:rPr sz="1300">
+              <a:rPr sz="1800">
                 <a:solidFill>
                   <a:srgbClr val="6D8C97"/>
                 </a:solidFill>
@@ -7928,7 +7485,7 @@
               <a:t>  25  </a:t>
             </a:r>
             <a:r>
-              <a:rPr sz="1300">
+              <a:rPr sz="1800">
                 <a:solidFill>
                   <a:srgbClr val="6D8C97"/>
                 </a:solidFill>
@@ -7944,7 +7501,7 @@
               </a:spcAft>
             </a:pPr>
             <a:r>
-              <a:rPr sz="1300">
+              <a:rPr sz="1800">
                 <a:solidFill>
                   <a:srgbClr val="6D8C97"/>
                 </a:solidFill>
@@ -7953,7 +7510,7 @@
               <a:t>  26  </a:t>
             </a:r>
             <a:r>
-              <a:rPr sz="1300">
+              <a:rPr sz="1800">
                 <a:solidFill>
                   <a:srgbClr val="6D8C97"/>
                 </a:solidFill>
@@ -7969,7 +7526,7 @@
               </a:spcAft>
             </a:pPr>
             <a:r>
-              <a:rPr sz="1300">
+              <a:rPr sz="1800">
                 <a:solidFill>
                   <a:srgbClr val="6D8C97"/>
                 </a:solidFill>
@@ -7978,7 +7535,7 @@
               <a:t>  27  </a:t>
             </a:r>
             <a:r>
-              <a:rPr sz="1300">
+              <a:rPr sz="1800">
                 <a:solidFill>
                   <a:srgbClr val="6D8C97"/>
                 </a:solidFill>
@@ -7994,7 +7551,7 @@
               </a:spcAft>
             </a:pPr>
             <a:r>
-              <a:rPr sz="1300">
+              <a:rPr sz="1800">
                 <a:solidFill>
                   <a:srgbClr val="6D8C97"/>
                 </a:solidFill>
@@ -8003,7 +7560,7 @@
               <a:t>  28  </a:t>
             </a:r>
             <a:r>
-              <a:rPr sz="1300">
+              <a:rPr sz="1800">
                 <a:solidFill>
                   <a:srgbClr val="6D8C97"/>
                 </a:solidFill>
@@ -8019,7 +7576,7 @@
               </a:spcAft>
             </a:pPr>
             <a:r>
-              <a:rPr sz="1300">
+              <a:rPr sz="1800">
                 <a:solidFill>
                   <a:srgbClr val="6D8C97"/>
                 </a:solidFill>
@@ -8028,63 +7585,13 @@
               <a:t>  29  </a:t>
             </a:r>
             <a:r>
-              <a:rPr sz="1300">
-                <a:solidFill>
-                  <a:srgbClr val="6D8C97"/>
+              <a:rPr sz="1800">
+                <a:solidFill>
+                  <a:srgbClr val="7FE0A0"/>
                 </a:solidFill>
                 <a:latin typeface="Consolas"/>
               </a:rPr>
               <a:t>  addLine('You', text);</a:t>
-            </a:r>
-          </a:p>
-          <a:p>
-            <a:pPr>
-              <a:spcAft>
-                <a:spcPts val="0"/>
-              </a:spcAft>
-            </a:pPr>
-            <a:r>
-              <a:rPr sz="1300">
-                <a:solidFill>
-                  <a:srgbClr val="6D8C97"/>
-                </a:solidFill>
-                <a:latin typeface="Consolas"/>
-              </a:rPr>
-              <a:t>  30  </a:t>
-            </a:r>
-            <a:r>
-              <a:rPr sz="1300">
-                <a:solidFill>
-                  <a:srgbClr val="6D8C97"/>
-                </a:solidFill>
-                <a:latin typeface="Consolas"/>
-              </a:rPr>
-              <a:t>  addLine('Companion', 'You said: ' + text);   // a pretend answer, for now</a:t>
-            </a:r>
-          </a:p>
-          <a:p>
-            <a:pPr>
-              <a:spcAft>
-                <a:spcPts val="0"/>
-              </a:spcAft>
-            </a:pPr>
-            <a:r>
-              <a:rPr sz="1300">
-                <a:solidFill>
-                  <a:srgbClr val="6D8C97"/>
-                </a:solidFill>
-                <a:latin typeface="Consolas"/>
-              </a:rPr>
-              <a:t>  31  </a:t>
-            </a:r>
-            <a:r>
-              <a:rPr sz="1300">
-                <a:solidFill>
-                  <a:srgbClr val="7FE0A0"/>
-                </a:solidFill>
-                <a:latin typeface="Consolas"/>
-              </a:rPr>
-              <a:t>});</a:t>
             </a:r>
           </a:p>
         </p:txBody>
@@ -8117,7 +7624,7 @@
                   <a:srgbClr val="DCECEF"/>
                 </a:solidFill>
               </a:rPr>
-              <a:t>Remove the 'thinking...' line now the real answer is here.</a:t>
+              <a:t>Change the pretend reply to a 'thinking...' line while we wait.</a:t>
             </a:r>
           </a:p>
         </p:txBody>
@@ -8176,7 +7683,7 @@
                   <a:srgbClr val="01AEFD"/>
                 </a:solidFill>
               </a:rPr>
-              <a:t>All together in script.js</a:t>
+              <a:t>Type this into script.js   -   line 30</a:t>
             </a:r>
           </a:p>
         </p:txBody>
@@ -8209,7 +7716,7 @@
               </a:spcAft>
             </a:pPr>
             <a:r>
-              <a:rPr sz="1300">
+              <a:rPr sz="1800">
                 <a:solidFill>
                   <a:srgbClr val="6D8C97"/>
                 </a:solidFill>
@@ -8218,263 +7725,238 @@
               <a:t>  21  </a:t>
             </a:r>
             <a:r>
-              <a:rPr sz="1300">
+              <a:rPr sz="1800">
+                <a:solidFill>
+                  <a:srgbClr val="6D8C97"/>
+                </a:solidFill>
+                <a:latin typeface="Consolas"/>
+              </a:rPr>
+              <a:t> </a:t>
+            </a:r>
+          </a:p>
+          <a:p>
+            <a:pPr>
+              <a:spcAft>
+                <a:spcPts val="0"/>
+              </a:spcAft>
+            </a:pPr>
+            <a:r>
+              <a:rPr sz="1800">
+                <a:solidFill>
+                  <a:srgbClr val="6D8C97"/>
+                </a:solidFill>
+                <a:latin typeface="Consolas"/>
+              </a:rPr>
+              <a:t>  22  </a:t>
+            </a:r>
+            <a:r>
+              <a:rPr sz="1800">
+                <a:solidFill>
+                  <a:srgbClr val="6D8C97"/>
+                </a:solidFill>
+                <a:latin typeface="Consolas"/>
+              </a:rPr>
+              <a:t>// In PixelPad your loop() checked 'was a key pressed?' every frame. Here you</a:t>
+            </a:r>
+          </a:p>
+          <a:p>
+            <a:pPr>
+              <a:spcAft>
+                <a:spcPts val="0"/>
+              </a:spcAft>
+            </a:pPr>
+            <a:r>
+              <a:rPr sz="1800">
+                <a:solidFill>
+                  <a:srgbClr val="6D8C97"/>
+                </a:solidFill>
+                <a:latin typeface="Consolas"/>
+              </a:rPr>
+              <a:t>  23  </a:t>
+            </a:r>
+            <a:r>
+              <a:rPr sz="1800">
+                <a:solidFill>
+                  <a:srgbClr val="6D8C97"/>
+                </a:solidFill>
+                <a:latin typeface="Consolas"/>
+              </a:rPr>
+              <a:t>// leave a note: when this form is submitted, run this. The browser waits.</a:t>
+            </a:r>
+          </a:p>
+          <a:p>
+            <a:pPr>
+              <a:spcAft>
+                <a:spcPts val="0"/>
+              </a:spcAft>
+            </a:pPr>
+            <a:r>
+              <a:rPr sz="1800">
+                <a:solidFill>
+                  <a:srgbClr val="6D8C97"/>
+                </a:solidFill>
+                <a:latin typeface="Consolas"/>
+              </a:rPr>
+              <a:t>  24  </a:t>
+            </a:r>
+            <a:r>
+              <a:rPr sz="1800">
+                <a:solidFill>
+                  <a:srgbClr val="6D8C97"/>
+                </a:solidFill>
+                <a:latin typeface="Consolas"/>
+              </a:rPr>
+              <a:t>composer.addEventListener('submit', function (event) {</a:t>
+            </a:r>
+          </a:p>
+          <a:p>
+            <a:pPr>
+              <a:spcAft>
+                <a:spcPts val="0"/>
+              </a:spcAft>
+            </a:pPr>
+            <a:r>
+              <a:rPr sz="1800">
+                <a:solidFill>
+                  <a:srgbClr val="6D8C97"/>
+                </a:solidFill>
+                <a:latin typeface="Consolas"/>
+              </a:rPr>
+              <a:t>  25  </a:t>
+            </a:r>
+            <a:r>
+              <a:rPr sz="1800">
+                <a:solidFill>
+                  <a:srgbClr val="6D8C97"/>
+                </a:solidFill>
+                <a:latin typeface="Consolas"/>
+              </a:rPr>
+              <a:t>  event.preventDefault();          // stop the browser reloading the page</a:t>
+            </a:r>
+          </a:p>
+          <a:p>
+            <a:pPr>
+              <a:spcAft>
+                <a:spcPts val="0"/>
+              </a:spcAft>
+            </a:pPr>
+            <a:r>
+              <a:rPr sz="1800">
+                <a:solidFill>
+                  <a:srgbClr val="6D8C97"/>
+                </a:solidFill>
+                <a:latin typeface="Consolas"/>
+              </a:rPr>
+              <a:t>  26  </a:t>
+            </a:r>
+            <a:r>
+              <a:rPr sz="1800">
+                <a:solidFill>
+                  <a:srgbClr val="6D8C97"/>
+                </a:solidFill>
+                <a:latin typeface="Consolas"/>
+              </a:rPr>
+              <a:t>  const text = promptBox.value.trim();</a:t>
+            </a:r>
+          </a:p>
+          <a:p>
+            <a:pPr>
+              <a:spcAft>
+                <a:spcPts val="0"/>
+              </a:spcAft>
+            </a:pPr>
+            <a:r>
+              <a:rPr sz="1800">
+                <a:solidFill>
+                  <a:srgbClr val="6D8C97"/>
+                </a:solidFill>
+                <a:latin typeface="Consolas"/>
+              </a:rPr>
+              <a:t>  27  </a:t>
+            </a:r>
+            <a:r>
+              <a:rPr sz="1800">
+                <a:solidFill>
+                  <a:srgbClr val="6D8C97"/>
+                </a:solidFill>
+                <a:latin typeface="Consolas"/>
+              </a:rPr>
+              <a:t>  if (text === '') { return; }     // nothing typed, nothing to do</a:t>
+            </a:r>
+          </a:p>
+          <a:p>
+            <a:pPr>
+              <a:spcAft>
+                <a:spcPts val="0"/>
+              </a:spcAft>
+            </a:pPr>
+            <a:r>
+              <a:rPr sz="1800">
+                <a:solidFill>
+                  <a:srgbClr val="6D8C97"/>
+                </a:solidFill>
+                <a:latin typeface="Consolas"/>
+              </a:rPr>
+              <a:t>  28  </a:t>
+            </a:r>
+            <a:r>
+              <a:rPr sz="1800">
+                <a:solidFill>
+                  <a:srgbClr val="6D8C97"/>
+                </a:solidFill>
+                <a:latin typeface="Consolas"/>
+              </a:rPr>
+              <a:t>  promptBox.value = '';            // clear the box, ready for the next one</a:t>
+            </a:r>
+          </a:p>
+          <a:p>
+            <a:pPr>
+              <a:spcAft>
+                <a:spcPts val="0"/>
+              </a:spcAft>
+            </a:pPr>
+            <a:r>
+              <a:rPr sz="1800">
+                <a:solidFill>
+                  <a:srgbClr val="6D8C97"/>
+                </a:solidFill>
+                <a:latin typeface="Consolas"/>
+              </a:rPr>
+              <a:t>  29  </a:t>
+            </a:r>
+            <a:r>
+              <a:rPr sz="1800">
+                <a:solidFill>
+                  <a:srgbClr val="6D8C97"/>
+                </a:solidFill>
+                <a:latin typeface="Consolas"/>
+              </a:rPr>
+              <a:t>  addLine('You', text);</a:t>
+            </a:r>
+          </a:p>
+          <a:p>
+            <a:pPr>
+              <a:spcAft>
+                <a:spcPts val="0"/>
+              </a:spcAft>
+            </a:pPr>
+            <a:r>
+              <a:rPr sz="1800">
+                <a:solidFill>
+                  <a:srgbClr val="6D8C97"/>
+                </a:solidFill>
+                <a:latin typeface="Consolas"/>
+              </a:rPr>
+              <a:t>  30  </a:t>
+            </a:r>
+            <a:r>
+              <a:rPr sz="1800">
                 <a:solidFill>
                   <a:srgbClr val="7FE0A0"/>
                 </a:solidFill>
                 <a:latin typeface="Consolas"/>
               </a:rPr>
-              <a:t> </a:t>
-            </a:r>
-          </a:p>
-          <a:p>
-            <a:pPr>
-              <a:spcAft>
-                <a:spcPts val="0"/>
-              </a:spcAft>
-            </a:pPr>
-            <a:r>
-              <a:rPr sz="1300">
-                <a:solidFill>
-                  <a:srgbClr val="6D8C97"/>
-                </a:solidFill>
-                <a:latin typeface="Consolas"/>
-              </a:rPr>
-              <a:t>  22  </a:t>
-            </a:r>
-            <a:r>
-              <a:rPr sz="1300">
-                <a:solidFill>
-                  <a:srgbClr val="7FE0A0"/>
-                </a:solidFill>
-                <a:latin typeface="Consolas"/>
-              </a:rPr>
-              <a:t>// In PixelPad your loop() checked 'was a key pressed?' every frame. Here you</a:t>
-            </a:r>
-          </a:p>
-          <a:p>
-            <a:pPr>
-              <a:spcAft>
-                <a:spcPts val="0"/>
-              </a:spcAft>
-            </a:pPr>
-            <a:r>
-              <a:rPr sz="1300">
-                <a:solidFill>
-                  <a:srgbClr val="6D8C97"/>
-                </a:solidFill>
-                <a:latin typeface="Consolas"/>
-              </a:rPr>
-              <a:t>  23  </a:t>
-            </a:r>
-            <a:r>
-              <a:rPr sz="1300">
-                <a:solidFill>
-                  <a:srgbClr val="7FE0A0"/>
-                </a:solidFill>
-                <a:latin typeface="Consolas"/>
-              </a:rPr>
-              <a:t>// leave a note: when this form is submitted, run this. The browser waits.</a:t>
-            </a:r>
-          </a:p>
-          <a:p>
-            <a:pPr>
-              <a:spcAft>
-                <a:spcPts val="0"/>
-              </a:spcAft>
-            </a:pPr>
-            <a:r>
-              <a:rPr sz="1300">
-                <a:solidFill>
-                  <a:srgbClr val="6D8C97"/>
-                </a:solidFill>
-                <a:latin typeface="Consolas"/>
-              </a:rPr>
-              <a:t>  24  </a:t>
-            </a:r>
-            <a:r>
-              <a:rPr sz="1300">
-                <a:solidFill>
-                  <a:srgbClr val="7FE0A0"/>
-                </a:solidFill>
-                <a:latin typeface="Consolas"/>
-              </a:rPr>
-              <a:t>composer.addEventListener('submit', function (event) {</a:t>
-            </a:r>
-          </a:p>
-          <a:p>
-            <a:pPr>
-              <a:spcAft>
-                <a:spcPts val="0"/>
-              </a:spcAft>
-            </a:pPr>
-            <a:r>
-              <a:rPr sz="1300">
-                <a:solidFill>
-                  <a:srgbClr val="6D8C97"/>
-                </a:solidFill>
-                <a:latin typeface="Consolas"/>
-              </a:rPr>
-              <a:t>  25  </a:t>
-            </a:r>
-            <a:r>
-              <a:rPr sz="1300">
-                <a:solidFill>
-                  <a:srgbClr val="7FE0A0"/>
-                </a:solidFill>
-                <a:latin typeface="Consolas"/>
-              </a:rPr>
-              <a:t>  event.preventDefault();          // stop the browser reloading the page</a:t>
-            </a:r>
-          </a:p>
-          <a:p>
-            <a:pPr>
-              <a:spcAft>
-                <a:spcPts val="0"/>
-              </a:spcAft>
-            </a:pPr>
-            <a:r>
-              <a:rPr sz="1300">
-                <a:solidFill>
-                  <a:srgbClr val="6D8C97"/>
-                </a:solidFill>
-                <a:latin typeface="Consolas"/>
-              </a:rPr>
-              <a:t>  26  </a:t>
-            </a:r>
-            <a:r>
-              <a:rPr sz="1300">
-                <a:solidFill>
-                  <a:srgbClr val="7FE0A0"/>
-                </a:solidFill>
-                <a:latin typeface="Consolas"/>
-              </a:rPr>
-              <a:t>  const text = promptBox.value.trim();</a:t>
-            </a:r>
-          </a:p>
-          <a:p>
-            <a:pPr>
-              <a:spcAft>
-                <a:spcPts val="0"/>
-              </a:spcAft>
-            </a:pPr>
-            <a:r>
-              <a:rPr sz="1300">
-                <a:solidFill>
-                  <a:srgbClr val="6D8C97"/>
-                </a:solidFill>
-                <a:latin typeface="Consolas"/>
-              </a:rPr>
-              <a:t>  27  </a:t>
-            </a:r>
-            <a:r>
-              <a:rPr sz="1300">
-                <a:solidFill>
-                  <a:srgbClr val="7FE0A0"/>
-                </a:solidFill>
-                <a:latin typeface="Consolas"/>
-              </a:rPr>
-              <a:t>  if (text === '') { return; }     // nothing typed, nothing to do</a:t>
-            </a:r>
-          </a:p>
-          <a:p>
-            <a:pPr>
-              <a:spcAft>
-                <a:spcPts val="0"/>
-              </a:spcAft>
-            </a:pPr>
-            <a:r>
-              <a:rPr sz="1300">
-                <a:solidFill>
-                  <a:srgbClr val="6D8C97"/>
-                </a:solidFill>
-                <a:latin typeface="Consolas"/>
-              </a:rPr>
-              <a:t>  28  </a:t>
-            </a:r>
-            <a:r>
-              <a:rPr sz="1300">
-                <a:solidFill>
-                  <a:srgbClr val="7FE0A0"/>
-                </a:solidFill>
-                <a:latin typeface="Consolas"/>
-              </a:rPr>
-              <a:t>  promptBox.value = '';            // clear the box, ready for the next one</a:t>
-            </a:r>
-          </a:p>
-          <a:p>
-            <a:pPr>
-              <a:spcAft>
-                <a:spcPts val="0"/>
-              </a:spcAft>
-            </a:pPr>
-            <a:r>
-              <a:rPr sz="1300">
-                <a:solidFill>
-                  <a:srgbClr val="6D8C97"/>
-                </a:solidFill>
-                <a:latin typeface="Consolas"/>
-              </a:rPr>
-              <a:t>  29  </a:t>
-            </a:r>
-            <a:r>
-              <a:rPr sz="1300">
-                <a:solidFill>
-                  <a:srgbClr val="7FE0A0"/>
-                </a:solidFill>
-                <a:latin typeface="Consolas"/>
-              </a:rPr>
-              <a:t>  addLine('You', text);</a:t>
-            </a:r>
-          </a:p>
-          <a:p>
-            <a:pPr>
-              <a:spcAft>
-                <a:spcPts val="0"/>
-              </a:spcAft>
-            </a:pPr>
-            <a:r>
-              <a:rPr sz="1300">
-                <a:solidFill>
-                  <a:srgbClr val="6D8C97"/>
-                </a:solidFill>
-                <a:latin typeface="Consolas"/>
-              </a:rPr>
-              <a:t>  30  </a:t>
-            </a:r>
-            <a:r>
-              <a:rPr sz="1300">
-                <a:solidFill>
-                  <a:srgbClr val="7FE0A0"/>
-                </a:solidFill>
-                <a:latin typeface="Consolas"/>
-              </a:rPr>
               <a:t>  addLine('Companion', 'You said: ' + text);   // a pretend answer, for now</a:t>
-            </a:r>
-          </a:p>
-          <a:p>
-            <a:pPr>
-              <a:spcAft>
-                <a:spcPts val="0"/>
-              </a:spcAft>
-            </a:pPr>
-            <a:r>
-              <a:rPr sz="1300">
-                <a:solidFill>
-                  <a:srgbClr val="6D8C97"/>
-                </a:solidFill>
-                <a:latin typeface="Consolas"/>
-              </a:rPr>
-              <a:t>  31  </a:t>
-            </a:r>
-            <a:r>
-              <a:rPr sz="1300">
-                <a:solidFill>
-                  <a:srgbClr val="7FE0A0"/>
-                </a:solidFill>
-                <a:latin typeface="Consolas"/>
-              </a:rPr>
-              <a:t>});</a:t>
             </a:r>
           </a:p>
         </p:txBody>
@@ -8507,7 +7989,7 @@
                   <a:srgbClr val="DCECEF"/>
                 </a:solidFill>
               </a:rPr>
-              <a:t>That is the whole piece. Check yours looks the same before moving on.</a:t>
+              <a:t>await askAI(text): the slow bit - ask the AI and wait for the answer.</a:t>
             </a:r>
           </a:p>
         </p:txBody>
@@ -8521,6 +8003,786 @@
 </file>
 
 <file path=ppt/slides/slide36.xml><?xml version="1.0" encoding="utf-8"?>
+<p:sld xmlns:a="http://schemas.openxmlformats.org/drawingml/2006/main" xmlns:p="http://schemas.openxmlformats.org/presentationml/2006/main" xmlns:r="http://schemas.openxmlformats.org/officeDocument/2006/relationships">
+  <p:cSld>
+    <p:bg>
+      <p:bgPr>
+        <a:solidFill>
+          <a:srgbClr val="102127"/>
+        </a:solidFill>
+        <a:effectLst/>
+      </p:bgPr>
+    </p:bg>
+    <p:spTree>
+      <p:nvGrpSpPr>
+        <p:cNvPr id="1" name=""/>
+        <p:cNvGrpSpPr/>
+        <p:nvPr/>
+      </p:nvGrpSpPr>
+      <p:grpSpPr/>
+      <p:sp>
+        <p:nvSpPr>
+          <p:cNvPr id="2" name="TextBox 1"/>
+          <p:cNvSpPr txBox="1"/>
+          <p:nvPr/>
+        </p:nvSpPr>
+        <p:spPr>
+          <a:xfrm>
+            <a:off x="502920" y="274320"/>
+            <a:ext cx="11155680" cy="548640"/>
+          </a:xfrm>
+          <a:prstGeom prst="rect">
+            <a:avLst/>
+          </a:prstGeom>
+          <a:noFill/>
+        </p:spPr>
+        <p:txBody>
+          <a:bodyPr wrap="none">
+            <a:spAutoFit/>
+          </a:bodyPr>
+          <a:lstStyle/>
+          <a:p>
+            <a:r>
+              <a:rPr sz="2200" b="1">
+                <a:solidFill>
+                  <a:srgbClr val="01AEFD"/>
+                </a:solidFill>
+              </a:rPr>
+              <a:t>Type this into script.js   -   line 31</a:t>
+            </a:r>
+          </a:p>
+        </p:txBody>
+      </p:sp>
+      <p:sp>
+        <p:nvSpPr>
+          <p:cNvPr id="3" name="TextBox 2"/>
+          <p:cNvSpPr txBox="1"/>
+          <p:nvPr/>
+        </p:nvSpPr>
+        <p:spPr>
+          <a:xfrm>
+            <a:off x="502920" y="960120"/>
+            <a:ext cx="11155680" cy="4297680"/>
+          </a:xfrm>
+          <a:prstGeom prst="rect">
+            <a:avLst/>
+          </a:prstGeom>
+          <a:noFill/>
+        </p:spPr>
+        <p:txBody>
+          <a:bodyPr wrap="none">
+            <a:spAutoFit/>
+          </a:bodyPr>
+          <a:lstStyle/>
+          <a:p>
+            <a:pPr>
+              <a:spcAft>
+                <a:spcPts val="0"/>
+              </a:spcAft>
+            </a:pPr>
+            <a:r>
+              <a:rPr sz="1300">
+                <a:solidFill>
+                  <a:srgbClr val="6D8C97"/>
+                </a:solidFill>
+                <a:latin typeface="Consolas"/>
+              </a:rPr>
+              <a:t>  21  </a:t>
+            </a:r>
+            <a:r>
+              <a:rPr sz="1300">
+                <a:solidFill>
+                  <a:srgbClr val="6D8C97"/>
+                </a:solidFill>
+                <a:latin typeface="Consolas"/>
+              </a:rPr>
+              <a:t> </a:t>
+            </a:r>
+          </a:p>
+          <a:p>
+            <a:pPr>
+              <a:spcAft>
+                <a:spcPts val="0"/>
+              </a:spcAft>
+            </a:pPr>
+            <a:r>
+              <a:rPr sz="1300">
+                <a:solidFill>
+                  <a:srgbClr val="6D8C97"/>
+                </a:solidFill>
+                <a:latin typeface="Consolas"/>
+              </a:rPr>
+              <a:t>  22  </a:t>
+            </a:r>
+            <a:r>
+              <a:rPr sz="1300">
+                <a:solidFill>
+                  <a:srgbClr val="6D8C97"/>
+                </a:solidFill>
+                <a:latin typeface="Consolas"/>
+              </a:rPr>
+              <a:t>// In PixelPad your loop() checked 'was a key pressed?' every frame. Here you</a:t>
+            </a:r>
+          </a:p>
+          <a:p>
+            <a:pPr>
+              <a:spcAft>
+                <a:spcPts val="0"/>
+              </a:spcAft>
+            </a:pPr>
+            <a:r>
+              <a:rPr sz="1300">
+                <a:solidFill>
+                  <a:srgbClr val="6D8C97"/>
+                </a:solidFill>
+                <a:latin typeface="Consolas"/>
+              </a:rPr>
+              <a:t>  23  </a:t>
+            </a:r>
+            <a:r>
+              <a:rPr sz="1300">
+                <a:solidFill>
+                  <a:srgbClr val="6D8C97"/>
+                </a:solidFill>
+                <a:latin typeface="Consolas"/>
+              </a:rPr>
+              <a:t>// leave a note: when this form is submitted, run this. The browser waits.</a:t>
+            </a:r>
+          </a:p>
+          <a:p>
+            <a:pPr>
+              <a:spcAft>
+                <a:spcPts val="0"/>
+              </a:spcAft>
+            </a:pPr>
+            <a:r>
+              <a:rPr sz="1300">
+                <a:solidFill>
+                  <a:srgbClr val="6D8C97"/>
+                </a:solidFill>
+                <a:latin typeface="Consolas"/>
+              </a:rPr>
+              <a:t>  24  </a:t>
+            </a:r>
+            <a:r>
+              <a:rPr sz="1300">
+                <a:solidFill>
+                  <a:srgbClr val="6D8C97"/>
+                </a:solidFill>
+                <a:latin typeface="Consolas"/>
+              </a:rPr>
+              <a:t>composer.addEventListener('submit', function (event) {</a:t>
+            </a:r>
+          </a:p>
+          <a:p>
+            <a:pPr>
+              <a:spcAft>
+                <a:spcPts val="0"/>
+              </a:spcAft>
+            </a:pPr>
+            <a:r>
+              <a:rPr sz="1300">
+                <a:solidFill>
+                  <a:srgbClr val="6D8C97"/>
+                </a:solidFill>
+                <a:latin typeface="Consolas"/>
+              </a:rPr>
+              <a:t>  25  </a:t>
+            </a:r>
+            <a:r>
+              <a:rPr sz="1300">
+                <a:solidFill>
+                  <a:srgbClr val="6D8C97"/>
+                </a:solidFill>
+                <a:latin typeface="Consolas"/>
+              </a:rPr>
+              <a:t>  event.preventDefault();          // stop the browser reloading the page</a:t>
+            </a:r>
+          </a:p>
+          <a:p>
+            <a:pPr>
+              <a:spcAft>
+                <a:spcPts val="0"/>
+              </a:spcAft>
+            </a:pPr>
+            <a:r>
+              <a:rPr sz="1300">
+                <a:solidFill>
+                  <a:srgbClr val="6D8C97"/>
+                </a:solidFill>
+                <a:latin typeface="Consolas"/>
+              </a:rPr>
+              <a:t>  26  </a:t>
+            </a:r>
+            <a:r>
+              <a:rPr sz="1300">
+                <a:solidFill>
+                  <a:srgbClr val="6D8C97"/>
+                </a:solidFill>
+                <a:latin typeface="Consolas"/>
+              </a:rPr>
+              <a:t>  const text = promptBox.value.trim();</a:t>
+            </a:r>
+          </a:p>
+          <a:p>
+            <a:pPr>
+              <a:spcAft>
+                <a:spcPts val="0"/>
+              </a:spcAft>
+            </a:pPr>
+            <a:r>
+              <a:rPr sz="1300">
+                <a:solidFill>
+                  <a:srgbClr val="6D8C97"/>
+                </a:solidFill>
+                <a:latin typeface="Consolas"/>
+              </a:rPr>
+              <a:t>  27  </a:t>
+            </a:r>
+            <a:r>
+              <a:rPr sz="1300">
+                <a:solidFill>
+                  <a:srgbClr val="6D8C97"/>
+                </a:solidFill>
+                <a:latin typeface="Consolas"/>
+              </a:rPr>
+              <a:t>  if (text === '') { return; }     // nothing typed, nothing to do</a:t>
+            </a:r>
+          </a:p>
+          <a:p>
+            <a:pPr>
+              <a:spcAft>
+                <a:spcPts val="0"/>
+              </a:spcAft>
+            </a:pPr>
+            <a:r>
+              <a:rPr sz="1300">
+                <a:solidFill>
+                  <a:srgbClr val="6D8C97"/>
+                </a:solidFill>
+                <a:latin typeface="Consolas"/>
+              </a:rPr>
+              <a:t>  28  </a:t>
+            </a:r>
+            <a:r>
+              <a:rPr sz="1300">
+                <a:solidFill>
+                  <a:srgbClr val="6D8C97"/>
+                </a:solidFill>
+                <a:latin typeface="Consolas"/>
+              </a:rPr>
+              <a:t>  promptBox.value = '';            // clear the box, ready for the next one</a:t>
+            </a:r>
+          </a:p>
+          <a:p>
+            <a:pPr>
+              <a:spcAft>
+                <a:spcPts val="0"/>
+              </a:spcAft>
+            </a:pPr>
+            <a:r>
+              <a:rPr sz="1300">
+                <a:solidFill>
+                  <a:srgbClr val="6D8C97"/>
+                </a:solidFill>
+                <a:latin typeface="Consolas"/>
+              </a:rPr>
+              <a:t>  29  </a:t>
+            </a:r>
+            <a:r>
+              <a:rPr sz="1300">
+                <a:solidFill>
+                  <a:srgbClr val="6D8C97"/>
+                </a:solidFill>
+                <a:latin typeface="Consolas"/>
+              </a:rPr>
+              <a:t>  addLine('You', text);</a:t>
+            </a:r>
+          </a:p>
+          <a:p>
+            <a:pPr>
+              <a:spcAft>
+                <a:spcPts val="0"/>
+              </a:spcAft>
+            </a:pPr>
+            <a:r>
+              <a:rPr sz="1300">
+                <a:solidFill>
+                  <a:srgbClr val="6D8C97"/>
+                </a:solidFill>
+                <a:latin typeface="Consolas"/>
+              </a:rPr>
+              <a:t>  30  </a:t>
+            </a:r>
+            <a:r>
+              <a:rPr sz="1300">
+                <a:solidFill>
+                  <a:srgbClr val="6D8C97"/>
+                </a:solidFill>
+                <a:latin typeface="Consolas"/>
+              </a:rPr>
+              <a:t>  addLine('Companion', 'You said: ' + text);   // a pretend answer, for now</a:t>
+            </a:r>
+          </a:p>
+          <a:p>
+            <a:pPr>
+              <a:spcAft>
+                <a:spcPts val="0"/>
+              </a:spcAft>
+            </a:pPr>
+            <a:r>
+              <a:rPr sz="1300">
+                <a:solidFill>
+                  <a:srgbClr val="6D8C97"/>
+                </a:solidFill>
+                <a:latin typeface="Consolas"/>
+              </a:rPr>
+              <a:t>  31  </a:t>
+            </a:r>
+            <a:r>
+              <a:rPr sz="1300">
+                <a:solidFill>
+                  <a:srgbClr val="7FE0A0"/>
+                </a:solidFill>
+                <a:latin typeface="Consolas"/>
+              </a:rPr>
+              <a:t>});</a:t>
+            </a:r>
+          </a:p>
+        </p:txBody>
+      </p:sp>
+      <p:sp>
+        <p:nvSpPr>
+          <p:cNvPr id="4" name="TextBox 3"/>
+          <p:cNvSpPr txBox="1"/>
+          <p:nvPr/>
+        </p:nvSpPr>
+        <p:spPr>
+          <a:xfrm>
+            <a:off x="548640" y="5623560"/>
+            <a:ext cx="11064240" cy="1051560"/>
+          </a:xfrm>
+          <a:prstGeom prst="rect">
+            <a:avLst/>
+          </a:prstGeom>
+          <a:noFill/>
+        </p:spPr>
+        <p:txBody>
+          <a:bodyPr wrap="square">
+            <a:spAutoFit/>
+          </a:bodyPr>
+          <a:lstStyle/>
+          <a:p>
+            <a:r>
+              <a:rPr sz="2000">
+                <a:solidFill>
+                  <a:srgbClr val="DCECEF"/>
+                </a:solidFill>
+              </a:rPr>
+              <a:t>Remove the 'thinking...' line now the real answer is here.</a:t>
+            </a:r>
+          </a:p>
+        </p:txBody>
+      </p:sp>
+    </p:spTree>
+  </p:cSld>
+  <p:clrMapOvr>
+    <a:masterClrMapping/>
+  </p:clrMapOvr>
+</p:sld>
+</file>
+
+<file path=ppt/slides/slide37.xml><?xml version="1.0" encoding="utf-8"?>
+<p:sld xmlns:a="http://schemas.openxmlformats.org/drawingml/2006/main" xmlns:p="http://schemas.openxmlformats.org/presentationml/2006/main" xmlns:r="http://schemas.openxmlformats.org/officeDocument/2006/relationships">
+  <p:cSld>
+    <p:bg>
+      <p:bgPr>
+        <a:solidFill>
+          <a:srgbClr val="102127"/>
+        </a:solidFill>
+        <a:effectLst/>
+      </p:bgPr>
+    </p:bg>
+    <p:spTree>
+      <p:nvGrpSpPr>
+        <p:cNvPr id="1" name=""/>
+        <p:cNvGrpSpPr/>
+        <p:nvPr/>
+      </p:nvGrpSpPr>
+      <p:grpSpPr/>
+      <p:sp>
+        <p:nvSpPr>
+          <p:cNvPr id="2" name="TextBox 1"/>
+          <p:cNvSpPr txBox="1"/>
+          <p:nvPr/>
+        </p:nvSpPr>
+        <p:spPr>
+          <a:xfrm>
+            <a:off x="502920" y="274320"/>
+            <a:ext cx="11155680" cy="548640"/>
+          </a:xfrm>
+          <a:prstGeom prst="rect">
+            <a:avLst/>
+          </a:prstGeom>
+          <a:noFill/>
+        </p:spPr>
+        <p:txBody>
+          <a:bodyPr wrap="none">
+            <a:spAutoFit/>
+          </a:bodyPr>
+          <a:lstStyle/>
+          <a:p>
+            <a:r>
+              <a:rPr sz="2200" b="1">
+                <a:solidFill>
+                  <a:srgbClr val="01AEFD"/>
+                </a:solidFill>
+              </a:rPr>
+              <a:t>All together in script.js</a:t>
+            </a:r>
+          </a:p>
+        </p:txBody>
+      </p:sp>
+      <p:sp>
+        <p:nvSpPr>
+          <p:cNvPr id="3" name="TextBox 2"/>
+          <p:cNvSpPr txBox="1"/>
+          <p:nvPr/>
+        </p:nvSpPr>
+        <p:spPr>
+          <a:xfrm>
+            <a:off x="502920" y="960120"/>
+            <a:ext cx="11155680" cy="4297680"/>
+          </a:xfrm>
+          <a:prstGeom prst="rect">
+            <a:avLst/>
+          </a:prstGeom>
+          <a:noFill/>
+        </p:spPr>
+        <p:txBody>
+          <a:bodyPr wrap="none">
+            <a:spAutoFit/>
+          </a:bodyPr>
+          <a:lstStyle/>
+          <a:p>
+            <a:pPr>
+              <a:spcAft>
+                <a:spcPts val="0"/>
+              </a:spcAft>
+            </a:pPr>
+            <a:r>
+              <a:rPr sz="1300">
+                <a:solidFill>
+                  <a:srgbClr val="6D8C97"/>
+                </a:solidFill>
+                <a:latin typeface="Consolas"/>
+              </a:rPr>
+              <a:t>  21  </a:t>
+            </a:r>
+            <a:r>
+              <a:rPr sz="1300">
+                <a:solidFill>
+                  <a:srgbClr val="7FE0A0"/>
+                </a:solidFill>
+                <a:latin typeface="Consolas"/>
+              </a:rPr>
+              <a:t> </a:t>
+            </a:r>
+          </a:p>
+          <a:p>
+            <a:pPr>
+              <a:spcAft>
+                <a:spcPts val="0"/>
+              </a:spcAft>
+            </a:pPr>
+            <a:r>
+              <a:rPr sz="1300">
+                <a:solidFill>
+                  <a:srgbClr val="6D8C97"/>
+                </a:solidFill>
+                <a:latin typeface="Consolas"/>
+              </a:rPr>
+              <a:t>  22  </a:t>
+            </a:r>
+            <a:r>
+              <a:rPr sz="1300">
+                <a:solidFill>
+                  <a:srgbClr val="7FE0A0"/>
+                </a:solidFill>
+                <a:latin typeface="Consolas"/>
+              </a:rPr>
+              <a:t>// In PixelPad your loop() checked 'was a key pressed?' every frame. Here you</a:t>
+            </a:r>
+          </a:p>
+          <a:p>
+            <a:pPr>
+              <a:spcAft>
+                <a:spcPts val="0"/>
+              </a:spcAft>
+            </a:pPr>
+            <a:r>
+              <a:rPr sz="1300">
+                <a:solidFill>
+                  <a:srgbClr val="6D8C97"/>
+                </a:solidFill>
+                <a:latin typeface="Consolas"/>
+              </a:rPr>
+              <a:t>  23  </a:t>
+            </a:r>
+            <a:r>
+              <a:rPr sz="1300">
+                <a:solidFill>
+                  <a:srgbClr val="7FE0A0"/>
+                </a:solidFill>
+                <a:latin typeface="Consolas"/>
+              </a:rPr>
+              <a:t>// leave a note: when this form is submitted, run this. The browser waits.</a:t>
+            </a:r>
+          </a:p>
+          <a:p>
+            <a:pPr>
+              <a:spcAft>
+                <a:spcPts val="0"/>
+              </a:spcAft>
+            </a:pPr>
+            <a:r>
+              <a:rPr sz="1300">
+                <a:solidFill>
+                  <a:srgbClr val="6D8C97"/>
+                </a:solidFill>
+                <a:latin typeface="Consolas"/>
+              </a:rPr>
+              <a:t>  24  </a:t>
+            </a:r>
+            <a:r>
+              <a:rPr sz="1300">
+                <a:solidFill>
+                  <a:srgbClr val="7FE0A0"/>
+                </a:solidFill>
+                <a:latin typeface="Consolas"/>
+              </a:rPr>
+              <a:t>composer.addEventListener('submit', function (event) {</a:t>
+            </a:r>
+          </a:p>
+          <a:p>
+            <a:pPr>
+              <a:spcAft>
+                <a:spcPts val="0"/>
+              </a:spcAft>
+            </a:pPr>
+            <a:r>
+              <a:rPr sz="1300">
+                <a:solidFill>
+                  <a:srgbClr val="6D8C97"/>
+                </a:solidFill>
+                <a:latin typeface="Consolas"/>
+              </a:rPr>
+              <a:t>  25  </a:t>
+            </a:r>
+            <a:r>
+              <a:rPr sz="1300">
+                <a:solidFill>
+                  <a:srgbClr val="7FE0A0"/>
+                </a:solidFill>
+                <a:latin typeface="Consolas"/>
+              </a:rPr>
+              <a:t>  event.preventDefault();          // stop the browser reloading the page</a:t>
+            </a:r>
+          </a:p>
+          <a:p>
+            <a:pPr>
+              <a:spcAft>
+                <a:spcPts val="0"/>
+              </a:spcAft>
+            </a:pPr>
+            <a:r>
+              <a:rPr sz="1300">
+                <a:solidFill>
+                  <a:srgbClr val="6D8C97"/>
+                </a:solidFill>
+                <a:latin typeface="Consolas"/>
+              </a:rPr>
+              <a:t>  26  </a:t>
+            </a:r>
+            <a:r>
+              <a:rPr sz="1300">
+                <a:solidFill>
+                  <a:srgbClr val="7FE0A0"/>
+                </a:solidFill>
+                <a:latin typeface="Consolas"/>
+              </a:rPr>
+              <a:t>  const text = promptBox.value.trim();</a:t>
+            </a:r>
+          </a:p>
+          <a:p>
+            <a:pPr>
+              <a:spcAft>
+                <a:spcPts val="0"/>
+              </a:spcAft>
+            </a:pPr>
+            <a:r>
+              <a:rPr sz="1300">
+                <a:solidFill>
+                  <a:srgbClr val="6D8C97"/>
+                </a:solidFill>
+                <a:latin typeface="Consolas"/>
+              </a:rPr>
+              <a:t>  27  </a:t>
+            </a:r>
+            <a:r>
+              <a:rPr sz="1300">
+                <a:solidFill>
+                  <a:srgbClr val="7FE0A0"/>
+                </a:solidFill>
+                <a:latin typeface="Consolas"/>
+              </a:rPr>
+              <a:t>  if (text === '') { return; }     // nothing typed, nothing to do</a:t>
+            </a:r>
+          </a:p>
+          <a:p>
+            <a:pPr>
+              <a:spcAft>
+                <a:spcPts val="0"/>
+              </a:spcAft>
+            </a:pPr>
+            <a:r>
+              <a:rPr sz="1300">
+                <a:solidFill>
+                  <a:srgbClr val="6D8C97"/>
+                </a:solidFill>
+                <a:latin typeface="Consolas"/>
+              </a:rPr>
+              <a:t>  28  </a:t>
+            </a:r>
+            <a:r>
+              <a:rPr sz="1300">
+                <a:solidFill>
+                  <a:srgbClr val="7FE0A0"/>
+                </a:solidFill>
+                <a:latin typeface="Consolas"/>
+              </a:rPr>
+              <a:t>  promptBox.value = '';            // clear the box, ready for the next one</a:t>
+            </a:r>
+          </a:p>
+          <a:p>
+            <a:pPr>
+              <a:spcAft>
+                <a:spcPts val="0"/>
+              </a:spcAft>
+            </a:pPr>
+            <a:r>
+              <a:rPr sz="1300">
+                <a:solidFill>
+                  <a:srgbClr val="6D8C97"/>
+                </a:solidFill>
+                <a:latin typeface="Consolas"/>
+              </a:rPr>
+              <a:t>  29  </a:t>
+            </a:r>
+            <a:r>
+              <a:rPr sz="1300">
+                <a:solidFill>
+                  <a:srgbClr val="7FE0A0"/>
+                </a:solidFill>
+                <a:latin typeface="Consolas"/>
+              </a:rPr>
+              <a:t>  addLine('You', text);</a:t>
+            </a:r>
+          </a:p>
+          <a:p>
+            <a:pPr>
+              <a:spcAft>
+                <a:spcPts val="0"/>
+              </a:spcAft>
+            </a:pPr>
+            <a:r>
+              <a:rPr sz="1300">
+                <a:solidFill>
+                  <a:srgbClr val="6D8C97"/>
+                </a:solidFill>
+                <a:latin typeface="Consolas"/>
+              </a:rPr>
+              <a:t>  30  </a:t>
+            </a:r>
+            <a:r>
+              <a:rPr sz="1300">
+                <a:solidFill>
+                  <a:srgbClr val="7FE0A0"/>
+                </a:solidFill>
+                <a:latin typeface="Consolas"/>
+              </a:rPr>
+              <a:t>  addLine('Companion', 'You said: ' + text);   // a pretend answer, for now</a:t>
+            </a:r>
+          </a:p>
+          <a:p>
+            <a:pPr>
+              <a:spcAft>
+                <a:spcPts val="0"/>
+              </a:spcAft>
+            </a:pPr>
+            <a:r>
+              <a:rPr sz="1300">
+                <a:solidFill>
+                  <a:srgbClr val="6D8C97"/>
+                </a:solidFill>
+                <a:latin typeface="Consolas"/>
+              </a:rPr>
+              <a:t>  31  </a:t>
+            </a:r>
+            <a:r>
+              <a:rPr sz="1300">
+                <a:solidFill>
+                  <a:srgbClr val="7FE0A0"/>
+                </a:solidFill>
+                <a:latin typeface="Consolas"/>
+              </a:rPr>
+              <a:t>});</a:t>
+            </a:r>
+          </a:p>
+        </p:txBody>
+      </p:sp>
+      <p:sp>
+        <p:nvSpPr>
+          <p:cNvPr id="4" name="TextBox 3"/>
+          <p:cNvSpPr txBox="1"/>
+          <p:nvPr/>
+        </p:nvSpPr>
+        <p:spPr>
+          <a:xfrm>
+            <a:off x="548640" y="5623560"/>
+            <a:ext cx="11064240" cy="1051560"/>
+          </a:xfrm>
+          <a:prstGeom prst="rect">
+            <a:avLst/>
+          </a:prstGeom>
+          <a:noFill/>
+        </p:spPr>
+        <p:txBody>
+          <a:bodyPr wrap="square">
+            <a:spAutoFit/>
+          </a:bodyPr>
+          <a:lstStyle/>
+          <a:p>
+            <a:r>
+              <a:rPr sz="2000">
+                <a:solidFill>
+                  <a:srgbClr val="DCECEF"/>
+                </a:solidFill>
+              </a:rPr>
+              <a:t>That is the whole piece. Check yours looks the same before moving on.</a:t>
+            </a:r>
+          </a:p>
+        </p:txBody>
+      </p:sp>
+    </p:spTree>
+  </p:cSld>
+  <p:clrMapOvr>
+    <a:masterClrMapping/>
+  </p:clrMapOvr>
+</p:sld>
+</file>
+
+<file path=ppt/slides/slide38.xml><?xml version="1.0" encoding="utf-8"?>
 <p:sld xmlns:a="http://schemas.openxmlformats.org/drawingml/2006/main" xmlns:p="http://schemas.openxmlformats.org/presentationml/2006/main" xmlns:r="http://schemas.openxmlformats.org/officeDocument/2006/relationships">
   <p:cSld>
     <p:spTree>

</xml_diff>

<commit_message>
Expand week 5 slides (when things break), and fix a note collision
Week 5 introduces ! (not), && (and), throw new Error(), try/catch, the
? : choice, and line-height; .lastChild and .remove() get their intro
too (first used in week 4, so this backfills week 4 as well). A checkpoint
lets the class try to break it and see a friendly Problem line instead of
a freeze.

Along the way, fixed a real collision: ask and submit change across weeks
but LINE_NOTES was keyed only by block, so week 4 quietly overwrote week
2s submit notes - week 2s slides were showing week 4s explanations. Notes
are now looked up per (week, file, block) with a plain fallback, and the
week-2 submit notes are restored.

370 -> 408 slides.

Co-Authored-By: Claude Opus 5 <noreply@anthropic.com>
</commit_message>
<xml_diff>
--- a/ai101/slides/week-02.pptx
+++ b/ai101/slides/week-02.pptx
@@ -44,6 +44,10 @@
     <p:sldId id="292" r:id="rId43"/>
     <p:sldId id="293" r:id="rId44"/>
     <p:sldId id="294" r:id="rId45"/>
+    <p:sldId id="295" r:id="rId46"/>
+    <p:sldId id="296" r:id="rId47"/>
+    <p:sldId id="297" r:id="rId48"/>
+    <p:sldId id="298" r:id="rId49"/>
   </p:sldIdLst>
   <p:sldSz cx="12191695" cy="6858000" type="screen4x3"/>
   <p:notesSz cx="6858000" cy="9144000"/>
@@ -6103,7 +6107,7 @@
                   <a:srgbClr val="DCECEF"/>
                 </a:solidFill>
               </a:rPr>
-              <a:t>A comment: the browser calls this when the form is submitted.</a:t>
+              <a:t>A comment tying this to PixelPad: instead of checking every frame, you leave a note for the browser.</a:t>
             </a:r>
           </a:p>
         </p:txBody>
@@ -6117,6 +6121,136 @@
 </file>
 
 <file path=ppt/slides/slide26.xml><?xml version="1.0" encoding="utf-8"?>
+<p:sld xmlns:a="http://schemas.openxmlformats.org/drawingml/2006/main" xmlns:p="http://schemas.openxmlformats.org/presentationml/2006/main" xmlns:r="http://schemas.openxmlformats.org/officeDocument/2006/relationships">
+  <p:cSld>
+    <p:spTree>
+      <p:nvGrpSpPr>
+        <p:cNvPr id="1" name=""/>
+        <p:cNvGrpSpPr/>
+        <p:nvPr/>
+      </p:nvGrpSpPr>
+      <p:grpSpPr/>
+      <p:sp>
+        <p:nvSpPr>
+          <p:cNvPr id="2" name="Title 1"/>
+          <p:cNvSpPr>
+            <a:spLocks noGrp="1"/>
+          </p:cNvSpPr>
+          <p:nvPr>
+            <p:ph type="title"/>
+          </p:nvPr>
+        </p:nvSpPr>
+        <p:spPr/>
+        <p:txBody>
+          <a:bodyPr/>
+          <a:lstStyle/>
+          <a:p>
+            <a:r>
+              <a:rPr sz="3800" b="1">
+                <a:solidFill>
+                  <a:srgbClr val="1F2A37"/>
+                </a:solidFill>
+              </a:rPr>
+              <a:t>.addEventListener()</a:t>
+            </a:r>
+          </a:p>
+        </p:txBody>
+      </p:sp>
+      <p:sp>
+        <p:nvSpPr>
+          <p:cNvPr id="3" name="TextBox 2"/>
+          <p:cNvSpPr txBox="1"/>
+          <p:nvPr/>
+        </p:nvSpPr>
+        <p:spPr>
+          <a:xfrm>
+            <a:off x="868680" y="502920"/>
+            <a:ext cx="5486400" cy="457200"/>
+          </a:xfrm>
+          <a:prstGeom prst="rect">
+            <a:avLst/>
+          </a:prstGeom>
+          <a:noFill/>
+        </p:spPr>
+        <p:txBody>
+          <a:bodyPr wrap="none">
+            <a:spAutoFit/>
+          </a:bodyPr>
+          <a:lstStyle/>
+          <a:p>
+            <a:r>
+              <a:rPr sz="1500" b="1">
+                <a:solidFill>
+                  <a:srgbClr val="01AEFD"/>
+                </a:solidFill>
+              </a:rPr>
+              <a:t>JAVASCRIPT</a:t>
+            </a:r>
+          </a:p>
+        </p:txBody>
+      </p:sp>
+      <p:sp>
+        <p:nvSpPr>
+          <p:cNvPr id="4" name="TextBox 3"/>
+          <p:cNvSpPr txBox="1"/>
+          <p:nvPr/>
+        </p:nvSpPr>
+        <p:spPr>
+          <a:xfrm>
+            <a:off x="822960" y="1828800"/>
+            <a:ext cx="10515600" cy="4206240"/>
+          </a:xfrm>
+          <a:prstGeom prst="rect">
+            <a:avLst/>
+          </a:prstGeom>
+          <a:noFill/>
+        </p:spPr>
+        <p:txBody>
+          <a:bodyPr wrap="square">
+            <a:spAutoFit/>
+          </a:bodyPr>
+          <a:lstStyle/>
+          <a:p>
+            <a:pPr>
+              <a:spcAft>
+                <a:spcPts val="1400"/>
+              </a:spcAft>
+            </a:pPr>
+            <a:r>
+              <a:rPr sz="2400">
+                <a:solidFill>
+                  <a:srgbClr val="1F2A37"/>
+                </a:solidFill>
+              </a:rPr>
+              <a:t>• Leaves a note: 'when THIS happens, run THAT'.</a:t>
+            </a:r>
+          </a:p>
+          <a:p>
+            <a:pPr>
+              <a:spcAft>
+                <a:spcPts val="1400"/>
+              </a:spcAft>
+            </a:pPr>
+            <a:r>
+              <a:rPr sz="2400">
+                <a:solidFill>
+                  <a:srgbClr val="1F2A37"/>
+                </a:solidFill>
+              </a:rPr>
+              <a:t>• Like your PixelPad loop watching for a key - but the browser waits and calls you.</a:t>
+            </a:r>
+          </a:p>
+        </p:txBody>
+      </p:sp>
+    </p:spTree>
+  </p:cSld>
+  <p:clrMapOvr>
+    <a:masterClrMapping/>
+  </p:clrMapOvr>
+</p:sld>
+</file>
+
+<file path=ppt/slides/slide27.xml><?xml version="1.0" encoding="utf-8"?>
 <p:sld xmlns:a="http://schemas.openxmlformats.org/drawingml/2006/main" xmlns:p="http://schemas.openxmlformats.org/presentationml/2006/main" xmlns:r="http://schemas.openxmlformats.org/officeDocument/2006/relationships">
   <p:cSld>
     <p:bg>
@@ -6162,7 +6296,7 @@
                   <a:srgbClr val="01AEFD"/>
                 </a:solidFill>
               </a:rPr>
-              <a:t>Type this into script.js   -   line 23</a:t>
+              <a:t>Type this into script.js   -   line 24</a:t>
             </a:r>
           </a:p>
         </p:txBody>
@@ -6256,11 +6390,36 @@
             <a:r>
               <a:rPr sz="1800">
                 <a:solidFill>
+                  <a:srgbClr val="6D8C97"/>
+                </a:solidFill>
+                <a:latin typeface="Consolas"/>
+              </a:rPr>
+              <a:t>// leave a note: when this form is submitted, run this. The browser waits.</a:t>
+            </a:r>
+          </a:p>
+          <a:p>
+            <a:pPr>
+              <a:spcAft>
+                <a:spcPts val="0"/>
+              </a:spcAft>
+            </a:pPr>
+            <a:r>
+              <a:rPr sz="1800">
+                <a:solidFill>
+                  <a:srgbClr val="6D8C97"/>
+                </a:solidFill>
+                <a:latin typeface="Consolas"/>
+              </a:rPr>
+              <a:t>  24  </a:t>
+            </a:r>
+            <a:r>
+              <a:rPr sz="1800">
+                <a:solidFill>
                   <a:srgbClr val="7FE0A0"/>
                 </a:solidFill>
                 <a:latin typeface="Consolas"/>
               </a:rPr>
-              <a:t>// leave a note: when this form is submitted, run this. The browser waits.</a:t>
+              <a:t>composer.addEventListener('submit', function (event) {</a:t>
             </a:r>
           </a:p>
         </p:txBody>
@@ -6293,137 +6452,7 @@
                   <a:srgbClr val="DCECEF"/>
                 </a:solidFill>
               </a:rPr>
-              <a:t>Add async so we are allowed to await the slow AI call inside.</a:t>
-            </a:r>
-          </a:p>
-        </p:txBody>
-      </p:sp>
-    </p:spTree>
-  </p:cSld>
-  <p:clrMapOvr>
-    <a:masterClrMapping/>
-  </p:clrMapOvr>
-</p:sld>
-</file>
-
-<file path=ppt/slides/slide27.xml><?xml version="1.0" encoding="utf-8"?>
-<p:sld xmlns:a="http://schemas.openxmlformats.org/drawingml/2006/main" xmlns:p="http://schemas.openxmlformats.org/presentationml/2006/main" xmlns:r="http://schemas.openxmlformats.org/officeDocument/2006/relationships">
-  <p:cSld>
-    <p:spTree>
-      <p:nvGrpSpPr>
-        <p:cNvPr id="1" name=""/>
-        <p:cNvGrpSpPr/>
-        <p:nvPr/>
-      </p:nvGrpSpPr>
-      <p:grpSpPr/>
-      <p:sp>
-        <p:nvSpPr>
-          <p:cNvPr id="2" name="Title 1"/>
-          <p:cNvSpPr>
-            <a:spLocks noGrp="1"/>
-          </p:cNvSpPr>
-          <p:nvPr>
-            <p:ph type="title"/>
-          </p:nvPr>
-        </p:nvSpPr>
-        <p:spPr/>
-        <p:txBody>
-          <a:bodyPr/>
-          <a:lstStyle/>
-          <a:p>
-            <a:r>
-              <a:rPr sz="3800" b="1">
-                <a:solidFill>
-                  <a:srgbClr val="1F2A37"/>
-                </a:solidFill>
-              </a:rPr>
-              <a:t>.addEventListener()</a:t>
-            </a:r>
-          </a:p>
-        </p:txBody>
-      </p:sp>
-      <p:sp>
-        <p:nvSpPr>
-          <p:cNvPr id="3" name="TextBox 2"/>
-          <p:cNvSpPr txBox="1"/>
-          <p:nvPr/>
-        </p:nvSpPr>
-        <p:spPr>
-          <a:xfrm>
-            <a:off x="868680" y="502920"/>
-            <a:ext cx="5486400" cy="457200"/>
-          </a:xfrm>
-          <a:prstGeom prst="rect">
-            <a:avLst/>
-          </a:prstGeom>
-          <a:noFill/>
-        </p:spPr>
-        <p:txBody>
-          <a:bodyPr wrap="none">
-            <a:spAutoFit/>
-          </a:bodyPr>
-          <a:lstStyle/>
-          <a:p>
-            <a:r>
-              <a:rPr sz="1500" b="1">
-                <a:solidFill>
-                  <a:srgbClr val="01AEFD"/>
-                </a:solidFill>
-              </a:rPr>
-              <a:t>JAVASCRIPT</a:t>
-            </a:r>
-          </a:p>
-        </p:txBody>
-      </p:sp>
-      <p:sp>
-        <p:nvSpPr>
-          <p:cNvPr id="4" name="TextBox 3"/>
-          <p:cNvSpPr txBox="1"/>
-          <p:nvPr/>
-        </p:nvSpPr>
-        <p:spPr>
-          <a:xfrm>
-            <a:off x="822960" y="1828800"/>
-            <a:ext cx="10515600" cy="4206240"/>
-          </a:xfrm>
-          <a:prstGeom prst="rect">
-            <a:avLst/>
-          </a:prstGeom>
-          <a:noFill/>
-        </p:spPr>
-        <p:txBody>
-          <a:bodyPr wrap="square">
-            <a:spAutoFit/>
-          </a:bodyPr>
-          <a:lstStyle/>
-          <a:p>
-            <a:pPr>
-              <a:spcAft>
-                <a:spcPts val="1400"/>
-              </a:spcAft>
-            </a:pPr>
-            <a:r>
-              <a:rPr sz="2400">
-                <a:solidFill>
-                  <a:srgbClr val="1F2A37"/>
-                </a:solidFill>
-              </a:rPr>
-              <a:t>• Leaves a note: 'when THIS happens, run THAT'.</a:t>
-            </a:r>
-          </a:p>
-          <a:p>
-            <a:pPr>
-              <a:spcAft>
-                <a:spcPts val="1400"/>
-              </a:spcAft>
-            </a:pPr>
-            <a:r>
-              <a:rPr sz="2400">
-                <a:solidFill>
-                  <a:srgbClr val="1F2A37"/>
-                </a:solidFill>
-              </a:rPr>
-              <a:t>• Like your PixelPad loop watching for a key - but the browser waits and calls you.</a:t>
+              <a:t>When the form is submitted, run this function. event holds the details of what happened.</a:t>
             </a:r>
           </a:p>
         </p:txBody>
@@ -6569,6 +6598,14 @@
 <file path=ppt/slides/slide29.xml><?xml version="1.0" encoding="utf-8"?>
 <p:sld xmlns:a="http://schemas.openxmlformats.org/drawingml/2006/main" xmlns:p="http://schemas.openxmlformats.org/presentationml/2006/main" xmlns:r="http://schemas.openxmlformats.org/officeDocument/2006/relationships">
   <p:cSld>
+    <p:bg>
+      <p:bgPr>
+        <a:solidFill>
+          <a:srgbClr val="102127"/>
+        </a:solidFill>
+        <a:effectLst/>
+      </p:bgPr>
+    </p:bg>
     <p:spTree>
       <p:nvGrpSpPr>
         <p:cNvPr id="1" name=""/>
@@ -6578,40 +6615,14 @@
       <p:grpSpPr/>
       <p:sp>
         <p:nvSpPr>
-          <p:cNvPr id="2" name="Title 1"/>
-          <p:cNvSpPr>
-            <a:spLocks noGrp="1"/>
-          </p:cNvSpPr>
-          <p:nvPr>
-            <p:ph type="title"/>
-          </p:nvPr>
-        </p:nvSpPr>
-        <p:spPr/>
-        <p:txBody>
-          <a:bodyPr/>
-          <a:lstStyle/>
-          <a:p>
-            <a:r>
-              <a:rPr sz="3800" b="1">
-                <a:solidFill>
-                  <a:srgbClr val="1F2A37"/>
-                </a:solidFill>
-              </a:rPr>
-              <a:t>Reading .value</a:t>
-            </a:r>
-          </a:p>
-        </p:txBody>
-      </p:sp>
-      <p:sp>
-        <p:nvSpPr>
-          <p:cNvPr id="3" name="TextBox 2"/>
+          <p:cNvPr id="2" name="TextBox 1"/>
           <p:cNvSpPr txBox="1"/>
           <p:nvPr/>
         </p:nvSpPr>
         <p:spPr>
           <a:xfrm>
-            <a:off x="868680" y="502920"/>
-            <a:ext cx="5486400" cy="457200"/>
+            <a:off x="502920" y="274320"/>
+            <a:ext cx="11155680" cy="548640"/>
           </a:xfrm>
           <a:prstGeom prst="rect">
             <a:avLst/>
@@ -6625,26 +6636,26 @@
           <a:lstStyle/>
           <a:p>
             <a:r>
-              <a:rPr sz="1500" b="1">
+              <a:rPr sz="2200" b="1">
                 <a:solidFill>
                   <a:srgbClr val="01AEFD"/>
                 </a:solidFill>
               </a:rPr>
-              <a:t>JAVASCRIPT</a:t>
-            </a:r>
-          </a:p>
-        </p:txBody>
-      </p:sp>
-      <p:sp>
-        <p:nvSpPr>
-          <p:cNvPr id="4" name="TextBox 3"/>
+              <a:t>Type this into script.js   -   line 25</a:t>
+            </a:r>
+          </a:p>
+        </p:txBody>
+      </p:sp>
+      <p:sp>
+        <p:nvSpPr>
+          <p:cNvPr id="3" name="TextBox 2"/>
           <p:cNvSpPr txBox="1"/>
           <p:nvPr/>
         </p:nvSpPr>
         <p:spPr>
           <a:xfrm>
-            <a:off x="822960" y="1828800"/>
-            <a:ext cx="10515600" cy="4206240"/>
+            <a:off x="502920" y="960120"/>
+            <a:ext cx="11155680" cy="4297680"/>
           </a:xfrm>
           <a:prstGeom prst="rect">
             <a:avLst/>
@@ -6652,23 +6663,166 @@
           <a:noFill/>
         </p:spPr>
         <p:txBody>
+          <a:bodyPr wrap="none">
+            <a:spAutoFit/>
+          </a:bodyPr>
+          <a:lstStyle/>
+          <a:p>
+            <a:pPr>
+              <a:spcAft>
+                <a:spcPts val="0"/>
+              </a:spcAft>
+            </a:pPr>
+            <a:r>
+              <a:rPr sz="1800">
+                <a:solidFill>
+                  <a:srgbClr val="6D8C97"/>
+                </a:solidFill>
+                <a:latin typeface="Consolas"/>
+              </a:rPr>
+              <a:t>  21  </a:t>
+            </a:r>
+            <a:r>
+              <a:rPr sz="1800">
+                <a:solidFill>
+                  <a:srgbClr val="6D8C97"/>
+                </a:solidFill>
+                <a:latin typeface="Consolas"/>
+              </a:rPr>
+              <a:t> </a:t>
+            </a:r>
+          </a:p>
+          <a:p>
+            <a:pPr>
+              <a:spcAft>
+                <a:spcPts val="0"/>
+              </a:spcAft>
+            </a:pPr>
+            <a:r>
+              <a:rPr sz="1800">
+                <a:solidFill>
+                  <a:srgbClr val="6D8C97"/>
+                </a:solidFill>
+                <a:latin typeface="Consolas"/>
+              </a:rPr>
+              <a:t>  22  </a:t>
+            </a:r>
+            <a:r>
+              <a:rPr sz="1800">
+                <a:solidFill>
+                  <a:srgbClr val="6D8C97"/>
+                </a:solidFill>
+                <a:latin typeface="Consolas"/>
+              </a:rPr>
+              <a:t>// In PixelPad your loop() checked 'was a key pressed?' every frame. Here you</a:t>
+            </a:r>
+          </a:p>
+          <a:p>
+            <a:pPr>
+              <a:spcAft>
+                <a:spcPts val="0"/>
+              </a:spcAft>
+            </a:pPr>
+            <a:r>
+              <a:rPr sz="1800">
+                <a:solidFill>
+                  <a:srgbClr val="6D8C97"/>
+                </a:solidFill>
+                <a:latin typeface="Consolas"/>
+              </a:rPr>
+              <a:t>  23  </a:t>
+            </a:r>
+            <a:r>
+              <a:rPr sz="1800">
+                <a:solidFill>
+                  <a:srgbClr val="6D8C97"/>
+                </a:solidFill>
+                <a:latin typeface="Consolas"/>
+              </a:rPr>
+              <a:t>// leave a note: when this form is submitted, run this. The browser waits.</a:t>
+            </a:r>
+          </a:p>
+          <a:p>
+            <a:pPr>
+              <a:spcAft>
+                <a:spcPts val="0"/>
+              </a:spcAft>
+            </a:pPr>
+            <a:r>
+              <a:rPr sz="1800">
+                <a:solidFill>
+                  <a:srgbClr val="6D8C97"/>
+                </a:solidFill>
+                <a:latin typeface="Consolas"/>
+              </a:rPr>
+              <a:t>  24  </a:t>
+            </a:r>
+            <a:r>
+              <a:rPr sz="1800">
+                <a:solidFill>
+                  <a:srgbClr val="6D8C97"/>
+                </a:solidFill>
+                <a:latin typeface="Consolas"/>
+              </a:rPr>
+              <a:t>composer.addEventListener('submit', function (event) {</a:t>
+            </a:r>
+          </a:p>
+          <a:p>
+            <a:pPr>
+              <a:spcAft>
+                <a:spcPts val="0"/>
+              </a:spcAft>
+            </a:pPr>
+            <a:r>
+              <a:rPr sz="1800">
+                <a:solidFill>
+                  <a:srgbClr val="6D8C97"/>
+                </a:solidFill>
+                <a:latin typeface="Consolas"/>
+              </a:rPr>
+              <a:t>  25  </a:t>
+            </a:r>
+            <a:r>
+              <a:rPr sz="1800">
+                <a:solidFill>
+                  <a:srgbClr val="7FE0A0"/>
+                </a:solidFill>
+                <a:latin typeface="Consolas"/>
+              </a:rPr>
+              <a:t>  event.preventDefault();          // stop the browser reloading the page</a:t>
+            </a:r>
+          </a:p>
+        </p:txBody>
+      </p:sp>
+      <p:sp>
+        <p:nvSpPr>
+          <p:cNvPr id="4" name="TextBox 3"/>
+          <p:cNvSpPr txBox="1"/>
+          <p:nvPr/>
+        </p:nvSpPr>
+        <p:spPr>
+          <a:xfrm>
+            <a:off x="548640" y="5623560"/>
+            <a:ext cx="11064240" cy="1051560"/>
+          </a:xfrm>
+          <a:prstGeom prst="rect">
+            <a:avLst/>
+          </a:prstGeom>
+          <a:noFill/>
+        </p:spPr>
+        <p:txBody>
           <a:bodyPr wrap="square">
             <a:spAutoFit/>
           </a:bodyPr>
           <a:lstStyle/>
           <a:p>
-            <a:pPr>
-              <a:spcAft>
-                <a:spcPts val="1400"/>
-              </a:spcAft>
-            </a:pPr>
-            <a:r>
-              <a:rPr sz="2400">
-                <a:solidFill>
-                  <a:srgbClr val="1F2A37"/>
-                </a:solidFill>
-              </a:rPr>
-              <a:t>• box.value is whatever you have typed in that box right now.</a:t>
+            <a:r>
+              <a:rPr sz="2000">
+                <a:solidFill>
+                  <a:srgbClr val="DCECEF"/>
+                </a:solidFill>
+              </a:rPr>
+              <a:t>Stops the browser reloading the page, so you handle it yourself.</a:t>
             </a:r>
           </a:p>
         </p:txBody>
@@ -6839,7 +6993,7 @@
                   <a:srgbClr val="1F2A37"/>
                 </a:solidFill>
               </a:rPr>
-              <a:t>.trim()</a:t>
+              <a:t>Reading .value</a:t>
             </a:r>
           </a:p>
         </p:txBody>
@@ -6910,22 +7064,7 @@
                   <a:srgbClr val="1F2A37"/>
                 </a:solidFill>
               </a:rPr>
-              <a:t>• Removes blank space from the ends of text.</a:t>
-            </a:r>
-          </a:p>
-          <a:p>
-            <a:pPr>
-              <a:spcAft>
-                <a:spcPts val="1400"/>
-              </a:spcAft>
-            </a:pPr>
-            <a:r>
-              <a:rPr sz="2400">
-                <a:solidFill>
-                  <a:srgbClr val="1F2A37"/>
-                </a:solidFill>
-              </a:rPr>
-              <a:t>• ' hi ' becomes 'hi'.</a:t>
+              <a:t>• box.value is whatever you have typed in that box right now.</a:t>
             </a:r>
           </a:p>
         </p:txBody>
@@ -6969,7 +7108,7 @@
                   <a:srgbClr val="1F2A37"/>
                 </a:solidFill>
               </a:rPr>
-              <a:t>Comparing with ===</a:t>
+              <a:t>.trim()</a:t>
             </a:r>
           </a:p>
         </p:txBody>
@@ -7040,7 +7179,7 @@
                   <a:srgbClr val="1F2A37"/>
                 </a:solidFill>
               </a:rPr>
-              <a:t>• === asks 'are these exactly equal?' and gives true or false.</a:t>
+              <a:t>• Removes blank space from the ends of text.</a:t>
             </a:r>
           </a:p>
           <a:p>
@@ -7055,7 +7194,7 @@
                   <a:srgbClr val="1F2A37"/>
                 </a:solidFill>
               </a:rPr>
-              <a:t>• One = SETS a value; three === CHECKS a value.</a:t>
+              <a:t>• ' hi ' becomes 'hi'.</a:t>
             </a:r>
           </a:p>
         </p:txBody>
@@ -7071,6 +7210,14 @@
 <file path=ppt/slides/slide32.xml><?xml version="1.0" encoding="utf-8"?>
 <p:sld xmlns:a="http://schemas.openxmlformats.org/drawingml/2006/main" xmlns:p="http://schemas.openxmlformats.org/presentationml/2006/main" xmlns:r="http://schemas.openxmlformats.org/officeDocument/2006/relationships">
   <p:cSld>
+    <p:bg>
+      <p:bgPr>
+        <a:solidFill>
+          <a:srgbClr val="102127"/>
+        </a:solidFill>
+        <a:effectLst/>
+      </p:bgPr>
+    </p:bg>
     <p:spTree>
       <p:nvGrpSpPr>
         <p:cNvPr id="1" name=""/>
@@ -7080,40 +7227,14 @@
       <p:grpSpPr/>
       <p:sp>
         <p:nvSpPr>
-          <p:cNvPr id="2" name="Title 1"/>
-          <p:cNvSpPr>
-            <a:spLocks noGrp="1"/>
-          </p:cNvSpPr>
-          <p:nvPr>
-            <p:ph type="title"/>
-          </p:nvPr>
-        </p:nvSpPr>
-        <p:spPr/>
-        <p:txBody>
-          <a:bodyPr/>
-          <a:lstStyle/>
-          <a:p>
-            <a:r>
-              <a:rPr sz="3800" b="1">
-                <a:solidFill>
-                  <a:srgbClr val="1F2A37"/>
-                </a:solidFill>
-              </a:rPr>
-              <a:t>The if statement</a:t>
-            </a:r>
-          </a:p>
-        </p:txBody>
-      </p:sp>
-      <p:sp>
-        <p:nvSpPr>
-          <p:cNvPr id="3" name="TextBox 2"/>
+          <p:cNvPr id="2" name="TextBox 1"/>
           <p:cNvSpPr txBox="1"/>
           <p:nvPr/>
         </p:nvSpPr>
         <p:spPr>
           <a:xfrm>
-            <a:off x="868680" y="502920"/>
-            <a:ext cx="5486400" cy="457200"/>
+            <a:off x="502920" y="274320"/>
+            <a:ext cx="11155680" cy="548640"/>
           </a:xfrm>
           <a:prstGeom prst="rect">
             <a:avLst/>
@@ -7127,26 +7248,26 @@
           <a:lstStyle/>
           <a:p>
             <a:r>
-              <a:rPr sz="1500" b="1">
+              <a:rPr sz="2200" b="1">
                 <a:solidFill>
                   <a:srgbClr val="01AEFD"/>
                 </a:solidFill>
               </a:rPr>
-              <a:t>JAVASCRIPT</a:t>
-            </a:r>
-          </a:p>
-        </p:txBody>
-      </p:sp>
-      <p:sp>
-        <p:nvSpPr>
-          <p:cNvPr id="4" name="TextBox 3"/>
+              <a:t>Type this into script.js   -   line 26</a:t>
+            </a:r>
+          </a:p>
+        </p:txBody>
+      </p:sp>
+      <p:sp>
+        <p:nvSpPr>
+          <p:cNvPr id="3" name="TextBox 2"/>
           <p:cNvSpPr txBox="1"/>
           <p:nvPr/>
         </p:nvSpPr>
         <p:spPr>
           <a:xfrm>
-            <a:off x="822960" y="1828800"/>
-            <a:ext cx="10515600" cy="4206240"/>
+            <a:off x="502920" y="960120"/>
+            <a:ext cx="11155680" cy="4297680"/>
           </a:xfrm>
           <a:prstGeom prst="rect">
             <a:avLst/>
@@ -7154,23 +7275,191 @@
           <a:noFill/>
         </p:spPr>
         <p:txBody>
+          <a:bodyPr wrap="none">
+            <a:spAutoFit/>
+          </a:bodyPr>
+          <a:lstStyle/>
+          <a:p>
+            <a:pPr>
+              <a:spcAft>
+                <a:spcPts val="0"/>
+              </a:spcAft>
+            </a:pPr>
+            <a:r>
+              <a:rPr sz="1800">
+                <a:solidFill>
+                  <a:srgbClr val="6D8C97"/>
+                </a:solidFill>
+                <a:latin typeface="Consolas"/>
+              </a:rPr>
+              <a:t>  21  </a:t>
+            </a:r>
+            <a:r>
+              <a:rPr sz="1800">
+                <a:solidFill>
+                  <a:srgbClr val="6D8C97"/>
+                </a:solidFill>
+                <a:latin typeface="Consolas"/>
+              </a:rPr>
+              <a:t> </a:t>
+            </a:r>
+          </a:p>
+          <a:p>
+            <a:pPr>
+              <a:spcAft>
+                <a:spcPts val="0"/>
+              </a:spcAft>
+            </a:pPr>
+            <a:r>
+              <a:rPr sz="1800">
+                <a:solidFill>
+                  <a:srgbClr val="6D8C97"/>
+                </a:solidFill>
+                <a:latin typeface="Consolas"/>
+              </a:rPr>
+              <a:t>  22  </a:t>
+            </a:r>
+            <a:r>
+              <a:rPr sz="1800">
+                <a:solidFill>
+                  <a:srgbClr val="6D8C97"/>
+                </a:solidFill>
+                <a:latin typeface="Consolas"/>
+              </a:rPr>
+              <a:t>// In PixelPad your loop() checked 'was a key pressed?' every frame. Here you</a:t>
+            </a:r>
+          </a:p>
+          <a:p>
+            <a:pPr>
+              <a:spcAft>
+                <a:spcPts val="0"/>
+              </a:spcAft>
+            </a:pPr>
+            <a:r>
+              <a:rPr sz="1800">
+                <a:solidFill>
+                  <a:srgbClr val="6D8C97"/>
+                </a:solidFill>
+                <a:latin typeface="Consolas"/>
+              </a:rPr>
+              <a:t>  23  </a:t>
+            </a:r>
+            <a:r>
+              <a:rPr sz="1800">
+                <a:solidFill>
+                  <a:srgbClr val="6D8C97"/>
+                </a:solidFill>
+                <a:latin typeface="Consolas"/>
+              </a:rPr>
+              <a:t>// leave a note: when this form is submitted, run this. The browser waits.</a:t>
+            </a:r>
+          </a:p>
+          <a:p>
+            <a:pPr>
+              <a:spcAft>
+                <a:spcPts val="0"/>
+              </a:spcAft>
+            </a:pPr>
+            <a:r>
+              <a:rPr sz="1800">
+                <a:solidFill>
+                  <a:srgbClr val="6D8C97"/>
+                </a:solidFill>
+                <a:latin typeface="Consolas"/>
+              </a:rPr>
+              <a:t>  24  </a:t>
+            </a:r>
+            <a:r>
+              <a:rPr sz="1800">
+                <a:solidFill>
+                  <a:srgbClr val="6D8C97"/>
+                </a:solidFill>
+                <a:latin typeface="Consolas"/>
+              </a:rPr>
+              <a:t>composer.addEventListener('submit', function (event) {</a:t>
+            </a:r>
+          </a:p>
+          <a:p>
+            <a:pPr>
+              <a:spcAft>
+                <a:spcPts val="0"/>
+              </a:spcAft>
+            </a:pPr>
+            <a:r>
+              <a:rPr sz="1800">
+                <a:solidFill>
+                  <a:srgbClr val="6D8C97"/>
+                </a:solidFill>
+                <a:latin typeface="Consolas"/>
+              </a:rPr>
+              <a:t>  25  </a:t>
+            </a:r>
+            <a:r>
+              <a:rPr sz="1800">
+                <a:solidFill>
+                  <a:srgbClr val="6D8C97"/>
+                </a:solidFill>
+                <a:latin typeface="Consolas"/>
+              </a:rPr>
+              <a:t>  event.preventDefault();          // stop the browser reloading the page</a:t>
+            </a:r>
+          </a:p>
+          <a:p>
+            <a:pPr>
+              <a:spcAft>
+                <a:spcPts val="0"/>
+              </a:spcAft>
+            </a:pPr>
+            <a:r>
+              <a:rPr sz="1800">
+                <a:solidFill>
+                  <a:srgbClr val="6D8C97"/>
+                </a:solidFill>
+                <a:latin typeface="Consolas"/>
+              </a:rPr>
+              <a:t>  26  </a:t>
+            </a:r>
+            <a:r>
+              <a:rPr sz="1800">
+                <a:solidFill>
+                  <a:srgbClr val="7FE0A0"/>
+                </a:solidFill>
+                <a:latin typeface="Consolas"/>
+              </a:rPr>
+              <a:t>  const text = promptBox.value.trim();</a:t>
+            </a:r>
+          </a:p>
+        </p:txBody>
+      </p:sp>
+      <p:sp>
+        <p:nvSpPr>
+          <p:cNvPr id="4" name="TextBox 3"/>
+          <p:cNvSpPr txBox="1"/>
+          <p:nvPr/>
+        </p:nvSpPr>
+        <p:spPr>
+          <a:xfrm>
+            <a:off x="548640" y="5623560"/>
+            <a:ext cx="11064240" cy="1051560"/>
+          </a:xfrm>
+          <a:prstGeom prst="rect">
+            <a:avLst/>
+          </a:prstGeom>
+          <a:noFill/>
+        </p:spPr>
+        <p:txBody>
           <a:bodyPr wrap="square">
             <a:spAutoFit/>
           </a:bodyPr>
           <a:lstStyle/>
           <a:p>
-            <a:pPr>
-              <a:spcAft>
-                <a:spcPts val="1400"/>
-              </a:spcAft>
-            </a:pPr>
-            <a:r>
-              <a:rPr sz="2400">
-                <a:solidFill>
-                  <a:srgbClr val="1F2A37"/>
-                </a:solidFill>
-              </a:rPr>
-              <a:t>• Runs the code in { } only WHEN the test in ( ) is true.</a:t>
+            <a:r>
+              <a:rPr sz="2000">
+                <a:solidFill>
+                  <a:srgbClr val="DCECEF"/>
+                </a:solidFill>
+              </a:rPr>
+              <a:t>Read what you typed and trim the blank space off the ends.</a:t>
             </a:r>
           </a:p>
         </p:txBody>
@@ -7214,7 +7503,7 @@
                   <a:srgbClr val="1F2A37"/>
                 </a:solidFill>
               </a:rPr>
-              <a:t>return</a:t>
+              <a:t>Comparing with ===</a:t>
             </a:r>
           </a:p>
         </p:txBody>
@@ -7285,7 +7574,22 @@
                   <a:srgbClr val="1F2A37"/>
                 </a:solidFill>
               </a:rPr>
-              <a:t>• Stops the function right there. Nothing after it runs.</a:t>
+              <a:t>• === asks 'are these exactly equal?' and gives true or false.</a:t>
+            </a:r>
+          </a:p>
+          <a:p>
+            <a:pPr>
+              <a:spcAft>
+                <a:spcPts val="1400"/>
+              </a:spcAft>
+            </a:pPr>
+            <a:r>
+              <a:rPr sz="2400">
+                <a:solidFill>
+                  <a:srgbClr val="1F2A37"/>
+                </a:solidFill>
+              </a:rPr>
+              <a:t>• One = SETS a value; three === CHECKS a value.</a:t>
             </a:r>
           </a:p>
         </p:txBody>
@@ -7301,14 +7605,6 @@
 <file path=ppt/slides/slide34.xml><?xml version="1.0" encoding="utf-8"?>
 <p:sld xmlns:a="http://schemas.openxmlformats.org/drawingml/2006/main" xmlns:p="http://schemas.openxmlformats.org/presentationml/2006/main" xmlns:r="http://schemas.openxmlformats.org/officeDocument/2006/relationships">
   <p:cSld>
-    <p:bg>
-      <p:bgPr>
-        <a:solidFill>
-          <a:srgbClr val="102127"/>
-        </a:solidFill>
-        <a:effectLst/>
-      </p:bgPr>
-    </p:bg>
     <p:spTree>
       <p:nvGrpSpPr>
         <p:cNvPr id="1" name=""/>
@@ -7318,14 +7614,40 @@
       <p:grpSpPr/>
       <p:sp>
         <p:nvSpPr>
-          <p:cNvPr id="2" name="TextBox 1"/>
+          <p:cNvPr id="2" name="Title 1"/>
+          <p:cNvSpPr>
+            <a:spLocks noGrp="1"/>
+          </p:cNvSpPr>
+          <p:nvPr>
+            <p:ph type="title"/>
+          </p:nvPr>
+        </p:nvSpPr>
+        <p:spPr/>
+        <p:txBody>
+          <a:bodyPr/>
+          <a:lstStyle/>
+          <a:p>
+            <a:r>
+              <a:rPr sz="3800" b="1">
+                <a:solidFill>
+                  <a:srgbClr val="1F2A37"/>
+                </a:solidFill>
+              </a:rPr>
+              <a:t>The if statement</a:t>
+            </a:r>
+          </a:p>
+        </p:txBody>
+      </p:sp>
+      <p:sp>
+        <p:nvSpPr>
+          <p:cNvPr id="3" name="TextBox 2"/>
           <p:cNvSpPr txBox="1"/>
           <p:nvPr/>
         </p:nvSpPr>
         <p:spPr>
           <a:xfrm>
-            <a:off x="502920" y="274320"/>
-            <a:ext cx="11155680" cy="548640"/>
+            <a:off x="868680" y="502920"/>
+            <a:ext cx="5486400" cy="457200"/>
           </a:xfrm>
           <a:prstGeom prst="rect">
             <a:avLst/>
@@ -7339,26 +7661,26 @@
           <a:lstStyle/>
           <a:p>
             <a:r>
-              <a:rPr sz="2200" b="1">
+              <a:rPr sz="1500" b="1">
                 <a:solidFill>
                   <a:srgbClr val="01AEFD"/>
                 </a:solidFill>
               </a:rPr>
-              <a:t>Type this into script.js   -   line 29</a:t>
-            </a:r>
-          </a:p>
-        </p:txBody>
-      </p:sp>
-      <p:sp>
-        <p:nvSpPr>
-          <p:cNvPr id="3" name="TextBox 2"/>
+              <a:t>JAVASCRIPT</a:t>
+            </a:r>
+          </a:p>
+        </p:txBody>
+      </p:sp>
+      <p:sp>
+        <p:nvSpPr>
+          <p:cNvPr id="4" name="TextBox 3"/>
           <p:cNvSpPr txBox="1"/>
           <p:nvPr/>
         </p:nvSpPr>
         <p:spPr>
           <a:xfrm>
-            <a:off x="502920" y="960120"/>
-            <a:ext cx="11155680" cy="4297680"/>
+            <a:off x="822960" y="1828800"/>
+            <a:ext cx="10515600" cy="4206240"/>
           </a:xfrm>
           <a:prstGeom prst="rect">
             <a:avLst/>
@@ -7366,266 +7688,23 @@
           <a:noFill/>
         </p:spPr>
         <p:txBody>
-          <a:bodyPr wrap="none">
-            <a:spAutoFit/>
-          </a:bodyPr>
-          <a:lstStyle/>
-          <a:p>
-            <a:pPr>
-              <a:spcAft>
-                <a:spcPts val="0"/>
-              </a:spcAft>
-            </a:pPr>
-            <a:r>
-              <a:rPr sz="1800">
-                <a:solidFill>
-                  <a:srgbClr val="6D8C97"/>
-                </a:solidFill>
-                <a:latin typeface="Consolas"/>
-              </a:rPr>
-              <a:t>  21  </a:t>
-            </a:r>
-            <a:r>
-              <a:rPr sz="1800">
-                <a:solidFill>
-                  <a:srgbClr val="6D8C97"/>
-                </a:solidFill>
-                <a:latin typeface="Consolas"/>
-              </a:rPr>
-              <a:t> </a:t>
-            </a:r>
-          </a:p>
-          <a:p>
-            <a:pPr>
-              <a:spcAft>
-                <a:spcPts val="0"/>
-              </a:spcAft>
-            </a:pPr>
-            <a:r>
-              <a:rPr sz="1800">
-                <a:solidFill>
-                  <a:srgbClr val="6D8C97"/>
-                </a:solidFill>
-                <a:latin typeface="Consolas"/>
-              </a:rPr>
-              <a:t>  22  </a:t>
-            </a:r>
-            <a:r>
-              <a:rPr sz="1800">
-                <a:solidFill>
-                  <a:srgbClr val="6D8C97"/>
-                </a:solidFill>
-                <a:latin typeface="Consolas"/>
-              </a:rPr>
-              <a:t>// In PixelPad your loop() checked 'was a key pressed?' every frame. Here you</a:t>
-            </a:r>
-          </a:p>
-          <a:p>
-            <a:pPr>
-              <a:spcAft>
-                <a:spcPts val="0"/>
-              </a:spcAft>
-            </a:pPr>
-            <a:r>
-              <a:rPr sz="1800">
-                <a:solidFill>
-                  <a:srgbClr val="6D8C97"/>
-                </a:solidFill>
-                <a:latin typeface="Consolas"/>
-              </a:rPr>
-              <a:t>  23  </a:t>
-            </a:r>
-            <a:r>
-              <a:rPr sz="1800">
-                <a:solidFill>
-                  <a:srgbClr val="6D8C97"/>
-                </a:solidFill>
-                <a:latin typeface="Consolas"/>
-              </a:rPr>
-              <a:t>// leave a note: when this form is submitted, run this. The browser waits.</a:t>
-            </a:r>
-          </a:p>
-          <a:p>
-            <a:pPr>
-              <a:spcAft>
-                <a:spcPts val="0"/>
-              </a:spcAft>
-            </a:pPr>
-            <a:r>
-              <a:rPr sz="1800">
-                <a:solidFill>
-                  <a:srgbClr val="6D8C97"/>
-                </a:solidFill>
-                <a:latin typeface="Consolas"/>
-              </a:rPr>
-              <a:t>  24  </a:t>
-            </a:r>
-            <a:r>
-              <a:rPr sz="1800">
-                <a:solidFill>
-                  <a:srgbClr val="6D8C97"/>
-                </a:solidFill>
-                <a:latin typeface="Consolas"/>
-              </a:rPr>
-              <a:t>composer.addEventListener('submit', function (event) {</a:t>
-            </a:r>
-          </a:p>
-          <a:p>
-            <a:pPr>
-              <a:spcAft>
-                <a:spcPts val="0"/>
-              </a:spcAft>
-            </a:pPr>
-            <a:r>
-              <a:rPr sz="1800">
-                <a:solidFill>
-                  <a:srgbClr val="6D8C97"/>
-                </a:solidFill>
-                <a:latin typeface="Consolas"/>
-              </a:rPr>
-              <a:t>  25  </a:t>
-            </a:r>
-            <a:r>
-              <a:rPr sz="1800">
-                <a:solidFill>
-                  <a:srgbClr val="6D8C97"/>
-                </a:solidFill>
-                <a:latin typeface="Consolas"/>
-              </a:rPr>
-              <a:t>  event.preventDefault();          // stop the browser reloading the page</a:t>
-            </a:r>
-          </a:p>
-          <a:p>
-            <a:pPr>
-              <a:spcAft>
-                <a:spcPts val="0"/>
-              </a:spcAft>
-            </a:pPr>
-            <a:r>
-              <a:rPr sz="1800">
-                <a:solidFill>
-                  <a:srgbClr val="6D8C97"/>
-                </a:solidFill>
-                <a:latin typeface="Consolas"/>
-              </a:rPr>
-              <a:t>  26  </a:t>
-            </a:r>
-            <a:r>
-              <a:rPr sz="1800">
-                <a:solidFill>
-                  <a:srgbClr val="6D8C97"/>
-                </a:solidFill>
-                <a:latin typeface="Consolas"/>
-              </a:rPr>
-              <a:t>  const text = promptBox.value.trim();</a:t>
-            </a:r>
-          </a:p>
-          <a:p>
-            <a:pPr>
-              <a:spcAft>
-                <a:spcPts val="0"/>
-              </a:spcAft>
-            </a:pPr>
-            <a:r>
-              <a:rPr sz="1800">
-                <a:solidFill>
-                  <a:srgbClr val="6D8C97"/>
-                </a:solidFill>
-                <a:latin typeface="Consolas"/>
-              </a:rPr>
-              <a:t>  27  </a:t>
-            </a:r>
-            <a:r>
-              <a:rPr sz="1800">
-                <a:solidFill>
-                  <a:srgbClr val="6D8C97"/>
-                </a:solidFill>
-                <a:latin typeface="Consolas"/>
-              </a:rPr>
-              <a:t>  if (text === '') { return; }     // nothing typed, nothing to do</a:t>
-            </a:r>
-          </a:p>
-          <a:p>
-            <a:pPr>
-              <a:spcAft>
-                <a:spcPts val="0"/>
-              </a:spcAft>
-            </a:pPr>
-            <a:r>
-              <a:rPr sz="1800">
-                <a:solidFill>
-                  <a:srgbClr val="6D8C97"/>
-                </a:solidFill>
-                <a:latin typeface="Consolas"/>
-              </a:rPr>
-              <a:t>  28  </a:t>
-            </a:r>
-            <a:r>
-              <a:rPr sz="1800">
-                <a:solidFill>
-                  <a:srgbClr val="6D8C97"/>
-                </a:solidFill>
-                <a:latin typeface="Consolas"/>
-              </a:rPr>
-              <a:t>  promptBox.value = '';            // clear the box, ready for the next one</a:t>
-            </a:r>
-          </a:p>
-          <a:p>
-            <a:pPr>
-              <a:spcAft>
-                <a:spcPts val="0"/>
-              </a:spcAft>
-            </a:pPr>
-            <a:r>
-              <a:rPr sz="1800">
-                <a:solidFill>
-                  <a:srgbClr val="6D8C97"/>
-                </a:solidFill>
-                <a:latin typeface="Consolas"/>
-              </a:rPr>
-              <a:t>  29  </a:t>
-            </a:r>
-            <a:r>
-              <a:rPr sz="1800">
-                <a:solidFill>
-                  <a:srgbClr val="7FE0A0"/>
-                </a:solidFill>
-                <a:latin typeface="Consolas"/>
-              </a:rPr>
-              <a:t>  addLine('You', text);</a:t>
-            </a:r>
-          </a:p>
-        </p:txBody>
-      </p:sp>
-      <p:sp>
-        <p:nvSpPr>
-          <p:cNvPr id="4" name="TextBox 3"/>
-          <p:cNvSpPr txBox="1"/>
-          <p:nvPr/>
-        </p:nvSpPr>
-        <p:spPr>
-          <a:xfrm>
-            <a:off x="548640" y="5623560"/>
-            <a:ext cx="11064240" cy="1051560"/>
-          </a:xfrm>
-          <a:prstGeom prst="rect">
-            <a:avLst/>
-          </a:prstGeom>
-          <a:noFill/>
-        </p:spPr>
-        <p:txBody>
           <a:bodyPr wrap="square">
             <a:spAutoFit/>
           </a:bodyPr>
           <a:lstStyle/>
           <a:p>
-            <a:r>
-              <a:rPr sz="2000">
-                <a:solidFill>
-                  <a:srgbClr val="DCECEF"/>
-                </a:solidFill>
-              </a:rPr>
-              <a:t>Change the pretend reply to a 'thinking...' line while we wait.</a:t>
+            <a:pPr>
+              <a:spcAft>
+                <a:spcPts val="1400"/>
+              </a:spcAft>
+            </a:pPr>
+            <a:r>
+              <a:rPr sz="2400">
+                <a:solidFill>
+                  <a:srgbClr val="1F2A37"/>
+                </a:solidFill>
+              </a:rPr>
+              <a:t>• Runs the code in { } only WHEN the test in ( ) is true.</a:t>
             </a:r>
           </a:p>
         </p:txBody>
@@ -7641,14 +7720,6 @@
 <file path=ppt/slides/slide35.xml><?xml version="1.0" encoding="utf-8"?>
 <p:sld xmlns:a="http://schemas.openxmlformats.org/drawingml/2006/main" xmlns:p="http://schemas.openxmlformats.org/presentationml/2006/main" xmlns:r="http://schemas.openxmlformats.org/officeDocument/2006/relationships">
   <p:cSld>
-    <p:bg>
-      <p:bgPr>
-        <a:solidFill>
-          <a:srgbClr val="102127"/>
-        </a:solidFill>
-        <a:effectLst/>
-      </p:bgPr>
-    </p:bg>
     <p:spTree>
       <p:nvGrpSpPr>
         <p:cNvPr id="1" name=""/>
@@ -7658,14 +7729,40 @@
       <p:grpSpPr/>
       <p:sp>
         <p:nvSpPr>
-          <p:cNvPr id="2" name="TextBox 1"/>
+          <p:cNvPr id="2" name="Title 1"/>
+          <p:cNvSpPr>
+            <a:spLocks noGrp="1"/>
+          </p:cNvSpPr>
+          <p:nvPr>
+            <p:ph type="title"/>
+          </p:nvPr>
+        </p:nvSpPr>
+        <p:spPr/>
+        <p:txBody>
+          <a:bodyPr/>
+          <a:lstStyle/>
+          <a:p>
+            <a:r>
+              <a:rPr sz="3800" b="1">
+                <a:solidFill>
+                  <a:srgbClr val="1F2A37"/>
+                </a:solidFill>
+              </a:rPr>
+              <a:t>return</a:t>
+            </a:r>
+          </a:p>
+        </p:txBody>
+      </p:sp>
+      <p:sp>
+        <p:nvSpPr>
+          <p:cNvPr id="3" name="TextBox 2"/>
           <p:cNvSpPr txBox="1"/>
           <p:nvPr/>
         </p:nvSpPr>
         <p:spPr>
           <a:xfrm>
-            <a:off x="502920" y="274320"/>
-            <a:ext cx="11155680" cy="548640"/>
+            <a:off x="868680" y="502920"/>
+            <a:ext cx="5486400" cy="457200"/>
           </a:xfrm>
           <a:prstGeom prst="rect">
             <a:avLst/>
@@ -7679,26 +7776,26 @@
           <a:lstStyle/>
           <a:p>
             <a:r>
-              <a:rPr sz="2200" b="1">
+              <a:rPr sz="1500" b="1">
                 <a:solidFill>
                   <a:srgbClr val="01AEFD"/>
                 </a:solidFill>
               </a:rPr>
-              <a:t>Type this into script.js   -   line 30</a:t>
-            </a:r>
-          </a:p>
-        </p:txBody>
-      </p:sp>
-      <p:sp>
-        <p:nvSpPr>
-          <p:cNvPr id="3" name="TextBox 2"/>
+              <a:t>JAVASCRIPT</a:t>
+            </a:r>
+          </a:p>
+        </p:txBody>
+      </p:sp>
+      <p:sp>
+        <p:nvSpPr>
+          <p:cNvPr id="4" name="TextBox 3"/>
           <p:cNvSpPr txBox="1"/>
           <p:nvPr/>
         </p:nvSpPr>
         <p:spPr>
           <a:xfrm>
-            <a:off x="502920" y="960120"/>
-            <a:ext cx="11155680" cy="4297680"/>
+            <a:off x="822960" y="1828800"/>
+            <a:ext cx="10515600" cy="4206240"/>
           </a:xfrm>
           <a:prstGeom prst="rect">
             <a:avLst/>
@@ -7706,291 +7803,23 @@
           <a:noFill/>
         </p:spPr>
         <p:txBody>
-          <a:bodyPr wrap="none">
-            <a:spAutoFit/>
-          </a:bodyPr>
-          <a:lstStyle/>
-          <a:p>
-            <a:pPr>
-              <a:spcAft>
-                <a:spcPts val="0"/>
-              </a:spcAft>
-            </a:pPr>
-            <a:r>
-              <a:rPr sz="1800">
-                <a:solidFill>
-                  <a:srgbClr val="6D8C97"/>
-                </a:solidFill>
-                <a:latin typeface="Consolas"/>
-              </a:rPr>
-              <a:t>  21  </a:t>
-            </a:r>
-            <a:r>
-              <a:rPr sz="1800">
-                <a:solidFill>
-                  <a:srgbClr val="6D8C97"/>
-                </a:solidFill>
-                <a:latin typeface="Consolas"/>
-              </a:rPr>
-              <a:t> </a:t>
-            </a:r>
-          </a:p>
-          <a:p>
-            <a:pPr>
-              <a:spcAft>
-                <a:spcPts val="0"/>
-              </a:spcAft>
-            </a:pPr>
-            <a:r>
-              <a:rPr sz="1800">
-                <a:solidFill>
-                  <a:srgbClr val="6D8C97"/>
-                </a:solidFill>
-                <a:latin typeface="Consolas"/>
-              </a:rPr>
-              <a:t>  22  </a:t>
-            </a:r>
-            <a:r>
-              <a:rPr sz="1800">
-                <a:solidFill>
-                  <a:srgbClr val="6D8C97"/>
-                </a:solidFill>
-                <a:latin typeface="Consolas"/>
-              </a:rPr>
-              <a:t>// In PixelPad your loop() checked 'was a key pressed?' every frame. Here you</a:t>
-            </a:r>
-          </a:p>
-          <a:p>
-            <a:pPr>
-              <a:spcAft>
-                <a:spcPts val="0"/>
-              </a:spcAft>
-            </a:pPr>
-            <a:r>
-              <a:rPr sz="1800">
-                <a:solidFill>
-                  <a:srgbClr val="6D8C97"/>
-                </a:solidFill>
-                <a:latin typeface="Consolas"/>
-              </a:rPr>
-              <a:t>  23  </a:t>
-            </a:r>
-            <a:r>
-              <a:rPr sz="1800">
-                <a:solidFill>
-                  <a:srgbClr val="6D8C97"/>
-                </a:solidFill>
-                <a:latin typeface="Consolas"/>
-              </a:rPr>
-              <a:t>// leave a note: when this form is submitted, run this. The browser waits.</a:t>
-            </a:r>
-          </a:p>
-          <a:p>
-            <a:pPr>
-              <a:spcAft>
-                <a:spcPts val="0"/>
-              </a:spcAft>
-            </a:pPr>
-            <a:r>
-              <a:rPr sz="1800">
-                <a:solidFill>
-                  <a:srgbClr val="6D8C97"/>
-                </a:solidFill>
-                <a:latin typeface="Consolas"/>
-              </a:rPr>
-              <a:t>  24  </a:t>
-            </a:r>
-            <a:r>
-              <a:rPr sz="1800">
-                <a:solidFill>
-                  <a:srgbClr val="6D8C97"/>
-                </a:solidFill>
-                <a:latin typeface="Consolas"/>
-              </a:rPr>
-              <a:t>composer.addEventListener('submit', function (event) {</a:t>
-            </a:r>
-          </a:p>
-          <a:p>
-            <a:pPr>
-              <a:spcAft>
-                <a:spcPts val="0"/>
-              </a:spcAft>
-            </a:pPr>
-            <a:r>
-              <a:rPr sz="1800">
-                <a:solidFill>
-                  <a:srgbClr val="6D8C97"/>
-                </a:solidFill>
-                <a:latin typeface="Consolas"/>
-              </a:rPr>
-              <a:t>  25  </a:t>
-            </a:r>
-            <a:r>
-              <a:rPr sz="1800">
-                <a:solidFill>
-                  <a:srgbClr val="6D8C97"/>
-                </a:solidFill>
-                <a:latin typeface="Consolas"/>
-              </a:rPr>
-              <a:t>  event.preventDefault();          // stop the browser reloading the page</a:t>
-            </a:r>
-          </a:p>
-          <a:p>
-            <a:pPr>
-              <a:spcAft>
-                <a:spcPts val="0"/>
-              </a:spcAft>
-            </a:pPr>
-            <a:r>
-              <a:rPr sz="1800">
-                <a:solidFill>
-                  <a:srgbClr val="6D8C97"/>
-                </a:solidFill>
-                <a:latin typeface="Consolas"/>
-              </a:rPr>
-              <a:t>  26  </a:t>
-            </a:r>
-            <a:r>
-              <a:rPr sz="1800">
-                <a:solidFill>
-                  <a:srgbClr val="6D8C97"/>
-                </a:solidFill>
-                <a:latin typeface="Consolas"/>
-              </a:rPr>
-              <a:t>  const text = promptBox.value.trim();</a:t>
-            </a:r>
-          </a:p>
-          <a:p>
-            <a:pPr>
-              <a:spcAft>
-                <a:spcPts val="0"/>
-              </a:spcAft>
-            </a:pPr>
-            <a:r>
-              <a:rPr sz="1800">
-                <a:solidFill>
-                  <a:srgbClr val="6D8C97"/>
-                </a:solidFill>
-                <a:latin typeface="Consolas"/>
-              </a:rPr>
-              <a:t>  27  </a:t>
-            </a:r>
-            <a:r>
-              <a:rPr sz="1800">
-                <a:solidFill>
-                  <a:srgbClr val="6D8C97"/>
-                </a:solidFill>
-                <a:latin typeface="Consolas"/>
-              </a:rPr>
-              <a:t>  if (text === '') { return; }     // nothing typed, nothing to do</a:t>
-            </a:r>
-          </a:p>
-          <a:p>
-            <a:pPr>
-              <a:spcAft>
-                <a:spcPts val="0"/>
-              </a:spcAft>
-            </a:pPr>
-            <a:r>
-              <a:rPr sz="1800">
-                <a:solidFill>
-                  <a:srgbClr val="6D8C97"/>
-                </a:solidFill>
-                <a:latin typeface="Consolas"/>
-              </a:rPr>
-              <a:t>  28  </a:t>
-            </a:r>
-            <a:r>
-              <a:rPr sz="1800">
-                <a:solidFill>
-                  <a:srgbClr val="6D8C97"/>
-                </a:solidFill>
-                <a:latin typeface="Consolas"/>
-              </a:rPr>
-              <a:t>  promptBox.value = '';            // clear the box, ready for the next one</a:t>
-            </a:r>
-          </a:p>
-          <a:p>
-            <a:pPr>
-              <a:spcAft>
-                <a:spcPts val="0"/>
-              </a:spcAft>
-            </a:pPr>
-            <a:r>
-              <a:rPr sz="1800">
-                <a:solidFill>
-                  <a:srgbClr val="6D8C97"/>
-                </a:solidFill>
-                <a:latin typeface="Consolas"/>
-              </a:rPr>
-              <a:t>  29  </a:t>
-            </a:r>
-            <a:r>
-              <a:rPr sz="1800">
-                <a:solidFill>
-                  <a:srgbClr val="6D8C97"/>
-                </a:solidFill>
-                <a:latin typeface="Consolas"/>
-              </a:rPr>
-              <a:t>  addLine('You', text);</a:t>
-            </a:r>
-          </a:p>
-          <a:p>
-            <a:pPr>
-              <a:spcAft>
-                <a:spcPts val="0"/>
-              </a:spcAft>
-            </a:pPr>
-            <a:r>
-              <a:rPr sz="1800">
-                <a:solidFill>
-                  <a:srgbClr val="6D8C97"/>
-                </a:solidFill>
-                <a:latin typeface="Consolas"/>
-              </a:rPr>
-              <a:t>  30  </a:t>
-            </a:r>
-            <a:r>
-              <a:rPr sz="1800">
-                <a:solidFill>
-                  <a:srgbClr val="7FE0A0"/>
-                </a:solidFill>
-                <a:latin typeface="Consolas"/>
-              </a:rPr>
-              <a:t>  addLine('Companion', 'You said: ' + text);   // a pretend answer, for now</a:t>
-            </a:r>
-          </a:p>
-        </p:txBody>
-      </p:sp>
-      <p:sp>
-        <p:nvSpPr>
-          <p:cNvPr id="4" name="TextBox 3"/>
-          <p:cNvSpPr txBox="1"/>
-          <p:nvPr/>
-        </p:nvSpPr>
-        <p:spPr>
-          <a:xfrm>
-            <a:off x="548640" y="5623560"/>
-            <a:ext cx="11064240" cy="1051560"/>
-          </a:xfrm>
-          <a:prstGeom prst="rect">
-            <a:avLst/>
-          </a:prstGeom>
-          <a:noFill/>
-        </p:spPr>
-        <p:txBody>
           <a:bodyPr wrap="square">
             <a:spAutoFit/>
           </a:bodyPr>
           <a:lstStyle/>
           <a:p>
-            <a:r>
-              <a:rPr sz="2000">
-                <a:solidFill>
-                  <a:srgbClr val="DCECEF"/>
-                </a:solidFill>
-              </a:rPr>
-              <a:t>await askAI(text): the slow bit - ask the AI and wait for the answer.</a:t>
+            <a:pPr>
+              <a:spcAft>
+                <a:spcPts val="1400"/>
+              </a:spcAft>
+            </a:pPr>
+            <a:r>
+              <a:rPr sz="2400">
+                <a:solidFill>
+                  <a:srgbClr val="1F2A37"/>
+                </a:solidFill>
+              </a:rPr>
+              <a:t>• Stops the function right there. Nothing after it runs.</a:t>
             </a:r>
           </a:p>
         </p:txBody>
@@ -8049,7 +7878,7 @@
                   <a:srgbClr val="01AEFD"/>
                 </a:solidFill>
               </a:rPr>
-              <a:t>Type this into script.js   -   line 31</a:t>
+              <a:t>Type this into script.js   -   line 27</a:t>
             </a:r>
           </a:p>
         </p:txBody>
@@ -8082,7 +7911,7 @@
               </a:spcAft>
             </a:pPr>
             <a:r>
-              <a:rPr sz="1300">
+              <a:rPr sz="1800">
                 <a:solidFill>
                   <a:srgbClr val="6D8C97"/>
                 </a:solidFill>
@@ -8091,7 +7920,7 @@
               <a:t>  21  </a:t>
             </a:r>
             <a:r>
-              <a:rPr sz="1300">
+              <a:rPr sz="1800">
                 <a:solidFill>
                   <a:srgbClr val="6D8C97"/>
                 </a:solidFill>
@@ -8107,7 +7936,7 @@
               </a:spcAft>
             </a:pPr>
             <a:r>
-              <a:rPr sz="1300">
+              <a:rPr sz="1800">
                 <a:solidFill>
                   <a:srgbClr val="6D8C97"/>
                 </a:solidFill>
@@ -8116,7 +7945,7 @@
               <a:t>  22  </a:t>
             </a:r>
             <a:r>
-              <a:rPr sz="1300">
+              <a:rPr sz="1800">
                 <a:solidFill>
                   <a:srgbClr val="6D8C97"/>
                 </a:solidFill>
@@ -8132,7 +7961,7 @@
               </a:spcAft>
             </a:pPr>
             <a:r>
-              <a:rPr sz="1300">
+              <a:rPr sz="1800">
                 <a:solidFill>
                   <a:srgbClr val="6D8C97"/>
                 </a:solidFill>
@@ -8141,7 +7970,7 @@
               <a:t>  23  </a:t>
             </a:r>
             <a:r>
-              <a:rPr sz="1300">
+              <a:rPr sz="1800">
                 <a:solidFill>
                   <a:srgbClr val="6D8C97"/>
                 </a:solidFill>
@@ -8157,7 +7986,7 @@
               </a:spcAft>
             </a:pPr>
             <a:r>
-              <a:rPr sz="1300">
+              <a:rPr sz="1800">
                 <a:solidFill>
                   <a:srgbClr val="6D8C97"/>
                 </a:solidFill>
@@ -8166,7 +7995,7 @@
               <a:t>  24  </a:t>
             </a:r>
             <a:r>
-              <a:rPr sz="1300">
+              <a:rPr sz="1800">
                 <a:solidFill>
                   <a:srgbClr val="6D8C97"/>
                 </a:solidFill>
@@ -8182,7 +8011,7 @@
               </a:spcAft>
             </a:pPr>
             <a:r>
-              <a:rPr sz="1300">
+              <a:rPr sz="1800">
                 <a:solidFill>
                   <a:srgbClr val="6D8C97"/>
                 </a:solidFill>
@@ -8191,7 +8020,7 @@
               <a:t>  25  </a:t>
             </a:r>
             <a:r>
-              <a:rPr sz="1300">
+              <a:rPr sz="1800">
                 <a:solidFill>
                   <a:srgbClr val="6D8C97"/>
                 </a:solidFill>
@@ -8207,7 +8036,7 @@
               </a:spcAft>
             </a:pPr>
             <a:r>
-              <a:rPr sz="1300">
+              <a:rPr sz="1800">
                 <a:solidFill>
                   <a:srgbClr val="6D8C97"/>
                 </a:solidFill>
@@ -8216,7 +8045,7 @@
               <a:t>  26  </a:t>
             </a:r>
             <a:r>
-              <a:rPr sz="1300">
+              <a:rPr sz="1800">
                 <a:solidFill>
                   <a:srgbClr val="6D8C97"/>
                 </a:solidFill>
@@ -8232,7 +8061,7 @@
               </a:spcAft>
             </a:pPr>
             <a:r>
-              <a:rPr sz="1300">
+              <a:rPr sz="1800">
                 <a:solidFill>
                   <a:srgbClr val="6D8C97"/>
                 </a:solidFill>
@@ -8241,113 +8070,13 @@
               <a:t>  27  </a:t>
             </a:r>
             <a:r>
-              <a:rPr sz="1300">
-                <a:solidFill>
-                  <a:srgbClr val="6D8C97"/>
+              <a:rPr sz="1800">
+                <a:solidFill>
+                  <a:srgbClr val="7FE0A0"/>
                 </a:solidFill>
                 <a:latin typeface="Consolas"/>
               </a:rPr>
               <a:t>  if (text === '') { return; }     // nothing typed, nothing to do</a:t>
-            </a:r>
-          </a:p>
-          <a:p>
-            <a:pPr>
-              <a:spcAft>
-                <a:spcPts val="0"/>
-              </a:spcAft>
-            </a:pPr>
-            <a:r>
-              <a:rPr sz="1300">
-                <a:solidFill>
-                  <a:srgbClr val="6D8C97"/>
-                </a:solidFill>
-                <a:latin typeface="Consolas"/>
-              </a:rPr>
-              <a:t>  28  </a:t>
-            </a:r>
-            <a:r>
-              <a:rPr sz="1300">
-                <a:solidFill>
-                  <a:srgbClr val="6D8C97"/>
-                </a:solidFill>
-                <a:latin typeface="Consolas"/>
-              </a:rPr>
-              <a:t>  promptBox.value = '';            // clear the box, ready for the next one</a:t>
-            </a:r>
-          </a:p>
-          <a:p>
-            <a:pPr>
-              <a:spcAft>
-                <a:spcPts val="0"/>
-              </a:spcAft>
-            </a:pPr>
-            <a:r>
-              <a:rPr sz="1300">
-                <a:solidFill>
-                  <a:srgbClr val="6D8C97"/>
-                </a:solidFill>
-                <a:latin typeface="Consolas"/>
-              </a:rPr>
-              <a:t>  29  </a:t>
-            </a:r>
-            <a:r>
-              <a:rPr sz="1300">
-                <a:solidFill>
-                  <a:srgbClr val="6D8C97"/>
-                </a:solidFill>
-                <a:latin typeface="Consolas"/>
-              </a:rPr>
-              <a:t>  addLine('You', text);</a:t>
-            </a:r>
-          </a:p>
-          <a:p>
-            <a:pPr>
-              <a:spcAft>
-                <a:spcPts val="0"/>
-              </a:spcAft>
-            </a:pPr>
-            <a:r>
-              <a:rPr sz="1300">
-                <a:solidFill>
-                  <a:srgbClr val="6D8C97"/>
-                </a:solidFill>
-                <a:latin typeface="Consolas"/>
-              </a:rPr>
-              <a:t>  30  </a:t>
-            </a:r>
-            <a:r>
-              <a:rPr sz="1300">
-                <a:solidFill>
-                  <a:srgbClr val="6D8C97"/>
-                </a:solidFill>
-                <a:latin typeface="Consolas"/>
-              </a:rPr>
-              <a:t>  addLine('Companion', 'You said: ' + text);   // a pretend answer, for now</a:t>
-            </a:r>
-          </a:p>
-          <a:p>
-            <a:pPr>
-              <a:spcAft>
-                <a:spcPts val="0"/>
-              </a:spcAft>
-            </a:pPr>
-            <a:r>
-              <a:rPr sz="1300">
-                <a:solidFill>
-                  <a:srgbClr val="6D8C97"/>
-                </a:solidFill>
-                <a:latin typeface="Consolas"/>
-              </a:rPr>
-              <a:t>  31  </a:t>
-            </a:r>
-            <a:r>
-              <a:rPr sz="1300">
-                <a:solidFill>
-                  <a:srgbClr val="7FE0A0"/>
-                </a:solidFill>
-                <a:latin typeface="Consolas"/>
-              </a:rPr>
-              <a:t>});</a:t>
             </a:r>
           </a:p>
         </p:txBody>
@@ -8380,7 +8109,7 @@
                   <a:srgbClr val="DCECEF"/>
                 </a:solidFill>
               </a:rPr>
-              <a:t>Remove the 'thinking...' line now the real answer is here.</a:t>
+              <a:t>If the box was empty, return - stop here and do nothing.</a:t>
             </a:r>
           </a:p>
         </p:txBody>
@@ -8439,7 +8168,7 @@
                   <a:srgbClr val="01AEFD"/>
                 </a:solidFill>
               </a:rPr>
-              <a:t>All together in script.js</a:t>
+              <a:t>Type this into script.js   -   line 28</a:t>
             </a:r>
           </a:p>
         </p:txBody>
@@ -8472,7 +8201,7 @@
               </a:spcAft>
             </a:pPr>
             <a:r>
-              <a:rPr sz="1300">
+              <a:rPr sz="1800">
                 <a:solidFill>
                   <a:srgbClr val="6D8C97"/>
                 </a:solidFill>
@@ -8481,263 +8210,188 @@
               <a:t>  21  </a:t>
             </a:r>
             <a:r>
-              <a:rPr sz="1300">
+              <a:rPr sz="1800">
+                <a:solidFill>
+                  <a:srgbClr val="6D8C97"/>
+                </a:solidFill>
+                <a:latin typeface="Consolas"/>
+              </a:rPr>
+              <a:t> </a:t>
+            </a:r>
+          </a:p>
+          <a:p>
+            <a:pPr>
+              <a:spcAft>
+                <a:spcPts val="0"/>
+              </a:spcAft>
+            </a:pPr>
+            <a:r>
+              <a:rPr sz="1800">
+                <a:solidFill>
+                  <a:srgbClr val="6D8C97"/>
+                </a:solidFill>
+                <a:latin typeface="Consolas"/>
+              </a:rPr>
+              <a:t>  22  </a:t>
+            </a:r>
+            <a:r>
+              <a:rPr sz="1800">
+                <a:solidFill>
+                  <a:srgbClr val="6D8C97"/>
+                </a:solidFill>
+                <a:latin typeface="Consolas"/>
+              </a:rPr>
+              <a:t>// In PixelPad your loop() checked 'was a key pressed?' every frame. Here you</a:t>
+            </a:r>
+          </a:p>
+          <a:p>
+            <a:pPr>
+              <a:spcAft>
+                <a:spcPts val="0"/>
+              </a:spcAft>
+            </a:pPr>
+            <a:r>
+              <a:rPr sz="1800">
+                <a:solidFill>
+                  <a:srgbClr val="6D8C97"/>
+                </a:solidFill>
+                <a:latin typeface="Consolas"/>
+              </a:rPr>
+              <a:t>  23  </a:t>
+            </a:r>
+            <a:r>
+              <a:rPr sz="1800">
+                <a:solidFill>
+                  <a:srgbClr val="6D8C97"/>
+                </a:solidFill>
+                <a:latin typeface="Consolas"/>
+              </a:rPr>
+              <a:t>// leave a note: when this form is submitted, run this. The browser waits.</a:t>
+            </a:r>
+          </a:p>
+          <a:p>
+            <a:pPr>
+              <a:spcAft>
+                <a:spcPts val="0"/>
+              </a:spcAft>
+            </a:pPr>
+            <a:r>
+              <a:rPr sz="1800">
+                <a:solidFill>
+                  <a:srgbClr val="6D8C97"/>
+                </a:solidFill>
+                <a:latin typeface="Consolas"/>
+              </a:rPr>
+              <a:t>  24  </a:t>
+            </a:r>
+            <a:r>
+              <a:rPr sz="1800">
+                <a:solidFill>
+                  <a:srgbClr val="6D8C97"/>
+                </a:solidFill>
+                <a:latin typeface="Consolas"/>
+              </a:rPr>
+              <a:t>composer.addEventListener('submit', function (event) {</a:t>
+            </a:r>
+          </a:p>
+          <a:p>
+            <a:pPr>
+              <a:spcAft>
+                <a:spcPts val="0"/>
+              </a:spcAft>
+            </a:pPr>
+            <a:r>
+              <a:rPr sz="1800">
+                <a:solidFill>
+                  <a:srgbClr val="6D8C97"/>
+                </a:solidFill>
+                <a:latin typeface="Consolas"/>
+              </a:rPr>
+              <a:t>  25  </a:t>
+            </a:r>
+            <a:r>
+              <a:rPr sz="1800">
+                <a:solidFill>
+                  <a:srgbClr val="6D8C97"/>
+                </a:solidFill>
+                <a:latin typeface="Consolas"/>
+              </a:rPr>
+              <a:t>  event.preventDefault();          // stop the browser reloading the page</a:t>
+            </a:r>
+          </a:p>
+          <a:p>
+            <a:pPr>
+              <a:spcAft>
+                <a:spcPts val="0"/>
+              </a:spcAft>
+            </a:pPr>
+            <a:r>
+              <a:rPr sz="1800">
+                <a:solidFill>
+                  <a:srgbClr val="6D8C97"/>
+                </a:solidFill>
+                <a:latin typeface="Consolas"/>
+              </a:rPr>
+              <a:t>  26  </a:t>
+            </a:r>
+            <a:r>
+              <a:rPr sz="1800">
+                <a:solidFill>
+                  <a:srgbClr val="6D8C97"/>
+                </a:solidFill>
+                <a:latin typeface="Consolas"/>
+              </a:rPr>
+              <a:t>  const text = promptBox.value.trim();</a:t>
+            </a:r>
+          </a:p>
+          <a:p>
+            <a:pPr>
+              <a:spcAft>
+                <a:spcPts val="0"/>
+              </a:spcAft>
+            </a:pPr>
+            <a:r>
+              <a:rPr sz="1800">
+                <a:solidFill>
+                  <a:srgbClr val="6D8C97"/>
+                </a:solidFill>
+                <a:latin typeface="Consolas"/>
+              </a:rPr>
+              <a:t>  27  </a:t>
+            </a:r>
+            <a:r>
+              <a:rPr sz="1800">
+                <a:solidFill>
+                  <a:srgbClr val="6D8C97"/>
+                </a:solidFill>
+                <a:latin typeface="Consolas"/>
+              </a:rPr>
+              <a:t>  if (text === '') { return; }     // nothing typed, nothing to do</a:t>
+            </a:r>
+          </a:p>
+          <a:p>
+            <a:pPr>
+              <a:spcAft>
+                <a:spcPts val="0"/>
+              </a:spcAft>
+            </a:pPr>
+            <a:r>
+              <a:rPr sz="1800">
+                <a:solidFill>
+                  <a:srgbClr val="6D8C97"/>
+                </a:solidFill>
+                <a:latin typeface="Consolas"/>
+              </a:rPr>
+              <a:t>  28  </a:t>
+            </a:r>
+            <a:r>
+              <a:rPr sz="1800">
                 <a:solidFill>
                   <a:srgbClr val="7FE0A0"/>
                 </a:solidFill>
                 <a:latin typeface="Consolas"/>
               </a:rPr>
-              <a:t> </a:t>
-            </a:r>
-          </a:p>
-          <a:p>
-            <a:pPr>
-              <a:spcAft>
-                <a:spcPts val="0"/>
-              </a:spcAft>
-            </a:pPr>
-            <a:r>
-              <a:rPr sz="1300">
-                <a:solidFill>
-                  <a:srgbClr val="6D8C97"/>
-                </a:solidFill>
-                <a:latin typeface="Consolas"/>
-              </a:rPr>
-              <a:t>  22  </a:t>
-            </a:r>
-            <a:r>
-              <a:rPr sz="1300">
-                <a:solidFill>
-                  <a:srgbClr val="7FE0A0"/>
-                </a:solidFill>
-                <a:latin typeface="Consolas"/>
-              </a:rPr>
-              <a:t>// In PixelPad your loop() checked 'was a key pressed?' every frame. Here you</a:t>
-            </a:r>
-          </a:p>
-          <a:p>
-            <a:pPr>
-              <a:spcAft>
-                <a:spcPts val="0"/>
-              </a:spcAft>
-            </a:pPr>
-            <a:r>
-              <a:rPr sz="1300">
-                <a:solidFill>
-                  <a:srgbClr val="6D8C97"/>
-                </a:solidFill>
-                <a:latin typeface="Consolas"/>
-              </a:rPr>
-              <a:t>  23  </a:t>
-            </a:r>
-            <a:r>
-              <a:rPr sz="1300">
-                <a:solidFill>
-                  <a:srgbClr val="7FE0A0"/>
-                </a:solidFill>
-                <a:latin typeface="Consolas"/>
-              </a:rPr>
-              <a:t>// leave a note: when this form is submitted, run this. The browser waits.</a:t>
-            </a:r>
-          </a:p>
-          <a:p>
-            <a:pPr>
-              <a:spcAft>
-                <a:spcPts val="0"/>
-              </a:spcAft>
-            </a:pPr>
-            <a:r>
-              <a:rPr sz="1300">
-                <a:solidFill>
-                  <a:srgbClr val="6D8C97"/>
-                </a:solidFill>
-                <a:latin typeface="Consolas"/>
-              </a:rPr>
-              <a:t>  24  </a:t>
-            </a:r>
-            <a:r>
-              <a:rPr sz="1300">
-                <a:solidFill>
-                  <a:srgbClr val="7FE0A0"/>
-                </a:solidFill>
-                <a:latin typeface="Consolas"/>
-              </a:rPr>
-              <a:t>composer.addEventListener('submit', function (event) {</a:t>
-            </a:r>
-          </a:p>
-          <a:p>
-            <a:pPr>
-              <a:spcAft>
-                <a:spcPts val="0"/>
-              </a:spcAft>
-            </a:pPr>
-            <a:r>
-              <a:rPr sz="1300">
-                <a:solidFill>
-                  <a:srgbClr val="6D8C97"/>
-                </a:solidFill>
-                <a:latin typeface="Consolas"/>
-              </a:rPr>
-              <a:t>  25  </a:t>
-            </a:r>
-            <a:r>
-              <a:rPr sz="1300">
-                <a:solidFill>
-                  <a:srgbClr val="7FE0A0"/>
-                </a:solidFill>
-                <a:latin typeface="Consolas"/>
-              </a:rPr>
-              <a:t>  event.preventDefault();          // stop the browser reloading the page</a:t>
-            </a:r>
-          </a:p>
-          <a:p>
-            <a:pPr>
-              <a:spcAft>
-                <a:spcPts val="0"/>
-              </a:spcAft>
-            </a:pPr>
-            <a:r>
-              <a:rPr sz="1300">
-                <a:solidFill>
-                  <a:srgbClr val="6D8C97"/>
-                </a:solidFill>
-                <a:latin typeface="Consolas"/>
-              </a:rPr>
-              <a:t>  26  </a:t>
-            </a:r>
-            <a:r>
-              <a:rPr sz="1300">
-                <a:solidFill>
-                  <a:srgbClr val="7FE0A0"/>
-                </a:solidFill>
-                <a:latin typeface="Consolas"/>
-              </a:rPr>
-              <a:t>  const text = promptBox.value.trim();</a:t>
-            </a:r>
-          </a:p>
-          <a:p>
-            <a:pPr>
-              <a:spcAft>
-                <a:spcPts val="0"/>
-              </a:spcAft>
-            </a:pPr>
-            <a:r>
-              <a:rPr sz="1300">
-                <a:solidFill>
-                  <a:srgbClr val="6D8C97"/>
-                </a:solidFill>
-                <a:latin typeface="Consolas"/>
-              </a:rPr>
-              <a:t>  27  </a:t>
-            </a:r>
-            <a:r>
-              <a:rPr sz="1300">
-                <a:solidFill>
-                  <a:srgbClr val="7FE0A0"/>
-                </a:solidFill>
-                <a:latin typeface="Consolas"/>
-              </a:rPr>
-              <a:t>  if (text === '') { return; }     // nothing typed, nothing to do</a:t>
-            </a:r>
-          </a:p>
-          <a:p>
-            <a:pPr>
-              <a:spcAft>
-                <a:spcPts val="0"/>
-              </a:spcAft>
-            </a:pPr>
-            <a:r>
-              <a:rPr sz="1300">
-                <a:solidFill>
-                  <a:srgbClr val="6D8C97"/>
-                </a:solidFill>
-                <a:latin typeface="Consolas"/>
-              </a:rPr>
-              <a:t>  28  </a:t>
-            </a:r>
-            <a:r>
-              <a:rPr sz="1300">
-                <a:solidFill>
-                  <a:srgbClr val="7FE0A0"/>
-                </a:solidFill>
-                <a:latin typeface="Consolas"/>
-              </a:rPr>
               <a:t>  promptBox.value = '';            // clear the box, ready for the next one</a:t>
-            </a:r>
-          </a:p>
-          <a:p>
-            <a:pPr>
-              <a:spcAft>
-                <a:spcPts val="0"/>
-              </a:spcAft>
-            </a:pPr>
-            <a:r>
-              <a:rPr sz="1300">
-                <a:solidFill>
-                  <a:srgbClr val="6D8C97"/>
-                </a:solidFill>
-                <a:latin typeface="Consolas"/>
-              </a:rPr>
-              <a:t>  29  </a:t>
-            </a:r>
-            <a:r>
-              <a:rPr sz="1300">
-                <a:solidFill>
-                  <a:srgbClr val="7FE0A0"/>
-                </a:solidFill>
-                <a:latin typeface="Consolas"/>
-              </a:rPr>
-              <a:t>  addLine('You', text);</a:t>
-            </a:r>
-          </a:p>
-          <a:p>
-            <a:pPr>
-              <a:spcAft>
-                <a:spcPts val="0"/>
-              </a:spcAft>
-            </a:pPr>
-            <a:r>
-              <a:rPr sz="1300">
-                <a:solidFill>
-                  <a:srgbClr val="6D8C97"/>
-                </a:solidFill>
-                <a:latin typeface="Consolas"/>
-              </a:rPr>
-              <a:t>  30  </a:t>
-            </a:r>
-            <a:r>
-              <a:rPr sz="1300">
-                <a:solidFill>
-                  <a:srgbClr val="7FE0A0"/>
-                </a:solidFill>
-                <a:latin typeface="Consolas"/>
-              </a:rPr>
-              <a:t>  addLine('Companion', 'You said: ' + text);   // a pretend answer, for now</a:t>
-            </a:r>
-          </a:p>
-          <a:p>
-            <a:pPr>
-              <a:spcAft>
-                <a:spcPts val="0"/>
-              </a:spcAft>
-            </a:pPr>
-            <a:r>
-              <a:rPr sz="1300">
-                <a:solidFill>
-                  <a:srgbClr val="6D8C97"/>
-                </a:solidFill>
-                <a:latin typeface="Consolas"/>
-              </a:rPr>
-              <a:t>  31  </a:t>
-            </a:r>
-            <a:r>
-              <a:rPr sz="1300">
-                <a:solidFill>
-                  <a:srgbClr val="7FE0A0"/>
-                </a:solidFill>
-                <a:latin typeface="Consolas"/>
-              </a:rPr>
-              <a:t>});</a:t>
             </a:r>
           </a:p>
         </p:txBody>
@@ -8770,7 +8424,7 @@
                   <a:srgbClr val="DCECEF"/>
                 </a:solidFill>
               </a:rPr>
-              <a:t>That is the whole piece. Check yours looks the same before moving on.</a:t>
+              <a:t>Empty the text box, ready for the next message.</a:t>
             </a:r>
           </a:p>
         </p:txBody>
@@ -8786,6 +8440,14 @@
 <file path=ppt/slides/slide38.xml><?xml version="1.0" encoding="utf-8"?>
 <p:sld xmlns:a="http://schemas.openxmlformats.org/drawingml/2006/main" xmlns:p="http://schemas.openxmlformats.org/presentationml/2006/main" xmlns:r="http://schemas.openxmlformats.org/officeDocument/2006/relationships">
   <p:cSld>
+    <p:bg>
+      <p:bgPr>
+        <a:solidFill>
+          <a:srgbClr val="102127"/>
+        </a:solidFill>
+        <a:effectLst/>
+      </p:bgPr>
+    </p:bg>
     <p:spTree>
       <p:nvGrpSpPr>
         <p:cNvPr id="1" name=""/>
@@ -8795,40 +8457,14 @@
       <p:grpSpPr/>
       <p:sp>
         <p:nvSpPr>
-          <p:cNvPr id="2" name="Title 1"/>
-          <p:cNvSpPr>
-            <a:spLocks noGrp="1"/>
-          </p:cNvSpPr>
-          <p:nvPr>
-            <p:ph type="title"/>
-          </p:nvPr>
-        </p:nvSpPr>
-        <p:spPr/>
-        <p:txBody>
-          <a:bodyPr/>
-          <a:lstStyle/>
-          <a:p>
-            <a:r>
-              <a:rPr sz="3800" b="1">
-                <a:solidFill>
-                  <a:srgbClr val="1F2A37"/>
-                </a:solidFill>
-              </a:rPr>
-              <a:t>Checkpoint: it echoes you</a:t>
-            </a:r>
-          </a:p>
-        </p:txBody>
-      </p:sp>
-      <p:sp>
-        <p:nvSpPr>
-          <p:cNvPr id="3" name="TextBox 2"/>
+          <p:cNvPr id="2" name="TextBox 1"/>
           <p:cNvSpPr txBox="1"/>
           <p:nvPr/>
         </p:nvSpPr>
         <p:spPr>
           <a:xfrm>
-            <a:off x="868680" y="502920"/>
-            <a:ext cx="5486400" cy="457200"/>
+            <a:off x="502920" y="274320"/>
+            <a:ext cx="11155680" cy="548640"/>
           </a:xfrm>
           <a:prstGeom prst="rect">
             <a:avLst/>
@@ -8842,26 +8478,26 @@
           <a:lstStyle/>
           <a:p>
             <a:r>
-              <a:rPr sz="1500" b="1">
+              <a:rPr sz="2200" b="1">
                 <a:solidFill>
                   <a:srgbClr val="01AEFD"/>
                 </a:solidFill>
               </a:rPr>
-              <a:t>CHECKPOINT - RUN IT</a:t>
-            </a:r>
-          </a:p>
-        </p:txBody>
-      </p:sp>
-      <p:sp>
-        <p:nvSpPr>
-          <p:cNvPr id="4" name="TextBox 3"/>
+              <a:t>Type this into script.js   -   line 29</a:t>
+            </a:r>
+          </a:p>
+        </p:txBody>
+      </p:sp>
+      <p:sp>
+        <p:nvSpPr>
+          <p:cNvPr id="3" name="TextBox 2"/>
           <p:cNvSpPr txBox="1"/>
           <p:nvPr/>
         </p:nvSpPr>
         <p:spPr>
           <a:xfrm>
-            <a:off x="822960" y="1828800"/>
-            <a:ext cx="10515600" cy="4206240"/>
+            <a:off x="502920" y="960120"/>
+            <a:ext cx="11155680" cy="4297680"/>
           </a:xfrm>
           <a:prstGeom prst="rect">
             <a:avLst/>
@@ -8869,53 +8505,266 @@
           <a:noFill/>
         </p:spPr>
         <p:txBody>
+          <a:bodyPr wrap="none">
+            <a:spAutoFit/>
+          </a:bodyPr>
+          <a:lstStyle/>
+          <a:p>
+            <a:pPr>
+              <a:spcAft>
+                <a:spcPts val="0"/>
+              </a:spcAft>
+            </a:pPr>
+            <a:r>
+              <a:rPr sz="1800">
+                <a:solidFill>
+                  <a:srgbClr val="6D8C97"/>
+                </a:solidFill>
+                <a:latin typeface="Consolas"/>
+              </a:rPr>
+              <a:t>  21  </a:t>
+            </a:r>
+            <a:r>
+              <a:rPr sz="1800">
+                <a:solidFill>
+                  <a:srgbClr val="6D8C97"/>
+                </a:solidFill>
+                <a:latin typeface="Consolas"/>
+              </a:rPr>
+              <a:t> </a:t>
+            </a:r>
+          </a:p>
+          <a:p>
+            <a:pPr>
+              <a:spcAft>
+                <a:spcPts val="0"/>
+              </a:spcAft>
+            </a:pPr>
+            <a:r>
+              <a:rPr sz="1800">
+                <a:solidFill>
+                  <a:srgbClr val="6D8C97"/>
+                </a:solidFill>
+                <a:latin typeface="Consolas"/>
+              </a:rPr>
+              <a:t>  22  </a:t>
+            </a:r>
+            <a:r>
+              <a:rPr sz="1800">
+                <a:solidFill>
+                  <a:srgbClr val="6D8C97"/>
+                </a:solidFill>
+                <a:latin typeface="Consolas"/>
+              </a:rPr>
+              <a:t>// In PixelPad your loop() checked 'was a key pressed?' every frame. Here you</a:t>
+            </a:r>
+          </a:p>
+          <a:p>
+            <a:pPr>
+              <a:spcAft>
+                <a:spcPts val="0"/>
+              </a:spcAft>
+            </a:pPr>
+            <a:r>
+              <a:rPr sz="1800">
+                <a:solidFill>
+                  <a:srgbClr val="6D8C97"/>
+                </a:solidFill>
+                <a:latin typeface="Consolas"/>
+              </a:rPr>
+              <a:t>  23  </a:t>
+            </a:r>
+            <a:r>
+              <a:rPr sz="1800">
+                <a:solidFill>
+                  <a:srgbClr val="6D8C97"/>
+                </a:solidFill>
+                <a:latin typeface="Consolas"/>
+              </a:rPr>
+              <a:t>// leave a note: when this form is submitted, run this. The browser waits.</a:t>
+            </a:r>
+          </a:p>
+          <a:p>
+            <a:pPr>
+              <a:spcAft>
+                <a:spcPts val="0"/>
+              </a:spcAft>
+            </a:pPr>
+            <a:r>
+              <a:rPr sz="1800">
+                <a:solidFill>
+                  <a:srgbClr val="6D8C97"/>
+                </a:solidFill>
+                <a:latin typeface="Consolas"/>
+              </a:rPr>
+              <a:t>  24  </a:t>
+            </a:r>
+            <a:r>
+              <a:rPr sz="1800">
+                <a:solidFill>
+                  <a:srgbClr val="6D8C97"/>
+                </a:solidFill>
+                <a:latin typeface="Consolas"/>
+              </a:rPr>
+              <a:t>composer.addEventListener('submit', function (event) {</a:t>
+            </a:r>
+          </a:p>
+          <a:p>
+            <a:pPr>
+              <a:spcAft>
+                <a:spcPts val="0"/>
+              </a:spcAft>
+            </a:pPr>
+            <a:r>
+              <a:rPr sz="1800">
+                <a:solidFill>
+                  <a:srgbClr val="6D8C97"/>
+                </a:solidFill>
+                <a:latin typeface="Consolas"/>
+              </a:rPr>
+              <a:t>  25  </a:t>
+            </a:r>
+            <a:r>
+              <a:rPr sz="1800">
+                <a:solidFill>
+                  <a:srgbClr val="6D8C97"/>
+                </a:solidFill>
+                <a:latin typeface="Consolas"/>
+              </a:rPr>
+              <a:t>  event.preventDefault();          // stop the browser reloading the page</a:t>
+            </a:r>
+          </a:p>
+          <a:p>
+            <a:pPr>
+              <a:spcAft>
+                <a:spcPts val="0"/>
+              </a:spcAft>
+            </a:pPr>
+            <a:r>
+              <a:rPr sz="1800">
+                <a:solidFill>
+                  <a:srgbClr val="6D8C97"/>
+                </a:solidFill>
+                <a:latin typeface="Consolas"/>
+              </a:rPr>
+              <a:t>  26  </a:t>
+            </a:r>
+            <a:r>
+              <a:rPr sz="1800">
+                <a:solidFill>
+                  <a:srgbClr val="6D8C97"/>
+                </a:solidFill>
+                <a:latin typeface="Consolas"/>
+              </a:rPr>
+              <a:t>  const text = promptBox.value.trim();</a:t>
+            </a:r>
+          </a:p>
+          <a:p>
+            <a:pPr>
+              <a:spcAft>
+                <a:spcPts val="0"/>
+              </a:spcAft>
+            </a:pPr>
+            <a:r>
+              <a:rPr sz="1800">
+                <a:solidFill>
+                  <a:srgbClr val="6D8C97"/>
+                </a:solidFill>
+                <a:latin typeface="Consolas"/>
+              </a:rPr>
+              <a:t>  27  </a:t>
+            </a:r>
+            <a:r>
+              <a:rPr sz="1800">
+                <a:solidFill>
+                  <a:srgbClr val="6D8C97"/>
+                </a:solidFill>
+                <a:latin typeface="Consolas"/>
+              </a:rPr>
+              <a:t>  if (text === '') { return; }     // nothing typed, nothing to do</a:t>
+            </a:r>
+          </a:p>
+          <a:p>
+            <a:pPr>
+              <a:spcAft>
+                <a:spcPts val="0"/>
+              </a:spcAft>
+            </a:pPr>
+            <a:r>
+              <a:rPr sz="1800">
+                <a:solidFill>
+                  <a:srgbClr val="6D8C97"/>
+                </a:solidFill>
+                <a:latin typeface="Consolas"/>
+              </a:rPr>
+              <a:t>  28  </a:t>
+            </a:r>
+            <a:r>
+              <a:rPr sz="1800">
+                <a:solidFill>
+                  <a:srgbClr val="6D8C97"/>
+                </a:solidFill>
+                <a:latin typeface="Consolas"/>
+              </a:rPr>
+              <a:t>  promptBox.value = '';            // clear the box, ready for the next one</a:t>
+            </a:r>
+          </a:p>
+          <a:p>
+            <a:pPr>
+              <a:spcAft>
+                <a:spcPts val="0"/>
+              </a:spcAft>
+            </a:pPr>
+            <a:r>
+              <a:rPr sz="1800">
+                <a:solidFill>
+                  <a:srgbClr val="6D8C97"/>
+                </a:solidFill>
+                <a:latin typeface="Consolas"/>
+              </a:rPr>
+              <a:t>  29  </a:t>
+            </a:r>
+            <a:r>
+              <a:rPr sz="1800">
+                <a:solidFill>
+                  <a:srgbClr val="7FE0A0"/>
+                </a:solidFill>
+                <a:latin typeface="Consolas"/>
+              </a:rPr>
+              <a:t>  addLine('You', text);</a:t>
+            </a:r>
+          </a:p>
+        </p:txBody>
+      </p:sp>
+      <p:sp>
+        <p:nvSpPr>
+          <p:cNvPr id="4" name="TextBox 3"/>
+          <p:cNvSpPr txBox="1"/>
+          <p:nvPr/>
+        </p:nvSpPr>
+        <p:spPr>
+          <a:xfrm>
+            <a:off x="548640" y="5623560"/>
+            <a:ext cx="11064240" cy="1051560"/>
+          </a:xfrm>
+          <a:prstGeom prst="rect">
+            <a:avLst/>
+          </a:prstGeom>
+          <a:noFill/>
+        </p:spPr>
+        <p:txBody>
           <a:bodyPr wrap="square">
             <a:spAutoFit/>
           </a:bodyPr>
           <a:lstStyle/>
           <a:p>
-            <a:pPr>
-              <a:spcAft>
-                <a:spcPts val="1400"/>
-              </a:spcAft>
-            </a:pPr>
-            <a:r>
-              <a:rPr sz="2800">
-                <a:solidFill>
-                  <a:srgbClr val="01AEFD"/>
-                </a:solidFill>
-              </a:rPr>
-              <a:t>Press Run, type a message and press Send. It should show as 'You: ...' and the companion echoes it back right below. This runs entirely in the browser - no AI yet.</a:t>
-            </a:r>
-          </a:p>
-          <a:p>
-            <a:pPr>
-              <a:spcAft>
-                <a:spcPts val="1400"/>
-              </a:spcAft>
-            </a:pPr>
-            <a:r>
-              <a:rPr sz="2400">
-                <a:solidFill>
-                  <a:srgbClr val="1F2A37"/>
-                </a:solidFill>
-              </a:rPr>
-              <a:t>• Run it in the classroom, or press Show the output in the web deck.</a:t>
-            </a:r>
-          </a:p>
-          <a:p>
-            <a:pPr>
-              <a:spcAft>
-                <a:spcPts val="1400"/>
-              </a:spcAft>
-            </a:pPr>
-            <a:r>
-              <a:rPr sz="2400">
-                <a:solidFill>
-                  <a:srgbClr val="1F2A37"/>
-                </a:solidFill>
-              </a:rPr>
-              <a:t>• Everyone's screen should match this.</a:t>
+            <a:r>
+              <a:rPr sz="2000">
+                <a:solidFill>
+                  <a:srgbClr val="DCECEF"/>
+                </a:solidFill>
+              </a:rPr>
+              <a:t>Add your message to the chat as 'You: ...'.</a:t>
             </a:r>
           </a:p>
         </p:txBody>
@@ -8931,6 +8780,14 @@
 <file path=ppt/slides/slide39.xml><?xml version="1.0" encoding="utf-8"?>
 <p:sld xmlns:a="http://schemas.openxmlformats.org/drawingml/2006/main" xmlns:p="http://schemas.openxmlformats.org/presentationml/2006/main" xmlns:r="http://schemas.openxmlformats.org/officeDocument/2006/relationships">
   <p:cSld>
+    <p:bg>
+      <p:bgPr>
+        <a:solidFill>
+          <a:srgbClr val="102127"/>
+        </a:solidFill>
+        <a:effectLst/>
+      </p:bgPr>
+    </p:bg>
     <p:spTree>
       <p:nvGrpSpPr>
         <p:cNvPr id="1" name=""/>
@@ -8940,40 +8797,14 @@
       <p:grpSpPr/>
       <p:sp>
         <p:nvSpPr>
-          <p:cNvPr id="2" name="Title 1"/>
-          <p:cNvSpPr>
-            <a:spLocks noGrp="1"/>
-          </p:cNvSpPr>
-          <p:nvPr>
-            <p:ph type="title"/>
-          </p:nvPr>
-        </p:nvSpPr>
-        <p:spPr/>
-        <p:txBody>
-          <a:bodyPr/>
-          <a:lstStyle/>
-          <a:p>
-            <a:r>
-              <a:rPr sz="3800" b="1">
-                <a:solidFill>
-                  <a:srgbClr val="1F2A37"/>
-                </a:solidFill>
-              </a:rPr>
-              <a:t>Your turn</a:t>
-            </a:r>
-          </a:p>
-        </p:txBody>
-      </p:sp>
-      <p:sp>
-        <p:nvSpPr>
-          <p:cNvPr id="3" name="TextBox 2"/>
+          <p:cNvPr id="2" name="TextBox 1"/>
           <p:cNvSpPr txBox="1"/>
           <p:nvPr/>
         </p:nvSpPr>
         <p:spPr>
           <a:xfrm>
-            <a:off x="822960" y="1828800"/>
-            <a:ext cx="10515600" cy="4206240"/>
+            <a:off x="502920" y="274320"/>
+            <a:ext cx="11155680" cy="548640"/>
           </a:xfrm>
           <a:prstGeom prst="rect">
             <a:avLst/>
@@ -8981,68 +8812,324 @@
           <a:noFill/>
         </p:spPr>
         <p:txBody>
+          <a:bodyPr wrap="none">
+            <a:spAutoFit/>
+          </a:bodyPr>
+          <a:lstStyle/>
+          <a:p>
+            <a:r>
+              <a:rPr sz="2200" b="1">
+                <a:solidFill>
+                  <a:srgbClr val="01AEFD"/>
+                </a:solidFill>
+              </a:rPr>
+              <a:t>Type this into script.js   -   line 30</a:t>
+            </a:r>
+          </a:p>
+        </p:txBody>
+      </p:sp>
+      <p:sp>
+        <p:nvSpPr>
+          <p:cNvPr id="3" name="TextBox 2"/>
+          <p:cNvSpPr txBox="1"/>
+          <p:nvPr/>
+        </p:nvSpPr>
+        <p:spPr>
+          <a:xfrm>
+            <a:off x="502920" y="960120"/>
+            <a:ext cx="11155680" cy="4297680"/>
+          </a:xfrm>
+          <a:prstGeom prst="rect">
+            <a:avLst/>
+          </a:prstGeom>
+          <a:noFill/>
+        </p:spPr>
+        <p:txBody>
+          <a:bodyPr wrap="none">
+            <a:spAutoFit/>
+          </a:bodyPr>
+          <a:lstStyle/>
+          <a:p>
+            <a:pPr>
+              <a:spcAft>
+                <a:spcPts val="0"/>
+              </a:spcAft>
+            </a:pPr>
+            <a:r>
+              <a:rPr sz="1800">
+                <a:solidFill>
+                  <a:srgbClr val="6D8C97"/>
+                </a:solidFill>
+                <a:latin typeface="Consolas"/>
+              </a:rPr>
+              <a:t>  21  </a:t>
+            </a:r>
+            <a:r>
+              <a:rPr sz="1800">
+                <a:solidFill>
+                  <a:srgbClr val="6D8C97"/>
+                </a:solidFill>
+                <a:latin typeface="Consolas"/>
+              </a:rPr>
+              <a:t> </a:t>
+            </a:r>
+          </a:p>
+          <a:p>
+            <a:pPr>
+              <a:spcAft>
+                <a:spcPts val="0"/>
+              </a:spcAft>
+            </a:pPr>
+            <a:r>
+              <a:rPr sz="1800">
+                <a:solidFill>
+                  <a:srgbClr val="6D8C97"/>
+                </a:solidFill>
+                <a:latin typeface="Consolas"/>
+              </a:rPr>
+              <a:t>  22  </a:t>
+            </a:r>
+            <a:r>
+              <a:rPr sz="1800">
+                <a:solidFill>
+                  <a:srgbClr val="6D8C97"/>
+                </a:solidFill>
+                <a:latin typeface="Consolas"/>
+              </a:rPr>
+              <a:t>// In PixelPad your loop() checked 'was a key pressed?' every frame. Here you</a:t>
+            </a:r>
+          </a:p>
+          <a:p>
+            <a:pPr>
+              <a:spcAft>
+                <a:spcPts val="0"/>
+              </a:spcAft>
+            </a:pPr>
+            <a:r>
+              <a:rPr sz="1800">
+                <a:solidFill>
+                  <a:srgbClr val="6D8C97"/>
+                </a:solidFill>
+                <a:latin typeface="Consolas"/>
+              </a:rPr>
+              <a:t>  23  </a:t>
+            </a:r>
+            <a:r>
+              <a:rPr sz="1800">
+                <a:solidFill>
+                  <a:srgbClr val="6D8C97"/>
+                </a:solidFill>
+                <a:latin typeface="Consolas"/>
+              </a:rPr>
+              <a:t>// leave a note: when this form is submitted, run this. The browser waits.</a:t>
+            </a:r>
+          </a:p>
+          <a:p>
+            <a:pPr>
+              <a:spcAft>
+                <a:spcPts val="0"/>
+              </a:spcAft>
+            </a:pPr>
+            <a:r>
+              <a:rPr sz="1800">
+                <a:solidFill>
+                  <a:srgbClr val="6D8C97"/>
+                </a:solidFill>
+                <a:latin typeface="Consolas"/>
+              </a:rPr>
+              <a:t>  24  </a:t>
+            </a:r>
+            <a:r>
+              <a:rPr sz="1800">
+                <a:solidFill>
+                  <a:srgbClr val="6D8C97"/>
+                </a:solidFill>
+                <a:latin typeface="Consolas"/>
+              </a:rPr>
+              <a:t>composer.addEventListener('submit', function (event) {</a:t>
+            </a:r>
+          </a:p>
+          <a:p>
+            <a:pPr>
+              <a:spcAft>
+                <a:spcPts val="0"/>
+              </a:spcAft>
+            </a:pPr>
+            <a:r>
+              <a:rPr sz="1800">
+                <a:solidFill>
+                  <a:srgbClr val="6D8C97"/>
+                </a:solidFill>
+                <a:latin typeface="Consolas"/>
+              </a:rPr>
+              <a:t>  25  </a:t>
+            </a:r>
+            <a:r>
+              <a:rPr sz="1800">
+                <a:solidFill>
+                  <a:srgbClr val="6D8C97"/>
+                </a:solidFill>
+                <a:latin typeface="Consolas"/>
+              </a:rPr>
+              <a:t>  event.preventDefault();          // stop the browser reloading the page</a:t>
+            </a:r>
+          </a:p>
+          <a:p>
+            <a:pPr>
+              <a:spcAft>
+                <a:spcPts val="0"/>
+              </a:spcAft>
+            </a:pPr>
+            <a:r>
+              <a:rPr sz="1800">
+                <a:solidFill>
+                  <a:srgbClr val="6D8C97"/>
+                </a:solidFill>
+                <a:latin typeface="Consolas"/>
+              </a:rPr>
+              <a:t>  26  </a:t>
+            </a:r>
+            <a:r>
+              <a:rPr sz="1800">
+                <a:solidFill>
+                  <a:srgbClr val="6D8C97"/>
+                </a:solidFill>
+                <a:latin typeface="Consolas"/>
+              </a:rPr>
+              <a:t>  const text = promptBox.value.trim();</a:t>
+            </a:r>
+          </a:p>
+          <a:p>
+            <a:pPr>
+              <a:spcAft>
+                <a:spcPts val="0"/>
+              </a:spcAft>
+            </a:pPr>
+            <a:r>
+              <a:rPr sz="1800">
+                <a:solidFill>
+                  <a:srgbClr val="6D8C97"/>
+                </a:solidFill>
+                <a:latin typeface="Consolas"/>
+              </a:rPr>
+              <a:t>  27  </a:t>
+            </a:r>
+            <a:r>
+              <a:rPr sz="1800">
+                <a:solidFill>
+                  <a:srgbClr val="6D8C97"/>
+                </a:solidFill>
+                <a:latin typeface="Consolas"/>
+              </a:rPr>
+              <a:t>  if (text === '') { return; }     // nothing typed, nothing to do</a:t>
+            </a:r>
+          </a:p>
+          <a:p>
+            <a:pPr>
+              <a:spcAft>
+                <a:spcPts val="0"/>
+              </a:spcAft>
+            </a:pPr>
+            <a:r>
+              <a:rPr sz="1800">
+                <a:solidFill>
+                  <a:srgbClr val="6D8C97"/>
+                </a:solidFill>
+                <a:latin typeface="Consolas"/>
+              </a:rPr>
+              <a:t>  28  </a:t>
+            </a:r>
+            <a:r>
+              <a:rPr sz="1800">
+                <a:solidFill>
+                  <a:srgbClr val="6D8C97"/>
+                </a:solidFill>
+                <a:latin typeface="Consolas"/>
+              </a:rPr>
+              <a:t>  promptBox.value = '';            // clear the box, ready for the next one</a:t>
+            </a:r>
+          </a:p>
+          <a:p>
+            <a:pPr>
+              <a:spcAft>
+                <a:spcPts val="0"/>
+              </a:spcAft>
+            </a:pPr>
+            <a:r>
+              <a:rPr sz="1800">
+                <a:solidFill>
+                  <a:srgbClr val="6D8C97"/>
+                </a:solidFill>
+                <a:latin typeface="Consolas"/>
+              </a:rPr>
+              <a:t>  29  </a:t>
+            </a:r>
+            <a:r>
+              <a:rPr sz="1800">
+                <a:solidFill>
+                  <a:srgbClr val="6D8C97"/>
+                </a:solidFill>
+                <a:latin typeface="Consolas"/>
+              </a:rPr>
+              <a:t>  addLine('You', text);</a:t>
+            </a:r>
+          </a:p>
+          <a:p>
+            <a:pPr>
+              <a:spcAft>
+                <a:spcPts val="0"/>
+              </a:spcAft>
+            </a:pPr>
+            <a:r>
+              <a:rPr sz="1800">
+                <a:solidFill>
+                  <a:srgbClr val="6D8C97"/>
+                </a:solidFill>
+                <a:latin typeface="Consolas"/>
+              </a:rPr>
+              <a:t>  30  </a:t>
+            </a:r>
+            <a:r>
+              <a:rPr sz="1800">
+                <a:solidFill>
+                  <a:srgbClr val="7FE0A0"/>
+                </a:solidFill>
+                <a:latin typeface="Consolas"/>
+              </a:rPr>
+              <a:t>  addLine('Companion', 'You said: ' + text);   // a pretend answer, for now</a:t>
+            </a:r>
+          </a:p>
+        </p:txBody>
+      </p:sp>
+      <p:sp>
+        <p:nvSpPr>
+          <p:cNvPr id="4" name="TextBox 3"/>
+          <p:cNvSpPr txBox="1"/>
+          <p:nvPr/>
+        </p:nvSpPr>
+        <p:spPr>
+          <a:xfrm>
+            <a:off x="548640" y="5623560"/>
+            <a:ext cx="11064240" cy="1051560"/>
+          </a:xfrm>
+          <a:prstGeom prst="rect">
+            <a:avLst/>
+          </a:prstGeom>
+          <a:noFill/>
+        </p:spPr>
+        <p:txBody>
           <a:bodyPr wrap="square">
             <a:spAutoFit/>
           </a:bodyPr>
           <a:lstStyle/>
           <a:p>
-            <a:pPr>
-              <a:spcAft>
-                <a:spcPts val="1400"/>
-              </a:spcAft>
-            </a:pPr>
-            <a:r>
-              <a:rPr sz="2800">
-                <a:solidFill>
-                  <a:srgbClr val="01AEFD"/>
-                </a:solidFill>
-              </a:rPr>
-              <a:t>Get the echo working</a:t>
-            </a:r>
-          </a:p>
-          <a:p>
-            <a:pPr>
-              <a:spcAft>
-                <a:spcPts val="1400"/>
-              </a:spcAft>
-            </a:pPr>
-            <a:r>
-              <a:rPr sz="2400">
-                <a:solidFill>
-                  <a:srgbClr val="1F2A37"/>
-                </a:solidFill>
-              </a:rPr>
-              <a:t>• Type a message</a:t>
-            </a:r>
-          </a:p>
-          <a:p>
-            <a:pPr>
-              <a:spcAft>
-                <a:spcPts val="1400"/>
-              </a:spcAft>
-            </a:pPr>
-            <a:r>
-              <a:rPr sz="2400">
-                <a:solidFill>
-                  <a:srgbClr val="1F2A37"/>
-                </a:solidFill>
-              </a:rPr>
-              <a:t>• Press Send</a:t>
-            </a:r>
-          </a:p>
-          <a:p>
-            <a:pPr>
-              <a:spcAft>
-                <a:spcPts val="1400"/>
-              </a:spcAft>
-            </a:pPr>
-            <a:r>
-              <a:rPr sz="2400">
-                <a:solidFill>
-                  <a:srgbClr val="1F2A37"/>
-                </a:solidFill>
-              </a:rPr>
-              <a:t>• See it appear twice</a:t>
+            <a:r>
+              <a:rPr sz="2000">
+                <a:solidFill>
+                  <a:srgbClr val="DCECEF"/>
+                </a:solidFill>
+              </a:rPr>
+              <a:t>Add a pretend reply for now - week 4 makes it real.</a:t>
             </a:r>
           </a:p>
         </p:txBody>
@@ -9208,6 +9295,1058 @@
                 </a:solidFill>
               </a:rPr>
               <a:t>A comment: this week we grab the boxes we built in week 1 so the code can use them.</a:t>
+            </a:r>
+          </a:p>
+        </p:txBody>
+      </p:sp>
+    </p:spTree>
+  </p:cSld>
+  <p:clrMapOvr>
+    <a:masterClrMapping/>
+  </p:clrMapOvr>
+</p:sld>
+</file>
+
+<file path=ppt/slides/slide40.xml><?xml version="1.0" encoding="utf-8"?>
+<p:sld xmlns:a="http://schemas.openxmlformats.org/drawingml/2006/main" xmlns:p="http://schemas.openxmlformats.org/presentationml/2006/main" xmlns:r="http://schemas.openxmlformats.org/officeDocument/2006/relationships">
+  <p:cSld>
+    <p:bg>
+      <p:bgPr>
+        <a:solidFill>
+          <a:srgbClr val="102127"/>
+        </a:solidFill>
+        <a:effectLst/>
+      </p:bgPr>
+    </p:bg>
+    <p:spTree>
+      <p:nvGrpSpPr>
+        <p:cNvPr id="1" name=""/>
+        <p:cNvGrpSpPr/>
+        <p:nvPr/>
+      </p:nvGrpSpPr>
+      <p:grpSpPr/>
+      <p:sp>
+        <p:nvSpPr>
+          <p:cNvPr id="2" name="TextBox 1"/>
+          <p:cNvSpPr txBox="1"/>
+          <p:nvPr/>
+        </p:nvSpPr>
+        <p:spPr>
+          <a:xfrm>
+            <a:off x="502920" y="274320"/>
+            <a:ext cx="11155680" cy="548640"/>
+          </a:xfrm>
+          <a:prstGeom prst="rect">
+            <a:avLst/>
+          </a:prstGeom>
+          <a:noFill/>
+        </p:spPr>
+        <p:txBody>
+          <a:bodyPr wrap="none">
+            <a:spAutoFit/>
+          </a:bodyPr>
+          <a:lstStyle/>
+          <a:p>
+            <a:r>
+              <a:rPr sz="2200" b="1">
+                <a:solidFill>
+                  <a:srgbClr val="01AEFD"/>
+                </a:solidFill>
+              </a:rPr>
+              <a:t>Type this into script.js   -   line 31</a:t>
+            </a:r>
+          </a:p>
+        </p:txBody>
+      </p:sp>
+      <p:sp>
+        <p:nvSpPr>
+          <p:cNvPr id="3" name="TextBox 2"/>
+          <p:cNvSpPr txBox="1"/>
+          <p:nvPr/>
+        </p:nvSpPr>
+        <p:spPr>
+          <a:xfrm>
+            <a:off x="502920" y="960120"/>
+            <a:ext cx="11155680" cy="4297680"/>
+          </a:xfrm>
+          <a:prstGeom prst="rect">
+            <a:avLst/>
+          </a:prstGeom>
+          <a:noFill/>
+        </p:spPr>
+        <p:txBody>
+          <a:bodyPr wrap="none">
+            <a:spAutoFit/>
+          </a:bodyPr>
+          <a:lstStyle/>
+          <a:p>
+            <a:pPr>
+              <a:spcAft>
+                <a:spcPts val="0"/>
+              </a:spcAft>
+            </a:pPr>
+            <a:r>
+              <a:rPr sz="1300">
+                <a:solidFill>
+                  <a:srgbClr val="6D8C97"/>
+                </a:solidFill>
+                <a:latin typeface="Consolas"/>
+              </a:rPr>
+              <a:t>  21  </a:t>
+            </a:r>
+            <a:r>
+              <a:rPr sz="1300">
+                <a:solidFill>
+                  <a:srgbClr val="6D8C97"/>
+                </a:solidFill>
+                <a:latin typeface="Consolas"/>
+              </a:rPr>
+              <a:t> </a:t>
+            </a:r>
+          </a:p>
+          <a:p>
+            <a:pPr>
+              <a:spcAft>
+                <a:spcPts val="0"/>
+              </a:spcAft>
+            </a:pPr>
+            <a:r>
+              <a:rPr sz="1300">
+                <a:solidFill>
+                  <a:srgbClr val="6D8C97"/>
+                </a:solidFill>
+                <a:latin typeface="Consolas"/>
+              </a:rPr>
+              <a:t>  22  </a:t>
+            </a:r>
+            <a:r>
+              <a:rPr sz="1300">
+                <a:solidFill>
+                  <a:srgbClr val="6D8C97"/>
+                </a:solidFill>
+                <a:latin typeface="Consolas"/>
+              </a:rPr>
+              <a:t>// In PixelPad your loop() checked 'was a key pressed?' every frame. Here you</a:t>
+            </a:r>
+          </a:p>
+          <a:p>
+            <a:pPr>
+              <a:spcAft>
+                <a:spcPts val="0"/>
+              </a:spcAft>
+            </a:pPr>
+            <a:r>
+              <a:rPr sz="1300">
+                <a:solidFill>
+                  <a:srgbClr val="6D8C97"/>
+                </a:solidFill>
+                <a:latin typeface="Consolas"/>
+              </a:rPr>
+              <a:t>  23  </a:t>
+            </a:r>
+            <a:r>
+              <a:rPr sz="1300">
+                <a:solidFill>
+                  <a:srgbClr val="6D8C97"/>
+                </a:solidFill>
+                <a:latin typeface="Consolas"/>
+              </a:rPr>
+              <a:t>// leave a note: when this form is submitted, run this. The browser waits.</a:t>
+            </a:r>
+          </a:p>
+          <a:p>
+            <a:pPr>
+              <a:spcAft>
+                <a:spcPts val="0"/>
+              </a:spcAft>
+            </a:pPr>
+            <a:r>
+              <a:rPr sz="1300">
+                <a:solidFill>
+                  <a:srgbClr val="6D8C97"/>
+                </a:solidFill>
+                <a:latin typeface="Consolas"/>
+              </a:rPr>
+              <a:t>  24  </a:t>
+            </a:r>
+            <a:r>
+              <a:rPr sz="1300">
+                <a:solidFill>
+                  <a:srgbClr val="6D8C97"/>
+                </a:solidFill>
+                <a:latin typeface="Consolas"/>
+              </a:rPr>
+              <a:t>composer.addEventListener('submit', function (event) {</a:t>
+            </a:r>
+          </a:p>
+          <a:p>
+            <a:pPr>
+              <a:spcAft>
+                <a:spcPts val="0"/>
+              </a:spcAft>
+            </a:pPr>
+            <a:r>
+              <a:rPr sz="1300">
+                <a:solidFill>
+                  <a:srgbClr val="6D8C97"/>
+                </a:solidFill>
+                <a:latin typeface="Consolas"/>
+              </a:rPr>
+              <a:t>  25  </a:t>
+            </a:r>
+            <a:r>
+              <a:rPr sz="1300">
+                <a:solidFill>
+                  <a:srgbClr val="6D8C97"/>
+                </a:solidFill>
+                <a:latin typeface="Consolas"/>
+              </a:rPr>
+              <a:t>  event.preventDefault();          // stop the browser reloading the page</a:t>
+            </a:r>
+          </a:p>
+          <a:p>
+            <a:pPr>
+              <a:spcAft>
+                <a:spcPts val="0"/>
+              </a:spcAft>
+            </a:pPr>
+            <a:r>
+              <a:rPr sz="1300">
+                <a:solidFill>
+                  <a:srgbClr val="6D8C97"/>
+                </a:solidFill>
+                <a:latin typeface="Consolas"/>
+              </a:rPr>
+              <a:t>  26  </a:t>
+            </a:r>
+            <a:r>
+              <a:rPr sz="1300">
+                <a:solidFill>
+                  <a:srgbClr val="6D8C97"/>
+                </a:solidFill>
+                <a:latin typeface="Consolas"/>
+              </a:rPr>
+              <a:t>  const text = promptBox.value.trim();</a:t>
+            </a:r>
+          </a:p>
+          <a:p>
+            <a:pPr>
+              <a:spcAft>
+                <a:spcPts val="0"/>
+              </a:spcAft>
+            </a:pPr>
+            <a:r>
+              <a:rPr sz="1300">
+                <a:solidFill>
+                  <a:srgbClr val="6D8C97"/>
+                </a:solidFill>
+                <a:latin typeface="Consolas"/>
+              </a:rPr>
+              <a:t>  27  </a:t>
+            </a:r>
+            <a:r>
+              <a:rPr sz="1300">
+                <a:solidFill>
+                  <a:srgbClr val="6D8C97"/>
+                </a:solidFill>
+                <a:latin typeface="Consolas"/>
+              </a:rPr>
+              <a:t>  if (text === '') { return; }     // nothing typed, nothing to do</a:t>
+            </a:r>
+          </a:p>
+          <a:p>
+            <a:pPr>
+              <a:spcAft>
+                <a:spcPts val="0"/>
+              </a:spcAft>
+            </a:pPr>
+            <a:r>
+              <a:rPr sz="1300">
+                <a:solidFill>
+                  <a:srgbClr val="6D8C97"/>
+                </a:solidFill>
+                <a:latin typeface="Consolas"/>
+              </a:rPr>
+              <a:t>  28  </a:t>
+            </a:r>
+            <a:r>
+              <a:rPr sz="1300">
+                <a:solidFill>
+                  <a:srgbClr val="6D8C97"/>
+                </a:solidFill>
+                <a:latin typeface="Consolas"/>
+              </a:rPr>
+              <a:t>  promptBox.value = '';            // clear the box, ready for the next one</a:t>
+            </a:r>
+          </a:p>
+          <a:p>
+            <a:pPr>
+              <a:spcAft>
+                <a:spcPts val="0"/>
+              </a:spcAft>
+            </a:pPr>
+            <a:r>
+              <a:rPr sz="1300">
+                <a:solidFill>
+                  <a:srgbClr val="6D8C97"/>
+                </a:solidFill>
+                <a:latin typeface="Consolas"/>
+              </a:rPr>
+              <a:t>  29  </a:t>
+            </a:r>
+            <a:r>
+              <a:rPr sz="1300">
+                <a:solidFill>
+                  <a:srgbClr val="6D8C97"/>
+                </a:solidFill>
+                <a:latin typeface="Consolas"/>
+              </a:rPr>
+              <a:t>  addLine('You', text);</a:t>
+            </a:r>
+          </a:p>
+          <a:p>
+            <a:pPr>
+              <a:spcAft>
+                <a:spcPts val="0"/>
+              </a:spcAft>
+            </a:pPr>
+            <a:r>
+              <a:rPr sz="1300">
+                <a:solidFill>
+                  <a:srgbClr val="6D8C97"/>
+                </a:solidFill>
+                <a:latin typeface="Consolas"/>
+              </a:rPr>
+              <a:t>  30  </a:t>
+            </a:r>
+            <a:r>
+              <a:rPr sz="1300">
+                <a:solidFill>
+                  <a:srgbClr val="6D8C97"/>
+                </a:solidFill>
+                <a:latin typeface="Consolas"/>
+              </a:rPr>
+              <a:t>  addLine('Companion', 'You said: ' + text);   // a pretend answer, for now</a:t>
+            </a:r>
+          </a:p>
+          <a:p>
+            <a:pPr>
+              <a:spcAft>
+                <a:spcPts val="0"/>
+              </a:spcAft>
+            </a:pPr>
+            <a:r>
+              <a:rPr sz="1300">
+                <a:solidFill>
+                  <a:srgbClr val="6D8C97"/>
+                </a:solidFill>
+                <a:latin typeface="Consolas"/>
+              </a:rPr>
+              <a:t>  31  </a:t>
+            </a:r>
+            <a:r>
+              <a:rPr sz="1300">
+                <a:solidFill>
+                  <a:srgbClr val="7FE0A0"/>
+                </a:solidFill>
+                <a:latin typeface="Consolas"/>
+              </a:rPr>
+              <a:t>});</a:t>
+            </a:r>
+          </a:p>
+        </p:txBody>
+      </p:sp>
+      <p:sp>
+        <p:nvSpPr>
+          <p:cNvPr id="4" name="TextBox 3"/>
+          <p:cNvSpPr txBox="1"/>
+          <p:nvPr/>
+        </p:nvSpPr>
+        <p:spPr>
+          <a:xfrm>
+            <a:off x="548640" y="5623560"/>
+            <a:ext cx="11064240" cy="1051560"/>
+          </a:xfrm>
+          <a:prstGeom prst="rect">
+            <a:avLst/>
+          </a:prstGeom>
+          <a:noFill/>
+        </p:spPr>
+        <p:txBody>
+          <a:bodyPr wrap="square">
+            <a:spAutoFit/>
+          </a:bodyPr>
+          <a:lstStyle/>
+          <a:p>
+            <a:r>
+              <a:rPr sz="2000">
+                <a:solidFill>
+                  <a:srgbClr val="DCECEF"/>
+                </a:solidFill>
+              </a:rPr>
+              <a:t>Close the listener. Type in the box and press Enter to try it.</a:t>
+            </a:r>
+          </a:p>
+        </p:txBody>
+      </p:sp>
+    </p:spTree>
+  </p:cSld>
+  <p:clrMapOvr>
+    <a:masterClrMapping/>
+  </p:clrMapOvr>
+</p:sld>
+</file>
+
+<file path=ppt/slides/slide41.xml><?xml version="1.0" encoding="utf-8"?>
+<p:sld xmlns:a="http://schemas.openxmlformats.org/drawingml/2006/main" xmlns:p="http://schemas.openxmlformats.org/presentationml/2006/main" xmlns:r="http://schemas.openxmlformats.org/officeDocument/2006/relationships">
+  <p:cSld>
+    <p:bg>
+      <p:bgPr>
+        <a:solidFill>
+          <a:srgbClr val="102127"/>
+        </a:solidFill>
+        <a:effectLst/>
+      </p:bgPr>
+    </p:bg>
+    <p:spTree>
+      <p:nvGrpSpPr>
+        <p:cNvPr id="1" name=""/>
+        <p:cNvGrpSpPr/>
+        <p:nvPr/>
+      </p:nvGrpSpPr>
+      <p:grpSpPr/>
+      <p:sp>
+        <p:nvSpPr>
+          <p:cNvPr id="2" name="TextBox 1"/>
+          <p:cNvSpPr txBox="1"/>
+          <p:nvPr/>
+        </p:nvSpPr>
+        <p:spPr>
+          <a:xfrm>
+            <a:off x="502920" y="274320"/>
+            <a:ext cx="11155680" cy="548640"/>
+          </a:xfrm>
+          <a:prstGeom prst="rect">
+            <a:avLst/>
+          </a:prstGeom>
+          <a:noFill/>
+        </p:spPr>
+        <p:txBody>
+          <a:bodyPr wrap="none">
+            <a:spAutoFit/>
+          </a:bodyPr>
+          <a:lstStyle/>
+          <a:p>
+            <a:r>
+              <a:rPr sz="2200" b="1">
+                <a:solidFill>
+                  <a:srgbClr val="01AEFD"/>
+                </a:solidFill>
+              </a:rPr>
+              <a:t>All together in script.js</a:t>
+            </a:r>
+          </a:p>
+        </p:txBody>
+      </p:sp>
+      <p:sp>
+        <p:nvSpPr>
+          <p:cNvPr id="3" name="TextBox 2"/>
+          <p:cNvSpPr txBox="1"/>
+          <p:nvPr/>
+        </p:nvSpPr>
+        <p:spPr>
+          <a:xfrm>
+            <a:off x="502920" y="960120"/>
+            <a:ext cx="11155680" cy="4297680"/>
+          </a:xfrm>
+          <a:prstGeom prst="rect">
+            <a:avLst/>
+          </a:prstGeom>
+          <a:noFill/>
+        </p:spPr>
+        <p:txBody>
+          <a:bodyPr wrap="none">
+            <a:spAutoFit/>
+          </a:bodyPr>
+          <a:lstStyle/>
+          <a:p>
+            <a:pPr>
+              <a:spcAft>
+                <a:spcPts val="0"/>
+              </a:spcAft>
+            </a:pPr>
+            <a:r>
+              <a:rPr sz="1300">
+                <a:solidFill>
+                  <a:srgbClr val="6D8C97"/>
+                </a:solidFill>
+                <a:latin typeface="Consolas"/>
+              </a:rPr>
+              <a:t>  21  </a:t>
+            </a:r>
+            <a:r>
+              <a:rPr sz="1300">
+                <a:solidFill>
+                  <a:srgbClr val="7FE0A0"/>
+                </a:solidFill>
+                <a:latin typeface="Consolas"/>
+              </a:rPr>
+              <a:t> </a:t>
+            </a:r>
+          </a:p>
+          <a:p>
+            <a:pPr>
+              <a:spcAft>
+                <a:spcPts val="0"/>
+              </a:spcAft>
+            </a:pPr>
+            <a:r>
+              <a:rPr sz="1300">
+                <a:solidFill>
+                  <a:srgbClr val="6D8C97"/>
+                </a:solidFill>
+                <a:latin typeface="Consolas"/>
+              </a:rPr>
+              <a:t>  22  </a:t>
+            </a:r>
+            <a:r>
+              <a:rPr sz="1300">
+                <a:solidFill>
+                  <a:srgbClr val="7FE0A0"/>
+                </a:solidFill>
+                <a:latin typeface="Consolas"/>
+              </a:rPr>
+              <a:t>// In PixelPad your loop() checked 'was a key pressed?' every frame. Here you</a:t>
+            </a:r>
+          </a:p>
+          <a:p>
+            <a:pPr>
+              <a:spcAft>
+                <a:spcPts val="0"/>
+              </a:spcAft>
+            </a:pPr>
+            <a:r>
+              <a:rPr sz="1300">
+                <a:solidFill>
+                  <a:srgbClr val="6D8C97"/>
+                </a:solidFill>
+                <a:latin typeface="Consolas"/>
+              </a:rPr>
+              <a:t>  23  </a:t>
+            </a:r>
+            <a:r>
+              <a:rPr sz="1300">
+                <a:solidFill>
+                  <a:srgbClr val="7FE0A0"/>
+                </a:solidFill>
+                <a:latin typeface="Consolas"/>
+              </a:rPr>
+              <a:t>// leave a note: when this form is submitted, run this. The browser waits.</a:t>
+            </a:r>
+          </a:p>
+          <a:p>
+            <a:pPr>
+              <a:spcAft>
+                <a:spcPts val="0"/>
+              </a:spcAft>
+            </a:pPr>
+            <a:r>
+              <a:rPr sz="1300">
+                <a:solidFill>
+                  <a:srgbClr val="6D8C97"/>
+                </a:solidFill>
+                <a:latin typeface="Consolas"/>
+              </a:rPr>
+              <a:t>  24  </a:t>
+            </a:r>
+            <a:r>
+              <a:rPr sz="1300">
+                <a:solidFill>
+                  <a:srgbClr val="7FE0A0"/>
+                </a:solidFill>
+                <a:latin typeface="Consolas"/>
+              </a:rPr>
+              <a:t>composer.addEventListener('submit', function (event) {</a:t>
+            </a:r>
+          </a:p>
+          <a:p>
+            <a:pPr>
+              <a:spcAft>
+                <a:spcPts val="0"/>
+              </a:spcAft>
+            </a:pPr>
+            <a:r>
+              <a:rPr sz="1300">
+                <a:solidFill>
+                  <a:srgbClr val="6D8C97"/>
+                </a:solidFill>
+                <a:latin typeface="Consolas"/>
+              </a:rPr>
+              <a:t>  25  </a:t>
+            </a:r>
+            <a:r>
+              <a:rPr sz="1300">
+                <a:solidFill>
+                  <a:srgbClr val="7FE0A0"/>
+                </a:solidFill>
+                <a:latin typeface="Consolas"/>
+              </a:rPr>
+              <a:t>  event.preventDefault();          // stop the browser reloading the page</a:t>
+            </a:r>
+          </a:p>
+          <a:p>
+            <a:pPr>
+              <a:spcAft>
+                <a:spcPts val="0"/>
+              </a:spcAft>
+            </a:pPr>
+            <a:r>
+              <a:rPr sz="1300">
+                <a:solidFill>
+                  <a:srgbClr val="6D8C97"/>
+                </a:solidFill>
+                <a:latin typeface="Consolas"/>
+              </a:rPr>
+              <a:t>  26  </a:t>
+            </a:r>
+            <a:r>
+              <a:rPr sz="1300">
+                <a:solidFill>
+                  <a:srgbClr val="7FE0A0"/>
+                </a:solidFill>
+                <a:latin typeface="Consolas"/>
+              </a:rPr>
+              <a:t>  const text = promptBox.value.trim();</a:t>
+            </a:r>
+          </a:p>
+          <a:p>
+            <a:pPr>
+              <a:spcAft>
+                <a:spcPts val="0"/>
+              </a:spcAft>
+            </a:pPr>
+            <a:r>
+              <a:rPr sz="1300">
+                <a:solidFill>
+                  <a:srgbClr val="6D8C97"/>
+                </a:solidFill>
+                <a:latin typeface="Consolas"/>
+              </a:rPr>
+              <a:t>  27  </a:t>
+            </a:r>
+            <a:r>
+              <a:rPr sz="1300">
+                <a:solidFill>
+                  <a:srgbClr val="7FE0A0"/>
+                </a:solidFill>
+                <a:latin typeface="Consolas"/>
+              </a:rPr>
+              <a:t>  if (text === '') { return; }     // nothing typed, nothing to do</a:t>
+            </a:r>
+          </a:p>
+          <a:p>
+            <a:pPr>
+              <a:spcAft>
+                <a:spcPts val="0"/>
+              </a:spcAft>
+            </a:pPr>
+            <a:r>
+              <a:rPr sz="1300">
+                <a:solidFill>
+                  <a:srgbClr val="6D8C97"/>
+                </a:solidFill>
+                <a:latin typeface="Consolas"/>
+              </a:rPr>
+              <a:t>  28  </a:t>
+            </a:r>
+            <a:r>
+              <a:rPr sz="1300">
+                <a:solidFill>
+                  <a:srgbClr val="7FE0A0"/>
+                </a:solidFill>
+                <a:latin typeface="Consolas"/>
+              </a:rPr>
+              <a:t>  promptBox.value = '';            // clear the box, ready for the next one</a:t>
+            </a:r>
+          </a:p>
+          <a:p>
+            <a:pPr>
+              <a:spcAft>
+                <a:spcPts val="0"/>
+              </a:spcAft>
+            </a:pPr>
+            <a:r>
+              <a:rPr sz="1300">
+                <a:solidFill>
+                  <a:srgbClr val="6D8C97"/>
+                </a:solidFill>
+                <a:latin typeface="Consolas"/>
+              </a:rPr>
+              <a:t>  29  </a:t>
+            </a:r>
+            <a:r>
+              <a:rPr sz="1300">
+                <a:solidFill>
+                  <a:srgbClr val="7FE0A0"/>
+                </a:solidFill>
+                <a:latin typeface="Consolas"/>
+              </a:rPr>
+              <a:t>  addLine('You', text);</a:t>
+            </a:r>
+          </a:p>
+          <a:p>
+            <a:pPr>
+              <a:spcAft>
+                <a:spcPts val="0"/>
+              </a:spcAft>
+            </a:pPr>
+            <a:r>
+              <a:rPr sz="1300">
+                <a:solidFill>
+                  <a:srgbClr val="6D8C97"/>
+                </a:solidFill>
+                <a:latin typeface="Consolas"/>
+              </a:rPr>
+              <a:t>  30  </a:t>
+            </a:r>
+            <a:r>
+              <a:rPr sz="1300">
+                <a:solidFill>
+                  <a:srgbClr val="7FE0A0"/>
+                </a:solidFill>
+                <a:latin typeface="Consolas"/>
+              </a:rPr>
+              <a:t>  addLine('Companion', 'You said: ' + text);   // a pretend answer, for now</a:t>
+            </a:r>
+          </a:p>
+          <a:p>
+            <a:pPr>
+              <a:spcAft>
+                <a:spcPts val="0"/>
+              </a:spcAft>
+            </a:pPr>
+            <a:r>
+              <a:rPr sz="1300">
+                <a:solidFill>
+                  <a:srgbClr val="6D8C97"/>
+                </a:solidFill>
+                <a:latin typeface="Consolas"/>
+              </a:rPr>
+              <a:t>  31  </a:t>
+            </a:r>
+            <a:r>
+              <a:rPr sz="1300">
+                <a:solidFill>
+                  <a:srgbClr val="7FE0A0"/>
+                </a:solidFill>
+                <a:latin typeface="Consolas"/>
+              </a:rPr>
+              <a:t>});</a:t>
+            </a:r>
+          </a:p>
+        </p:txBody>
+      </p:sp>
+      <p:sp>
+        <p:nvSpPr>
+          <p:cNvPr id="4" name="TextBox 3"/>
+          <p:cNvSpPr txBox="1"/>
+          <p:nvPr/>
+        </p:nvSpPr>
+        <p:spPr>
+          <a:xfrm>
+            <a:off x="548640" y="5623560"/>
+            <a:ext cx="11064240" cy="1051560"/>
+          </a:xfrm>
+          <a:prstGeom prst="rect">
+            <a:avLst/>
+          </a:prstGeom>
+          <a:noFill/>
+        </p:spPr>
+        <p:txBody>
+          <a:bodyPr wrap="square">
+            <a:spAutoFit/>
+          </a:bodyPr>
+          <a:lstStyle/>
+          <a:p>
+            <a:r>
+              <a:rPr sz="2000">
+                <a:solidFill>
+                  <a:srgbClr val="DCECEF"/>
+                </a:solidFill>
+              </a:rPr>
+              <a:t>That is the whole piece. Check yours looks the same before moving on.</a:t>
+            </a:r>
+          </a:p>
+        </p:txBody>
+      </p:sp>
+    </p:spTree>
+  </p:cSld>
+  <p:clrMapOvr>
+    <a:masterClrMapping/>
+  </p:clrMapOvr>
+</p:sld>
+</file>
+
+<file path=ppt/slides/slide42.xml><?xml version="1.0" encoding="utf-8"?>
+<p:sld xmlns:a="http://schemas.openxmlformats.org/drawingml/2006/main" xmlns:p="http://schemas.openxmlformats.org/presentationml/2006/main" xmlns:r="http://schemas.openxmlformats.org/officeDocument/2006/relationships">
+  <p:cSld>
+    <p:spTree>
+      <p:nvGrpSpPr>
+        <p:cNvPr id="1" name=""/>
+        <p:cNvGrpSpPr/>
+        <p:nvPr/>
+      </p:nvGrpSpPr>
+      <p:grpSpPr/>
+      <p:sp>
+        <p:nvSpPr>
+          <p:cNvPr id="2" name="Title 1"/>
+          <p:cNvSpPr>
+            <a:spLocks noGrp="1"/>
+          </p:cNvSpPr>
+          <p:nvPr>
+            <p:ph type="title"/>
+          </p:nvPr>
+        </p:nvSpPr>
+        <p:spPr/>
+        <p:txBody>
+          <a:bodyPr/>
+          <a:lstStyle/>
+          <a:p>
+            <a:r>
+              <a:rPr sz="3800" b="1">
+                <a:solidFill>
+                  <a:srgbClr val="1F2A37"/>
+                </a:solidFill>
+              </a:rPr>
+              <a:t>Checkpoint: it echoes you</a:t>
+            </a:r>
+          </a:p>
+        </p:txBody>
+      </p:sp>
+      <p:sp>
+        <p:nvSpPr>
+          <p:cNvPr id="3" name="TextBox 2"/>
+          <p:cNvSpPr txBox="1"/>
+          <p:nvPr/>
+        </p:nvSpPr>
+        <p:spPr>
+          <a:xfrm>
+            <a:off x="868680" y="502920"/>
+            <a:ext cx="5486400" cy="457200"/>
+          </a:xfrm>
+          <a:prstGeom prst="rect">
+            <a:avLst/>
+          </a:prstGeom>
+          <a:noFill/>
+        </p:spPr>
+        <p:txBody>
+          <a:bodyPr wrap="none">
+            <a:spAutoFit/>
+          </a:bodyPr>
+          <a:lstStyle/>
+          <a:p>
+            <a:r>
+              <a:rPr sz="1500" b="1">
+                <a:solidFill>
+                  <a:srgbClr val="01AEFD"/>
+                </a:solidFill>
+              </a:rPr>
+              <a:t>CHECKPOINT - RUN IT</a:t>
+            </a:r>
+          </a:p>
+        </p:txBody>
+      </p:sp>
+      <p:sp>
+        <p:nvSpPr>
+          <p:cNvPr id="4" name="TextBox 3"/>
+          <p:cNvSpPr txBox="1"/>
+          <p:nvPr/>
+        </p:nvSpPr>
+        <p:spPr>
+          <a:xfrm>
+            <a:off x="822960" y="1828800"/>
+            <a:ext cx="10515600" cy="4206240"/>
+          </a:xfrm>
+          <a:prstGeom prst="rect">
+            <a:avLst/>
+          </a:prstGeom>
+          <a:noFill/>
+        </p:spPr>
+        <p:txBody>
+          <a:bodyPr wrap="square">
+            <a:spAutoFit/>
+          </a:bodyPr>
+          <a:lstStyle/>
+          <a:p>
+            <a:pPr>
+              <a:spcAft>
+                <a:spcPts val="1400"/>
+              </a:spcAft>
+            </a:pPr>
+            <a:r>
+              <a:rPr sz="2800">
+                <a:solidFill>
+                  <a:srgbClr val="01AEFD"/>
+                </a:solidFill>
+              </a:rPr>
+              <a:t>Press Run, type a message and press Send. It should show as 'You: ...' and the companion echoes it back right below. This runs entirely in the browser - no AI yet.</a:t>
+            </a:r>
+          </a:p>
+          <a:p>
+            <a:pPr>
+              <a:spcAft>
+                <a:spcPts val="1400"/>
+              </a:spcAft>
+            </a:pPr>
+            <a:r>
+              <a:rPr sz="2400">
+                <a:solidFill>
+                  <a:srgbClr val="1F2A37"/>
+                </a:solidFill>
+              </a:rPr>
+              <a:t>• Run it in the classroom, or press Show the output in the web deck.</a:t>
+            </a:r>
+          </a:p>
+          <a:p>
+            <a:pPr>
+              <a:spcAft>
+                <a:spcPts val="1400"/>
+              </a:spcAft>
+            </a:pPr>
+            <a:r>
+              <a:rPr sz="2400">
+                <a:solidFill>
+                  <a:srgbClr val="1F2A37"/>
+                </a:solidFill>
+              </a:rPr>
+              <a:t>• Everyone's screen should match this.</a:t>
+            </a:r>
+          </a:p>
+        </p:txBody>
+      </p:sp>
+    </p:spTree>
+  </p:cSld>
+  <p:clrMapOvr>
+    <a:masterClrMapping/>
+  </p:clrMapOvr>
+</p:sld>
+</file>
+
+<file path=ppt/slides/slide43.xml><?xml version="1.0" encoding="utf-8"?>
+<p:sld xmlns:a="http://schemas.openxmlformats.org/drawingml/2006/main" xmlns:p="http://schemas.openxmlformats.org/presentationml/2006/main" xmlns:r="http://schemas.openxmlformats.org/officeDocument/2006/relationships">
+  <p:cSld>
+    <p:spTree>
+      <p:nvGrpSpPr>
+        <p:cNvPr id="1" name=""/>
+        <p:cNvGrpSpPr/>
+        <p:nvPr/>
+      </p:nvGrpSpPr>
+      <p:grpSpPr/>
+      <p:sp>
+        <p:nvSpPr>
+          <p:cNvPr id="2" name="Title 1"/>
+          <p:cNvSpPr>
+            <a:spLocks noGrp="1"/>
+          </p:cNvSpPr>
+          <p:nvPr>
+            <p:ph type="title"/>
+          </p:nvPr>
+        </p:nvSpPr>
+        <p:spPr/>
+        <p:txBody>
+          <a:bodyPr/>
+          <a:lstStyle/>
+          <a:p>
+            <a:r>
+              <a:rPr sz="3800" b="1">
+                <a:solidFill>
+                  <a:srgbClr val="1F2A37"/>
+                </a:solidFill>
+              </a:rPr>
+              <a:t>Your turn</a:t>
+            </a:r>
+          </a:p>
+        </p:txBody>
+      </p:sp>
+      <p:sp>
+        <p:nvSpPr>
+          <p:cNvPr id="3" name="TextBox 2"/>
+          <p:cNvSpPr txBox="1"/>
+          <p:nvPr/>
+        </p:nvSpPr>
+        <p:spPr>
+          <a:xfrm>
+            <a:off x="822960" y="1828800"/>
+            <a:ext cx="10515600" cy="4206240"/>
+          </a:xfrm>
+          <a:prstGeom prst="rect">
+            <a:avLst/>
+          </a:prstGeom>
+          <a:noFill/>
+        </p:spPr>
+        <p:txBody>
+          <a:bodyPr wrap="square">
+            <a:spAutoFit/>
+          </a:bodyPr>
+          <a:lstStyle/>
+          <a:p>
+            <a:pPr>
+              <a:spcAft>
+                <a:spcPts val="1400"/>
+              </a:spcAft>
+            </a:pPr>
+            <a:r>
+              <a:rPr sz="2800">
+                <a:solidFill>
+                  <a:srgbClr val="01AEFD"/>
+                </a:solidFill>
+              </a:rPr>
+              <a:t>Get the echo working</a:t>
+            </a:r>
+          </a:p>
+          <a:p>
+            <a:pPr>
+              <a:spcAft>
+                <a:spcPts val="1400"/>
+              </a:spcAft>
+            </a:pPr>
+            <a:r>
+              <a:rPr sz="2400">
+                <a:solidFill>
+                  <a:srgbClr val="1F2A37"/>
+                </a:solidFill>
+              </a:rPr>
+              <a:t>• Type a message</a:t>
+            </a:r>
+          </a:p>
+          <a:p>
+            <a:pPr>
+              <a:spcAft>
+                <a:spcPts val="1400"/>
+              </a:spcAft>
+            </a:pPr>
+            <a:r>
+              <a:rPr sz="2400">
+                <a:solidFill>
+                  <a:srgbClr val="1F2A37"/>
+                </a:solidFill>
+              </a:rPr>
+              <a:t>• Press Send</a:t>
+            </a:r>
+          </a:p>
+          <a:p>
+            <a:pPr>
+              <a:spcAft>
+                <a:spcPts val="1400"/>
+              </a:spcAft>
+            </a:pPr>
+            <a:r>
+              <a:rPr sz="2400">
+                <a:solidFill>
+                  <a:srgbClr val="1F2A37"/>
+                </a:solidFill>
+              </a:rPr>
+              <a:t>• See it appear twice</a:t>
             </a:r>
           </a:p>
         </p:txBody>

</xml_diff>

<commit_message>
Backfill quizzes to weeks 1-11 and balance answer positions
Quizzes were only on weeks 12-15, and every correct answer was option A.

- course.py: one quiz set per week 1-11, keyed to that week's culminating
  block so the check lands right after the topic is typed and run. Each
  set is a few questions on the new code plus one spaced-repetition
  question from an earlier week.
- build.py: balance_quiz() deterministically reseats the correct option
  (from a hash of the question text) so answers spread across A/B/C/D
  instead of always A - stable across rebuilds and identical in the .html
  and .pptx. Quizzes are authored correct-option-first; the build balances.
- SLIDE-RULES.md: documents one-per-week placement and the balancing.

66 questions now spread A=15 B=17 C=18 D=16 (was 22, all A). 900 slides.

Co-Authored-By: Claude Opus 4.8 <noreply@anthropic.com>
</commit_message>
<xml_diff>
--- a/ai101/slides/week-02.pptx
+++ b/ai101/slides/week-02.pptx
@@ -54,6 +54,14 @@
     <p:sldId id="302" r:id="rId53"/>
     <p:sldId id="303" r:id="rId54"/>
     <p:sldId id="304" r:id="rId55"/>
+    <p:sldId id="305" r:id="rId56"/>
+    <p:sldId id="306" r:id="rId57"/>
+    <p:sldId id="307" r:id="rId58"/>
+    <p:sldId id="308" r:id="rId59"/>
+    <p:sldId id="309" r:id="rId60"/>
+    <p:sldId id="310" r:id="rId61"/>
+    <p:sldId id="311" r:id="rId62"/>
+    <p:sldId id="312" r:id="rId63"/>
   </p:sldIdLst>
   <p:sldSz cx="12191695" cy="6858000" type="screen4x3"/>
   <p:notesSz cx="6858000" cy="9144000"/>
@@ -13778,7 +13786,7 @@
                   <a:srgbClr val="1F2A37"/>
                 </a:solidFill>
               </a:rPr>
-              <a:t>Checkpoint: it echoes you</a:t>
+              <a:t>What is a function?</a:t>
             </a:r>
           </a:p>
         </p:txBody>
@@ -13811,7 +13819,7 @@
                   <a:srgbClr val="01AEFD"/>
                 </a:solidFill>
               </a:rPr>
-              <a:t>CHECKPOINT - RUN IT</a:t>
+              <a:t>QUICK CHECK</a:t>
             </a:r>
           </a:p>
         </p:txBody>
@@ -13844,12 +13852,12 @@
               </a:spcAft>
             </a:pPr>
             <a:r>
-              <a:rPr sz="2800">
-                <a:solidFill>
-                  <a:srgbClr val="01AEFD"/>
-                </a:solidFill>
-              </a:rPr>
-              <a:t>Press Run, type a message and press Send. It should show as 'You: ...' and the companion echoes it back right below. This runs entirely in the browser - no AI yet.</a:t>
+              <a:rPr sz="2400">
+                <a:solidFill>
+                  <a:srgbClr val="1F2A37"/>
+                </a:solidFill>
+              </a:rPr>
+              <a:t>• A. A reusable block of code you run by name</a:t>
             </a:r>
           </a:p>
           <a:p>
@@ -13864,7 +13872,7 @@
                   <a:srgbClr val="1F2A37"/>
                 </a:solidFill>
               </a:rPr>
-              <a:t>• Run it in the classroom, or press Show the output in the web deck.</a:t>
+              <a:t>• B. A kind of colour</a:t>
             </a:r>
           </a:p>
           <a:p>
@@ -13879,7 +13887,37 @@
                   <a:srgbClr val="1F2A37"/>
                 </a:solidFill>
               </a:rPr>
-              <a:t>• Everyone's screen should match this.</a:t>
+              <a:t>• C. A CSS rule</a:t>
+            </a:r>
+          </a:p>
+          <a:p>
+            <a:pPr>
+              <a:spcAft>
+                <a:spcPts val="1400"/>
+              </a:spcAft>
+            </a:pPr>
+            <a:r>
+              <a:rPr sz="2400">
+                <a:solidFill>
+                  <a:srgbClr val="1F2A37"/>
+                </a:solidFill>
+              </a:rPr>
+              <a:t>• D. An HTML tag</a:t>
+            </a:r>
+          </a:p>
+          <a:p>
+            <a:pPr>
+              <a:spcAft>
+                <a:spcPts val="1400"/>
+              </a:spcAft>
+            </a:pPr>
+            <a:r>
+              <a:rPr sz="2400">
+                <a:solidFill>
+                  <a:srgbClr val="1F2A37"/>
+                </a:solidFill>
+              </a:rPr>
+              <a:t>• Pick one - the answer is on the next slide.</a:t>
             </a:r>
           </a:p>
         </p:txBody>
@@ -13923,7 +13961,7 @@
                   <a:srgbClr val="1F2A37"/>
                 </a:solidFill>
               </a:rPr>
-              <a:t>Your turn</a:t>
+              <a:t>What is a function?</a:t>
             </a:r>
           </a:p>
         </p:txBody>
@@ -13931,6 +13969,39 @@
       <p:sp>
         <p:nvSpPr>
           <p:cNvPr id="3" name="TextBox 2"/>
+          <p:cNvSpPr txBox="1"/>
+          <p:nvPr/>
+        </p:nvSpPr>
+        <p:spPr>
+          <a:xfrm>
+            <a:off x="868680" y="502920"/>
+            <a:ext cx="5486400" cy="457200"/>
+          </a:xfrm>
+          <a:prstGeom prst="rect">
+            <a:avLst/>
+          </a:prstGeom>
+          <a:noFill/>
+        </p:spPr>
+        <p:txBody>
+          <a:bodyPr wrap="none">
+            <a:spAutoFit/>
+          </a:bodyPr>
+          <a:lstStyle/>
+          <a:p>
+            <a:r>
+              <a:rPr sz="1500" b="1">
+                <a:solidFill>
+                  <a:srgbClr val="01AEFD"/>
+                </a:solidFill>
+              </a:rPr>
+              <a:t>ANSWER</a:t>
+            </a:r>
+          </a:p>
+        </p:txBody>
+      </p:sp>
+      <p:sp>
+        <p:nvSpPr>
+          <p:cNvPr id="4" name="TextBox 3"/>
           <p:cNvSpPr txBox="1"/>
           <p:nvPr/>
         </p:nvSpPr>
@@ -13956,12 +14027,12 @@
               </a:spcAft>
             </a:pPr>
             <a:r>
-              <a:rPr sz="2800">
-                <a:solidFill>
-                  <a:srgbClr val="01AEFD"/>
-                </a:solidFill>
-              </a:rPr>
-              <a:t>Get the echo working</a:t>
+              <a:rPr sz="2400">
+                <a:solidFill>
+                  <a:srgbClr val="1F2A37"/>
+                </a:solidFill>
+              </a:rPr>
+              <a:t>• A. A reusable block of code you run by name (correct)</a:t>
             </a:r>
           </a:p>
           <a:p>
@@ -13976,7 +14047,7 @@
                   <a:srgbClr val="1F2A37"/>
                 </a:solidFill>
               </a:rPr>
-              <a:t>• Type a message</a:t>
+              <a:t>• B. A kind of colour</a:t>
             </a:r>
           </a:p>
           <a:p>
@@ -13991,7 +14062,7 @@
                   <a:srgbClr val="1F2A37"/>
                 </a:solidFill>
               </a:rPr>
-              <a:t>• Press Send</a:t>
+              <a:t>• C. A CSS rule</a:t>
             </a:r>
           </a:p>
           <a:p>
@@ -14006,7 +14077,22 @@
                   <a:srgbClr val="1F2A37"/>
                 </a:solidFill>
               </a:rPr>
-              <a:t>• See it appear twice</a:t>
+              <a:t>• D. An HTML tag</a:t>
+            </a:r>
+          </a:p>
+          <a:p>
+            <a:pPr>
+              <a:spcAft>
+                <a:spcPts val="1400"/>
+              </a:spcAft>
+            </a:pPr>
+            <a:r>
+              <a:rPr sz="2400">
+                <a:solidFill>
+                  <a:srgbClr val="1F2A37"/>
+                </a:solidFill>
+              </a:rPr>
+              <a:t>• A function is a named block of code you can run whenever you call it.</a:t>
             </a:r>
           </a:p>
         </p:txBody>
@@ -14137,6 +14223,1328 @@
                 </a:solidFill>
               </a:rPr>
               <a:t>• const chat = ... means 'let chat stand for this from now on'.</a:t>
+            </a:r>
+          </a:p>
+        </p:txBody>
+      </p:sp>
+    </p:spTree>
+  </p:cSld>
+  <p:clrMapOvr>
+    <a:masterClrMapping/>
+  </p:clrMapOvr>
+</p:sld>
+</file>
+
+<file path=ppt/slides/slide50.xml><?xml version="1.0" encoding="utf-8"?>
+<p:sld xmlns:a="http://schemas.openxmlformats.org/drawingml/2006/main" xmlns:p="http://schemas.openxmlformats.org/presentationml/2006/main" xmlns:r="http://schemas.openxmlformats.org/officeDocument/2006/relationships">
+  <p:cSld>
+    <p:spTree>
+      <p:nvGrpSpPr>
+        <p:cNvPr id="1" name=""/>
+        <p:cNvGrpSpPr/>
+        <p:nvPr/>
+      </p:nvGrpSpPr>
+      <p:grpSpPr/>
+      <p:sp>
+        <p:nvSpPr>
+          <p:cNvPr id="2" name="Title 1"/>
+          <p:cNvSpPr>
+            <a:spLocks noGrp="1"/>
+          </p:cNvSpPr>
+          <p:nvPr>
+            <p:ph type="title"/>
+          </p:nvPr>
+        </p:nvSpPr>
+        <p:spPr/>
+        <p:txBody>
+          <a:bodyPr/>
+          <a:lstStyle/>
+          <a:p>
+            <a:r>
+              <a:rPr sz="3800" b="1">
+                <a:solidFill>
+                  <a:srgbClr val="1F2A37"/>
+                </a:solidFill>
+              </a:rPr>
+              <a:t>form.addEventListener('submit', ...) runs your code when?</a:t>
+            </a:r>
+          </a:p>
+        </p:txBody>
+      </p:sp>
+      <p:sp>
+        <p:nvSpPr>
+          <p:cNvPr id="3" name="TextBox 2"/>
+          <p:cNvSpPr txBox="1"/>
+          <p:nvPr/>
+        </p:nvSpPr>
+        <p:spPr>
+          <a:xfrm>
+            <a:off x="868680" y="502920"/>
+            <a:ext cx="5486400" cy="457200"/>
+          </a:xfrm>
+          <a:prstGeom prst="rect">
+            <a:avLst/>
+          </a:prstGeom>
+          <a:noFill/>
+        </p:spPr>
+        <p:txBody>
+          <a:bodyPr wrap="none">
+            <a:spAutoFit/>
+          </a:bodyPr>
+          <a:lstStyle/>
+          <a:p>
+            <a:r>
+              <a:rPr sz="1500" b="1">
+                <a:solidFill>
+                  <a:srgbClr val="01AEFD"/>
+                </a:solidFill>
+              </a:rPr>
+              <a:t>QUICK CHECK</a:t>
+            </a:r>
+          </a:p>
+        </p:txBody>
+      </p:sp>
+      <p:sp>
+        <p:nvSpPr>
+          <p:cNvPr id="4" name="TextBox 3"/>
+          <p:cNvSpPr txBox="1"/>
+          <p:nvPr/>
+        </p:nvSpPr>
+        <p:spPr>
+          <a:xfrm>
+            <a:off x="822960" y="1828800"/>
+            <a:ext cx="10515600" cy="4206240"/>
+          </a:xfrm>
+          <a:prstGeom prst="rect">
+            <a:avLst/>
+          </a:prstGeom>
+          <a:noFill/>
+        </p:spPr>
+        <p:txBody>
+          <a:bodyPr wrap="square">
+            <a:spAutoFit/>
+          </a:bodyPr>
+          <a:lstStyle/>
+          <a:p>
+            <a:pPr>
+              <a:spcAft>
+                <a:spcPts val="1400"/>
+              </a:spcAft>
+            </a:pPr>
+            <a:r>
+              <a:rPr sz="2400">
+                <a:solidFill>
+                  <a:srgbClr val="1F2A37"/>
+                </a:solidFill>
+              </a:rPr>
+              <a:t>• A. The form is submitted</a:t>
+            </a:r>
+          </a:p>
+          <a:p>
+            <a:pPr>
+              <a:spcAft>
+                <a:spcPts val="1400"/>
+              </a:spcAft>
+            </a:pPr>
+            <a:r>
+              <a:rPr sz="2400">
+                <a:solidFill>
+                  <a:srgbClr val="1F2A37"/>
+                </a:solidFill>
+              </a:rPr>
+              <a:t>• B. The page first loads</a:t>
+            </a:r>
+          </a:p>
+          <a:p>
+            <a:pPr>
+              <a:spcAft>
+                <a:spcPts val="1400"/>
+              </a:spcAft>
+            </a:pPr>
+            <a:r>
+              <a:rPr sz="2400">
+                <a:solidFill>
+                  <a:srgbClr val="1F2A37"/>
+                </a:solidFill>
+              </a:rPr>
+              <a:t>• C. A colour changes</a:t>
+            </a:r>
+          </a:p>
+          <a:p>
+            <a:pPr>
+              <a:spcAft>
+                <a:spcPts val="1400"/>
+              </a:spcAft>
+            </a:pPr>
+            <a:r>
+              <a:rPr sz="2400">
+                <a:solidFill>
+                  <a:srgbClr val="1F2A37"/>
+                </a:solidFill>
+              </a:rPr>
+              <a:t>• D. Never</a:t>
+            </a:r>
+          </a:p>
+          <a:p>
+            <a:pPr>
+              <a:spcAft>
+                <a:spcPts val="1400"/>
+              </a:spcAft>
+            </a:pPr>
+            <a:r>
+              <a:rPr sz="2400">
+                <a:solidFill>
+                  <a:srgbClr val="1F2A37"/>
+                </a:solidFill>
+              </a:rPr>
+              <a:t>• Pick one - the answer is on the next slide.</a:t>
+            </a:r>
+          </a:p>
+        </p:txBody>
+      </p:sp>
+    </p:spTree>
+  </p:cSld>
+  <p:clrMapOvr>
+    <a:masterClrMapping/>
+  </p:clrMapOvr>
+</p:sld>
+</file>
+
+<file path=ppt/slides/slide51.xml><?xml version="1.0" encoding="utf-8"?>
+<p:sld xmlns:a="http://schemas.openxmlformats.org/drawingml/2006/main" xmlns:p="http://schemas.openxmlformats.org/presentationml/2006/main" xmlns:r="http://schemas.openxmlformats.org/officeDocument/2006/relationships">
+  <p:cSld>
+    <p:spTree>
+      <p:nvGrpSpPr>
+        <p:cNvPr id="1" name=""/>
+        <p:cNvGrpSpPr/>
+        <p:nvPr/>
+      </p:nvGrpSpPr>
+      <p:grpSpPr/>
+      <p:sp>
+        <p:nvSpPr>
+          <p:cNvPr id="2" name="Title 1"/>
+          <p:cNvSpPr>
+            <a:spLocks noGrp="1"/>
+          </p:cNvSpPr>
+          <p:nvPr>
+            <p:ph type="title"/>
+          </p:nvPr>
+        </p:nvSpPr>
+        <p:spPr/>
+        <p:txBody>
+          <a:bodyPr/>
+          <a:lstStyle/>
+          <a:p>
+            <a:r>
+              <a:rPr sz="3800" b="1">
+                <a:solidFill>
+                  <a:srgbClr val="1F2A37"/>
+                </a:solidFill>
+              </a:rPr>
+              <a:t>form.addEventListener('submit', ...) runs your code when?</a:t>
+            </a:r>
+          </a:p>
+        </p:txBody>
+      </p:sp>
+      <p:sp>
+        <p:nvSpPr>
+          <p:cNvPr id="3" name="TextBox 2"/>
+          <p:cNvSpPr txBox="1"/>
+          <p:nvPr/>
+        </p:nvSpPr>
+        <p:spPr>
+          <a:xfrm>
+            <a:off x="868680" y="502920"/>
+            <a:ext cx="5486400" cy="457200"/>
+          </a:xfrm>
+          <a:prstGeom prst="rect">
+            <a:avLst/>
+          </a:prstGeom>
+          <a:noFill/>
+        </p:spPr>
+        <p:txBody>
+          <a:bodyPr wrap="none">
+            <a:spAutoFit/>
+          </a:bodyPr>
+          <a:lstStyle/>
+          <a:p>
+            <a:r>
+              <a:rPr sz="1500" b="1">
+                <a:solidFill>
+                  <a:srgbClr val="01AEFD"/>
+                </a:solidFill>
+              </a:rPr>
+              <a:t>ANSWER</a:t>
+            </a:r>
+          </a:p>
+        </p:txBody>
+      </p:sp>
+      <p:sp>
+        <p:nvSpPr>
+          <p:cNvPr id="4" name="TextBox 3"/>
+          <p:cNvSpPr txBox="1"/>
+          <p:nvPr/>
+        </p:nvSpPr>
+        <p:spPr>
+          <a:xfrm>
+            <a:off x="822960" y="1828800"/>
+            <a:ext cx="10515600" cy="4206240"/>
+          </a:xfrm>
+          <a:prstGeom prst="rect">
+            <a:avLst/>
+          </a:prstGeom>
+          <a:noFill/>
+        </p:spPr>
+        <p:txBody>
+          <a:bodyPr wrap="square">
+            <a:spAutoFit/>
+          </a:bodyPr>
+          <a:lstStyle/>
+          <a:p>
+            <a:pPr>
+              <a:spcAft>
+                <a:spcPts val="1400"/>
+              </a:spcAft>
+            </a:pPr>
+            <a:r>
+              <a:rPr sz="2400">
+                <a:solidFill>
+                  <a:srgbClr val="1F2A37"/>
+                </a:solidFill>
+              </a:rPr>
+              <a:t>• A. The form is submitted (correct)</a:t>
+            </a:r>
+          </a:p>
+          <a:p>
+            <a:pPr>
+              <a:spcAft>
+                <a:spcPts val="1400"/>
+              </a:spcAft>
+            </a:pPr>
+            <a:r>
+              <a:rPr sz="2400">
+                <a:solidFill>
+                  <a:srgbClr val="1F2A37"/>
+                </a:solidFill>
+              </a:rPr>
+              <a:t>• B. The page first loads</a:t>
+            </a:r>
+          </a:p>
+          <a:p>
+            <a:pPr>
+              <a:spcAft>
+                <a:spcPts val="1400"/>
+              </a:spcAft>
+            </a:pPr>
+            <a:r>
+              <a:rPr sz="2400">
+                <a:solidFill>
+                  <a:srgbClr val="1F2A37"/>
+                </a:solidFill>
+              </a:rPr>
+              <a:t>• C. A colour changes</a:t>
+            </a:r>
+          </a:p>
+          <a:p>
+            <a:pPr>
+              <a:spcAft>
+                <a:spcPts val="1400"/>
+              </a:spcAft>
+            </a:pPr>
+            <a:r>
+              <a:rPr sz="2400">
+                <a:solidFill>
+                  <a:srgbClr val="1F2A37"/>
+                </a:solidFill>
+              </a:rPr>
+              <a:t>• D. Never</a:t>
+            </a:r>
+          </a:p>
+          <a:p>
+            <a:pPr>
+              <a:spcAft>
+                <a:spcPts val="1400"/>
+              </a:spcAft>
+            </a:pPr>
+            <a:r>
+              <a:rPr sz="2400">
+                <a:solidFill>
+                  <a:srgbClr val="1F2A37"/>
+                </a:solidFill>
+              </a:rPr>
+              <a:t>• addEventListener runs your code every time that event happens.</a:t>
+            </a:r>
+          </a:p>
+        </p:txBody>
+      </p:sp>
+    </p:spTree>
+  </p:cSld>
+  <p:clrMapOvr>
+    <a:masterClrMapping/>
+  </p:clrMapOvr>
+</p:sld>
+</file>
+
+<file path=ppt/slides/slide52.xml><?xml version="1.0" encoding="utf-8"?>
+<p:sld xmlns:a="http://schemas.openxmlformats.org/drawingml/2006/main" xmlns:p="http://schemas.openxmlformats.org/presentationml/2006/main" xmlns:r="http://schemas.openxmlformats.org/officeDocument/2006/relationships">
+  <p:cSld>
+    <p:spTree>
+      <p:nvGrpSpPr>
+        <p:cNvPr id="1" name=""/>
+        <p:cNvGrpSpPr/>
+        <p:nvPr/>
+      </p:nvGrpSpPr>
+      <p:grpSpPr/>
+      <p:sp>
+        <p:nvSpPr>
+          <p:cNvPr id="2" name="Title 1"/>
+          <p:cNvSpPr>
+            <a:spLocks noGrp="1"/>
+          </p:cNvSpPr>
+          <p:nvPr>
+            <p:ph type="title"/>
+          </p:nvPr>
+        </p:nvSpPr>
+        <p:spPr/>
+        <p:txBody>
+          <a:bodyPr/>
+          <a:lstStyle/>
+          <a:p>
+            <a:r>
+              <a:rPr sz="3800" b="1">
+                <a:solidFill>
+                  <a:srgbClr val="1F2A37"/>
+                </a:solidFill>
+              </a:rPr>
+              <a:t>Why call  event.preventDefault()  in a submit handler?</a:t>
+            </a:r>
+          </a:p>
+        </p:txBody>
+      </p:sp>
+      <p:sp>
+        <p:nvSpPr>
+          <p:cNvPr id="3" name="TextBox 2"/>
+          <p:cNvSpPr txBox="1"/>
+          <p:nvPr/>
+        </p:nvSpPr>
+        <p:spPr>
+          <a:xfrm>
+            <a:off x="868680" y="502920"/>
+            <a:ext cx="5486400" cy="457200"/>
+          </a:xfrm>
+          <a:prstGeom prst="rect">
+            <a:avLst/>
+          </a:prstGeom>
+          <a:noFill/>
+        </p:spPr>
+        <p:txBody>
+          <a:bodyPr wrap="none">
+            <a:spAutoFit/>
+          </a:bodyPr>
+          <a:lstStyle/>
+          <a:p>
+            <a:r>
+              <a:rPr sz="1500" b="1">
+                <a:solidFill>
+                  <a:srgbClr val="01AEFD"/>
+                </a:solidFill>
+              </a:rPr>
+              <a:t>QUICK CHECK</a:t>
+            </a:r>
+          </a:p>
+        </p:txBody>
+      </p:sp>
+      <p:sp>
+        <p:nvSpPr>
+          <p:cNvPr id="4" name="TextBox 3"/>
+          <p:cNvSpPr txBox="1"/>
+          <p:nvPr/>
+        </p:nvSpPr>
+        <p:spPr>
+          <a:xfrm>
+            <a:off x="822960" y="1828800"/>
+            <a:ext cx="10515600" cy="4206240"/>
+          </a:xfrm>
+          <a:prstGeom prst="rect">
+            <a:avLst/>
+          </a:prstGeom>
+          <a:noFill/>
+        </p:spPr>
+        <p:txBody>
+          <a:bodyPr wrap="square">
+            <a:spAutoFit/>
+          </a:bodyPr>
+          <a:lstStyle/>
+          <a:p>
+            <a:pPr>
+              <a:spcAft>
+                <a:spcPts val="1400"/>
+              </a:spcAft>
+            </a:pPr>
+            <a:r>
+              <a:rPr sz="2400">
+                <a:solidFill>
+                  <a:srgbClr val="1F2A37"/>
+                </a:solidFill>
+              </a:rPr>
+              <a:t>• A. To send the message twice</a:t>
+            </a:r>
+          </a:p>
+          <a:p>
+            <a:pPr>
+              <a:spcAft>
+                <a:spcPts val="1400"/>
+              </a:spcAft>
+            </a:pPr>
+            <a:r>
+              <a:rPr sz="2400">
+                <a:solidFill>
+                  <a:srgbClr val="1F2A37"/>
+                </a:solidFill>
+              </a:rPr>
+              <a:t>• B. To clear the CSS</a:t>
+            </a:r>
+          </a:p>
+          <a:p>
+            <a:pPr>
+              <a:spcAft>
+                <a:spcPts val="1400"/>
+              </a:spcAft>
+            </a:pPr>
+            <a:r>
+              <a:rPr sz="2400">
+                <a:solidFill>
+                  <a:srgbClr val="1F2A37"/>
+                </a:solidFill>
+              </a:rPr>
+              <a:t>• C. To stop the page reloading</a:t>
+            </a:r>
+          </a:p>
+          <a:p>
+            <a:pPr>
+              <a:spcAft>
+                <a:spcPts val="1400"/>
+              </a:spcAft>
+            </a:pPr>
+            <a:r>
+              <a:rPr sz="2400">
+                <a:solidFill>
+                  <a:srgbClr val="1F2A37"/>
+                </a:solidFill>
+              </a:rPr>
+              <a:t>• D. To make text bold</a:t>
+            </a:r>
+          </a:p>
+          <a:p>
+            <a:pPr>
+              <a:spcAft>
+                <a:spcPts val="1400"/>
+              </a:spcAft>
+            </a:pPr>
+            <a:r>
+              <a:rPr sz="2400">
+                <a:solidFill>
+                  <a:srgbClr val="1F2A37"/>
+                </a:solidFill>
+              </a:rPr>
+              <a:t>• Pick one - the answer is on the next slide.</a:t>
+            </a:r>
+          </a:p>
+        </p:txBody>
+      </p:sp>
+    </p:spTree>
+  </p:cSld>
+  <p:clrMapOvr>
+    <a:masterClrMapping/>
+  </p:clrMapOvr>
+</p:sld>
+</file>
+
+<file path=ppt/slides/slide53.xml><?xml version="1.0" encoding="utf-8"?>
+<p:sld xmlns:a="http://schemas.openxmlformats.org/drawingml/2006/main" xmlns:p="http://schemas.openxmlformats.org/presentationml/2006/main" xmlns:r="http://schemas.openxmlformats.org/officeDocument/2006/relationships">
+  <p:cSld>
+    <p:spTree>
+      <p:nvGrpSpPr>
+        <p:cNvPr id="1" name=""/>
+        <p:cNvGrpSpPr/>
+        <p:nvPr/>
+      </p:nvGrpSpPr>
+      <p:grpSpPr/>
+      <p:sp>
+        <p:nvSpPr>
+          <p:cNvPr id="2" name="Title 1"/>
+          <p:cNvSpPr>
+            <a:spLocks noGrp="1"/>
+          </p:cNvSpPr>
+          <p:nvPr>
+            <p:ph type="title"/>
+          </p:nvPr>
+        </p:nvSpPr>
+        <p:spPr/>
+        <p:txBody>
+          <a:bodyPr/>
+          <a:lstStyle/>
+          <a:p>
+            <a:r>
+              <a:rPr sz="3800" b="1">
+                <a:solidFill>
+                  <a:srgbClr val="1F2A37"/>
+                </a:solidFill>
+              </a:rPr>
+              <a:t>Why call  event.preventDefault()  in a submit handler?</a:t>
+            </a:r>
+          </a:p>
+        </p:txBody>
+      </p:sp>
+      <p:sp>
+        <p:nvSpPr>
+          <p:cNvPr id="3" name="TextBox 2"/>
+          <p:cNvSpPr txBox="1"/>
+          <p:nvPr/>
+        </p:nvSpPr>
+        <p:spPr>
+          <a:xfrm>
+            <a:off x="868680" y="502920"/>
+            <a:ext cx="5486400" cy="457200"/>
+          </a:xfrm>
+          <a:prstGeom prst="rect">
+            <a:avLst/>
+          </a:prstGeom>
+          <a:noFill/>
+        </p:spPr>
+        <p:txBody>
+          <a:bodyPr wrap="none">
+            <a:spAutoFit/>
+          </a:bodyPr>
+          <a:lstStyle/>
+          <a:p>
+            <a:r>
+              <a:rPr sz="1500" b="1">
+                <a:solidFill>
+                  <a:srgbClr val="01AEFD"/>
+                </a:solidFill>
+              </a:rPr>
+              <a:t>ANSWER</a:t>
+            </a:r>
+          </a:p>
+        </p:txBody>
+      </p:sp>
+      <p:sp>
+        <p:nvSpPr>
+          <p:cNvPr id="4" name="TextBox 3"/>
+          <p:cNvSpPr txBox="1"/>
+          <p:nvPr/>
+        </p:nvSpPr>
+        <p:spPr>
+          <a:xfrm>
+            <a:off x="822960" y="1828800"/>
+            <a:ext cx="10515600" cy="4206240"/>
+          </a:xfrm>
+          <a:prstGeom prst="rect">
+            <a:avLst/>
+          </a:prstGeom>
+          <a:noFill/>
+        </p:spPr>
+        <p:txBody>
+          <a:bodyPr wrap="square">
+            <a:spAutoFit/>
+          </a:bodyPr>
+          <a:lstStyle/>
+          <a:p>
+            <a:pPr>
+              <a:spcAft>
+                <a:spcPts val="1400"/>
+              </a:spcAft>
+            </a:pPr>
+            <a:r>
+              <a:rPr sz="2400">
+                <a:solidFill>
+                  <a:srgbClr val="1F2A37"/>
+                </a:solidFill>
+              </a:rPr>
+              <a:t>• A. To send the message twice</a:t>
+            </a:r>
+          </a:p>
+          <a:p>
+            <a:pPr>
+              <a:spcAft>
+                <a:spcPts val="1400"/>
+              </a:spcAft>
+            </a:pPr>
+            <a:r>
+              <a:rPr sz="2400">
+                <a:solidFill>
+                  <a:srgbClr val="1F2A37"/>
+                </a:solidFill>
+              </a:rPr>
+              <a:t>• B. To clear the CSS</a:t>
+            </a:r>
+          </a:p>
+          <a:p>
+            <a:pPr>
+              <a:spcAft>
+                <a:spcPts val="1400"/>
+              </a:spcAft>
+            </a:pPr>
+            <a:r>
+              <a:rPr sz="2400">
+                <a:solidFill>
+                  <a:srgbClr val="1F2A37"/>
+                </a:solidFill>
+              </a:rPr>
+              <a:t>• C. To stop the page reloading (correct)</a:t>
+            </a:r>
+          </a:p>
+          <a:p>
+            <a:pPr>
+              <a:spcAft>
+                <a:spcPts val="1400"/>
+              </a:spcAft>
+            </a:pPr>
+            <a:r>
+              <a:rPr sz="2400">
+                <a:solidFill>
+                  <a:srgbClr val="1F2A37"/>
+                </a:solidFill>
+              </a:rPr>
+              <a:t>• D. To make text bold</a:t>
+            </a:r>
+          </a:p>
+          <a:p>
+            <a:pPr>
+              <a:spcAft>
+                <a:spcPts val="1400"/>
+              </a:spcAft>
+            </a:pPr>
+            <a:r>
+              <a:rPr sz="2400">
+                <a:solidFill>
+                  <a:srgbClr val="1F2A37"/>
+                </a:solidFill>
+              </a:rPr>
+              <a:t>• Submitting a form reloads the page by default; preventDefault stops that.</a:t>
+            </a:r>
+          </a:p>
+        </p:txBody>
+      </p:sp>
+    </p:spTree>
+  </p:cSld>
+  <p:clrMapOvr>
+    <a:masterClrMapping/>
+  </p:clrMapOvr>
+</p:sld>
+</file>
+
+<file path=ppt/slides/slide54.xml><?xml version="1.0" encoding="utf-8"?>
+<p:sld xmlns:a="http://schemas.openxmlformats.org/drawingml/2006/main" xmlns:p="http://schemas.openxmlformats.org/presentationml/2006/main" xmlns:r="http://schemas.openxmlformats.org/officeDocument/2006/relationships">
+  <p:cSld>
+    <p:spTree>
+      <p:nvGrpSpPr>
+        <p:cNvPr id="1" name=""/>
+        <p:cNvGrpSpPr/>
+        <p:nvPr/>
+      </p:nvGrpSpPr>
+      <p:grpSpPr/>
+      <p:sp>
+        <p:nvSpPr>
+          <p:cNvPr id="2" name="Title 1"/>
+          <p:cNvSpPr>
+            <a:spLocks noGrp="1"/>
+          </p:cNvSpPr>
+          <p:nvPr>
+            <p:ph type="title"/>
+          </p:nvPr>
+        </p:nvSpPr>
+        <p:spPr/>
+        <p:txBody>
+          <a:bodyPr/>
+          <a:lstStyle/>
+          <a:p>
+            <a:r>
+              <a:rPr sz="3800" b="1">
+                <a:solidFill>
+                  <a:srgbClr val="1F2A37"/>
+                </a:solidFill>
+              </a:rPr>
+              <a:t>Which one creates a paragraph of text? (from week 1)</a:t>
+            </a:r>
+          </a:p>
+        </p:txBody>
+      </p:sp>
+      <p:sp>
+        <p:nvSpPr>
+          <p:cNvPr id="3" name="TextBox 2"/>
+          <p:cNvSpPr txBox="1"/>
+          <p:nvPr/>
+        </p:nvSpPr>
+        <p:spPr>
+          <a:xfrm>
+            <a:off x="868680" y="502920"/>
+            <a:ext cx="5486400" cy="457200"/>
+          </a:xfrm>
+          <a:prstGeom prst="rect">
+            <a:avLst/>
+          </a:prstGeom>
+          <a:noFill/>
+        </p:spPr>
+        <p:txBody>
+          <a:bodyPr wrap="none">
+            <a:spAutoFit/>
+          </a:bodyPr>
+          <a:lstStyle/>
+          <a:p>
+            <a:r>
+              <a:rPr sz="1500" b="1">
+                <a:solidFill>
+                  <a:srgbClr val="01AEFD"/>
+                </a:solidFill>
+              </a:rPr>
+              <a:t>QUICK CHECK</a:t>
+            </a:r>
+          </a:p>
+        </p:txBody>
+      </p:sp>
+      <p:sp>
+        <p:nvSpPr>
+          <p:cNvPr id="4" name="TextBox 3"/>
+          <p:cNvSpPr txBox="1"/>
+          <p:nvPr/>
+        </p:nvSpPr>
+        <p:spPr>
+          <a:xfrm>
+            <a:off x="822960" y="1828800"/>
+            <a:ext cx="10515600" cy="4206240"/>
+          </a:xfrm>
+          <a:prstGeom prst="rect">
+            <a:avLst/>
+          </a:prstGeom>
+          <a:noFill/>
+        </p:spPr>
+        <p:txBody>
+          <a:bodyPr wrap="square">
+            <a:spAutoFit/>
+          </a:bodyPr>
+          <a:lstStyle/>
+          <a:p>
+            <a:pPr>
+              <a:spcAft>
+                <a:spcPts val="1400"/>
+              </a:spcAft>
+            </a:pPr>
+            <a:r>
+              <a:rPr sz="2400">
+                <a:solidFill>
+                  <a:srgbClr val="1F2A37"/>
+                </a:solidFill>
+              </a:rPr>
+              <a:t>• A. &lt;button&gt;</a:t>
+            </a:r>
+          </a:p>
+          <a:p>
+            <a:pPr>
+              <a:spcAft>
+                <a:spcPts val="1400"/>
+              </a:spcAft>
+            </a:pPr>
+            <a:r>
+              <a:rPr sz="2400">
+                <a:solidFill>
+                  <a:srgbClr val="1F2A37"/>
+                </a:solidFill>
+              </a:rPr>
+              <a:t>• B. body { }</a:t>
+            </a:r>
+          </a:p>
+          <a:p>
+            <a:pPr>
+              <a:spcAft>
+                <a:spcPts val="1400"/>
+              </a:spcAft>
+            </a:pPr>
+            <a:r>
+              <a:rPr sz="2400">
+                <a:solidFill>
+                  <a:srgbClr val="1F2A37"/>
+                </a:solidFill>
+              </a:rPr>
+              <a:t>• C. .app</a:t>
+            </a:r>
+          </a:p>
+          <a:p>
+            <a:pPr>
+              <a:spcAft>
+                <a:spcPts val="1400"/>
+              </a:spcAft>
+            </a:pPr>
+            <a:r>
+              <a:rPr sz="2400">
+                <a:solidFill>
+                  <a:srgbClr val="1F2A37"/>
+                </a:solidFill>
+              </a:rPr>
+              <a:t>• D. &lt;p&gt;...&lt;/p&gt;</a:t>
+            </a:r>
+          </a:p>
+          <a:p>
+            <a:pPr>
+              <a:spcAft>
+                <a:spcPts val="1400"/>
+              </a:spcAft>
+            </a:pPr>
+            <a:r>
+              <a:rPr sz="2400">
+                <a:solidFill>
+                  <a:srgbClr val="1F2A37"/>
+                </a:solidFill>
+              </a:rPr>
+              <a:t>• Pick one - the answer is on the next slide.</a:t>
+            </a:r>
+          </a:p>
+        </p:txBody>
+      </p:sp>
+    </p:spTree>
+  </p:cSld>
+  <p:clrMapOvr>
+    <a:masterClrMapping/>
+  </p:clrMapOvr>
+</p:sld>
+</file>
+
+<file path=ppt/slides/slide55.xml><?xml version="1.0" encoding="utf-8"?>
+<p:sld xmlns:a="http://schemas.openxmlformats.org/drawingml/2006/main" xmlns:p="http://schemas.openxmlformats.org/presentationml/2006/main" xmlns:r="http://schemas.openxmlformats.org/officeDocument/2006/relationships">
+  <p:cSld>
+    <p:spTree>
+      <p:nvGrpSpPr>
+        <p:cNvPr id="1" name=""/>
+        <p:cNvGrpSpPr/>
+        <p:nvPr/>
+      </p:nvGrpSpPr>
+      <p:grpSpPr/>
+      <p:sp>
+        <p:nvSpPr>
+          <p:cNvPr id="2" name="Title 1"/>
+          <p:cNvSpPr>
+            <a:spLocks noGrp="1"/>
+          </p:cNvSpPr>
+          <p:nvPr>
+            <p:ph type="title"/>
+          </p:nvPr>
+        </p:nvSpPr>
+        <p:spPr/>
+        <p:txBody>
+          <a:bodyPr/>
+          <a:lstStyle/>
+          <a:p>
+            <a:r>
+              <a:rPr sz="3800" b="1">
+                <a:solidFill>
+                  <a:srgbClr val="1F2A37"/>
+                </a:solidFill>
+              </a:rPr>
+              <a:t>Which one creates a paragraph of text? (from week 1)</a:t>
+            </a:r>
+          </a:p>
+        </p:txBody>
+      </p:sp>
+      <p:sp>
+        <p:nvSpPr>
+          <p:cNvPr id="3" name="TextBox 2"/>
+          <p:cNvSpPr txBox="1"/>
+          <p:nvPr/>
+        </p:nvSpPr>
+        <p:spPr>
+          <a:xfrm>
+            <a:off x="868680" y="502920"/>
+            <a:ext cx="5486400" cy="457200"/>
+          </a:xfrm>
+          <a:prstGeom prst="rect">
+            <a:avLst/>
+          </a:prstGeom>
+          <a:noFill/>
+        </p:spPr>
+        <p:txBody>
+          <a:bodyPr wrap="none">
+            <a:spAutoFit/>
+          </a:bodyPr>
+          <a:lstStyle/>
+          <a:p>
+            <a:r>
+              <a:rPr sz="1500" b="1">
+                <a:solidFill>
+                  <a:srgbClr val="01AEFD"/>
+                </a:solidFill>
+              </a:rPr>
+              <a:t>ANSWER</a:t>
+            </a:r>
+          </a:p>
+        </p:txBody>
+      </p:sp>
+      <p:sp>
+        <p:nvSpPr>
+          <p:cNvPr id="4" name="TextBox 3"/>
+          <p:cNvSpPr txBox="1"/>
+          <p:nvPr/>
+        </p:nvSpPr>
+        <p:spPr>
+          <a:xfrm>
+            <a:off x="822960" y="1828800"/>
+            <a:ext cx="10515600" cy="4206240"/>
+          </a:xfrm>
+          <a:prstGeom prst="rect">
+            <a:avLst/>
+          </a:prstGeom>
+          <a:noFill/>
+        </p:spPr>
+        <p:txBody>
+          <a:bodyPr wrap="square">
+            <a:spAutoFit/>
+          </a:bodyPr>
+          <a:lstStyle/>
+          <a:p>
+            <a:pPr>
+              <a:spcAft>
+                <a:spcPts val="1400"/>
+              </a:spcAft>
+            </a:pPr>
+            <a:r>
+              <a:rPr sz="2400">
+                <a:solidFill>
+                  <a:srgbClr val="1F2A37"/>
+                </a:solidFill>
+              </a:rPr>
+              <a:t>• A. &lt;button&gt;</a:t>
+            </a:r>
+          </a:p>
+          <a:p>
+            <a:pPr>
+              <a:spcAft>
+                <a:spcPts val="1400"/>
+              </a:spcAft>
+            </a:pPr>
+            <a:r>
+              <a:rPr sz="2400">
+                <a:solidFill>
+                  <a:srgbClr val="1F2A37"/>
+                </a:solidFill>
+              </a:rPr>
+              <a:t>• B. body { }</a:t>
+            </a:r>
+          </a:p>
+          <a:p>
+            <a:pPr>
+              <a:spcAft>
+                <a:spcPts val="1400"/>
+              </a:spcAft>
+            </a:pPr>
+            <a:r>
+              <a:rPr sz="2400">
+                <a:solidFill>
+                  <a:srgbClr val="1F2A37"/>
+                </a:solidFill>
+              </a:rPr>
+              <a:t>• C. .app</a:t>
+            </a:r>
+          </a:p>
+          <a:p>
+            <a:pPr>
+              <a:spcAft>
+                <a:spcPts val="1400"/>
+              </a:spcAft>
+            </a:pPr>
+            <a:r>
+              <a:rPr sz="2400">
+                <a:solidFill>
+                  <a:srgbClr val="1F2A37"/>
+                </a:solidFill>
+              </a:rPr>
+              <a:t>• D. &lt;p&gt;...&lt;/p&gt; (correct)</a:t>
+            </a:r>
+          </a:p>
+          <a:p>
+            <a:pPr>
+              <a:spcAft>
+                <a:spcPts val="1400"/>
+              </a:spcAft>
+            </a:pPr>
+            <a:r>
+              <a:rPr sz="2400">
+                <a:solidFill>
+                  <a:srgbClr val="1F2A37"/>
+                </a:solidFill>
+              </a:rPr>
+              <a:t>• &lt;p&gt; wraps a paragraph; the others are a button, a rule, and a selector.</a:t>
+            </a:r>
+          </a:p>
+        </p:txBody>
+      </p:sp>
+    </p:spTree>
+  </p:cSld>
+  <p:clrMapOvr>
+    <a:masterClrMapping/>
+  </p:clrMapOvr>
+</p:sld>
+</file>
+
+<file path=ppt/slides/slide56.xml><?xml version="1.0" encoding="utf-8"?>
+<p:sld xmlns:a="http://schemas.openxmlformats.org/drawingml/2006/main" xmlns:p="http://schemas.openxmlformats.org/presentationml/2006/main" xmlns:r="http://schemas.openxmlformats.org/officeDocument/2006/relationships">
+  <p:cSld>
+    <p:spTree>
+      <p:nvGrpSpPr>
+        <p:cNvPr id="1" name=""/>
+        <p:cNvGrpSpPr/>
+        <p:nvPr/>
+      </p:nvGrpSpPr>
+      <p:grpSpPr/>
+      <p:sp>
+        <p:nvSpPr>
+          <p:cNvPr id="2" name="Title 1"/>
+          <p:cNvSpPr>
+            <a:spLocks noGrp="1"/>
+          </p:cNvSpPr>
+          <p:nvPr>
+            <p:ph type="title"/>
+          </p:nvPr>
+        </p:nvSpPr>
+        <p:spPr/>
+        <p:txBody>
+          <a:bodyPr/>
+          <a:lstStyle/>
+          <a:p>
+            <a:r>
+              <a:rPr sz="3800" b="1">
+                <a:solidFill>
+                  <a:srgbClr val="1F2A37"/>
+                </a:solidFill>
+              </a:rPr>
+              <a:t>Checkpoint: it echoes you</a:t>
+            </a:r>
+          </a:p>
+        </p:txBody>
+      </p:sp>
+      <p:sp>
+        <p:nvSpPr>
+          <p:cNvPr id="3" name="TextBox 2"/>
+          <p:cNvSpPr txBox="1"/>
+          <p:nvPr/>
+        </p:nvSpPr>
+        <p:spPr>
+          <a:xfrm>
+            <a:off x="868680" y="502920"/>
+            <a:ext cx="5486400" cy="457200"/>
+          </a:xfrm>
+          <a:prstGeom prst="rect">
+            <a:avLst/>
+          </a:prstGeom>
+          <a:noFill/>
+        </p:spPr>
+        <p:txBody>
+          <a:bodyPr wrap="none">
+            <a:spAutoFit/>
+          </a:bodyPr>
+          <a:lstStyle/>
+          <a:p>
+            <a:r>
+              <a:rPr sz="1500" b="1">
+                <a:solidFill>
+                  <a:srgbClr val="01AEFD"/>
+                </a:solidFill>
+              </a:rPr>
+              <a:t>CHECKPOINT - RUN IT</a:t>
+            </a:r>
+          </a:p>
+        </p:txBody>
+      </p:sp>
+      <p:sp>
+        <p:nvSpPr>
+          <p:cNvPr id="4" name="TextBox 3"/>
+          <p:cNvSpPr txBox="1"/>
+          <p:nvPr/>
+        </p:nvSpPr>
+        <p:spPr>
+          <a:xfrm>
+            <a:off x="822960" y="1828800"/>
+            <a:ext cx="10515600" cy="4206240"/>
+          </a:xfrm>
+          <a:prstGeom prst="rect">
+            <a:avLst/>
+          </a:prstGeom>
+          <a:noFill/>
+        </p:spPr>
+        <p:txBody>
+          <a:bodyPr wrap="square">
+            <a:spAutoFit/>
+          </a:bodyPr>
+          <a:lstStyle/>
+          <a:p>
+            <a:pPr>
+              <a:spcAft>
+                <a:spcPts val="1400"/>
+              </a:spcAft>
+            </a:pPr>
+            <a:r>
+              <a:rPr sz="2800">
+                <a:solidFill>
+                  <a:srgbClr val="01AEFD"/>
+                </a:solidFill>
+              </a:rPr>
+              <a:t>Press Run, type a message and press Send. It should show as 'You: ...' and the companion echoes it back right below. This runs entirely in the browser - no AI yet.</a:t>
+            </a:r>
+          </a:p>
+          <a:p>
+            <a:pPr>
+              <a:spcAft>
+                <a:spcPts val="1400"/>
+              </a:spcAft>
+            </a:pPr>
+            <a:r>
+              <a:rPr sz="2400">
+                <a:solidFill>
+                  <a:srgbClr val="1F2A37"/>
+                </a:solidFill>
+              </a:rPr>
+              <a:t>• Run it in the classroom, or press Show the output in the web deck.</a:t>
+            </a:r>
+          </a:p>
+          <a:p>
+            <a:pPr>
+              <a:spcAft>
+                <a:spcPts val="1400"/>
+              </a:spcAft>
+            </a:pPr>
+            <a:r>
+              <a:rPr sz="2400">
+                <a:solidFill>
+                  <a:srgbClr val="1F2A37"/>
+                </a:solidFill>
+              </a:rPr>
+              <a:t>• Everyone's screen should match this.</a:t>
+            </a:r>
+          </a:p>
+        </p:txBody>
+      </p:sp>
+    </p:spTree>
+  </p:cSld>
+  <p:clrMapOvr>
+    <a:masterClrMapping/>
+  </p:clrMapOvr>
+</p:sld>
+</file>
+
+<file path=ppt/slides/slide57.xml><?xml version="1.0" encoding="utf-8"?>
+<p:sld xmlns:a="http://schemas.openxmlformats.org/drawingml/2006/main" xmlns:p="http://schemas.openxmlformats.org/presentationml/2006/main" xmlns:r="http://schemas.openxmlformats.org/officeDocument/2006/relationships">
+  <p:cSld>
+    <p:spTree>
+      <p:nvGrpSpPr>
+        <p:cNvPr id="1" name=""/>
+        <p:cNvGrpSpPr/>
+        <p:nvPr/>
+      </p:nvGrpSpPr>
+      <p:grpSpPr/>
+      <p:sp>
+        <p:nvSpPr>
+          <p:cNvPr id="2" name="Title 1"/>
+          <p:cNvSpPr>
+            <a:spLocks noGrp="1"/>
+          </p:cNvSpPr>
+          <p:nvPr>
+            <p:ph type="title"/>
+          </p:nvPr>
+        </p:nvSpPr>
+        <p:spPr/>
+        <p:txBody>
+          <a:bodyPr/>
+          <a:lstStyle/>
+          <a:p>
+            <a:r>
+              <a:rPr sz="3800" b="1">
+                <a:solidFill>
+                  <a:srgbClr val="1F2A37"/>
+                </a:solidFill>
+              </a:rPr>
+              <a:t>Your turn</a:t>
+            </a:r>
+          </a:p>
+        </p:txBody>
+      </p:sp>
+      <p:sp>
+        <p:nvSpPr>
+          <p:cNvPr id="3" name="TextBox 2"/>
+          <p:cNvSpPr txBox="1"/>
+          <p:nvPr/>
+        </p:nvSpPr>
+        <p:spPr>
+          <a:xfrm>
+            <a:off x="822960" y="1828800"/>
+            <a:ext cx="10515600" cy="4206240"/>
+          </a:xfrm>
+          <a:prstGeom prst="rect">
+            <a:avLst/>
+          </a:prstGeom>
+          <a:noFill/>
+        </p:spPr>
+        <p:txBody>
+          <a:bodyPr wrap="square">
+            <a:spAutoFit/>
+          </a:bodyPr>
+          <a:lstStyle/>
+          <a:p>
+            <a:pPr>
+              <a:spcAft>
+                <a:spcPts val="1400"/>
+              </a:spcAft>
+            </a:pPr>
+            <a:r>
+              <a:rPr sz="2800">
+                <a:solidFill>
+                  <a:srgbClr val="01AEFD"/>
+                </a:solidFill>
+              </a:rPr>
+              <a:t>Get the echo working</a:t>
+            </a:r>
+          </a:p>
+          <a:p>
+            <a:pPr>
+              <a:spcAft>
+                <a:spcPts val="1400"/>
+              </a:spcAft>
+            </a:pPr>
+            <a:r>
+              <a:rPr sz="2400">
+                <a:solidFill>
+                  <a:srgbClr val="1F2A37"/>
+                </a:solidFill>
+              </a:rPr>
+              <a:t>• Type a message</a:t>
+            </a:r>
+          </a:p>
+          <a:p>
+            <a:pPr>
+              <a:spcAft>
+                <a:spcPts val="1400"/>
+              </a:spcAft>
+            </a:pPr>
+            <a:r>
+              <a:rPr sz="2400">
+                <a:solidFill>
+                  <a:srgbClr val="1F2A37"/>
+                </a:solidFill>
+              </a:rPr>
+              <a:t>• Press Send</a:t>
+            </a:r>
+          </a:p>
+          <a:p>
+            <a:pPr>
+              <a:spcAft>
+                <a:spcPts val="1400"/>
+              </a:spcAft>
+            </a:pPr>
+            <a:r>
+              <a:rPr sz="2400">
+                <a:solidFill>
+                  <a:srgbClr val="1F2A37"/>
+                </a:solidFill>
+              </a:rPr>
+              <a:t>• See it appear twice</a:t>
             </a:r>
           </a:p>
         </p:txBody>

</xml_diff>